<commit_message>
Update business plan presentation to white theme with official TT Clinics brand icons
</commit_message>
<xml_diff>
--- a/TT_Clinics_Bedrijfsplan.pptx
+++ b/TT_Clinics_Bedrijfsplan.pptx
@@ -3113,7 +3113,7 @@
             <a:avLst/>
           </a:prstGeom>
           <a:solidFill>
-            <a:srgbClr val="101014"/>
+            <a:srgbClr val="FFFFFF"/>
           </a:solidFill>
           <a:ln>
             <a:noFill/>
@@ -3199,7 +3199,7 @@
             <a:avLst/>
           </a:prstGeom>
           <a:solidFill>
-            <a:srgbClr val="231914"/>
+            <a:srgbClr val="FFF5EE"/>
           </a:solidFill>
           <a:ln>
             <a:noFill/>
@@ -3266,7 +3266,7 @@
             <a:avLst/>
           </a:prstGeom>
           <a:solidFill>
-            <a:srgbClr val="281C14"/>
+            <a:srgbClr val="FFF3EB"/>
           </a:solidFill>
           <a:ln w="12700">
             <a:solidFill>
@@ -3295,7 +3295,7 @@
             <a:pPr algn="ctr">
               <a:defRPr sz="950" b="1">
                 <a:solidFill>
-                  <a:srgbClr val="FF6B00"/>
+                  <a:srgbClr val="D95500"/>
                 </a:solidFill>
                 <a:latin typeface="Arial Black"/>
               </a:defRPr>
@@ -3331,7 +3331,7 @@
             <a:pPr>
               <a:defRPr sz="4000" b="1">
                 <a:solidFill>
-                  <a:srgbClr val="FFFFFF"/>
+                  <a:srgbClr val="111827"/>
                 </a:solidFill>
                 <a:latin typeface="Arial Black"/>
               </a:defRPr>
@@ -3383,7 +3383,7 @@
             <a:pPr>
               <a:defRPr sz="1300" b="1">
                 <a:solidFill>
-                  <a:srgbClr val="D2D2D7"/>
+                  <a:srgbClr val="1E293B"/>
                 </a:solidFill>
                 <a:latin typeface="Arial Black"/>
               </a:defRPr>
@@ -3399,7 +3399,7 @@
               </a:spcBef>
               <a:defRPr sz="1100">
                 <a:solidFill>
-                  <a:srgbClr val="8C8C96"/>
+                  <a:srgbClr val="94A3B8"/>
                 </a:solidFill>
                 <a:latin typeface="Arial"/>
               </a:defRPr>
@@ -3410,6 +3410,30 @@
           </a:p>
         </p:txBody>
       </p:sp>
+      <p:pic>
+        <p:nvPicPr>
+          <p:cNvPr id="9" name="Picture 8" descr="icon-trophy.png"/>
+          <p:cNvPicPr>
+            <a:picLocks noChangeAspect="1"/>
+          </p:cNvPicPr>
+          <p:nvPr/>
+        </p:nvPicPr>
+        <p:blipFill>
+          <a:blip r:embed="rId3"/>
+          <a:stretch>
+            <a:fillRect/>
+          </a:stretch>
+        </p:blipFill>
+        <p:spPr>
+          <a:xfrm>
+            <a:off x="9326880" y="3474720"/>
+            <a:ext cx="1828800" cy="1828800"/>
+          </a:xfrm>
+          <a:prstGeom prst="rect">
+            <a:avLst/>
+          </a:prstGeom>
+        </p:spPr>
+      </p:pic>
     </p:spTree>
   </p:cSld>
   <p:clrMapOvr>
@@ -3443,7 +3467,7 @@
             <a:avLst/>
           </a:prstGeom>
           <a:solidFill>
-            <a:srgbClr val="101014"/>
+            <a:srgbClr val="F8FAFC"/>
           </a:solidFill>
           <a:ln>
             <a:noFill/>
@@ -3563,7 +3587,7 @@
             <a:pPr>
               <a:defRPr sz="950" b="1">
                 <a:solidFill>
-                  <a:srgbClr val="FF6B00"/>
+                  <a:srgbClr val="D95500"/>
                 </a:solidFill>
                 <a:latin typeface="Arial Black"/>
               </a:defRPr>
@@ -3599,7 +3623,7 @@
             <a:pPr>
               <a:defRPr sz="2400" b="1">
                 <a:solidFill>
-                  <a:srgbClr val="FFFFFF"/>
+                  <a:srgbClr val="111827"/>
                 </a:solidFill>
                 <a:latin typeface="Arial Black"/>
               </a:defRPr>
@@ -3678,7 +3702,7 @@
             <a:pPr>
               <a:defRPr sz="850">
                 <a:solidFill>
-                  <a:srgbClr val="8C8C96"/>
+                  <a:srgbClr val="94A3B8"/>
                 </a:solidFill>
                 <a:latin typeface="Arial"/>
               </a:defRPr>
@@ -3704,11 +3728,11 @@
             <a:avLst/>
           </a:prstGeom>
           <a:solidFill>
-            <a:srgbClr val="1C1C22"/>
+            <a:srgbClr val="FFFFFF"/>
           </a:solidFill>
           <a:ln w="12700">
             <a:solidFill>
-              <a:srgbClr val="32323C"/>
+              <a:srgbClr val="E2E8F0"/>
             </a:solidFill>
           </a:ln>
         </p:spPr>
@@ -3734,9 +3758,33 @@
           </a:p>
         </p:txBody>
       </p:sp>
-      <p:sp>
-        <p:nvSpPr>
-          <p:cNvPr id="10" name="TextBox 9"/>
+      <p:pic>
+        <p:nvPicPr>
+          <p:cNvPr id="10" name="Picture 9" descr="icon-location.png"/>
+          <p:cNvPicPr>
+            <a:picLocks noChangeAspect="1"/>
+          </p:cNvPicPr>
+          <p:nvPr/>
+        </p:nvPicPr>
+        <p:blipFill>
+          <a:blip r:embed="rId3"/>
+          <a:stretch>
+            <a:fillRect/>
+          </a:stretch>
+        </p:blipFill>
+        <p:spPr>
+          <a:xfrm>
+            <a:off x="3364992" y="1828800"/>
+            <a:ext cx="640080" cy="640080"/>
+          </a:xfrm>
+          <a:prstGeom prst="rect">
+            <a:avLst/>
+          </a:prstGeom>
+        </p:spPr>
+      </p:pic>
+      <p:sp>
+        <p:nvSpPr>
+          <p:cNvPr id="11" name="TextBox 10"/>
           <p:cNvSpPr txBox="1"/>
           <p:nvPr/>
         </p:nvSpPr>
@@ -3757,46 +3805,46 @@
           <a:lstStyle/>
           <a:p>
             <a:pPr>
+              <a:defRPr sz="1150" b="1">
+                <a:solidFill>
+                  <a:srgbClr val="1E293B"/>
+                </a:solidFill>
+                <a:latin typeface="Arial Black"/>
+              </a:defRPr>
+            </a:pPr>
+            <a:r>
+              <a:t>FASE 1: 2026</a:t>
+            </a:r>
+          </a:p>
+          <a:p>
+            <a:pPr>
+              <a:spcBef>
+                <a:spcPts val="200"/>
+              </a:spcBef>
+              <a:defRPr sz="1300" b="1">
+                <a:solidFill>
+                  <a:srgbClr val="111827"/>
+                </a:solidFill>
+                <a:latin typeface="Arial Black"/>
+              </a:defRPr>
+            </a:pPr>
+            <a:r>
+              <a:t>Fundament &amp; Tractie</a:t>
+            </a:r>
+          </a:p>
+          <a:p>
+            <a:pPr>
+              <a:spcBef>
+                <a:spcPts val="400"/>
+              </a:spcBef>
               <a:defRPr sz="1200" b="1">
                 <a:solidFill>
-                  <a:srgbClr val="FFFFFF"/>
+                  <a:srgbClr val="FF6B00"/>
                 </a:solidFill>
                 <a:latin typeface="Arial Black"/>
               </a:defRPr>
             </a:pPr>
             <a:r>
-              <a:t>FASE 1: 2026</a:t>
-            </a:r>
-          </a:p>
-          <a:p>
-            <a:pPr>
-              <a:spcBef>
-                <a:spcPts val="200"/>
-              </a:spcBef>
-              <a:defRPr sz="1400" b="1">
-                <a:solidFill>
-                  <a:srgbClr val="FFFFFF"/>
-                </a:solidFill>
-                <a:latin typeface="Arial Black"/>
-              </a:defRPr>
-            </a:pPr>
-            <a:r>
-              <a:t>Fundament &amp; Tractie</a:t>
-            </a:r>
-          </a:p>
-          <a:p>
-            <a:pPr>
-              <a:spcBef>
-                <a:spcPts val="400"/>
-              </a:spcBef>
-              <a:defRPr sz="1200" b="1">
-                <a:solidFill>
-                  <a:srgbClr val="FF6B00"/>
-                </a:solidFill>
-                <a:latin typeface="Arial Black"/>
-              </a:defRPr>
-            </a:pPr>
-            <a:r>
               <a:t>Omzetdoel: €25.000 - €35.000</a:t>
             </a:r>
           </a:p>
@@ -3807,12 +3855,12 @@
               </a:spcBef>
               <a:defRPr sz="800">
                 <a:solidFill>
-                  <a:srgbClr val="32323C"/>
-                </a:solidFill>
-              </a:defRPr>
-            </a:pPr>
-            <a:r>
-              <a:t>——————————————————</a:t>
+                  <a:srgbClr val="CBD5E1"/>
+                </a:solidFill>
+              </a:defRPr>
+            </a:pPr>
+            <a:r>
+              <a:t>——————————————————————</a:t>
             </a:r>
           </a:p>
           <a:p>
@@ -3822,7 +3870,7 @@
               </a:spcBef>
               <a:defRPr sz="950">
                 <a:solidFill>
-                  <a:srgbClr val="D2D2D7"/>
+                  <a:srgbClr val="475569"/>
                 </a:solidFill>
                 <a:latin typeface="Arial"/>
               </a:defRPr>
@@ -3838,7 +3886,7 @@
               </a:spcBef>
               <a:defRPr sz="950">
                 <a:solidFill>
-                  <a:srgbClr val="D2D2D7"/>
+                  <a:srgbClr val="475569"/>
                 </a:solidFill>
                 <a:latin typeface="Arial"/>
               </a:defRPr>
@@ -3854,7 +3902,7 @@
               </a:spcBef>
               <a:defRPr sz="950">
                 <a:solidFill>
-                  <a:srgbClr val="D2D2D7"/>
+                  <a:srgbClr val="475569"/>
                 </a:solidFill>
                 <a:latin typeface="Arial"/>
               </a:defRPr>
@@ -3870,7 +3918,7 @@
               </a:spcBef>
               <a:defRPr sz="950">
                 <a:solidFill>
-                  <a:srgbClr val="D2D2D7"/>
+                  <a:srgbClr val="475569"/>
                 </a:solidFill>
                 <a:latin typeface="Arial"/>
               </a:defRPr>
@@ -3886,7 +3934,7 @@
               </a:spcBef>
               <a:defRPr sz="950">
                 <a:solidFill>
-                  <a:srgbClr val="D2D2D7"/>
+                  <a:srgbClr val="475569"/>
                 </a:solidFill>
                 <a:latin typeface="Arial"/>
               </a:defRPr>
@@ -3899,7 +3947,7 @@
       </p:sp>
       <p:sp>
         <p:nvSpPr>
-          <p:cNvPr id="11" name="Rounded Rectangle 10"/>
+          <p:cNvPr id="12" name="Rounded Rectangle 11"/>
           <p:cNvSpPr/>
           <p:nvPr/>
         </p:nvSpPr>
@@ -3912,11 +3960,11 @@
             <a:avLst/>
           </a:prstGeom>
           <a:solidFill>
-            <a:srgbClr val="261E18"/>
+            <a:srgbClr val="FFF8F2"/>
           </a:solidFill>
           <a:ln w="12700">
             <a:solidFill>
-              <a:srgbClr val="32323C"/>
+              <a:srgbClr val="FF6B00"/>
             </a:solidFill>
           </a:ln>
         </p:spPr>
@@ -3944,7 +3992,7 @@
       </p:sp>
       <p:sp>
         <p:nvSpPr>
-          <p:cNvPr id="12" name="Rectangle 11"/>
+          <p:cNvPr id="13" name="Rectangle 12"/>
           <p:cNvSpPr/>
           <p:nvPr/>
         </p:nvSpPr>
@@ -3985,9 +4033,33 @@
           </a:p>
         </p:txBody>
       </p:sp>
-      <p:sp>
-        <p:nvSpPr>
-          <p:cNvPr id="13" name="TextBox 12"/>
+      <p:pic>
+        <p:nvPicPr>
+          <p:cNvPr id="14" name="Picture 13" descr="icon-chart.png"/>
+          <p:cNvPicPr>
+            <a:picLocks noChangeAspect="1"/>
+          </p:cNvPicPr>
+          <p:nvPr/>
+        </p:nvPicPr>
+        <p:blipFill>
+          <a:blip r:embed="rId4"/>
+          <a:stretch>
+            <a:fillRect/>
+          </a:stretch>
+        </p:blipFill>
+        <p:spPr>
+          <a:xfrm>
+            <a:off x="7004304" y="1828800"/>
+            <a:ext cx="640080" cy="640080"/>
+          </a:xfrm>
+          <a:prstGeom prst="rect">
+            <a:avLst/>
+          </a:prstGeom>
+        </p:spPr>
+      </p:pic>
+      <p:sp>
+        <p:nvSpPr>
+          <p:cNvPr id="15" name="TextBox 14"/>
           <p:cNvSpPr txBox="1"/>
           <p:nvPr/>
         </p:nvSpPr>
@@ -4008,6 +4080,38 @@
           <a:lstStyle/>
           <a:p>
             <a:pPr>
+              <a:defRPr sz="1150" b="1">
+                <a:solidFill>
+                  <a:srgbClr val="D95500"/>
+                </a:solidFill>
+                <a:latin typeface="Arial Black"/>
+              </a:defRPr>
+            </a:pPr>
+            <a:r>
+              <a:t>FASE 2: 2027</a:t>
+            </a:r>
+          </a:p>
+          <a:p>
+            <a:pPr>
+              <a:spcBef>
+                <a:spcPts val="200"/>
+              </a:spcBef>
+              <a:defRPr sz="1300" b="1">
+                <a:solidFill>
+                  <a:srgbClr val="111827"/>
+                </a:solidFill>
+                <a:latin typeface="Arial Black"/>
+              </a:defRPr>
+            </a:pPr>
+            <a:r>
+              <a:t>Opschaling &amp; Abonnementen</a:t>
+            </a:r>
+          </a:p>
+          <a:p>
+            <a:pPr>
+              <a:spcBef>
+                <a:spcPts val="400"/>
+              </a:spcBef>
               <a:defRPr sz="1200" b="1">
                 <a:solidFill>
                   <a:srgbClr val="FF6B00"/>
@@ -4016,38 +4120,6 @@
               </a:defRPr>
             </a:pPr>
             <a:r>
-              <a:t>FASE 2: 2027</a:t>
-            </a:r>
-          </a:p>
-          <a:p>
-            <a:pPr>
-              <a:spcBef>
-                <a:spcPts val="200"/>
-              </a:spcBef>
-              <a:defRPr sz="1400" b="1">
-                <a:solidFill>
-                  <a:srgbClr val="FFFFFF"/>
-                </a:solidFill>
-                <a:latin typeface="Arial Black"/>
-              </a:defRPr>
-            </a:pPr>
-            <a:r>
-              <a:t>Opschaling &amp; Abonnementen</a:t>
-            </a:r>
-          </a:p>
-          <a:p>
-            <a:pPr>
-              <a:spcBef>
-                <a:spcPts val="400"/>
-              </a:spcBef>
-              <a:defRPr sz="1200" b="1">
-                <a:solidFill>
-                  <a:srgbClr val="FF6B00"/>
-                </a:solidFill>
-                <a:latin typeface="Arial Black"/>
-              </a:defRPr>
-            </a:pPr>
-            <a:r>
               <a:t>Omzetdoel: €60.000 - €75.000</a:t>
             </a:r>
           </a:p>
@@ -4058,12 +4130,12 @@
               </a:spcBef>
               <a:defRPr sz="800">
                 <a:solidFill>
-                  <a:srgbClr val="32323C"/>
-                </a:solidFill>
-              </a:defRPr>
-            </a:pPr>
-            <a:r>
-              <a:t>——————————————————</a:t>
+                  <a:srgbClr val="CBD5E1"/>
+                </a:solidFill>
+              </a:defRPr>
+            </a:pPr>
+            <a:r>
+              <a:t>——————————————————————</a:t>
             </a:r>
           </a:p>
           <a:p>
@@ -4073,7 +4145,7 @@
               </a:spcBef>
               <a:defRPr sz="950">
                 <a:solidFill>
-                  <a:srgbClr val="D2D2D7"/>
+                  <a:srgbClr val="475569"/>
                 </a:solidFill>
                 <a:latin typeface="Arial"/>
               </a:defRPr>
@@ -4089,7 +4161,7 @@
               </a:spcBef>
               <a:defRPr sz="950">
                 <a:solidFill>
-                  <a:srgbClr val="D2D2D7"/>
+                  <a:srgbClr val="475569"/>
                 </a:solidFill>
                 <a:latin typeface="Arial"/>
               </a:defRPr>
@@ -4105,7 +4177,7 @@
               </a:spcBef>
               <a:defRPr sz="950">
                 <a:solidFill>
-                  <a:srgbClr val="D2D2D7"/>
+                  <a:srgbClr val="475569"/>
                 </a:solidFill>
                 <a:latin typeface="Arial"/>
               </a:defRPr>
@@ -4121,7 +4193,7 @@
               </a:spcBef>
               <a:defRPr sz="950">
                 <a:solidFill>
-                  <a:srgbClr val="D2D2D7"/>
+                  <a:srgbClr val="475569"/>
                 </a:solidFill>
                 <a:latin typeface="Arial"/>
               </a:defRPr>
@@ -4137,7 +4209,7 @@
               </a:spcBef>
               <a:defRPr sz="950">
                 <a:solidFill>
-                  <a:srgbClr val="D2D2D7"/>
+                  <a:srgbClr val="475569"/>
                 </a:solidFill>
                 <a:latin typeface="Arial"/>
               </a:defRPr>
@@ -4150,7 +4222,7 @@
       </p:sp>
       <p:sp>
         <p:nvSpPr>
-          <p:cNvPr id="14" name="Rounded Rectangle 13"/>
+          <p:cNvPr id="16" name="Rounded Rectangle 15"/>
           <p:cNvSpPr/>
           <p:nvPr/>
         </p:nvSpPr>
@@ -4163,11 +4235,11 @@
             <a:avLst/>
           </a:prstGeom>
           <a:solidFill>
-            <a:srgbClr val="1C1C22"/>
+            <a:srgbClr val="FFFFFF"/>
           </a:solidFill>
           <a:ln w="12700">
             <a:solidFill>
-              <a:srgbClr val="32323C"/>
+              <a:srgbClr val="E2E8F0"/>
             </a:solidFill>
           </a:ln>
         </p:spPr>
@@ -4193,9 +4265,33 @@
           </a:p>
         </p:txBody>
       </p:sp>
-      <p:sp>
-        <p:nvSpPr>
-          <p:cNvPr id="15" name="TextBox 14"/>
+      <p:pic>
+        <p:nvPicPr>
+          <p:cNvPr id="17" name="Picture 16" descr="icon-trophy.png"/>
+          <p:cNvPicPr>
+            <a:picLocks noChangeAspect="1"/>
+          </p:cNvPicPr>
+          <p:nvPr/>
+        </p:nvPicPr>
+        <p:blipFill>
+          <a:blip r:embed="rId5"/>
+          <a:stretch>
+            <a:fillRect/>
+          </a:stretch>
+        </p:blipFill>
+        <p:spPr>
+          <a:xfrm>
+            <a:off x="10643616" y="1828800"/>
+            <a:ext cx="640080" cy="640080"/>
+          </a:xfrm>
+          <a:prstGeom prst="rect">
+            <a:avLst/>
+          </a:prstGeom>
+        </p:spPr>
+      </p:pic>
+      <p:sp>
+        <p:nvSpPr>
+          <p:cNvPr id="18" name="TextBox 17"/>
           <p:cNvSpPr txBox="1"/>
           <p:nvPr/>
         </p:nvSpPr>
@@ -4216,46 +4312,46 @@
           <a:lstStyle/>
           <a:p>
             <a:pPr>
+              <a:defRPr sz="1150" b="1">
+                <a:solidFill>
+                  <a:srgbClr val="1E293B"/>
+                </a:solidFill>
+                <a:latin typeface="Arial Black"/>
+              </a:defRPr>
+            </a:pPr>
+            <a:r>
+              <a:t>FASE 3: 2028</a:t>
+            </a:r>
+          </a:p>
+          <a:p>
+            <a:pPr>
+              <a:spcBef>
+                <a:spcPts val="200"/>
+              </a:spcBef>
+              <a:defRPr sz="1300" b="1">
+                <a:solidFill>
+                  <a:srgbClr val="111827"/>
+                </a:solidFill>
+                <a:latin typeface="Arial Black"/>
+              </a:defRPr>
+            </a:pPr>
+            <a:r>
+              <a:t>Landelijke Autoriteit</a:t>
+            </a:r>
+          </a:p>
+          <a:p>
+            <a:pPr>
+              <a:spcBef>
+                <a:spcPts val="400"/>
+              </a:spcBef>
               <a:defRPr sz="1200" b="1">
                 <a:solidFill>
-                  <a:srgbClr val="FFFFFF"/>
+                  <a:srgbClr val="FF6B00"/>
                 </a:solidFill>
                 <a:latin typeface="Arial Black"/>
               </a:defRPr>
             </a:pPr>
             <a:r>
-              <a:t>FASE 3: 2028</a:t>
-            </a:r>
-          </a:p>
-          <a:p>
-            <a:pPr>
-              <a:spcBef>
-                <a:spcPts val="200"/>
-              </a:spcBef>
-              <a:defRPr sz="1400" b="1">
-                <a:solidFill>
-                  <a:srgbClr val="FFFFFF"/>
-                </a:solidFill>
-                <a:latin typeface="Arial Black"/>
-              </a:defRPr>
-            </a:pPr>
-            <a:r>
-              <a:t>Landelijke Autoriteit</a:t>
-            </a:r>
-          </a:p>
-          <a:p>
-            <a:pPr>
-              <a:spcBef>
-                <a:spcPts val="400"/>
-              </a:spcBef>
-              <a:defRPr sz="1200" b="1">
-                <a:solidFill>
-                  <a:srgbClr val="FF6B00"/>
-                </a:solidFill>
-                <a:latin typeface="Arial Black"/>
-              </a:defRPr>
-            </a:pPr>
-            <a:r>
               <a:t>Omzetdoel: €100.000+</a:t>
             </a:r>
           </a:p>
@@ -4266,12 +4362,12 @@
               </a:spcBef>
               <a:defRPr sz="800">
                 <a:solidFill>
-                  <a:srgbClr val="32323C"/>
-                </a:solidFill>
-              </a:defRPr>
-            </a:pPr>
-            <a:r>
-              <a:t>——————————————————</a:t>
+                  <a:srgbClr val="CBD5E1"/>
+                </a:solidFill>
+              </a:defRPr>
+            </a:pPr>
+            <a:r>
+              <a:t>——————————————————————</a:t>
             </a:r>
           </a:p>
           <a:p>
@@ -4281,7 +4377,7 @@
               </a:spcBef>
               <a:defRPr sz="950">
                 <a:solidFill>
-                  <a:srgbClr val="D2D2D7"/>
+                  <a:srgbClr val="475569"/>
                 </a:solidFill>
                 <a:latin typeface="Arial"/>
               </a:defRPr>
@@ -4297,7 +4393,7 @@
               </a:spcBef>
               <a:defRPr sz="950">
                 <a:solidFill>
-                  <a:srgbClr val="D2D2D7"/>
+                  <a:srgbClr val="475569"/>
                 </a:solidFill>
                 <a:latin typeface="Arial"/>
               </a:defRPr>
@@ -4313,7 +4409,7 @@
               </a:spcBef>
               <a:defRPr sz="950">
                 <a:solidFill>
-                  <a:srgbClr val="D2D2D7"/>
+                  <a:srgbClr val="475569"/>
                 </a:solidFill>
                 <a:latin typeface="Arial"/>
               </a:defRPr>
@@ -4329,7 +4425,7 @@
               </a:spcBef>
               <a:defRPr sz="950">
                 <a:solidFill>
-                  <a:srgbClr val="D2D2D7"/>
+                  <a:srgbClr val="475569"/>
                 </a:solidFill>
                 <a:latin typeface="Arial"/>
               </a:defRPr>
@@ -4345,7 +4441,7 @@
               </a:spcBef>
               <a:defRPr sz="950">
                 <a:solidFill>
-                  <a:srgbClr val="D2D2D7"/>
+                  <a:srgbClr val="475569"/>
                 </a:solidFill>
                 <a:latin typeface="Arial"/>
               </a:defRPr>
@@ -4389,7 +4485,7 @@
             <a:avLst/>
           </a:prstGeom>
           <a:solidFill>
-            <a:srgbClr val="101014"/>
+            <a:srgbClr val="F8FAFC"/>
           </a:solidFill>
           <a:ln>
             <a:noFill/>
@@ -4509,7 +4605,7 @@
             <a:pPr>
               <a:defRPr sz="950" b="1">
                 <a:solidFill>
-                  <a:srgbClr val="FF6B00"/>
+                  <a:srgbClr val="D95500"/>
                 </a:solidFill>
                 <a:latin typeface="Arial Black"/>
               </a:defRPr>
@@ -4545,7 +4641,7 @@
             <a:pPr>
               <a:defRPr sz="2400" b="1">
                 <a:solidFill>
-                  <a:srgbClr val="FFFFFF"/>
+                  <a:srgbClr val="111827"/>
                 </a:solidFill>
                 <a:latin typeface="Arial Black"/>
               </a:defRPr>
@@ -4624,7 +4720,7 @@
             <a:pPr>
               <a:defRPr sz="850">
                 <a:solidFill>
-                  <a:srgbClr val="8C8C96"/>
+                  <a:srgbClr val="94A3B8"/>
                 </a:solidFill>
                 <a:latin typeface="Arial"/>
               </a:defRPr>
@@ -4650,11 +4746,11 @@
             <a:avLst/>
           </a:prstGeom>
           <a:solidFill>
-            <a:srgbClr val="1C1C22"/>
+            <a:srgbClr val="FFFFFF"/>
           </a:solidFill>
           <a:ln w="12700">
             <a:solidFill>
-              <a:srgbClr val="32323C"/>
+              <a:srgbClr val="E2E8F0"/>
             </a:solidFill>
           </a:ln>
         </p:spPr>
@@ -4772,7 +4868,7 @@
             <a:pPr>
               <a:defRPr sz="1800" b="1">
                 <a:solidFill>
-                  <a:srgbClr val="FFFFFF"/>
+                  <a:srgbClr val="111827"/>
                 </a:solidFill>
                 <a:latin typeface="Arial Black"/>
               </a:defRPr>
@@ -4788,7 +4884,7 @@
               </a:spcBef>
               <a:defRPr sz="1000" b="1">
                 <a:solidFill>
-                  <a:srgbClr val="FF6B00"/>
+                  <a:srgbClr val="D95500"/>
                 </a:solidFill>
                 <a:latin typeface="Arial Black"/>
               </a:defRPr>
@@ -4804,13 +4900,13 @@
               </a:spcBef>
               <a:defRPr sz="1000" i="1">
                 <a:solidFill>
-                  <a:srgbClr val="D2D2D7"/>
-                </a:solidFill>
-                <a:latin typeface="Arial"/>
-              </a:defRPr>
-            </a:pPr>
-            <a:r>
-              <a:t>"TT Clinics is het bewijs dat de mooiste dingen soms heel klein beginnen. Wat startte als een bescheiden clubje op de woensdagmorgen, is inmiddels uitgegroeid tot een professionele partner voor bedrijfsvitaliteit. Tafeltennis is dé manier om laagdrempelig in beweging te komen en als team onvergetelijk plezier te maken."</a:t>
+                  <a:srgbClr val="475569"/>
+                </a:solidFill>
+                <a:latin typeface="Arial"/>
+              </a:defRPr>
+            </a:pPr>
+            <a:r>
+              <a:t>"TT Clinics is het bewijs dat de mooiste dingen soms heel klein beginnen. Wat startte als een bescheiden clubje op de woensdagmorgen, is inmiddels uitgegroeid tot een professionele partner voor bedrijfsvitaliteit en teambuilding. Tafeltennis is dé manier om laagdrempelig in beweging te komen en als team onvergetelijk plezier te maken."</a:t>
             </a:r>
           </a:p>
           <a:p>
@@ -4820,7 +4916,7 @@
               </a:spcBef>
               <a:defRPr sz="950" b="1">
                 <a:solidFill>
-                  <a:srgbClr val="FF9A4D"/>
+                  <a:srgbClr val="D95500"/>
                 </a:solidFill>
                 <a:latin typeface="Arial Black"/>
               </a:defRPr>
@@ -4846,11 +4942,11 @@
             <a:avLst/>
           </a:prstGeom>
           <a:solidFill>
-            <a:srgbClr val="1C1C22"/>
+            <a:srgbClr val="FFFFFF"/>
           </a:solidFill>
           <a:ln w="12700">
             <a:solidFill>
-              <a:srgbClr val="32323C"/>
+              <a:srgbClr val="E2E8F0"/>
             </a:solidFill>
           </a:ln>
         </p:spPr>
@@ -4944,7 +5040,7 @@
             <a:pPr>
               <a:defRPr sz="1400" b="1">
                 <a:solidFill>
-                  <a:srgbClr val="FFFFFF"/>
+                  <a:srgbClr val="111827"/>
                 </a:solidFill>
                 <a:latin typeface="Arial Black"/>
               </a:defRPr>
@@ -4960,7 +5056,7 @@
               </a:spcBef>
               <a:defRPr sz="1000">
                 <a:solidFill>
-                  <a:srgbClr val="D2D2D7"/>
+                  <a:srgbClr val="475569"/>
                 </a:solidFill>
                 <a:latin typeface="Arial"/>
               </a:defRPr>
@@ -4976,7 +5072,7 @@
               </a:spcBef>
               <a:defRPr sz="1000">
                 <a:solidFill>
-                  <a:srgbClr val="D2D2D7"/>
+                  <a:srgbClr val="475569"/>
                 </a:solidFill>
                 <a:latin typeface="Arial"/>
               </a:defRPr>
@@ -4992,7 +5088,7 @@
               </a:spcBef>
               <a:defRPr sz="1000">
                 <a:solidFill>
-                  <a:srgbClr val="D2D2D7"/>
+                  <a:srgbClr val="475569"/>
                 </a:solidFill>
                 <a:latin typeface="Arial"/>
               </a:defRPr>
@@ -5008,7 +5104,7 @@
               </a:spcBef>
               <a:defRPr sz="1000">
                 <a:solidFill>
-                  <a:srgbClr val="D2D2D7"/>
+                  <a:srgbClr val="475569"/>
                 </a:solidFill>
                 <a:latin typeface="Arial"/>
               </a:defRPr>
@@ -5068,7 +5164,7 @@
             <a:pPr algn="ctr">
               <a:defRPr sz="850">
                 <a:solidFill>
-                  <a:srgbClr val="8C8C96"/>
+                  <a:srgbClr val="94A3B8"/>
                 </a:solidFill>
                 <a:latin typeface="Arial"/>
               </a:defRPr>
@@ -5112,7 +5208,7 @@
             <a:avLst/>
           </a:prstGeom>
           <a:solidFill>
-            <a:srgbClr val="101014"/>
+            <a:srgbClr val="F8FAFC"/>
           </a:solidFill>
           <a:ln>
             <a:noFill/>
@@ -5232,7 +5328,7 @@
             <a:pPr>
               <a:defRPr sz="950" b="1">
                 <a:solidFill>
-                  <a:srgbClr val="FF6B00"/>
+                  <a:srgbClr val="D95500"/>
                 </a:solidFill>
                 <a:latin typeface="Arial Black"/>
               </a:defRPr>
@@ -5268,7 +5364,7 @@
             <a:pPr>
               <a:defRPr sz="2400" b="1">
                 <a:solidFill>
-                  <a:srgbClr val="FFFFFF"/>
+                  <a:srgbClr val="111827"/>
                 </a:solidFill>
                 <a:latin typeface="Arial Black"/>
               </a:defRPr>
@@ -5347,7 +5443,7 @@
             <a:pPr>
               <a:defRPr sz="850">
                 <a:solidFill>
-                  <a:srgbClr val="8C8C96"/>
+                  <a:srgbClr val="94A3B8"/>
                 </a:solidFill>
                 <a:latin typeface="Arial"/>
               </a:defRPr>
@@ -5373,11 +5469,11 @@
             <a:avLst/>
           </a:prstGeom>
           <a:solidFill>
-            <a:srgbClr val="1C1C22"/>
+            <a:srgbClr val="FFFFFF"/>
           </a:solidFill>
           <a:ln w="12700">
             <a:solidFill>
-              <a:srgbClr val="32323C"/>
+              <a:srgbClr val="E2E8F0"/>
             </a:solidFill>
           </a:ln>
         </p:spPr>
@@ -5446,16 +5542,40 @@
           </a:p>
         </p:txBody>
       </p:sp>
-      <p:sp>
-        <p:nvSpPr>
-          <p:cNvPr id="11" name="TextBox 10"/>
+      <p:pic>
+        <p:nvPicPr>
+          <p:cNvPr id="11" name="Picture 10" descr="icon-trophy.png"/>
+          <p:cNvPicPr>
+            <a:picLocks noChangeAspect="1"/>
+          </p:cNvPicPr>
+          <p:nvPr/>
+        </p:nvPicPr>
+        <p:blipFill>
+          <a:blip r:embed="rId3"/>
+          <a:stretch>
+            <a:fillRect/>
+          </a:stretch>
+        </p:blipFill>
+        <p:spPr>
+          <a:xfrm>
+            <a:off x="5166360" y="1874520"/>
+            <a:ext cx="594360" cy="594360"/>
+          </a:xfrm>
+          <a:prstGeom prst="rect">
+            <a:avLst/>
+          </a:prstGeom>
+        </p:spPr>
+      </p:pic>
+      <p:sp>
+        <p:nvSpPr>
+          <p:cNvPr id="12" name="TextBox 11"/>
           <p:cNvSpPr txBox="1"/>
           <p:nvPr/>
         </p:nvSpPr>
         <p:spPr>
           <a:xfrm>
             <a:off x="1005840" y="1874520"/>
-            <a:ext cx="4709160" cy="1600200"/>
+            <a:ext cx="4069080" cy="1600200"/>
           </a:xfrm>
           <a:prstGeom prst="rect">
             <a:avLst/>
@@ -5471,7 +5591,7 @@
             <a:pPr>
               <a:defRPr sz="1300" b="1">
                 <a:solidFill>
-                  <a:srgbClr val="FF6B00"/>
+                  <a:srgbClr val="D95500"/>
                 </a:solidFill>
                 <a:latin typeface="Arial Black"/>
               </a:defRPr>
@@ -5485,9 +5605,9 @@
               <a:spcBef>
                 <a:spcPts val="800"/>
               </a:spcBef>
-              <a:defRPr sz="1100">
-                <a:solidFill>
-                  <a:srgbClr val="D2D2D7"/>
+              <a:defRPr sz="1050">
+                <a:solidFill>
+                  <a:srgbClr val="475569"/>
                 </a:solidFill>
                 <a:latin typeface="Arial"/>
               </a:defRPr>
@@ -5500,7 +5620,7 @@
       </p:sp>
       <p:sp>
         <p:nvSpPr>
-          <p:cNvPr id="12" name="Rounded Rectangle 11"/>
+          <p:cNvPr id="13" name="Rounded Rectangle 12"/>
           <p:cNvSpPr/>
           <p:nvPr/>
         </p:nvSpPr>
@@ -5513,11 +5633,11 @@
             <a:avLst/>
           </a:prstGeom>
           <a:solidFill>
-            <a:srgbClr val="1C1C22"/>
+            <a:srgbClr val="FFFFFF"/>
           </a:solidFill>
           <a:ln w="12700">
             <a:solidFill>
-              <a:srgbClr val="32323C"/>
+              <a:srgbClr val="E2E8F0"/>
             </a:solidFill>
           </a:ln>
         </p:spPr>
@@ -5545,110 +5665,13 @@
       </p:sp>
       <p:sp>
         <p:nvSpPr>
-          <p:cNvPr id="13" name="TextBox 12"/>
-          <p:cNvSpPr txBox="1"/>
-          <p:nvPr/>
-        </p:nvSpPr>
-        <p:spPr>
-          <a:xfrm>
-            <a:off x="6446520" y="1874520"/>
-            <a:ext cx="4709160" cy="1600200"/>
-          </a:xfrm>
-          <a:prstGeom prst="rect">
-            <a:avLst/>
-          </a:prstGeom>
-          <a:noFill/>
-        </p:spPr>
-        <p:txBody>
-          <a:bodyPr wrap="square" lIns="0" tIns="0">
-            <a:spAutoFit/>
-          </a:bodyPr>
-          <a:lstStyle/>
-          <a:p>
-            <a:pPr>
-              <a:defRPr sz="1300" b="1">
-                <a:solidFill>
-                  <a:srgbClr val="FFFFFF"/>
-                </a:solidFill>
-                <a:latin typeface="Arial Black"/>
-              </a:defRPr>
-            </a:pPr>
-            <a:r>
-              <a:t>DE MISSIE</a:t>
-            </a:r>
-          </a:p>
-          <a:p>
-            <a:pPr>
-              <a:spcBef>
-                <a:spcPts val="800"/>
-              </a:spcBef>
-              <a:defRPr sz="1100">
-                <a:solidFill>
-                  <a:srgbClr val="D2D2D7"/>
-                </a:solidFill>
-                <a:latin typeface="Arial"/>
-              </a:defRPr>
-            </a:pPr>
-            <a:r>
-              <a:t>Teams verbinden, beeldschermmoeheid doorbreken en vitaliteit bevorderen met 'schaken op topsnelheid'. Tafeltennis is fysiek én mentaal de ultieme breinfitness.</a:t>
-            </a:r>
-          </a:p>
-        </p:txBody>
-      </p:sp>
-      <p:sp>
-        <p:nvSpPr>
-          <p:cNvPr id="14" name="Rounded Rectangle 13"/>
+          <p:cNvPr id="14" name="Rectangle 13"/>
           <p:cNvSpPr/>
           <p:nvPr/>
         </p:nvSpPr>
         <p:spPr>
           <a:xfrm>
-            <a:off x="731520" y="3931920"/>
-            <a:ext cx="5257800" cy="2057400"/>
-          </a:xfrm>
-          <a:prstGeom prst="roundRect">
-            <a:avLst/>
-          </a:prstGeom>
-          <a:solidFill>
-            <a:srgbClr val="1C1C22"/>
-          </a:solidFill>
-          <a:ln w="12700">
-            <a:solidFill>
-              <a:srgbClr val="32323C"/>
-            </a:solidFill>
-          </a:ln>
-        </p:spPr>
-        <p:style>
-          <a:lnRef idx="1">
-            <a:schemeClr val="accent1"/>
-          </a:lnRef>
-          <a:fillRef idx="3">
-            <a:schemeClr val="accent1"/>
-          </a:fillRef>
-          <a:effectRef idx="2">
-            <a:schemeClr val="accent1"/>
-          </a:effectRef>
-          <a:fontRef idx="minor">
-            <a:schemeClr val="lt1"/>
-          </a:fontRef>
-        </p:style>
-        <p:txBody>
-          <a:bodyPr rtlCol="0" anchor="ctr"/>
-          <a:lstStyle/>
-          <a:p>
-            <a:pPr algn="ctr"/>
-          </a:p>
-        </p:txBody>
-      </p:sp>
-      <p:sp>
-        <p:nvSpPr>
-          <p:cNvPr id="15" name="Rectangle 14"/>
-          <p:cNvSpPr/>
-          <p:nvPr/>
-        </p:nvSpPr>
-        <p:spPr>
-          <a:xfrm>
-            <a:off x="731520" y="3931920"/>
+            <a:off x="6172200" y="1645920"/>
             <a:ext cx="5257800" cy="73152"/>
           </a:xfrm>
           <a:prstGeom prst="rect">
@@ -5683,6 +5706,30 @@
           </a:p>
         </p:txBody>
       </p:sp>
+      <p:pic>
+        <p:nvPicPr>
+          <p:cNvPr id="15" name="Picture 14" descr="icon-heartbeat.png"/>
+          <p:cNvPicPr>
+            <a:picLocks noChangeAspect="1"/>
+          </p:cNvPicPr>
+          <p:nvPr/>
+        </p:nvPicPr>
+        <p:blipFill>
+          <a:blip r:embed="rId4"/>
+          <a:stretch>
+            <a:fillRect/>
+          </a:stretch>
+        </p:blipFill>
+        <p:spPr>
+          <a:xfrm>
+            <a:off x="10607040" y="1874520"/>
+            <a:ext cx="594360" cy="594360"/>
+          </a:xfrm>
+          <a:prstGeom prst="rect">
+            <a:avLst/>
+          </a:prstGeom>
+        </p:spPr>
+      </p:pic>
       <p:sp>
         <p:nvSpPr>
           <p:cNvPr id="16" name="TextBox 15"/>
@@ -5691,8 +5738,8 @@
         </p:nvSpPr>
         <p:spPr>
           <a:xfrm>
-            <a:off x="1005840" y="4160520"/>
-            <a:ext cx="4709160" cy="1600200"/>
+            <a:off x="6446520" y="1874520"/>
+            <a:ext cx="4069080" cy="1600200"/>
           </a:xfrm>
           <a:prstGeom prst="rect">
             <a:avLst/>
@@ -5708,13 +5755,13 @@
             <a:pPr>
               <a:defRPr sz="1300" b="1">
                 <a:solidFill>
-                  <a:srgbClr val="FF6B00"/>
+                  <a:srgbClr val="D95500"/>
                 </a:solidFill>
                 <a:latin typeface="Arial Black"/>
               </a:defRPr>
             </a:pPr>
             <a:r>
-              <a:t>DE OORSPRONG</a:t>
+              <a:t>DE MISSIE</a:t>
             </a:r>
           </a:p>
           <a:p>
@@ -5722,15 +5769,15 @@
               <a:spcBef>
                 <a:spcPts val="800"/>
               </a:spcBef>
-              <a:defRPr sz="1100">
-                <a:solidFill>
-                  <a:srgbClr val="D2D2D7"/>
-                </a:solidFill>
-                <a:latin typeface="Arial"/>
-              </a:defRPr>
-            </a:pPr>
-            <a:r>
-              <a:t>Wat begon als een bescheiden, gezellig tafeltennisclubje op de woensdagmorgen, is uitgegroeid tot een professionele partner voor bedrijfsvitaliteit en teambuilding.</a:t>
+              <a:defRPr sz="1050">
+                <a:solidFill>
+                  <a:srgbClr val="475569"/>
+                </a:solidFill>
+                <a:latin typeface="Arial"/>
+              </a:defRPr>
+            </a:pPr>
+            <a:r>
+              <a:t>Teams verbinden, beeldschermmoeheid doorbreken en vitaliteit bevorderen met 'schaken op topsnelheid'. Tafeltennis is fysiek én mentaal de ultieme breinfitness.</a:t>
             </a:r>
           </a:p>
         </p:txBody>
@@ -5743,18 +5790,18 @@
         </p:nvSpPr>
         <p:spPr>
           <a:xfrm>
-            <a:off x="6172200" y="3931920"/>
+            <a:off x="731520" y="3931920"/>
             <a:ext cx="5257800" cy="2057400"/>
           </a:xfrm>
           <a:prstGeom prst="roundRect">
             <a:avLst/>
           </a:prstGeom>
           <a:solidFill>
-            <a:srgbClr val="1C1C22"/>
+            <a:srgbClr val="FFFFFF"/>
           </a:solidFill>
           <a:ln w="12700">
             <a:solidFill>
-              <a:srgbClr val="32323C"/>
+              <a:srgbClr val="E2E8F0"/>
             </a:solidFill>
           </a:ln>
         </p:spPr>
@@ -5782,14 +5829,81 @@
       </p:sp>
       <p:sp>
         <p:nvSpPr>
-          <p:cNvPr id="18" name="TextBox 17"/>
+          <p:cNvPr id="18" name="Rectangle 17"/>
+          <p:cNvSpPr/>
+          <p:nvPr/>
+        </p:nvSpPr>
+        <p:spPr>
+          <a:xfrm>
+            <a:off x="731520" y="3931920"/>
+            <a:ext cx="5257800" cy="73152"/>
+          </a:xfrm>
+          <a:prstGeom prst="rect">
+            <a:avLst/>
+          </a:prstGeom>
+          <a:solidFill>
+            <a:srgbClr val="FF6B00"/>
+          </a:solidFill>
+          <a:ln>
+            <a:noFill/>
+          </a:ln>
+        </p:spPr>
+        <p:style>
+          <a:lnRef idx="1">
+            <a:schemeClr val="accent1"/>
+          </a:lnRef>
+          <a:fillRef idx="3">
+            <a:schemeClr val="accent1"/>
+          </a:fillRef>
+          <a:effectRef idx="2">
+            <a:schemeClr val="accent1"/>
+          </a:effectRef>
+          <a:fontRef idx="minor">
+            <a:schemeClr val="lt1"/>
+          </a:fontRef>
+        </p:style>
+        <p:txBody>
+          <a:bodyPr rtlCol="0" anchor="ctr"/>
+          <a:lstStyle/>
+          <a:p>
+            <a:pPr algn="ctr"/>
+          </a:p>
+        </p:txBody>
+      </p:sp>
+      <p:pic>
+        <p:nvPicPr>
+          <p:cNvPr id="19" name="Picture 18" descr="icon-location.png"/>
+          <p:cNvPicPr>
+            <a:picLocks noChangeAspect="1"/>
+          </p:cNvPicPr>
+          <p:nvPr/>
+        </p:nvPicPr>
+        <p:blipFill>
+          <a:blip r:embed="rId5"/>
+          <a:stretch>
+            <a:fillRect/>
+          </a:stretch>
+        </p:blipFill>
+        <p:spPr>
+          <a:xfrm>
+            <a:off x="5166360" y="4160520"/>
+            <a:ext cx="594360" cy="594360"/>
+          </a:xfrm>
+          <a:prstGeom prst="rect">
+            <a:avLst/>
+          </a:prstGeom>
+        </p:spPr>
+      </p:pic>
+      <p:sp>
+        <p:nvSpPr>
+          <p:cNvPr id="20" name="TextBox 19"/>
           <p:cNvSpPr txBox="1"/>
           <p:nvPr/>
         </p:nvSpPr>
         <p:spPr>
           <a:xfrm>
-            <a:off x="6446520" y="4160520"/>
-            <a:ext cx="4709160" cy="1600200"/>
+            <a:off x="1005840" y="4160520"/>
+            <a:ext cx="4069080" cy="1600200"/>
           </a:xfrm>
           <a:prstGeom prst="rect">
             <a:avLst/>
@@ -5805,12 +5919,176 @@
             <a:pPr>
               <a:defRPr sz="1300" b="1">
                 <a:solidFill>
-                  <a:srgbClr val="FFFFFF"/>
+                  <a:srgbClr val="D95500"/>
                 </a:solidFill>
                 <a:latin typeface="Arial Black"/>
               </a:defRPr>
             </a:pPr>
             <a:r>
+              <a:t>DE OORSPRONG</a:t>
+            </a:r>
+          </a:p>
+          <a:p>
+            <a:pPr>
+              <a:spcBef>
+                <a:spcPts val="800"/>
+              </a:spcBef>
+              <a:defRPr sz="1050">
+                <a:solidFill>
+                  <a:srgbClr val="475569"/>
+                </a:solidFill>
+                <a:latin typeface="Arial"/>
+              </a:defRPr>
+            </a:pPr>
+            <a:r>
+              <a:t>Wat begon als een bescheiden, gezellig tafeltennisclubje op de woensdagmorgen, is uitgegroeid tot een professionele partner voor bedrijfsvitaliteit en teambuilding.</a:t>
+            </a:r>
+          </a:p>
+        </p:txBody>
+      </p:sp>
+      <p:sp>
+        <p:nvSpPr>
+          <p:cNvPr id="21" name="Rounded Rectangle 20"/>
+          <p:cNvSpPr/>
+          <p:nvPr/>
+        </p:nvSpPr>
+        <p:spPr>
+          <a:xfrm>
+            <a:off x="6172200" y="3931920"/>
+            <a:ext cx="5257800" cy="2057400"/>
+          </a:xfrm>
+          <a:prstGeom prst="roundRect">
+            <a:avLst/>
+          </a:prstGeom>
+          <a:solidFill>
+            <a:srgbClr val="FFFFFF"/>
+          </a:solidFill>
+          <a:ln w="12700">
+            <a:solidFill>
+              <a:srgbClr val="E2E8F0"/>
+            </a:solidFill>
+          </a:ln>
+        </p:spPr>
+        <p:style>
+          <a:lnRef idx="1">
+            <a:schemeClr val="accent1"/>
+          </a:lnRef>
+          <a:fillRef idx="3">
+            <a:schemeClr val="accent1"/>
+          </a:fillRef>
+          <a:effectRef idx="2">
+            <a:schemeClr val="accent1"/>
+          </a:effectRef>
+          <a:fontRef idx="minor">
+            <a:schemeClr val="lt1"/>
+          </a:fontRef>
+        </p:style>
+        <p:txBody>
+          <a:bodyPr rtlCol="0" anchor="ctr"/>
+          <a:lstStyle/>
+          <a:p>
+            <a:pPr algn="ctr"/>
+          </a:p>
+        </p:txBody>
+      </p:sp>
+      <p:sp>
+        <p:nvSpPr>
+          <p:cNvPr id="22" name="Rectangle 21"/>
+          <p:cNvSpPr/>
+          <p:nvPr/>
+        </p:nvSpPr>
+        <p:spPr>
+          <a:xfrm>
+            <a:off x="6172200" y="3931920"/>
+            <a:ext cx="5257800" cy="73152"/>
+          </a:xfrm>
+          <a:prstGeom prst="rect">
+            <a:avLst/>
+          </a:prstGeom>
+          <a:solidFill>
+            <a:srgbClr val="FF6B00"/>
+          </a:solidFill>
+          <a:ln>
+            <a:noFill/>
+          </a:ln>
+        </p:spPr>
+        <p:style>
+          <a:lnRef idx="1">
+            <a:schemeClr val="accent1"/>
+          </a:lnRef>
+          <a:fillRef idx="3">
+            <a:schemeClr val="accent1"/>
+          </a:fillRef>
+          <a:effectRef idx="2">
+            <a:schemeClr val="accent1"/>
+          </a:effectRef>
+          <a:fontRef idx="minor">
+            <a:schemeClr val="lt1"/>
+          </a:fontRef>
+        </p:style>
+        <p:txBody>
+          <a:bodyPr rtlCol="0" anchor="ctr"/>
+          <a:lstStyle/>
+          <a:p>
+            <a:pPr algn="ctr"/>
+          </a:p>
+        </p:txBody>
+      </p:sp>
+      <p:pic>
+        <p:nvPicPr>
+          <p:cNvPr id="23" name="Picture 22" descr="icon-chart.png"/>
+          <p:cNvPicPr>
+            <a:picLocks noChangeAspect="1"/>
+          </p:cNvPicPr>
+          <p:nvPr/>
+        </p:nvPicPr>
+        <p:blipFill>
+          <a:blip r:embed="rId6"/>
+          <a:stretch>
+            <a:fillRect/>
+          </a:stretch>
+        </p:blipFill>
+        <p:spPr>
+          <a:xfrm>
+            <a:off x="10607040" y="4160520"/>
+            <a:ext cx="594360" cy="594360"/>
+          </a:xfrm>
+          <a:prstGeom prst="rect">
+            <a:avLst/>
+          </a:prstGeom>
+        </p:spPr>
+      </p:pic>
+      <p:sp>
+        <p:nvSpPr>
+          <p:cNvPr id="24" name="TextBox 23"/>
+          <p:cNvSpPr txBox="1"/>
+          <p:nvPr/>
+        </p:nvSpPr>
+        <p:spPr>
+          <a:xfrm>
+            <a:off x="6446520" y="4160520"/>
+            <a:ext cx="4069080" cy="1600200"/>
+          </a:xfrm>
+          <a:prstGeom prst="rect">
+            <a:avLst/>
+          </a:prstGeom>
+          <a:noFill/>
+        </p:spPr>
+        <p:txBody>
+          <a:bodyPr wrap="square" lIns="0" tIns="0">
+            <a:spAutoFit/>
+          </a:bodyPr>
+          <a:lstStyle/>
+          <a:p>
+            <a:pPr>
+              <a:defRPr sz="1300" b="1">
+                <a:solidFill>
+                  <a:srgbClr val="D95500"/>
+                </a:solidFill>
+                <a:latin typeface="Arial Black"/>
+              </a:defRPr>
+            </a:pPr>
+            <a:r>
               <a:t>DE AMBITIE</a:t>
             </a:r>
           </a:p>
@@ -5819,9 +6097,9 @@
               <a:spcBef>
                 <a:spcPts val="800"/>
               </a:spcBef>
-              <a:defRPr sz="1100">
-                <a:solidFill>
-                  <a:srgbClr val="D2D2D7"/>
+              <a:defRPr sz="1050">
+                <a:solidFill>
+                  <a:srgbClr val="475569"/>
                 </a:solidFill>
                 <a:latin typeface="Arial"/>
               </a:defRPr>
@@ -5865,7 +6143,7 @@
             <a:avLst/>
           </a:prstGeom>
           <a:solidFill>
-            <a:srgbClr val="101014"/>
+            <a:srgbClr val="F8FAFC"/>
           </a:solidFill>
           <a:ln>
             <a:noFill/>
@@ -5985,7 +6263,7 @@
             <a:pPr>
               <a:defRPr sz="950" b="1">
                 <a:solidFill>
-                  <a:srgbClr val="FF6B00"/>
+                  <a:srgbClr val="D95500"/>
                 </a:solidFill>
                 <a:latin typeface="Arial Black"/>
               </a:defRPr>
@@ -6021,7 +6299,7 @@
             <a:pPr>
               <a:defRPr sz="2400" b="1">
                 <a:solidFill>
-                  <a:srgbClr val="FFFFFF"/>
+                  <a:srgbClr val="111827"/>
                 </a:solidFill>
                 <a:latin typeface="Arial Black"/>
               </a:defRPr>
@@ -6100,7 +6378,7 @@
             <a:pPr>
               <a:defRPr sz="850">
                 <a:solidFill>
-                  <a:srgbClr val="8C8C96"/>
+                  <a:srgbClr val="94A3B8"/>
                 </a:solidFill>
                 <a:latin typeface="Arial"/>
               </a:defRPr>
@@ -6126,11 +6404,11 @@
             <a:avLst/>
           </a:prstGeom>
           <a:solidFill>
-            <a:srgbClr val="1A1616"/>
+            <a:srgbClr val="FFFAFA"/>
           </a:solidFill>
           <a:ln w="12700">
             <a:solidFill>
-              <a:srgbClr val="502828"/>
+              <a:srgbClr val="FECACA"/>
             </a:solidFill>
           </a:ln>
         </p:spPr>
@@ -6171,7 +6449,7 @@
             <a:avLst/>
           </a:prstGeom>
           <a:solidFill>
-            <a:srgbClr val="DC3C3C"/>
+            <a:srgbClr val="DC2626"/>
           </a:solidFill>
           <a:ln>
             <a:noFill/>
@@ -6199,9 +6477,33 @@
           </a:p>
         </p:txBody>
       </p:sp>
-      <p:sp>
-        <p:nvSpPr>
-          <p:cNvPr id="11" name="TextBox 10"/>
+      <p:pic>
+        <p:nvPicPr>
+          <p:cNvPr id="11" name="Picture 10" descr="icon-shield.png"/>
+          <p:cNvPicPr>
+            <a:picLocks noChangeAspect="1"/>
+          </p:cNvPicPr>
+          <p:nvPr/>
+        </p:nvPicPr>
+        <p:blipFill>
+          <a:blip r:embed="rId3"/>
+          <a:stretch>
+            <a:fillRect/>
+          </a:stretch>
+        </p:blipFill>
+        <p:spPr>
+          <a:xfrm>
+            <a:off x="5303520" y="1783080"/>
+            <a:ext cx="548640" cy="548640"/>
+          </a:xfrm>
+          <a:prstGeom prst="rect">
+            <a:avLst/>
+          </a:prstGeom>
+        </p:spPr>
+      </p:pic>
+      <p:sp>
+        <p:nvSpPr>
+          <p:cNvPr id="12" name="TextBox 11"/>
           <p:cNvSpPr txBox="1"/>
           <p:nvPr/>
         </p:nvSpPr>
@@ -6222,9 +6524,9 @@
           <a:lstStyle/>
           <a:p>
             <a:pPr>
-              <a:defRPr sz="1400">
-                <a:solidFill>
-                  <a:srgbClr val="FF5A5A"/>
+              <a:defRPr sz="1300">
+                <a:solidFill>
+                  <a:srgbClr val="B91C1C"/>
                 </a:solidFill>
                 <a:latin typeface="Arial Black"/>
               </a:defRPr>
@@ -6236,17 +6538,17 @@
           <a:p>
             <a:pPr>
               <a:spcBef>
-                <a:spcPts val="1000"/>
-              </a:spcBef>
-              <a:defRPr sz="1100">
-                <a:solidFill>
-                  <a:srgbClr val="FFFFFF"/>
+                <a:spcPts val="800"/>
+              </a:spcBef>
+              <a:defRPr sz="1050">
+                <a:solidFill>
+                  <a:srgbClr val="1E293B"/>
                 </a:solidFill>
                 <a:latin typeface="Arial Black"/>
               </a:defRPr>
             </a:pPr>
             <a:r>
-              <a:t>• Schermmoeheid &amp; Zitgedrag</a:t>
+              <a:t>✕  Schermmoeheid &amp; Zitgedrag</a:t>
             </a:r>
           </a:p>
           <a:p>
@@ -6254,9 +6556,9 @@
               <a:spcBef>
                 <a:spcPts val="200"/>
               </a:spcBef>
-              <a:defRPr sz="1000">
-                <a:solidFill>
-                  <a:srgbClr val="8C8C96"/>
+              <a:defRPr sz="950">
+                <a:solidFill>
+                  <a:srgbClr val="475569"/>
                 </a:solidFill>
                 <a:latin typeface="Arial"/>
               </a:defRPr>
@@ -6268,17 +6570,17 @@
           <a:p>
             <a:pPr>
               <a:spcBef>
-                <a:spcPts val="1000"/>
-              </a:spcBef>
-              <a:defRPr sz="1100">
-                <a:solidFill>
-                  <a:srgbClr val="FFFFFF"/>
+                <a:spcPts val="800"/>
+              </a:spcBef>
+              <a:defRPr sz="1050">
+                <a:solidFill>
+                  <a:srgbClr val="1E293B"/>
                 </a:solidFill>
                 <a:latin typeface="Arial Black"/>
               </a:defRPr>
             </a:pPr>
             <a:r>
-              <a:t>• Vervreemding door Hybride Werken</a:t>
+              <a:t>✕  Vervreemding door Hybride Werken</a:t>
             </a:r>
           </a:p>
           <a:p>
@@ -6286,9 +6588,9 @@
               <a:spcBef>
                 <a:spcPts val="200"/>
               </a:spcBef>
-              <a:defRPr sz="1000">
-                <a:solidFill>
-                  <a:srgbClr val="8C8C96"/>
+              <a:defRPr sz="950">
+                <a:solidFill>
+                  <a:srgbClr val="475569"/>
                 </a:solidFill>
                 <a:latin typeface="Arial"/>
               </a:defRPr>
@@ -6300,17 +6602,17 @@
           <a:p>
             <a:pPr>
               <a:spcBef>
-                <a:spcPts val="1000"/>
-              </a:spcBef>
-              <a:defRPr sz="1100">
-                <a:solidFill>
-                  <a:srgbClr val="FFFFFF"/>
+                <a:spcPts val="800"/>
+              </a:spcBef>
+              <a:defRPr sz="1050">
+                <a:solidFill>
+                  <a:srgbClr val="1E293B"/>
                 </a:solidFill>
                 <a:latin typeface="Arial Black"/>
               </a:defRPr>
             </a:pPr>
             <a:r>
-              <a:t>• Saaie &amp; Passieve Bedrijfsuitjes</a:t>
+              <a:t>✕  Saaie &amp; Passieve Bedrijfsuitjes</a:t>
             </a:r>
           </a:p>
           <a:p>
@@ -6318,9 +6620,9 @@
               <a:spcBef>
                 <a:spcPts val="200"/>
               </a:spcBef>
-              <a:defRPr sz="1000">
-                <a:solidFill>
-                  <a:srgbClr val="8C8C96"/>
+              <a:defRPr sz="950">
+                <a:solidFill>
+                  <a:srgbClr val="475569"/>
                 </a:solidFill>
                 <a:latin typeface="Arial"/>
               </a:defRPr>
@@ -6332,17 +6634,17 @@
           <a:p>
             <a:pPr>
               <a:spcBef>
-                <a:spcPts val="1000"/>
-              </a:spcBef>
-              <a:defRPr sz="1100">
-                <a:solidFill>
-                  <a:srgbClr val="FFFFFF"/>
+                <a:spcPts val="800"/>
+              </a:spcBef>
+              <a:defRPr sz="1050">
+                <a:solidFill>
+                  <a:srgbClr val="1E293B"/>
                 </a:solidFill>
                 <a:latin typeface="Arial Black"/>
               </a:defRPr>
             </a:pPr>
             <a:r>
-              <a:t>• Hoge Drempels bij Sportuitjes</a:t>
+              <a:t>✕  Hoge Drempels bij Sportuitjes</a:t>
             </a:r>
           </a:p>
           <a:p>
@@ -6350,9 +6652,9 @@
               <a:spcBef>
                 <a:spcPts val="200"/>
               </a:spcBef>
-              <a:defRPr sz="1000">
-                <a:solidFill>
-                  <a:srgbClr val="8C8C96"/>
+              <a:defRPr sz="950">
+                <a:solidFill>
+                  <a:srgbClr val="475569"/>
                 </a:solidFill>
                 <a:latin typeface="Arial"/>
               </a:defRPr>
@@ -6365,7 +6667,7 @@
       </p:sp>
       <p:sp>
         <p:nvSpPr>
-          <p:cNvPr id="12" name="Rounded Rectangle 11"/>
+          <p:cNvPr id="13" name="Rounded Rectangle 12"/>
           <p:cNvSpPr/>
           <p:nvPr/>
         </p:nvSpPr>
@@ -6378,11 +6680,11 @@
             <a:avLst/>
           </a:prstGeom>
           <a:solidFill>
-            <a:srgbClr val="161C18"/>
+            <a:srgbClr val="FFF8F2"/>
           </a:solidFill>
           <a:ln w="12700">
             <a:solidFill>
-              <a:srgbClr val="285032"/>
+              <a:srgbClr val="FF6B00"/>
             </a:solidFill>
           </a:ln>
         </p:spPr>
@@ -6410,7 +6712,7 @@
       </p:sp>
       <p:sp>
         <p:nvSpPr>
-          <p:cNvPr id="13" name="Rectangle 12"/>
+          <p:cNvPr id="14" name="Rectangle 13"/>
           <p:cNvSpPr/>
           <p:nvPr/>
         </p:nvSpPr>
@@ -6451,9 +6753,33 @@
           </a:p>
         </p:txBody>
       </p:sp>
-      <p:sp>
-        <p:nvSpPr>
-          <p:cNvPr id="14" name="TextBox 13"/>
+      <p:pic>
+        <p:nvPicPr>
+          <p:cNvPr id="15" name="Picture 14" descr="icon-trophy.png"/>
+          <p:cNvPicPr>
+            <a:picLocks noChangeAspect="1"/>
+          </p:cNvPicPr>
+          <p:nvPr/>
+        </p:nvPicPr>
+        <p:blipFill>
+          <a:blip r:embed="rId4"/>
+          <a:stretch>
+            <a:fillRect/>
+          </a:stretch>
+        </p:blipFill>
+        <p:spPr>
+          <a:xfrm>
+            <a:off x="10744200" y="1783080"/>
+            <a:ext cx="548640" cy="548640"/>
+          </a:xfrm>
+          <a:prstGeom prst="rect">
+            <a:avLst/>
+          </a:prstGeom>
+        </p:spPr>
+      </p:pic>
+      <p:sp>
+        <p:nvSpPr>
+          <p:cNvPr id="16" name="TextBox 15"/>
           <p:cNvSpPr txBox="1"/>
           <p:nvPr/>
         </p:nvSpPr>
@@ -6474,9 +6800,9 @@
           <a:lstStyle/>
           <a:p>
             <a:pPr>
-              <a:defRPr sz="1400">
-                <a:solidFill>
-                  <a:srgbClr val="FF9A4D"/>
+              <a:defRPr sz="1300">
+                <a:solidFill>
+                  <a:srgbClr val="D95500"/>
                 </a:solidFill>
                 <a:latin typeface="Arial Black"/>
               </a:defRPr>
@@ -6488,17 +6814,17 @@
           <a:p>
             <a:pPr>
               <a:spcBef>
-                <a:spcPts val="1000"/>
-              </a:spcBef>
-              <a:defRPr sz="1100">
-                <a:solidFill>
-                  <a:srgbClr val="FFFFFF"/>
+                <a:spcPts val="800"/>
+              </a:spcBef>
+              <a:defRPr sz="1050">
+                <a:solidFill>
+                  <a:srgbClr val="1E293B"/>
                 </a:solidFill>
                 <a:latin typeface="Arial Black"/>
               </a:defRPr>
             </a:pPr>
             <a:r>
-              <a:t>✓ Groeiend Vitaliteitsbudget (WKR)</a:t>
+              <a:t>✓  Groeiend Vitaliteitsbudget (WKR)</a:t>
             </a:r>
           </a:p>
           <a:p>
@@ -6506,9 +6832,9 @@
               <a:spcBef>
                 <a:spcPts val="200"/>
               </a:spcBef>
-              <a:defRPr sz="1000">
-                <a:solidFill>
-                  <a:srgbClr val="8C8C96"/>
+              <a:defRPr sz="950">
+                <a:solidFill>
+                  <a:srgbClr val="475569"/>
                 </a:solidFill>
                 <a:latin typeface="Arial"/>
               </a:defRPr>
@@ -6520,17 +6846,17 @@
           <a:p>
             <a:pPr>
               <a:spcBef>
-                <a:spcPts val="1000"/>
-              </a:spcBef>
-              <a:defRPr sz="1100">
-                <a:solidFill>
-                  <a:srgbClr val="FFFFFF"/>
+                <a:spcPts val="800"/>
+              </a:spcBef>
+              <a:defRPr sz="1050">
+                <a:solidFill>
+                  <a:srgbClr val="1E293B"/>
                 </a:solidFill>
                 <a:latin typeface="Arial Black"/>
               </a:defRPr>
             </a:pPr>
             <a:r>
-              <a:t>✓ De Tafeltennis Herwaardering</a:t>
+              <a:t>✓  De Tafeltennis Herwaardering</a:t>
             </a:r>
           </a:p>
           <a:p>
@@ -6538,9 +6864,9 @@
               <a:spcBef>
                 <a:spcPts val="200"/>
               </a:spcBef>
-              <a:defRPr sz="1000">
-                <a:solidFill>
-                  <a:srgbClr val="8C8C96"/>
+              <a:defRPr sz="950">
+                <a:solidFill>
+                  <a:srgbClr val="475569"/>
                 </a:solidFill>
                 <a:latin typeface="Arial"/>
               </a:defRPr>
@@ -6552,17 +6878,17 @@
           <a:p>
             <a:pPr>
               <a:spcBef>
-                <a:spcPts val="1000"/>
-              </a:spcBef>
-              <a:defRPr sz="1100">
-                <a:solidFill>
-                  <a:srgbClr val="FFFFFF"/>
+                <a:spcPts val="800"/>
+              </a:spcBef>
+              <a:defRPr sz="1050">
+                <a:solidFill>
+                  <a:srgbClr val="1E293B"/>
                 </a:solidFill>
                 <a:latin typeface="Arial Black"/>
               </a:defRPr>
             </a:pPr>
             <a:r>
-              <a:t>✓ Schaken op Topsnelheid</a:t>
+              <a:t>✓  Schaken op Topsnelheid</a:t>
             </a:r>
           </a:p>
           <a:p>
@@ -6570,9 +6896,9 @@
               <a:spcBef>
                 <a:spcPts val="200"/>
               </a:spcBef>
-              <a:defRPr sz="1000">
-                <a:solidFill>
-                  <a:srgbClr val="8C8C96"/>
+              <a:defRPr sz="950">
+                <a:solidFill>
+                  <a:srgbClr val="475569"/>
                 </a:solidFill>
                 <a:latin typeface="Arial"/>
               </a:defRPr>
@@ -6584,17 +6910,17 @@
           <a:p>
             <a:pPr>
               <a:spcBef>
-                <a:spcPts val="1000"/>
-              </a:spcBef>
-              <a:defRPr sz="1100">
-                <a:solidFill>
-                  <a:srgbClr val="FFFFFF"/>
+                <a:spcPts val="800"/>
+              </a:spcBef>
+              <a:defRPr sz="1050">
+                <a:solidFill>
+                  <a:srgbClr val="1E293B"/>
                 </a:solidFill>
                 <a:latin typeface="Arial Black"/>
               </a:defRPr>
             </a:pPr>
             <a:r>
-              <a:t>✓ Flexibel &amp; Schaalbaar Model</a:t>
+              <a:t>✓  Flexibel &amp; Schaalbaar Model</a:t>
             </a:r>
           </a:p>
           <a:p>
@@ -6602,9 +6928,9 @@
               <a:spcBef>
                 <a:spcPts val="200"/>
               </a:spcBef>
-              <a:defRPr sz="1000">
-                <a:solidFill>
-                  <a:srgbClr val="8C8C96"/>
+              <a:defRPr sz="950">
+                <a:solidFill>
+                  <a:srgbClr val="475569"/>
                 </a:solidFill>
                 <a:latin typeface="Arial"/>
               </a:defRPr>
@@ -6648,7 +6974,7 @@
             <a:avLst/>
           </a:prstGeom>
           <a:solidFill>
-            <a:srgbClr val="101014"/>
+            <a:srgbClr val="F8FAFC"/>
           </a:solidFill>
           <a:ln>
             <a:noFill/>
@@ -6768,7 +7094,7 @@
             <a:pPr>
               <a:defRPr sz="950" b="1">
                 <a:solidFill>
-                  <a:srgbClr val="FF6B00"/>
+                  <a:srgbClr val="D95500"/>
                 </a:solidFill>
                 <a:latin typeface="Arial Black"/>
               </a:defRPr>
@@ -6804,7 +7130,7 @@
             <a:pPr>
               <a:defRPr sz="2400" b="1">
                 <a:solidFill>
-                  <a:srgbClr val="FFFFFF"/>
+                  <a:srgbClr val="111827"/>
                 </a:solidFill>
                 <a:latin typeface="Arial Black"/>
               </a:defRPr>
@@ -6883,7 +7209,7 @@
             <a:pPr>
               <a:defRPr sz="850">
                 <a:solidFill>
-                  <a:srgbClr val="8C8C96"/>
+                  <a:srgbClr val="94A3B8"/>
                 </a:solidFill>
                 <a:latin typeface="Arial"/>
               </a:defRPr>
@@ -6909,11 +7235,11 @@
             <a:avLst/>
           </a:prstGeom>
           <a:solidFill>
-            <a:srgbClr val="1C1C22"/>
+            <a:srgbClr val="FFFFFF"/>
           </a:solidFill>
           <a:ln w="12700">
             <a:solidFill>
-              <a:srgbClr val="32323C"/>
+              <a:srgbClr val="E2E8F0"/>
             </a:solidFill>
           </a:ln>
         </p:spPr>
@@ -6939,9 +7265,33 @@
           </a:p>
         </p:txBody>
       </p:sp>
-      <p:sp>
-        <p:nvSpPr>
-          <p:cNvPr id="10" name="TextBox 9"/>
+      <p:pic>
+        <p:nvPicPr>
+          <p:cNvPr id="10" name="Picture 9" descr="icon-location.png"/>
+          <p:cNvPicPr>
+            <a:picLocks noChangeAspect="1"/>
+          </p:cNvPicPr>
+          <p:nvPr/>
+        </p:nvPicPr>
+        <p:blipFill>
+          <a:blip r:embed="rId3"/>
+          <a:stretch>
+            <a:fillRect/>
+          </a:stretch>
+        </p:blipFill>
+        <p:spPr>
+          <a:xfrm>
+            <a:off x="3319272" y="1828800"/>
+            <a:ext cx="685800" cy="685800"/>
+          </a:xfrm>
+          <a:prstGeom prst="rect">
+            <a:avLst/>
+          </a:prstGeom>
+        </p:spPr>
+      </p:pic>
+      <p:sp>
+        <p:nvSpPr>
+          <p:cNvPr id="11" name="TextBox 10"/>
           <p:cNvSpPr txBox="1"/>
           <p:nvPr/>
         </p:nvSpPr>
@@ -6962,9 +7312,9 @@
           <a:lstStyle/>
           <a:p>
             <a:pPr>
-              <a:defRPr sz="1300" b="1">
-                <a:solidFill>
-                  <a:srgbClr val="FFFFFF"/>
+              <a:defRPr sz="1150" b="1">
+                <a:solidFill>
+                  <a:srgbClr val="1E293B"/>
                 </a:solidFill>
                 <a:latin typeface="Arial Black"/>
               </a:defRPr>
@@ -6980,7 +7330,7 @@
               </a:spcBef>
               <a:defRPr sz="2600" b="1">
                 <a:solidFill>
-                  <a:srgbClr val="FFFFFF"/>
+                  <a:srgbClr val="111827"/>
                 </a:solidFill>
                 <a:latin typeface="Arial Black"/>
               </a:defRPr>
@@ -6996,7 +7346,7 @@
               </a:spcBef>
               <a:defRPr sz="950">
                 <a:solidFill>
-                  <a:srgbClr val="8C8C96"/>
+                  <a:srgbClr val="94A3B8"/>
                 </a:solidFill>
                 <a:latin typeface="Arial"/>
               </a:defRPr>
@@ -7012,12 +7362,12 @@
               </a:spcBef>
               <a:defRPr sz="800">
                 <a:solidFill>
-                  <a:srgbClr val="32323C"/>
-                </a:solidFill>
-              </a:defRPr>
-            </a:pPr>
-            <a:r>
-              <a:t>——————————————————</a:t>
+                  <a:srgbClr val="CBD5E1"/>
+                </a:solidFill>
+              </a:defRPr>
+            </a:pPr>
+            <a:r>
+              <a:t>——————————————————————</a:t>
             </a:r>
           </a:p>
           <a:p>
@@ -7027,13 +7377,13 @@
               </a:spcBef>
               <a:defRPr sz="950">
                 <a:solidFill>
-                  <a:srgbClr val="D2D2D7"/>
-                </a:solidFill>
-                <a:latin typeface="Arial"/>
-              </a:defRPr>
-            </a:pPr>
-            <a:r>
-              <a:t>• Masterclass basistechniek &amp; effectspin</a:t>
+                  <a:srgbClr val="475569"/>
+                </a:solidFill>
+                <a:latin typeface="Arial"/>
+              </a:defRPr>
+            </a:pPr>
+            <a:r>
+              <a:t>✓ Masterclass basistechniek &amp; effectspin</a:t>
             </a:r>
           </a:p>
           <a:p>
@@ -7043,13 +7393,13 @@
               </a:spcBef>
               <a:defRPr sz="950">
                 <a:solidFill>
-                  <a:srgbClr val="D2D2D7"/>
-                </a:solidFill>
-                <a:latin typeface="Arial"/>
-              </a:defRPr>
-            </a:pPr>
-            <a:r>
-              <a:t>• King of the Court toernooitje</a:t>
+                  <a:srgbClr val="475569"/>
+                </a:solidFill>
+                <a:latin typeface="Arial"/>
+              </a:defRPr>
+            </a:pPr>
+            <a:r>
+              <a:t>✓ King of the Court toernooitje</a:t>
             </a:r>
           </a:p>
           <a:p>
@@ -7059,13 +7409,13 @@
               </a:spcBef>
               <a:defRPr sz="950">
                 <a:solidFill>
-                  <a:srgbClr val="D2D2D7"/>
-                </a:solidFill>
-                <a:latin typeface="Arial"/>
-              </a:defRPr>
-            </a:pPr>
-            <a:r>
-              <a:t>• Professionele batjes &amp; ballen inbegrepen</a:t>
+                  <a:srgbClr val="475569"/>
+                </a:solidFill>
+                <a:latin typeface="Arial"/>
+              </a:defRPr>
+            </a:pPr>
+            <a:r>
+              <a:t>✓ Professionele batjes &amp; ballen inbegrepen</a:t>
             </a:r>
           </a:p>
           <a:p>
@@ -7075,13 +7425,13 @@
               </a:spcBef>
               <a:defRPr sz="950">
                 <a:solidFill>
-                  <a:srgbClr val="D2D2D7"/>
-                </a:solidFill>
-                <a:latin typeface="Arial"/>
-              </a:defRPr>
-            </a:pPr>
-            <a:r>
-              <a:t>• Op eigen kantoor of sportlocatie</a:t>
+                  <a:srgbClr val="475569"/>
+                </a:solidFill>
+                <a:latin typeface="Arial"/>
+              </a:defRPr>
+            </a:pPr>
+            <a:r>
+              <a:t>✓ Op eigen kantoor of sportlocatie</a:t>
             </a:r>
           </a:p>
           <a:p>
@@ -7091,20 +7441,20 @@
               </a:spcBef>
               <a:defRPr sz="950">
                 <a:solidFill>
-                  <a:srgbClr val="D2D2D7"/>
-                </a:solidFill>
-                <a:latin typeface="Arial"/>
-              </a:defRPr>
-            </a:pPr>
-            <a:r>
-              <a:t>• Ideaal voor afdelingen &amp; kleine teams</a:t>
-            </a:r>
-          </a:p>
-        </p:txBody>
-      </p:sp>
-      <p:sp>
-        <p:nvSpPr>
-          <p:cNvPr id="11" name="Rounded Rectangle 10"/>
+                  <a:srgbClr val="475569"/>
+                </a:solidFill>
+                <a:latin typeface="Arial"/>
+              </a:defRPr>
+            </a:pPr>
+            <a:r>
+              <a:t>✓ Ideaal voor afdelingen &amp; kleine teams</a:t>
+            </a:r>
+          </a:p>
+        </p:txBody>
+      </p:sp>
+      <p:sp>
+        <p:nvSpPr>
+          <p:cNvPr id="12" name="Rounded Rectangle 11"/>
           <p:cNvSpPr/>
           <p:nvPr/>
         </p:nvSpPr>
@@ -7117,7 +7467,7 @@
             <a:avLst/>
           </a:prstGeom>
           <a:solidFill>
-            <a:srgbClr val="261E18"/>
+            <a:srgbClr val="FFF8F2"/>
           </a:solidFill>
           <a:ln w="12700">
             <a:solidFill>
@@ -7149,7 +7499,7 @@
       </p:sp>
       <p:sp>
         <p:nvSpPr>
-          <p:cNvPr id="12" name="Rectangle 11"/>
+          <p:cNvPr id="13" name="Rectangle 12"/>
           <p:cNvSpPr/>
           <p:nvPr/>
         </p:nvSpPr>
@@ -7190,9 +7540,33 @@
           </a:p>
         </p:txBody>
       </p:sp>
-      <p:sp>
-        <p:nvSpPr>
-          <p:cNvPr id="13" name="TextBox 12"/>
+      <p:pic>
+        <p:nvPicPr>
+          <p:cNvPr id="14" name="Picture 13" descr="icon-trophy.png"/>
+          <p:cNvPicPr>
+            <a:picLocks noChangeAspect="1"/>
+          </p:cNvPicPr>
+          <p:nvPr/>
+        </p:nvPicPr>
+        <p:blipFill>
+          <a:blip r:embed="rId4"/>
+          <a:stretch>
+            <a:fillRect/>
+          </a:stretch>
+        </p:blipFill>
+        <p:spPr>
+          <a:xfrm>
+            <a:off x="6958584" y="1828800"/>
+            <a:ext cx="685800" cy="685800"/>
+          </a:xfrm>
+          <a:prstGeom prst="rect">
+            <a:avLst/>
+          </a:prstGeom>
+        </p:spPr>
+      </p:pic>
+      <p:sp>
+        <p:nvSpPr>
+          <p:cNvPr id="15" name="TextBox 14"/>
           <p:cNvSpPr txBox="1"/>
           <p:nvPr/>
         </p:nvSpPr>
@@ -7213,7 +7587,23 @@
           <a:lstStyle/>
           <a:p>
             <a:pPr>
-              <a:defRPr sz="1300" b="1">
+              <a:defRPr sz="1150" b="1">
+                <a:solidFill>
+                  <a:srgbClr val="D95500"/>
+                </a:solidFill>
+                <a:latin typeface="Arial Black"/>
+              </a:defRPr>
+            </a:pPr>
+            <a:r>
+              <a:t>COMPANY BATTLE (FLAGSHIP)</a:t>
+            </a:r>
+          </a:p>
+          <a:p>
+            <a:pPr>
+              <a:spcBef>
+                <a:spcPts val="400"/>
+              </a:spcBef>
+              <a:defRPr sz="2600" b="1">
                 <a:solidFill>
                   <a:srgbClr val="FF6B00"/>
                 </a:solidFill>
@@ -7221,22 +7611,6 @@
               </a:defRPr>
             </a:pPr>
             <a:r>
-              <a:t>COMPANY BATTLE (FLAGSHIP)</a:t>
-            </a:r>
-          </a:p>
-          <a:p>
-            <a:pPr>
-              <a:spcBef>
-                <a:spcPts val="400"/>
-              </a:spcBef>
-              <a:defRPr sz="2600" b="1">
-                <a:solidFill>
-                  <a:srgbClr val="FFFFFF"/>
-                </a:solidFill>
-                <a:latin typeface="Arial Black"/>
-              </a:defRPr>
-            </a:pPr>
-            <a:r>
               <a:t>€745</a:t>
             </a:r>
           </a:p>
@@ -7247,7 +7621,7 @@
               </a:spcBef>
               <a:defRPr sz="950">
                 <a:solidFill>
-                  <a:srgbClr val="8C8C96"/>
+                  <a:srgbClr val="94A3B8"/>
                 </a:solidFill>
                 <a:latin typeface="Arial"/>
               </a:defRPr>
@@ -7263,12 +7637,12 @@
               </a:spcBef>
               <a:defRPr sz="800">
                 <a:solidFill>
-                  <a:srgbClr val="32323C"/>
-                </a:solidFill>
-              </a:defRPr>
-            </a:pPr>
-            <a:r>
-              <a:t>——————————————————</a:t>
+                  <a:srgbClr val="CBD5E1"/>
+                </a:solidFill>
+              </a:defRPr>
+            </a:pPr>
+            <a:r>
+              <a:t>——————————————————————</a:t>
             </a:r>
           </a:p>
           <a:p>
@@ -7278,13 +7652,13 @@
               </a:spcBef>
               <a:defRPr sz="950">
                 <a:solidFill>
-                  <a:srgbClr val="D2D2D7"/>
-                </a:solidFill>
-                <a:latin typeface="Arial"/>
-              </a:defRPr>
-            </a:pPr>
-            <a:r>
-              <a:t>• Complete clinic + trickshots van Edward</a:t>
+                  <a:srgbClr val="475569"/>
+                </a:solidFill>
+                <a:latin typeface="Arial"/>
+              </a:defRPr>
+            </a:pPr>
+            <a:r>
+              <a:t>✓ Complete clinic + trickshots van Edward</a:t>
             </a:r>
           </a:p>
           <a:p>
@@ -7294,13 +7668,13 @@
               </a:spcBef>
               <a:defRPr sz="950">
                 <a:solidFill>
-                  <a:srgbClr val="D2D2D7"/>
-                </a:solidFill>
-                <a:latin typeface="Arial"/>
-              </a:defRPr>
-            </a:pPr>
-            <a:r>
-              <a:t>• Volledig verzorgd bedrijfscompetitie toernooi</a:t>
+                  <a:srgbClr val="475569"/>
+                </a:solidFill>
+                <a:latin typeface="Arial"/>
+              </a:defRPr>
+            </a:pPr>
+            <a:r>
+              <a:t>✓ Volledig verzorgd bedrijfscompetitie toernooi</a:t>
             </a:r>
           </a:p>
           <a:p>
@@ -7310,13 +7684,13 @@
               </a:spcBef>
               <a:defRPr sz="950">
                 <a:solidFill>
-                  <a:srgbClr val="D2D2D7"/>
-                </a:solidFill>
-                <a:latin typeface="Arial"/>
-              </a:defRPr>
-            </a:pPr>
-            <a:r>
-              <a:t>• Officiële TT Clinics wisseltrofee &amp; medailles</a:t>
+                  <a:srgbClr val="475569"/>
+                </a:solidFill>
+                <a:latin typeface="Arial"/>
+              </a:defRPr>
+            </a:pPr>
+            <a:r>
+              <a:t>✓ Officiële TT Clinics wisseltrofee &amp; medailles</a:t>
             </a:r>
           </a:p>
           <a:p>
@@ -7326,13 +7700,13 @@
               </a:spcBef>
               <a:defRPr sz="950">
                 <a:solidFill>
-                  <a:srgbClr val="D2D2D7"/>
-                </a:solidFill>
-                <a:latin typeface="Arial"/>
-              </a:defRPr>
-            </a:pPr>
-            <a:r>
-              <a:t>• Meest gekozen bedrijfsuitje &amp; kick-off</a:t>
+                  <a:srgbClr val="475569"/>
+                </a:solidFill>
+                <a:latin typeface="Arial"/>
+              </a:defRPr>
+            </a:pPr>
+            <a:r>
+              <a:t>✓ Meest gekozen bedrijfsuitje &amp; kick-off</a:t>
             </a:r>
           </a:p>
           <a:p>
@@ -7342,20 +7716,20 @@
               </a:spcBef>
               <a:defRPr sz="950">
                 <a:solidFill>
-                  <a:srgbClr val="D2D2D7"/>
-                </a:solidFill>
-                <a:latin typeface="Arial"/>
-              </a:defRPr>
-            </a:pPr>
-            <a:r>
-              <a:t>• Optioneel: borrel &amp; bittergarnituur arrangement</a:t>
-            </a:r>
-          </a:p>
-        </p:txBody>
-      </p:sp>
-      <p:sp>
-        <p:nvSpPr>
-          <p:cNvPr id="14" name="Rounded Rectangle 13"/>
+                  <a:srgbClr val="475569"/>
+                </a:solidFill>
+                <a:latin typeface="Arial"/>
+              </a:defRPr>
+            </a:pPr>
+            <a:r>
+              <a:t>✓ Optioneel: borrel &amp; bittergarnituur arrangement</a:t>
+            </a:r>
+          </a:p>
+        </p:txBody>
+      </p:sp>
+      <p:sp>
+        <p:nvSpPr>
+          <p:cNvPr id="16" name="Rounded Rectangle 15"/>
           <p:cNvSpPr/>
           <p:nvPr/>
         </p:nvSpPr>
@@ -7368,11 +7742,11 @@
             <a:avLst/>
           </a:prstGeom>
           <a:solidFill>
-            <a:srgbClr val="1C1C22"/>
+            <a:srgbClr val="FFFFFF"/>
           </a:solidFill>
           <a:ln w="12700">
             <a:solidFill>
-              <a:srgbClr val="32323C"/>
+              <a:srgbClr val="E2E8F0"/>
             </a:solidFill>
           </a:ln>
         </p:spPr>
@@ -7398,9 +7772,33 @@
           </a:p>
         </p:txBody>
       </p:sp>
-      <p:sp>
-        <p:nvSpPr>
-          <p:cNvPr id="15" name="TextBox 14"/>
+      <p:pic>
+        <p:nvPicPr>
+          <p:cNvPr id="17" name="Picture 16" descr="icon-heartbeat.png"/>
+          <p:cNvPicPr>
+            <a:picLocks noChangeAspect="1"/>
+          </p:cNvPicPr>
+          <p:nvPr/>
+        </p:nvPicPr>
+        <p:blipFill>
+          <a:blip r:embed="rId5"/>
+          <a:stretch>
+            <a:fillRect/>
+          </a:stretch>
+        </p:blipFill>
+        <p:spPr>
+          <a:xfrm>
+            <a:off x="10597896" y="1828800"/>
+            <a:ext cx="685800" cy="685800"/>
+          </a:xfrm>
+          <a:prstGeom prst="rect">
+            <a:avLst/>
+          </a:prstGeom>
+        </p:spPr>
+      </p:pic>
+      <p:sp>
+        <p:nvSpPr>
+          <p:cNvPr id="18" name="TextBox 17"/>
           <p:cNvSpPr txBox="1"/>
           <p:nvPr/>
         </p:nvSpPr>
@@ -7421,9 +7819,9 @@
           <a:lstStyle/>
           <a:p>
             <a:pPr>
-              <a:defRPr sz="1300" b="1">
-                <a:solidFill>
-                  <a:srgbClr val="FFFFFF"/>
+              <a:defRPr sz="1150" b="1">
+                <a:solidFill>
+                  <a:srgbClr val="1E293B"/>
                 </a:solidFill>
                 <a:latin typeface="Arial Black"/>
               </a:defRPr>
@@ -7439,7 +7837,7 @@
               </a:spcBef>
               <a:defRPr sz="2600" b="1">
                 <a:solidFill>
-                  <a:srgbClr val="FFFFFF"/>
+                  <a:srgbClr val="111827"/>
                 </a:solidFill>
                 <a:latin typeface="Arial Black"/>
               </a:defRPr>
@@ -7455,7 +7853,7 @@
               </a:spcBef>
               <a:defRPr sz="950">
                 <a:solidFill>
-                  <a:srgbClr val="8C8C96"/>
+                  <a:srgbClr val="94A3B8"/>
                 </a:solidFill>
                 <a:latin typeface="Arial"/>
               </a:defRPr>
@@ -7471,12 +7869,12 @@
               </a:spcBef>
               <a:defRPr sz="800">
                 <a:solidFill>
-                  <a:srgbClr val="32323C"/>
-                </a:solidFill>
-              </a:defRPr>
-            </a:pPr>
-            <a:r>
-              <a:t>——————————————————</a:t>
+                  <a:srgbClr val="CBD5E1"/>
+                </a:solidFill>
+              </a:defRPr>
+            </a:pPr>
+            <a:r>
+              <a:t>——————————————————————</a:t>
             </a:r>
           </a:p>
           <a:p>
@@ -7486,13 +7884,13 @@
               </a:spcBef>
               <a:defRPr sz="950">
                 <a:solidFill>
-                  <a:srgbClr val="D2D2D7"/>
-                </a:solidFill>
-                <a:latin typeface="Arial"/>
-              </a:defRPr>
-            </a:pPr>
-            <a:r>
-              <a:t>• Gezondheids- en vitaliteitsweken op kantoor</a:t>
+                  <a:srgbClr val="475569"/>
+                </a:solidFill>
+                <a:latin typeface="Arial"/>
+              </a:defRPr>
+            </a:pPr>
+            <a:r>
+              <a:t>✓ Gezondheids- en vitaliteitsweken op kantoor</a:t>
             </a:r>
           </a:p>
           <a:p>
@@ -7502,13 +7900,13 @@
               </a:spcBef>
               <a:defRPr sz="950">
                 <a:solidFill>
-                  <a:srgbClr val="D2D2D7"/>
-                </a:solidFill>
-                <a:latin typeface="Arial"/>
-              </a:defRPr>
-            </a:pPr>
-            <a:r>
-              <a:t>• Meerdere trainers &amp; mobiele wedstrijdtafels</a:t>
+                  <a:srgbClr val="475569"/>
+                </a:solidFill>
+                <a:latin typeface="Arial"/>
+              </a:defRPr>
+            </a:pPr>
+            <a:r>
+              <a:t>✓ Meerdere trainers &amp; mobiele wedstrijdtafels</a:t>
             </a:r>
           </a:p>
           <a:p>
@@ -7518,13 +7916,13 @@
               </a:spcBef>
               <a:defRPr sz="950">
                 <a:solidFill>
-                  <a:srgbClr val="D2D2D7"/>
-                </a:solidFill>
-                <a:latin typeface="Arial"/>
-              </a:defRPr>
-            </a:pPr>
-            <a:r>
-              <a:t>• Bedrijfscompetitie opzet voor het hele jaar</a:t>
+                  <a:srgbClr val="475569"/>
+                </a:solidFill>
+                <a:latin typeface="Arial"/>
+              </a:defRPr>
+            </a:pPr>
+            <a:r>
+              <a:t>✓ Bedrijfscompetitie opzet voor het hele jaar</a:t>
             </a:r>
           </a:p>
           <a:p>
@@ -7534,13 +7932,13 @@
               </a:spcBef>
               <a:defRPr sz="950">
                 <a:solidFill>
-                  <a:srgbClr val="D2D2D7"/>
-                </a:solidFill>
-                <a:latin typeface="Arial"/>
-              </a:defRPr>
-            </a:pPr>
-            <a:r>
-              <a:t>• Volledig afgestemd op corporate programma</a:t>
+                  <a:srgbClr val="475569"/>
+                </a:solidFill>
+                <a:latin typeface="Arial"/>
+              </a:defRPr>
+            </a:pPr>
+            <a:r>
+              <a:t>✓ Volledig afgestemd op corporate programma</a:t>
             </a:r>
           </a:p>
           <a:p>
@@ -7550,13 +7948,13 @@
               </a:spcBef>
               <a:defRPr sz="950">
                 <a:solidFill>
-                  <a:srgbClr val="D2D2D7"/>
-                </a:solidFill>
-                <a:latin typeface="Arial"/>
-              </a:defRPr>
-            </a:pPr>
-            <a:r>
-              <a:t>• Grote organisaties &amp; evenementen</a:t>
+                  <a:srgbClr val="475569"/>
+                </a:solidFill>
+                <a:latin typeface="Arial"/>
+              </a:defRPr>
+            </a:pPr>
+            <a:r>
+              <a:t>✓ Grote organisaties &amp; evenementen</a:t>
             </a:r>
           </a:p>
         </p:txBody>
@@ -7594,7 +7992,7 @@
             <a:avLst/>
           </a:prstGeom>
           <a:solidFill>
-            <a:srgbClr val="101014"/>
+            <a:srgbClr val="F8FAFC"/>
           </a:solidFill>
           <a:ln>
             <a:noFill/>
@@ -7714,7 +8112,7 @@
             <a:pPr>
               <a:defRPr sz="950" b="1">
                 <a:solidFill>
-                  <a:srgbClr val="FF6B00"/>
+                  <a:srgbClr val="D95500"/>
                 </a:solidFill>
                 <a:latin typeface="Arial Black"/>
               </a:defRPr>
@@ -7750,7 +8148,7 @@
             <a:pPr>
               <a:defRPr sz="2400" b="1">
                 <a:solidFill>
-                  <a:srgbClr val="FFFFFF"/>
+                  <a:srgbClr val="111827"/>
                 </a:solidFill>
                 <a:latin typeface="Arial Black"/>
               </a:defRPr>
@@ -7829,7 +8227,7 @@
             <a:pPr>
               <a:defRPr sz="850">
                 <a:solidFill>
-                  <a:srgbClr val="8C8C96"/>
+                  <a:srgbClr val="94A3B8"/>
                 </a:solidFill>
                 <a:latin typeface="Arial"/>
               </a:defRPr>
@@ -7855,11 +8253,11 @@
             <a:avLst/>
           </a:prstGeom>
           <a:solidFill>
-            <a:srgbClr val="1C1C22"/>
+            <a:srgbClr val="FFFFFF"/>
           </a:solidFill>
           <a:ln w="12700">
             <a:solidFill>
-              <a:srgbClr val="32323C"/>
+              <a:srgbClr val="E2E8F0"/>
             </a:solidFill>
           </a:ln>
         </p:spPr>
@@ -7928,16 +8326,40 @@
           </a:p>
         </p:txBody>
       </p:sp>
-      <p:sp>
-        <p:nvSpPr>
-          <p:cNvPr id="11" name="TextBox 10"/>
+      <p:pic>
+        <p:nvPicPr>
+          <p:cNvPr id="11" name="Picture 10" descr="icon-location.png"/>
+          <p:cNvPicPr>
+            <a:picLocks noChangeAspect="1"/>
+          </p:cNvPicPr>
+          <p:nvPr/>
+        </p:nvPicPr>
+        <p:blipFill>
+          <a:blip r:embed="rId3"/>
+          <a:stretch>
+            <a:fillRect/>
+          </a:stretch>
+        </p:blipFill>
+        <p:spPr>
+          <a:xfrm>
+            <a:off x="1005840" y="1920240"/>
+            <a:ext cx="685800" cy="685800"/>
+          </a:xfrm>
+          <a:prstGeom prst="rect">
+            <a:avLst/>
+          </a:prstGeom>
+        </p:spPr>
+      </p:pic>
+      <p:sp>
+        <p:nvSpPr>
+          <p:cNvPr id="12" name="TextBox 11"/>
           <p:cNvSpPr txBox="1"/>
           <p:nvPr/>
         </p:nvSpPr>
         <p:spPr>
           <a:xfrm>
-            <a:off x="1005840" y="1874520"/>
-            <a:ext cx="4709160" cy="1600200"/>
+            <a:off x="1828800" y="1874520"/>
+            <a:ext cx="3931920" cy="1600200"/>
           </a:xfrm>
           <a:prstGeom prst="rect">
             <a:avLst/>
@@ -7951,25 +8373,25 @@
           <a:lstStyle/>
           <a:p>
             <a:pPr>
-              <a:defRPr sz="1300" b="1">
-                <a:solidFill>
-                  <a:srgbClr val="FFFFFF"/>
+              <a:defRPr sz="1200" b="1">
+                <a:solidFill>
+                  <a:srgbClr val="1E293B"/>
                 </a:solidFill>
                 <a:latin typeface="Arial Black"/>
               </a:defRPr>
             </a:pPr>
             <a:r>
-              <a:t>🏓  100% INCLUSIEF &amp; GELIJKWAARDIG</a:t>
-            </a:r>
-          </a:p>
-          <a:p>
-            <a:pPr>
-              <a:spcBef>
-                <a:spcPts val="800"/>
-              </a:spcBef>
-              <a:defRPr sz="1100">
-                <a:solidFill>
-                  <a:srgbClr val="D2D2D7"/>
+              <a:t>100% INCLUSIEF &amp; GELIJKWAARDIG</a:t>
+            </a:r>
+          </a:p>
+          <a:p>
+            <a:pPr>
+              <a:spcBef>
+                <a:spcPts val="600"/>
+              </a:spcBef>
+              <a:defRPr sz="1050">
+                <a:solidFill>
+                  <a:srgbClr val="475569"/>
                 </a:solidFill>
                 <a:latin typeface="Arial"/>
               </a:defRPr>
@@ -7982,7 +8404,7 @@
       </p:sp>
       <p:sp>
         <p:nvSpPr>
-          <p:cNvPr id="12" name="Rounded Rectangle 11"/>
+          <p:cNvPr id="13" name="Rounded Rectangle 12"/>
           <p:cNvSpPr/>
           <p:nvPr/>
         </p:nvSpPr>
@@ -7995,11 +8417,11 @@
             <a:avLst/>
           </a:prstGeom>
           <a:solidFill>
-            <a:srgbClr val="1C1C22"/>
+            <a:srgbClr val="FFFFFF"/>
           </a:solidFill>
           <a:ln w="12700">
             <a:solidFill>
-              <a:srgbClr val="32323C"/>
+              <a:srgbClr val="E2E8F0"/>
             </a:solidFill>
           </a:ln>
         </p:spPr>
@@ -8027,7 +8449,7 @@
       </p:sp>
       <p:sp>
         <p:nvSpPr>
-          <p:cNvPr id="13" name="Rectangle 12"/>
+          <p:cNvPr id="14" name="Rectangle 13"/>
           <p:cNvSpPr/>
           <p:nvPr/>
         </p:nvSpPr>
@@ -8068,16 +8490,40 @@
           </a:p>
         </p:txBody>
       </p:sp>
-      <p:sp>
-        <p:nvSpPr>
-          <p:cNvPr id="14" name="TextBox 13"/>
+      <p:pic>
+        <p:nvPicPr>
+          <p:cNvPr id="15" name="Picture 14" descr="icon-heartbeat.png"/>
+          <p:cNvPicPr>
+            <a:picLocks noChangeAspect="1"/>
+          </p:cNvPicPr>
+          <p:nvPr/>
+        </p:nvPicPr>
+        <p:blipFill>
+          <a:blip r:embed="rId4"/>
+          <a:stretch>
+            <a:fillRect/>
+          </a:stretch>
+        </p:blipFill>
+        <p:spPr>
+          <a:xfrm>
+            <a:off x="6446520" y="1920240"/>
+            <a:ext cx="685800" cy="685800"/>
+          </a:xfrm>
+          <a:prstGeom prst="rect">
+            <a:avLst/>
+          </a:prstGeom>
+        </p:spPr>
+      </p:pic>
+      <p:sp>
+        <p:nvSpPr>
+          <p:cNvPr id="16" name="TextBox 15"/>
           <p:cNvSpPr txBox="1"/>
           <p:nvPr/>
         </p:nvSpPr>
         <p:spPr>
           <a:xfrm>
-            <a:off x="6446520" y="1874520"/>
-            <a:ext cx="4709160" cy="1600200"/>
+            <a:off x="7269480" y="1874520"/>
+            <a:ext cx="3931920" cy="1600200"/>
           </a:xfrm>
           <a:prstGeom prst="rect">
             <a:avLst/>
@@ -8091,25 +8537,25 @@
           <a:lstStyle/>
           <a:p>
             <a:pPr>
-              <a:defRPr sz="1300" b="1">
-                <a:solidFill>
-                  <a:srgbClr val="FFFFFF"/>
+              <a:defRPr sz="1200" b="1">
+                <a:solidFill>
+                  <a:srgbClr val="1E293B"/>
                 </a:solidFill>
                 <a:latin typeface="Arial Black"/>
               </a:defRPr>
             </a:pPr>
             <a:r>
-              <a:t>⚡  SCHAKEN OP TOPSNELHEID</a:t>
-            </a:r>
-          </a:p>
-          <a:p>
-            <a:pPr>
-              <a:spcBef>
-                <a:spcPts val="800"/>
-              </a:spcBef>
-              <a:defRPr sz="1100">
-                <a:solidFill>
-                  <a:srgbClr val="D2D2D7"/>
+              <a:t>SCHAKEN OP TOPSNELHEID</a:t>
+            </a:r>
+          </a:p>
+          <a:p>
+            <a:pPr>
+              <a:spcBef>
+                <a:spcPts val="600"/>
+              </a:spcBef>
+              <a:defRPr sz="1050">
+                <a:solidFill>
+                  <a:srgbClr val="475569"/>
                 </a:solidFill>
                 <a:latin typeface="Arial"/>
               </a:defRPr>
@@ -8122,7 +8568,7 @@
       </p:sp>
       <p:sp>
         <p:nvSpPr>
-          <p:cNvPr id="15" name="Rounded Rectangle 14"/>
+          <p:cNvPr id="17" name="Rounded Rectangle 16"/>
           <p:cNvSpPr/>
           <p:nvPr/>
         </p:nvSpPr>
@@ -8135,11 +8581,11 @@
             <a:avLst/>
           </a:prstGeom>
           <a:solidFill>
-            <a:srgbClr val="1C1C22"/>
+            <a:srgbClr val="FFFFFF"/>
           </a:solidFill>
           <a:ln w="12700">
             <a:solidFill>
-              <a:srgbClr val="32323C"/>
+              <a:srgbClr val="E2E8F0"/>
             </a:solidFill>
           </a:ln>
         </p:spPr>
@@ -8167,7 +8613,7 @@
       </p:sp>
       <p:sp>
         <p:nvSpPr>
-          <p:cNvPr id="16" name="Rectangle 15"/>
+          <p:cNvPr id="18" name="Rectangle 17"/>
           <p:cNvSpPr/>
           <p:nvPr/>
         </p:nvSpPr>
@@ -8208,16 +8654,40 @@
           </a:p>
         </p:txBody>
       </p:sp>
-      <p:sp>
-        <p:nvSpPr>
-          <p:cNvPr id="17" name="TextBox 16"/>
+      <p:pic>
+        <p:nvPicPr>
+          <p:cNvPr id="19" name="Picture 18" descr="icon-trophy.png"/>
+          <p:cNvPicPr>
+            <a:picLocks noChangeAspect="1"/>
+          </p:cNvPicPr>
+          <p:nvPr/>
+        </p:nvPicPr>
+        <p:blipFill>
+          <a:blip r:embed="rId5"/>
+          <a:stretch>
+            <a:fillRect/>
+          </a:stretch>
+        </p:blipFill>
+        <p:spPr>
+          <a:xfrm>
+            <a:off x="1005840" y="4206240"/>
+            <a:ext cx="685800" cy="685800"/>
+          </a:xfrm>
+          <a:prstGeom prst="rect">
+            <a:avLst/>
+          </a:prstGeom>
+        </p:spPr>
+      </p:pic>
+      <p:sp>
+        <p:nvSpPr>
+          <p:cNvPr id="20" name="TextBox 19"/>
           <p:cNvSpPr txBox="1"/>
           <p:nvPr/>
         </p:nvSpPr>
         <p:spPr>
           <a:xfrm>
-            <a:off x="1005840" y="4160520"/>
-            <a:ext cx="4709160" cy="1600200"/>
+            <a:off x="1828800" y="4160520"/>
+            <a:ext cx="3931920" cy="1600200"/>
           </a:xfrm>
           <a:prstGeom prst="rect">
             <a:avLst/>
@@ -8231,38 +8701,38 @@
           <a:lstStyle/>
           <a:p>
             <a:pPr>
-              <a:defRPr sz="1300" b="1">
-                <a:solidFill>
-                  <a:srgbClr val="FFFFFF"/>
+              <a:defRPr sz="1200" b="1">
+                <a:solidFill>
+                  <a:srgbClr val="1E293B"/>
                 </a:solidFill>
                 <a:latin typeface="Arial Black"/>
               </a:defRPr>
             </a:pPr>
             <a:r>
-              <a:t>🏆  DIRECT LACHEN &amp; RIVALITEIT</a:t>
-            </a:r>
-          </a:p>
-          <a:p>
-            <a:pPr>
-              <a:spcBef>
-                <a:spcPts val="800"/>
-              </a:spcBef>
-              <a:defRPr sz="1100">
-                <a:solidFill>
-                  <a:srgbClr val="D2D2D7"/>
-                </a:solidFill>
-                <a:latin typeface="Arial"/>
-              </a:defRPr>
-            </a:pPr>
-            <a:r>
-              <a:t>Binnen 2 minuten ontstaan er rally's, spectaculaire punten en hilarische missers. Gegarandeerd positieve teamenergie.</a:t>
-            </a:r>
-          </a:p>
-        </p:txBody>
-      </p:sp>
-      <p:sp>
-        <p:nvSpPr>
-          <p:cNvPr id="18" name="Rounded Rectangle 17"/>
+              <a:t>DIRECT LACHEN &amp; RIVALITEIT</a:t>
+            </a:r>
+          </a:p>
+          <a:p>
+            <a:pPr>
+              <a:spcBef>
+                <a:spcPts val="600"/>
+              </a:spcBef>
+              <a:defRPr sz="1050">
+                <a:solidFill>
+                  <a:srgbClr val="475569"/>
+                </a:solidFill>
+                <a:latin typeface="Arial"/>
+              </a:defRPr>
+            </a:pPr>
+            <a:r>
+              <a:t>Binnen 2 minuten ontstaan er spannende rally's, spectaculaire punten en hilarische missers. Gegarandeerd positieve teamenergie.</a:t>
+            </a:r>
+          </a:p>
+        </p:txBody>
+      </p:sp>
+      <p:sp>
+        <p:nvSpPr>
+          <p:cNvPr id="21" name="Rounded Rectangle 20"/>
           <p:cNvSpPr/>
           <p:nvPr/>
         </p:nvSpPr>
@@ -8275,11 +8745,11 @@
             <a:avLst/>
           </a:prstGeom>
           <a:solidFill>
-            <a:srgbClr val="1C1C22"/>
+            <a:srgbClr val="FFFFFF"/>
           </a:solidFill>
           <a:ln w="12700">
             <a:solidFill>
-              <a:srgbClr val="32323C"/>
+              <a:srgbClr val="E2E8F0"/>
             </a:solidFill>
           </a:ln>
         </p:spPr>
@@ -8307,7 +8777,7 @@
       </p:sp>
       <p:sp>
         <p:nvSpPr>
-          <p:cNvPr id="19" name="Rectangle 18"/>
+          <p:cNvPr id="22" name="Rectangle 21"/>
           <p:cNvSpPr/>
           <p:nvPr/>
         </p:nvSpPr>
@@ -8348,16 +8818,40 @@
           </a:p>
         </p:txBody>
       </p:sp>
-      <p:sp>
-        <p:nvSpPr>
-          <p:cNvPr id="20" name="TextBox 19"/>
+      <p:pic>
+        <p:nvPicPr>
+          <p:cNvPr id="23" name="Picture 22" descr="icon-shield.png"/>
+          <p:cNvPicPr>
+            <a:picLocks noChangeAspect="1"/>
+          </p:cNvPicPr>
+          <p:nvPr/>
+        </p:nvPicPr>
+        <p:blipFill>
+          <a:blip r:embed="rId6"/>
+          <a:stretch>
+            <a:fillRect/>
+          </a:stretch>
+        </p:blipFill>
+        <p:spPr>
+          <a:xfrm>
+            <a:off x="6446520" y="4206240"/>
+            <a:ext cx="685800" cy="685800"/>
+          </a:xfrm>
+          <a:prstGeom prst="rect">
+            <a:avLst/>
+          </a:prstGeom>
+        </p:spPr>
+      </p:pic>
+      <p:sp>
+        <p:nvSpPr>
+          <p:cNvPr id="24" name="TextBox 23"/>
           <p:cNvSpPr txBox="1"/>
           <p:nvPr/>
         </p:nvSpPr>
         <p:spPr>
           <a:xfrm>
-            <a:off x="6446520" y="4160520"/>
-            <a:ext cx="4709160" cy="1600200"/>
+            <a:off x="7269480" y="4160520"/>
+            <a:ext cx="3931920" cy="1600200"/>
           </a:xfrm>
           <a:prstGeom prst="rect">
             <a:avLst/>
@@ -8371,25 +8865,25 @@
           <a:lstStyle/>
           <a:p>
             <a:pPr>
-              <a:defRPr sz="1300" b="1">
-                <a:solidFill>
-                  <a:srgbClr val="FFFFFF"/>
+              <a:defRPr sz="1200" b="1">
+                <a:solidFill>
+                  <a:srgbClr val="1E293B"/>
                 </a:solidFill>
                 <a:latin typeface="Arial Black"/>
               </a:defRPr>
             </a:pPr>
             <a:r>
-              <a:t>🛡️  VOLLEDIG ZONDER BLESSURES</a:t>
-            </a:r>
-          </a:p>
-          <a:p>
-            <a:pPr>
-              <a:spcBef>
-                <a:spcPts val="800"/>
-              </a:spcBef>
-              <a:defRPr sz="1100">
-                <a:solidFill>
-                  <a:srgbClr val="D2D2D7"/>
+              <a:t>VOLLEDIG ZONDER BLESSURES</a:t>
+            </a:r>
+          </a:p>
+          <a:p>
+            <a:pPr>
+              <a:spcBef>
+                <a:spcPts val="600"/>
+              </a:spcBef>
+              <a:defRPr sz="1050">
+                <a:solidFill>
+                  <a:srgbClr val="475569"/>
                 </a:solidFill>
                 <a:latin typeface="Arial"/>
               </a:defRPr>
@@ -8433,7 +8927,7 @@
             <a:avLst/>
           </a:prstGeom>
           <a:solidFill>
-            <a:srgbClr val="101014"/>
+            <a:srgbClr val="F8FAFC"/>
           </a:solidFill>
           <a:ln>
             <a:noFill/>
@@ -8553,7 +9047,7 @@
             <a:pPr>
               <a:defRPr sz="950" b="1">
                 <a:solidFill>
-                  <a:srgbClr val="FF6B00"/>
+                  <a:srgbClr val="D95500"/>
                 </a:solidFill>
                 <a:latin typeface="Arial Black"/>
               </a:defRPr>
@@ -8589,7 +9083,7 @@
             <a:pPr>
               <a:defRPr sz="2400" b="1">
                 <a:solidFill>
-                  <a:srgbClr val="FFFFFF"/>
+                  <a:srgbClr val="111827"/>
                 </a:solidFill>
                 <a:latin typeface="Arial Black"/>
               </a:defRPr>
@@ -8668,7 +9162,7 @@
             <a:pPr>
               <a:defRPr sz="850">
                 <a:solidFill>
-                  <a:srgbClr val="8C8C96"/>
+                  <a:srgbClr val="94A3B8"/>
                 </a:solidFill>
                 <a:latin typeface="Arial"/>
               </a:defRPr>
@@ -8694,11 +9188,11 @@
             <a:avLst/>
           </a:prstGeom>
           <a:solidFill>
-            <a:srgbClr val="1C1C22"/>
+            <a:srgbClr val="FFFFFF"/>
           </a:solidFill>
           <a:ln w="12700">
             <a:solidFill>
-              <a:srgbClr val="32323C"/>
+              <a:srgbClr val="E2E8F0"/>
             </a:solidFill>
           </a:ln>
         </p:spPr>
@@ -8749,7 +9243,7 @@
             <a:pPr>
               <a:defRPr sz="1200" b="1">
                 <a:solidFill>
-                  <a:srgbClr val="FF6B00"/>
+                  <a:srgbClr val="D95500"/>
                 </a:solidFill>
                 <a:latin typeface="Arial Black"/>
               </a:defRPr>
@@ -8765,7 +9259,7 @@
               </a:spcBef>
               <a:defRPr sz="950">
                 <a:solidFill>
-                  <a:srgbClr val="8C8C96"/>
+                  <a:srgbClr val="94A3B8"/>
                 </a:solidFill>
                 <a:latin typeface="Arial"/>
               </a:defRPr>
@@ -8781,13 +9275,13 @@
               </a:spcBef>
               <a:defRPr sz="900">
                 <a:solidFill>
-                  <a:srgbClr val="D2D2D7"/>
-                </a:solidFill>
-                <a:latin typeface="Arial"/>
-              </a:defRPr>
-            </a:pPr>
-            <a:r>
-              <a:t>• Hoge schermtijd, zittend werk</a:t>
+                  <a:srgbClr val="475569"/>
+                </a:solidFill>
+                <a:latin typeface="Arial"/>
+              </a:defRPr>
+            </a:pPr>
+            <a:r>
+              <a:t>• Hoge schermtijd, langdurig zittend werk</a:t>
             </a:r>
           </a:p>
           <a:p>
@@ -8797,13 +9291,13 @@
               </a:spcBef>
               <a:defRPr sz="900">
                 <a:solidFill>
-                  <a:srgbClr val="D2D2D7"/>
-                </a:solidFill>
-                <a:latin typeface="Arial"/>
-              </a:defRPr>
-            </a:pPr>
-            <a:r>
-              <a:t>• Jong &amp; dynamisch team</a:t>
+                  <a:srgbClr val="475569"/>
+                </a:solidFill>
+                <a:latin typeface="Arial"/>
+              </a:defRPr>
+            </a:pPr>
+            <a:r>
+              <a:t>• Jong &amp; dynamisch team dat competitie waardeert</a:t>
             </a:r>
           </a:p>
           <a:p>
@@ -8813,7 +9307,7 @@
               </a:spcBef>
               <a:defRPr sz="900">
                 <a:solidFill>
-                  <a:srgbClr val="D2D2D7"/>
+                  <a:srgbClr val="475569"/>
                 </a:solidFill>
                 <a:latin typeface="Arial"/>
               </a:defRPr>
@@ -8829,7 +9323,7 @@
               </a:spcBef>
               <a:defRPr sz="900">
                 <a:solidFill>
-                  <a:srgbClr val="D2D2D7"/>
+                  <a:srgbClr val="475569"/>
                 </a:solidFill>
                 <a:latin typeface="Arial"/>
               </a:defRPr>
@@ -8855,11 +9349,11 @@
             <a:avLst/>
           </a:prstGeom>
           <a:solidFill>
-            <a:srgbClr val="1C1C22"/>
+            <a:srgbClr val="FFFFFF"/>
           </a:solidFill>
           <a:ln w="12700">
             <a:solidFill>
-              <a:srgbClr val="32323C"/>
+              <a:srgbClr val="E2E8F0"/>
             </a:solidFill>
           </a:ln>
         </p:spPr>
@@ -8910,7 +9404,7 @@
             <a:pPr>
               <a:defRPr sz="1200" b="1">
                 <a:solidFill>
-                  <a:srgbClr val="FF6B00"/>
+                  <a:srgbClr val="D95500"/>
                 </a:solidFill>
                 <a:latin typeface="Arial Black"/>
               </a:defRPr>
@@ -8926,7 +9420,7 @@
               </a:spcBef>
               <a:defRPr sz="950">
                 <a:solidFill>
-                  <a:srgbClr val="8C8C96"/>
+                  <a:srgbClr val="94A3B8"/>
                 </a:solidFill>
                 <a:latin typeface="Arial"/>
               </a:defRPr>
@@ -8942,7 +9436,7 @@
               </a:spcBef>
               <a:defRPr sz="900">
                 <a:solidFill>
-                  <a:srgbClr val="D2D2D7"/>
+                  <a:srgbClr val="475569"/>
                 </a:solidFill>
                 <a:latin typeface="Arial"/>
               </a:defRPr>
@@ -8958,7 +9452,7 @@
               </a:spcBef>
               <a:defRPr sz="900">
                 <a:solidFill>
-                  <a:srgbClr val="D2D2D7"/>
+                  <a:srgbClr val="475569"/>
                 </a:solidFill>
                 <a:latin typeface="Arial"/>
               </a:defRPr>
@@ -8974,7 +9468,7 @@
               </a:spcBef>
               <a:defRPr sz="900">
                 <a:solidFill>
-                  <a:srgbClr val="D2D2D7"/>
+                  <a:srgbClr val="475569"/>
                 </a:solidFill>
                 <a:latin typeface="Arial"/>
               </a:defRPr>
@@ -8990,7 +9484,7 @@
               </a:spcBef>
               <a:defRPr sz="900">
                 <a:solidFill>
-                  <a:srgbClr val="D2D2D7"/>
+                  <a:srgbClr val="475569"/>
                 </a:solidFill>
                 <a:latin typeface="Arial"/>
               </a:defRPr>
@@ -9016,11 +9510,11 @@
             <a:avLst/>
           </a:prstGeom>
           <a:solidFill>
-            <a:srgbClr val="1C1C22"/>
+            <a:srgbClr val="FFFFFF"/>
           </a:solidFill>
           <a:ln w="12700">
             <a:solidFill>
-              <a:srgbClr val="32323C"/>
+              <a:srgbClr val="E2E8F0"/>
             </a:solidFill>
           </a:ln>
         </p:spPr>
@@ -9071,7 +9565,7 @@
             <a:pPr>
               <a:defRPr sz="1200" b="1">
                 <a:solidFill>
-                  <a:srgbClr val="FF6B00"/>
+                  <a:srgbClr val="D95500"/>
                 </a:solidFill>
                 <a:latin typeface="Arial Black"/>
               </a:defRPr>
@@ -9087,7 +9581,7 @@
               </a:spcBef>
               <a:defRPr sz="950">
                 <a:solidFill>
-                  <a:srgbClr val="8C8C96"/>
+                  <a:srgbClr val="94A3B8"/>
                 </a:solidFill>
                 <a:latin typeface="Arial"/>
               </a:defRPr>
@@ -9103,7 +9597,7 @@
               </a:spcBef>
               <a:defRPr sz="900">
                 <a:solidFill>
-                  <a:srgbClr val="D2D2D7"/>
+                  <a:srgbClr val="475569"/>
                 </a:solidFill>
                 <a:latin typeface="Arial"/>
               </a:defRPr>
@@ -9119,7 +9613,7 @@
               </a:spcBef>
               <a:defRPr sz="900">
                 <a:solidFill>
-                  <a:srgbClr val="D2D2D7"/>
+                  <a:srgbClr val="475569"/>
                 </a:solidFill>
                 <a:latin typeface="Arial"/>
               </a:defRPr>
@@ -9135,7 +9629,7 @@
               </a:spcBef>
               <a:defRPr sz="900">
                 <a:solidFill>
-                  <a:srgbClr val="D2D2D7"/>
+                  <a:srgbClr val="475569"/>
                 </a:solidFill>
                 <a:latin typeface="Arial"/>
               </a:defRPr>
@@ -9151,7 +9645,7 @@
               </a:spcBef>
               <a:defRPr sz="900">
                 <a:solidFill>
-                  <a:srgbClr val="D2D2D7"/>
+                  <a:srgbClr val="475569"/>
                 </a:solidFill>
                 <a:latin typeface="Arial"/>
               </a:defRPr>
@@ -9177,11 +9671,11 @@
             <a:avLst/>
           </a:prstGeom>
           <a:solidFill>
-            <a:srgbClr val="1C1C22"/>
+            <a:srgbClr val="FFFFFF"/>
           </a:solidFill>
           <a:ln w="12700">
             <a:solidFill>
-              <a:srgbClr val="32323C"/>
+              <a:srgbClr val="E2E8F0"/>
             </a:solidFill>
           </a:ln>
         </p:spPr>
@@ -9232,7 +9726,7 @@
             <a:pPr>
               <a:defRPr sz="1200" b="1">
                 <a:solidFill>
-                  <a:srgbClr val="FF6B00"/>
+                  <a:srgbClr val="D95500"/>
                 </a:solidFill>
                 <a:latin typeface="Arial Black"/>
               </a:defRPr>
@@ -9248,7 +9742,7 @@
               </a:spcBef>
               <a:defRPr sz="950">
                 <a:solidFill>
-                  <a:srgbClr val="8C8C96"/>
+                  <a:srgbClr val="94A3B8"/>
                 </a:solidFill>
                 <a:latin typeface="Arial"/>
               </a:defRPr>
@@ -9264,7 +9758,7 @@
               </a:spcBef>
               <a:defRPr sz="900">
                 <a:solidFill>
-                  <a:srgbClr val="D2D2D7"/>
+                  <a:srgbClr val="475569"/>
                 </a:solidFill>
                 <a:latin typeface="Arial"/>
               </a:defRPr>
@@ -9280,7 +9774,7 @@
               </a:spcBef>
               <a:defRPr sz="900">
                 <a:solidFill>
-                  <a:srgbClr val="D2D2D7"/>
+                  <a:srgbClr val="475569"/>
                 </a:solidFill>
                 <a:latin typeface="Arial"/>
               </a:defRPr>
@@ -9296,7 +9790,7 @@
               </a:spcBef>
               <a:defRPr sz="900">
                 <a:solidFill>
-                  <a:srgbClr val="D2D2D7"/>
+                  <a:srgbClr val="475569"/>
                 </a:solidFill>
                 <a:latin typeface="Arial"/>
               </a:defRPr>
@@ -9312,7 +9806,7 @@
               </a:spcBef>
               <a:defRPr sz="900">
                 <a:solidFill>
-                  <a:srgbClr val="D2D2D7"/>
+                  <a:srgbClr val="475569"/>
                 </a:solidFill>
                 <a:latin typeface="Arial"/>
               </a:defRPr>
@@ -9356,7 +9850,7 @@
             <a:avLst/>
           </a:prstGeom>
           <a:solidFill>
-            <a:srgbClr val="101014"/>
+            <a:srgbClr val="F8FAFC"/>
           </a:solidFill>
           <a:ln>
             <a:noFill/>
@@ -9476,7 +9970,7 @@
             <a:pPr>
               <a:defRPr sz="950" b="1">
                 <a:solidFill>
-                  <a:srgbClr val="FF6B00"/>
+                  <a:srgbClr val="D95500"/>
                 </a:solidFill>
                 <a:latin typeface="Arial Black"/>
               </a:defRPr>
@@ -9512,7 +10006,7 @@
             <a:pPr>
               <a:defRPr sz="2400" b="1">
                 <a:solidFill>
-                  <a:srgbClr val="FFFFFF"/>
+                  <a:srgbClr val="111827"/>
                 </a:solidFill>
                 <a:latin typeface="Arial Black"/>
               </a:defRPr>
@@ -9591,7 +10085,7 @@
             <a:pPr>
               <a:defRPr sz="850">
                 <a:solidFill>
-                  <a:srgbClr val="8C8C96"/>
+                  <a:srgbClr val="94A3B8"/>
                 </a:solidFill>
                 <a:latin typeface="Arial"/>
               </a:defRPr>
@@ -9617,11 +10111,11 @@
             <a:avLst/>
           </a:prstGeom>
           <a:solidFill>
-            <a:srgbClr val="1C1C22"/>
+            <a:srgbClr val="FFFFFF"/>
           </a:solidFill>
           <a:ln w="12700">
             <a:solidFill>
-              <a:srgbClr val="32323C"/>
+              <a:srgbClr val="E2E8F0"/>
             </a:solidFill>
           </a:ln>
         </p:spPr>
@@ -9690,9 +10184,33 @@
           </a:p>
         </p:txBody>
       </p:sp>
-      <p:sp>
-        <p:nvSpPr>
-          <p:cNvPr id="11" name="TextBox 10"/>
+      <p:pic>
+        <p:nvPicPr>
+          <p:cNvPr id="11" name="Picture 10" descr="icon-trophy.png"/>
+          <p:cNvPicPr>
+            <a:picLocks noChangeAspect="1"/>
+          </p:cNvPicPr>
+          <p:nvPr/>
+        </p:nvPicPr>
+        <p:blipFill>
+          <a:blip r:embed="rId3"/>
+          <a:stretch>
+            <a:fillRect/>
+          </a:stretch>
+        </p:blipFill>
+        <p:spPr>
+          <a:xfrm>
+            <a:off x="3364992" y="1828800"/>
+            <a:ext cx="640080" cy="640080"/>
+          </a:xfrm>
+          <a:prstGeom prst="rect">
+            <a:avLst/>
+          </a:prstGeom>
+        </p:spPr>
+      </p:pic>
+      <p:sp>
+        <p:nvSpPr>
+          <p:cNvPr id="12" name="TextBox 11"/>
           <p:cNvSpPr txBox="1"/>
           <p:nvPr/>
         </p:nvSpPr>
@@ -9713,9 +10231,9 @@
           <a:lstStyle/>
           <a:p>
             <a:pPr>
-              <a:defRPr sz="1150" b="1">
-                <a:solidFill>
-                  <a:srgbClr val="FF6B00"/>
+              <a:defRPr sz="1100" b="1">
+                <a:solidFill>
+                  <a:srgbClr val="D95500"/>
                 </a:solidFill>
                 <a:latin typeface="Arial Black"/>
               </a:defRPr>
@@ -9731,7 +10249,7 @@
               </a:spcBef>
               <a:defRPr sz="950">
                 <a:solidFill>
-                  <a:srgbClr val="8C8C96"/>
+                  <a:srgbClr val="94A3B8"/>
                 </a:solidFill>
                 <a:latin typeface="Arial"/>
               </a:defRPr>
@@ -9747,12 +10265,12 @@
               </a:spcBef>
               <a:defRPr sz="800">
                 <a:solidFill>
-                  <a:srgbClr val="32323C"/>
-                </a:solidFill>
-              </a:defRPr>
-            </a:pPr>
-            <a:r>
-              <a:t>——————————————————</a:t>
+                  <a:srgbClr val="CBD5E1"/>
+                </a:solidFill>
+              </a:defRPr>
+            </a:pPr>
+            <a:r>
+              <a:t>——————————————————————</a:t>
             </a:r>
           </a:p>
           <a:p>
@@ -9762,7 +10280,7 @@
               </a:spcBef>
               <a:defRPr sz="950">
                 <a:solidFill>
-                  <a:srgbClr val="D2D2D7"/>
+                  <a:srgbClr val="475569"/>
                 </a:solidFill>
                 <a:latin typeface="Arial"/>
               </a:defRPr>
@@ -9778,7 +10296,7 @@
               </a:spcBef>
               <a:defRPr sz="950">
                 <a:solidFill>
-                  <a:srgbClr val="D2D2D7"/>
+                  <a:srgbClr val="475569"/>
                 </a:solidFill>
                 <a:latin typeface="Arial"/>
               </a:defRPr>
@@ -9794,7 +10312,7 @@
               </a:spcBef>
               <a:defRPr sz="950">
                 <a:solidFill>
-                  <a:srgbClr val="D2D2D7"/>
+                  <a:srgbClr val="475569"/>
                 </a:solidFill>
                 <a:latin typeface="Arial"/>
               </a:defRPr>
@@ -9807,7 +10325,7 @@
       </p:sp>
       <p:sp>
         <p:nvSpPr>
-          <p:cNvPr id="12" name="Rounded Rectangle 11"/>
+          <p:cNvPr id="13" name="Rounded Rectangle 12"/>
           <p:cNvSpPr/>
           <p:nvPr/>
         </p:nvSpPr>
@@ -9820,11 +10338,11 @@
             <a:avLst/>
           </a:prstGeom>
           <a:solidFill>
-            <a:srgbClr val="1C1C22"/>
+            <a:srgbClr val="FFFFFF"/>
           </a:solidFill>
           <a:ln w="12700">
             <a:solidFill>
-              <a:srgbClr val="32323C"/>
+              <a:srgbClr val="E2E8F0"/>
             </a:solidFill>
           </a:ln>
         </p:spPr>
@@ -9852,7 +10370,7 @@
       </p:sp>
       <p:sp>
         <p:nvSpPr>
-          <p:cNvPr id="13" name="Rectangle 12"/>
+          <p:cNvPr id="14" name="Rectangle 13"/>
           <p:cNvSpPr/>
           <p:nvPr/>
         </p:nvSpPr>
@@ -9893,9 +10411,33 @@
           </a:p>
         </p:txBody>
       </p:sp>
-      <p:sp>
-        <p:nvSpPr>
-          <p:cNvPr id="14" name="TextBox 13"/>
+      <p:pic>
+        <p:nvPicPr>
+          <p:cNvPr id="15" name="Picture 14" descr="icon-location.png"/>
+          <p:cNvPicPr>
+            <a:picLocks noChangeAspect="1"/>
+          </p:cNvPicPr>
+          <p:nvPr/>
+        </p:nvPicPr>
+        <p:blipFill>
+          <a:blip r:embed="rId4"/>
+          <a:stretch>
+            <a:fillRect/>
+          </a:stretch>
+        </p:blipFill>
+        <p:spPr>
+          <a:xfrm>
+            <a:off x="7004304" y="1828800"/>
+            <a:ext cx="640080" cy="640080"/>
+          </a:xfrm>
+          <a:prstGeom prst="rect">
+            <a:avLst/>
+          </a:prstGeom>
+        </p:spPr>
+      </p:pic>
+      <p:sp>
+        <p:nvSpPr>
+          <p:cNvPr id="16" name="TextBox 15"/>
           <p:cNvSpPr txBox="1"/>
           <p:nvPr/>
         </p:nvSpPr>
@@ -9916,9 +10458,9 @@
           <a:lstStyle/>
           <a:p>
             <a:pPr>
-              <a:defRPr sz="1150" b="1">
-                <a:solidFill>
-                  <a:srgbClr val="FFFFFF"/>
+              <a:defRPr sz="1100" b="1">
+                <a:solidFill>
+                  <a:srgbClr val="D95500"/>
                 </a:solidFill>
                 <a:latin typeface="Arial Black"/>
               </a:defRPr>
@@ -9934,7 +10476,7 @@
               </a:spcBef>
               <a:defRPr sz="950">
                 <a:solidFill>
-                  <a:srgbClr val="8C8C96"/>
+                  <a:srgbClr val="94A3B8"/>
                 </a:solidFill>
                 <a:latin typeface="Arial"/>
               </a:defRPr>
@@ -9950,12 +10492,12 @@
               </a:spcBef>
               <a:defRPr sz="800">
                 <a:solidFill>
-                  <a:srgbClr val="32323C"/>
-                </a:solidFill>
-              </a:defRPr>
-            </a:pPr>
-            <a:r>
-              <a:t>——————————————————</a:t>
+                  <a:srgbClr val="CBD5E1"/>
+                </a:solidFill>
+              </a:defRPr>
+            </a:pPr>
+            <a:r>
+              <a:t>——————————————————————</a:t>
             </a:r>
           </a:p>
           <a:p>
@@ -9965,7 +10507,7 @@
               </a:spcBef>
               <a:defRPr sz="950">
                 <a:solidFill>
-                  <a:srgbClr val="D2D2D7"/>
+                  <a:srgbClr val="475569"/>
                 </a:solidFill>
                 <a:latin typeface="Arial"/>
               </a:defRPr>
@@ -9981,7 +10523,7 @@
               </a:spcBef>
               <a:defRPr sz="950">
                 <a:solidFill>
-                  <a:srgbClr val="D2D2D7"/>
+                  <a:srgbClr val="475569"/>
                 </a:solidFill>
                 <a:latin typeface="Arial"/>
               </a:defRPr>
@@ -9997,7 +10539,7 @@
               </a:spcBef>
               <a:defRPr sz="950">
                 <a:solidFill>
-                  <a:srgbClr val="D2D2D7"/>
+                  <a:srgbClr val="475569"/>
                 </a:solidFill>
                 <a:latin typeface="Arial"/>
               </a:defRPr>
@@ -10010,7 +10552,7 @@
       </p:sp>
       <p:sp>
         <p:nvSpPr>
-          <p:cNvPr id="15" name="Rounded Rectangle 14"/>
+          <p:cNvPr id="17" name="Rounded Rectangle 16"/>
           <p:cNvSpPr/>
           <p:nvPr/>
         </p:nvSpPr>
@@ -10023,11 +10565,11 @@
             <a:avLst/>
           </a:prstGeom>
           <a:solidFill>
-            <a:srgbClr val="1C1C22"/>
+            <a:srgbClr val="FFFFFF"/>
           </a:solidFill>
           <a:ln w="12700">
             <a:solidFill>
-              <a:srgbClr val="32323C"/>
+              <a:srgbClr val="E2E8F0"/>
             </a:solidFill>
           </a:ln>
         </p:spPr>
@@ -10055,7 +10597,7 @@
       </p:sp>
       <p:sp>
         <p:nvSpPr>
-          <p:cNvPr id="16" name="Rectangle 15"/>
+          <p:cNvPr id="18" name="Rectangle 17"/>
           <p:cNvSpPr/>
           <p:nvPr/>
         </p:nvSpPr>
@@ -10096,9 +10638,33 @@
           </a:p>
         </p:txBody>
       </p:sp>
-      <p:sp>
-        <p:nvSpPr>
-          <p:cNvPr id="17" name="TextBox 16"/>
+      <p:pic>
+        <p:nvPicPr>
+          <p:cNvPr id="19" name="Picture 18" descr="icon-chart.png"/>
+          <p:cNvPicPr>
+            <a:picLocks noChangeAspect="1"/>
+          </p:cNvPicPr>
+          <p:nvPr/>
+        </p:nvPicPr>
+        <p:blipFill>
+          <a:blip r:embed="rId5"/>
+          <a:stretch>
+            <a:fillRect/>
+          </a:stretch>
+        </p:blipFill>
+        <p:spPr>
+          <a:xfrm>
+            <a:off x="10643616" y="1828800"/>
+            <a:ext cx="640080" cy="640080"/>
+          </a:xfrm>
+          <a:prstGeom prst="rect">
+            <a:avLst/>
+          </a:prstGeom>
+        </p:spPr>
+      </p:pic>
+      <p:sp>
+        <p:nvSpPr>
+          <p:cNvPr id="20" name="TextBox 19"/>
           <p:cNvSpPr txBox="1"/>
           <p:nvPr/>
         </p:nvSpPr>
@@ -10119,15 +10685,15 @@
           <a:lstStyle/>
           <a:p>
             <a:pPr>
-              <a:defRPr sz="1150" b="1">
-                <a:solidFill>
-                  <a:srgbClr val="FF9A4D"/>
+              <a:defRPr sz="1100" b="1">
+                <a:solidFill>
+                  <a:srgbClr val="D95500"/>
                 </a:solidFill>
                 <a:latin typeface="Arial Black"/>
               </a:defRPr>
             </a:pPr>
             <a:r>
-              <a:t>3. RECURRING BEDRIJFSCOMPETITIES</a:t>
+              <a:t>3. RECURRING COMPETITIES</a:t>
             </a:r>
           </a:p>
           <a:p>
@@ -10137,7 +10703,7 @@
               </a:spcBef>
               <a:defRPr sz="950">
                 <a:solidFill>
-                  <a:srgbClr val="8C8C96"/>
+                  <a:srgbClr val="94A3B8"/>
                 </a:solidFill>
                 <a:latin typeface="Arial"/>
               </a:defRPr>
@@ -10153,12 +10719,12 @@
               </a:spcBef>
               <a:defRPr sz="800">
                 <a:solidFill>
-                  <a:srgbClr val="32323C"/>
-                </a:solidFill>
-              </a:defRPr>
-            </a:pPr>
-            <a:r>
-              <a:t>——————————————————</a:t>
+                  <a:srgbClr val="CBD5E1"/>
+                </a:solidFill>
+              </a:defRPr>
+            </a:pPr>
+            <a:r>
+              <a:t>——————————————————————</a:t>
             </a:r>
           </a:p>
           <a:p>
@@ -10168,7 +10734,7 @@
               </a:spcBef>
               <a:defRPr sz="950">
                 <a:solidFill>
-                  <a:srgbClr val="D2D2D7"/>
+                  <a:srgbClr val="475569"/>
                 </a:solidFill>
                 <a:latin typeface="Arial"/>
               </a:defRPr>
@@ -10184,7 +10750,7 @@
               </a:spcBef>
               <a:defRPr sz="950">
                 <a:solidFill>
-                  <a:srgbClr val="D2D2D7"/>
+                  <a:srgbClr val="475569"/>
                 </a:solidFill>
                 <a:latin typeface="Arial"/>
               </a:defRPr>
@@ -10200,7 +10766,7 @@
               </a:spcBef>
               <a:defRPr sz="950">
                 <a:solidFill>
-                  <a:srgbClr val="D2D2D7"/>
+                  <a:srgbClr val="475569"/>
                 </a:solidFill>
                 <a:latin typeface="Arial"/>
               </a:defRPr>
@@ -10244,7 +10810,7 @@
             <a:avLst/>
           </a:prstGeom>
           <a:solidFill>
-            <a:srgbClr val="101014"/>
+            <a:srgbClr val="F8FAFC"/>
           </a:solidFill>
           <a:ln>
             <a:noFill/>
@@ -10364,7 +10930,7 @@
             <a:pPr>
               <a:defRPr sz="950" b="1">
                 <a:solidFill>
-                  <a:srgbClr val="FF6B00"/>
+                  <a:srgbClr val="D95500"/>
                 </a:solidFill>
                 <a:latin typeface="Arial Black"/>
               </a:defRPr>
@@ -10400,7 +10966,7 @@
             <a:pPr>
               <a:defRPr sz="2400" b="1">
                 <a:solidFill>
-                  <a:srgbClr val="FFFFFF"/>
+                  <a:srgbClr val="111827"/>
                 </a:solidFill>
                 <a:latin typeface="Arial Black"/>
               </a:defRPr>
@@ -10479,7 +11045,7 @@
             <a:pPr>
               <a:defRPr sz="850">
                 <a:solidFill>
-                  <a:srgbClr val="8C8C96"/>
+                  <a:srgbClr val="94A3B8"/>
                 </a:solidFill>
                 <a:latin typeface="Arial"/>
               </a:defRPr>
@@ -10505,11 +11071,11 @@
             <a:avLst/>
           </a:prstGeom>
           <a:solidFill>
-            <a:srgbClr val="1C1C22"/>
+            <a:srgbClr val="FFFFFF"/>
           </a:solidFill>
           <a:ln w="12700">
             <a:solidFill>
-              <a:srgbClr val="32323C"/>
+              <a:srgbClr val="E2E8F0"/>
             </a:solidFill>
           </a:ln>
         </p:spPr>
@@ -10560,7 +11126,7 @@
             <a:pPr>
               <a:defRPr sz="1200" b="1">
                 <a:solidFill>
-                  <a:srgbClr val="FFFFFF"/>
+                  <a:srgbClr val="1E293B"/>
                 </a:solidFill>
                 <a:latin typeface="Arial Black"/>
               </a:defRPr>
@@ -10576,7 +11142,7 @@
               </a:spcBef>
               <a:defRPr sz="950">
                 <a:solidFill>
-                  <a:srgbClr val="FF6B00"/>
+                  <a:srgbClr val="D95500"/>
                 </a:solidFill>
                 <a:latin typeface="Arial"/>
               </a:defRPr>
@@ -10592,7 +11158,7 @@
               </a:spcBef>
               <a:defRPr sz="900">
                 <a:solidFill>
-                  <a:srgbClr val="D2D2D7"/>
+                  <a:srgbClr val="475569"/>
                 </a:solidFill>
                 <a:latin typeface="Arial"/>
               </a:defRPr>
@@ -10608,7 +11174,7 @@
               </a:spcBef>
               <a:defRPr sz="900">
                 <a:solidFill>
-                  <a:srgbClr val="D2D2D7"/>
+                  <a:srgbClr val="475569"/>
                 </a:solidFill>
                 <a:latin typeface="Arial"/>
               </a:defRPr>
@@ -10624,7 +11190,7 @@
               </a:spcBef>
               <a:defRPr sz="900">
                 <a:solidFill>
-                  <a:srgbClr val="D2D2D7"/>
+                  <a:srgbClr val="475569"/>
                 </a:solidFill>
                 <a:latin typeface="Arial"/>
               </a:defRPr>
@@ -10650,11 +11216,11 @@
             <a:avLst/>
           </a:prstGeom>
           <a:solidFill>
-            <a:srgbClr val="1C1C22"/>
+            <a:srgbClr val="FFFFFF"/>
           </a:solidFill>
           <a:ln w="12700">
             <a:solidFill>
-              <a:srgbClr val="32323C"/>
+              <a:srgbClr val="E2E8F0"/>
             </a:solidFill>
           </a:ln>
         </p:spPr>
@@ -10705,7 +11271,7 @@
             <a:pPr>
               <a:defRPr sz="1200" b="1">
                 <a:solidFill>
-                  <a:srgbClr val="FFFFFF"/>
+                  <a:srgbClr val="1E293B"/>
                 </a:solidFill>
                 <a:latin typeface="Arial Black"/>
               </a:defRPr>
@@ -10721,7 +11287,7 @@
               </a:spcBef>
               <a:defRPr sz="950">
                 <a:solidFill>
-                  <a:srgbClr val="FF6B00"/>
+                  <a:srgbClr val="D95500"/>
                 </a:solidFill>
                 <a:latin typeface="Arial"/>
               </a:defRPr>
@@ -10737,7 +11303,7 @@
               </a:spcBef>
               <a:defRPr sz="900">
                 <a:solidFill>
-                  <a:srgbClr val="D2D2D7"/>
+                  <a:srgbClr val="475569"/>
                 </a:solidFill>
                 <a:latin typeface="Arial"/>
               </a:defRPr>
@@ -10753,7 +11319,7 @@
               </a:spcBef>
               <a:defRPr sz="900">
                 <a:solidFill>
-                  <a:srgbClr val="D2D2D7"/>
+                  <a:srgbClr val="475569"/>
                 </a:solidFill>
                 <a:latin typeface="Arial"/>
               </a:defRPr>
@@ -10769,7 +11335,7 @@
               </a:spcBef>
               <a:defRPr sz="900">
                 <a:solidFill>
-                  <a:srgbClr val="D2D2D7"/>
+                  <a:srgbClr val="475569"/>
                 </a:solidFill>
                 <a:latin typeface="Arial"/>
               </a:defRPr>
@@ -10795,11 +11361,11 @@
             <a:avLst/>
           </a:prstGeom>
           <a:solidFill>
-            <a:srgbClr val="1C1C22"/>
+            <a:srgbClr val="FFFFFF"/>
           </a:solidFill>
           <a:ln w="12700">
             <a:solidFill>
-              <a:srgbClr val="32323C"/>
+              <a:srgbClr val="E2E8F0"/>
             </a:solidFill>
           </a:ln>
         </p:spPr>
@@ -10850,7 +11416,7 @@
             <a:pPr>
               <a:defRPr sz="1200" b="1">
                 <a:solidFill>
-                  <a:srgbClr val="FFFFFF"/>
+                  <a:srgbClr val="1E293B"/>
                 </a:solidFill>
                 <a:latin typeface="Arial Black"/>
               </a:defRPr>
@@ -10866,7 +11432,7 @@
               </a:spcBef>
               <a:defRPr sz="950">
                 <a:solidFill>
-                  <a:srgbClr val="FF6B00"/>
+                  <a:srgbClr val="D95500"/>
                 </a:solidFill>
                 <a:latin typeface="Arial"/>
               </a:defRPr>
@@ -10882,7 +11448,7 @@
               </a:spcBef>
               <a:defRPr sz="900">
                 <a:solidFill>
-                  <a:srgbClr val="D2D2D7"/>
+                  <a:srgbClr val="475569"/>
                 </a:solidFill>
                 <a:latin typeface="Arial"/>
               </a:defRPr>
@@ -10898,7 +11464,7 @@
               </a:spcBef>
               <a:defRPr sz="900">
                 <a:solidFill>
-                  <a:srgbClr val="D2D2D7"/>
+                  <a:srgbClr val="475569"/>
                 </a:solidFill>
                 <a:latin typeface="Arial"/>
               </a:defRPr>
@@ -10914,7 +11480,7 @@
               </a:spcBef>
               <a:defRPr sz="900">
                 <a:solidFill>
-                  <a:srgbClr val="D2D2D7"/>
+                  <a:srgbClr val="475569"/>
                 </a:solidFill>
                 <a:latin typeface="Arial"/>
               </a:defRPr>
@@ -10940,11 +11506,11 @@
             <a:avLst/>
           </a:prstGeom>
           <a:solidFill>
-            <a:srgbClr val="1C1C22"/>
+            <a:srgbClr val="FFFFFF"/>
           </a:solidFill>
           <a:ln w="12700">
             <a:solidFill>
-              <a:srgbClr val="32323C"/>
+              <a:srgbClr val="E2E8F0"/>
             </a:solidFill>
           </a:ln>
         </p:spPr>
@@ -10995,7 +11561,7 @@
             <a:pPr>
               <a:defRPr sz="1200" b="1">
                 <a:solidFill>
-                  <a:srgbClr val="FFFFFF"/>
+                  <a:srgbClr val="1E293B"/>
                 </a:solidFill>
                 <a:latin typeface="Arial Black"/>
               </a:defRPr>
@@ -11011,7 +11577,7 @@
               </a:spcBef>
               <a:defRPr sz="950">
                 <a:solidFill>
-                  <a:srgbClr val="FF6B00"/>
+                  <a:srgbClr val="D95500"/>
                 </a:solidFill>
                 <a:latin typeface="Arial"/>
               </a:defRPr>
@@ -11027,7 +11593,7 @@
               </a:spcBef>
               <a:defRPr sz="900">
                 <a:solidFill>
-                  <a:srgbClr val="D2D2D7"/>
+                  <a:srgbClr val="475569"/>
                 </a:solidFill>
                 <a:latin typeface="Arial"/>
               </a:defRPr>
@@ -11043,7 +11609,7 @@
               </a:spcBef>
               <a:defRPr sz="900">
                 <a:solidFill>
-                  <a:srgbClr val="D2D2D7"/>
+                  <a:srgbClr val="475569"/>
                 </a:solidFill>
                 <a:latin typeface="Arial"/>
               </a:defRPr>
@@ -11059,7 +11625,7 @@
               </a:spcBef>
               <a:defRPr sz="900">
                 <a:solidFill>
-                  <a:srgbClr val="D2D2D7"/>
+                  <a:srgbClr val="475569"/>
                 </a:solidFill>
                 <a:latin typeface="Arial"/>
               </a:defRPr>
@@ -11103,7 +11669,7 @@
             <a:avLst/>
           </a:prstGeom>
           <a:solidFill>
-            <a:srgbClr val="101014"/>
+            <a:srgbClr val="F8FAFC"/>
           </a:solidFill>
           <a:ln>
             <a:noFill/>
@@ -11223,7 +11789,7 @@
             <a:pPr>
               <a:defRPr sz="950" b="1">
                 <a:solidFill>
-                  <a:srgbClr val="FF6B00"/>
+                  <a:srgbClr val="D95500"/>
                 </a:solidFill>
                 <a:latin typeface="Arial Black"/>
               </a:defRPr>
@@ -11259,7 +11825,7 @@
             <a:pPr>
               <a:defRPr sz="2400" b="1">
                 <a:solidFill>
-                  <a:srgbClr val="FFFFFF"/>
+                  <a:srgbClr val="111827"/>
                 </a:solidFill>
                 <a:latin typeface="Arial Black"/>
               </a:defRPr>
@@ -11338,7 +11904,7 @@
             <a:pPr>
               <a:defRPr sz="850">
                 <a:solidFill>
-                  <a:srgbClr val="8C8C96"/>
+                  <a:srgbClr val="94A3B8"/>
                 </a:solidFill>
                 <a:latin typeface="Arial"/>
               </a:defRPr>
@@ -11364,11 +11930,11 @@
             <a:avLst/>
           </a:prstGeom>
           <a:solidFill>
-            <a:srgbClr val="1C1C22"/>
+            <a:srgbClr val="FFFFFF"/>
           </a:solidFill>
           <a:ln w="12700">
             <a:solidFill>
-              <a:srgbClr val="32323C"/>
+              <a:srgbClr val="E2E8F0"/>
             </a:solidFill>
           </a:ln>
         </p:spPr>
@@ -11419,7 +11985,7 @@
             <a:pPr>
               <a:defRPr sz="1200" b="1">
                 <a:solidFill>
-                  <a:srgbClr val="FF6B00"/>
+                  <a:srgbClr val="D95500"/>
                 </a:solidFill>
                 <a:latin typeface="Arial Black"/>
               </a:defRPr>
@@ -11435,7 +12001,7 @@
               </a:spcBef>
               <a:defRPr sz="950">
                 <a:solidFill>
-                  <a:srgbClr val="8C8C96"/>
+                  <a:srgbClr val="94A3B8"/>
                 </a:solidFill>
                 <a:latin typeface="Arial"/>
               </a:defRPr>
@@ -11451,7 +12017,7 @@
               </a:spcBef>
               <a:defRPr sz="900">
                 <a:solidFill>
-                  <a:srgbClr val="D2D2D7"/>
+                  <a:srgbClr val="475569"/>
                 </a:solidFill>
                 <a:latin typeface="Arial"/>
               </a:defRPr>
@@ -11467,13 +12033,13 @@
               </a:spcBef>
               <a:defRPr sz="900">
                 <a:solidFill>
-                  <a:srgbClr val="D2D2D7"/>
-                </a:solidFill>
-                <a:latin typeface="Arial"/>
-              </a:defRPr>
-            </a:pPr>
-            <a:r>
-              <a:t>• Hoogwaardige trainingsbatjes met professionele rubbers (voor maximale controle en spin).</a:t>
+                  <a:srgbClr val="475569"/>
+                </a:solidFill>
+                <a:latin typeface="Arial"/>
+              </a:defRPr>
+            </a:pPr>
+            <a:r>
+              <a:t>• Hoogwaardige trainingsbatjes met professionele rubbers (maximale controle en spin).</a:t>
             </a:r>
           </a:p>
           <a:p>
@@ -11483,7 +12049,7 @@
               </a:spcBef>
               <a:defRPr sz="900">
                 <a:solidFill>
-                  <a:srgbClr val="D2D2D7"/>
+                  <a:srgbClr val="475569"/>
                 </a:solidFill>
                 <a:latin typeface="Arial"/>
               </a:defRPr>
@@ -11499,7 +12065,7 @@
               </a:spcBef>
               <a:defRPr sz="900">
                 <a:solidFill>
-                  <a:srgbClr val="D2D2D7"/>
+                  <a:srgbClr val="475569"/>
                 </a:solidFill>
                 <a:latin typeface="Arial"/>
               </a:defRPr>
@@ -11525,11 +12091,11 @@
             <a:avLst/>
           </a:prstGeom>
           <a:solidFill>
-            <a:srgbClr val="1C1C22"/>
+            <a:srgbClr val="FFFFFF"/>
           </a:solidFill>
           <a:ln w="12700">
             <a:solidFill>
-              <a:srgbClr val="32323C"/>
+              <a:srgbClr val="E2E8F0"/>
             </a:solidFill>
           </a:ln>
         </p:spPr>
@@ -11580,7 +12146,7 @@
             <a:pPr>
               <a:defRPr sz="1200" b="1">
                 <a:solidFill>
-                  <a:srgbClr val="FF6B00"/>
+                  <a:srgbClr val="D95500"/>
                 </a:solidFill>
                 <a:latin typeface="Arial Black"/>
               </a:defRPr>
@@ -11596,7 +12162,7 @@
               </a:spcBef>
               <a:defRPr sz="950">
                 <a:solidFill>
-                  <a:srgbClr val="8C8C96"/>
+                  <a:srgbClr val="94A3B8"/>
                 </a:solidFill>
                 <a:latin typeface="Arial"/>
               </a:defRPr>
@@ -11612,13 +12178,13 @@
               </a:spcBef>
               <a:defRPr sz="900">
                 <a:solidFill>
-                  <a:srgbClr val="D2D2D7"/>
-                </a:solidFill>
-                <a:latin typeface="Arial"/>
-              </a:defRPr>
-            </a:pPr>
-            <a:r>
-              <a:t>• Kantoor/Bedrijfskantine: Wij transformeren elke vergaderzaal of kantine in 20 minuten tot toernooiarena.</a:t>
+                  <a:srgbClr val="475569"/>
+                </a:solidFill>
+                <a:latin typeface="Arial"/>
+              </a:defRPr>
+            </a:pPr>
+            <a:r>
+              <a:t>• Kantoor/Bedrijfskantine: Transformatie in 20 minuten tot toernooiarena.</a:t>
             </a:r>
           </a:p>
           <a:p>
@@ -11628,13 +12194,13 @@
               </a:spcBef>
               <a:defRPr sz="900">
                 <a:solidFill>
-                  <a:srgbClr val="D2D2D7"/>
-                </a:solidFill>
-                <a:latin typeface="Arial"/>
-              </a:defRPr>
-            </a:pPr>
-            <a:r>
-              <a:t>• Sportaccommodaties: Vaste afspraken met zalen inclusief kleedkamers en afsluitende horeca/borrel.</a:t>
+                  <a:srgbClr val="475569"/>
+                </a:solidFill>
+                <a:latin typeface="Arial"/>
+              </a:defRPr>
+            </a:pPr>
+            <a:r>
+              <a:t>• Sportaccommodaties: Vaste afspraken met zalen inclusief kleedkamers en afsluitende borrel.</a:t>
             </a:r>
           </a:p>
           <a:p>
@@ -11644,7 +12210,7 @@
               </a:spcBef>
               <a:defRPr sz="900">
                 <a:solidFill>
-                  <a:srgbClr val="D2D2D7"/>
+                  <a:srgbClr val="475569"/>
                 </a:solidFill>
                 <a:latin typeface="Arial"/>
               </a:defRPr>
@@ -11670,11 +12236,11 @@
             <a:avLst/>
           </a:prstGeom>
           <a:solidFill>
-            <a:srgbClr val="1C1C22"/>
+            <a:srgbClr val="FFFFFF"/>
           </a:solidFill>
           <a:ln w="12700">
             <a:solidFill>
-              <a:srgbClr val="32323C"/>
+              <a:srgbClr val="E2E8F0"/>
             </a:solidFill>
           </a:ln>
         </p:spPr>
@@ -11725,7 +12291,7 @@
             <a:pPr>
               <a:defRPr sz="1200" b="1">
                 <a:solidFill>
-                  <a:srgbClr val="FF6B00"/>
+                  <a:srgbClr val="D95500"/>
                 </a:solidFill>
                 <a:latin typeface="Arial Black"/>
               </a:defRPr>
@@ -11741,7 +12307,7 @@
               </a:spcBef>
               <a:defRPr sz="950">
                 <a:solidFill>
-                  <a:srgbClr val="8C8C96"/>
+                  <a:srgbClr val="94A3B8"/>
                 </a:solidFill>
                 <a:latin typeface="Arial"/>
               </a:defRPr>
@@ -11757,7 +12323,7 @@
               </a:spcBef>
               <a:defRPr sz="900">
                 <a:solidFill>
-                  <a:srgbClr val="D2D2D7"/>
+                  <a:srgbClr val="475569"/>
                 </a:solidFill>
                 <a:latin typeface="Arial"/>
               </a:defRPr>
@@ -11773,13 +12339,13 @@
               </a:spcBef>
               <a:defRPr sz="900">
                 <a:solidFill>
-                  <a:srgbClr val="D2D2D7"/>
-                </a:solidFill>
-                <a:latin typeface="Arial"/>
-              </a:defRPr>
-            </a:pPr>
-            <a:r>
-              <a:t>• Pool van ervaren competitiespelers en gediplomeerde gasttrainers voor piekmomenten.</a:t>
+                  <a:srgbClr val="475569"/>
+                </a:solidFill>
+                <a:latin typeface="Arial"/>
+              </a:defRPr>
+            </a:pPr>
+            <a:r>
+              <a:t>• Pool van ervaren competitiespelers en gediplomeerde trainers voor piekmomenten.</a:t>
             </a:r>
           </a:p>
           <a:p>
@@ -11789,13 +12355,13 @@
               </a:spcBef>
               <a:defRPr sz="900">
                 <a:solidFill>
-                  <a:srgbClr val="D2D2D7"/>
-                </a:solidFill>
-                <a:latin typeface="Arial"/>
-              </a:defRPr>
-            </a:pPr>
-            <a:r>
-              <a:t>• Standaard clinic-draaiboek garandeert consistente kwaliteit en hoge klanttevredenheid.</a:t>
+                  <a:srgbClr val="475569"/>
+                </a:solidFill>
+                <a:latin typeface="Arial"/>
+              </a:defRPr>
+            </a:pPr>
+            <a:r>
+              <a:t>• Standaard clinic-draaiboek garandeert consistente kwaliteit en enthousiasme.</a:t>
             </a:r>
           </a:p>
         </p:txBody>
@@ -11815,11 +12381,11 @@
             <a:avLst/>
           </a:prstGeom>
           <a:solidFill>
-            <a:srgbClr val="1C1C22"/>
+            <a:srgbClr val="FFFFFF"/>
           </a:solidFill>
           <a:ln w="12700">
             <a:solidFill>
-              <a:srgbClr val="32323C"/>
+              <a:srgbClr val="E2E8F0"/>
             </a:solidFill>
           </a:ln>
         </p:spPr>
@@ -11870,7 +12436,7 @@
             <a:pPr>
               <a:defRPr sz="1200" b="1">
                 <a:solidFill>
-                  <a:srgbClr val="FF6B00"/>
+                  <a:srgbClr val="D95500"/>
                 </a:solidFill>
                 <a:latin typeface="Arial Black"/>
               </a:defRPr>
@@ -11886,7 +12452,7 @@
               </a:spcBef>
               <a:defRPr sz="950">
                 <a:solidFill>
-                  <a:srgbClr val="8C8C96"/>
+                  <a:srgbClr val="94A3B8"/>
                 </a:solidFill>
                 <a:latin typeface="Arial"/>
               </a:defRPr>
@@ -11902,7 +12468,7 @@
               </a:spcBef>
               <a:defRPr sz="900">
                 <a:solidFill>
-                  <a:srgbClr val="D2D2D7"/>
+                  <a:srgbClr val="475569"/>
                 </a:solidFill>
                 <a:latin typeface="Arial"/>
               </a:defRPr>
@@ -11918,7 +12484,7 @@
               </a:spcBef>
               <a:defRPr sz="900">
                 <a:solidFill>
-                  <a:srgbClr val="D2D2D7"/>
+                  <a:srgbClr val="475569"/>
                 </a:solidFill>
                 <a:latin typeface="Arial"/>
               </a:defRPr>
@@ -11934,7 +12500,7 @@
               </a:spcBef>
               <a:defRPr sz="900">
                 <a:solidFill>
-                  <a:srgbClr val="D2D2D7"/>
+                  <a:srgbClr val="475569"/>
                 </a:solidFill>
                 <a:latin typeface="Arial"/>
               </a:defRPr>
@@ -11950,7 +12516,7 @@
               </a:spcBef>
               <a:defRPr sz="900">
                 <a:solidFill>
-                  <a:srgbClr val="D2D2D7"/>
+                  <a:srgbClr val="475569"/>
                 </a:solidFill>
                 <a:latin typeface="Arial"/>
               </a:defRPr>

</xml_diff>

<commit_message>
Enlarge typography and increase slide inner margins for optimal readability and breathing room
</commit_message>
<xml_diff>
--- a/TT_Clinics_Bedrijfsplan.pptx
+++ b/TT_Clinics_Bedrijfsplan.pptx
@@ -3243,8 +3243,8 @@
         </p:blipFill>
         <p:spPr>
           <a:xfrm>
-            <a:off x="1097280" y="1097280"/>
-            <a:ext cx="1252025" cy="1188720"/>
+            <a:off x="1554480" y="1005840"/>
+            <a:ext cx="1348334" cy="1280160"/>
           </a:xfrm>
           <a:prstGeom prst="rect">
             <a:avLst/>
@@ -3259,8 +3259,8 @@
         </p:nvSpPr>
         <p:spPr>
           <a:xfrm>
-            <a:off x="1097280" y="2651760"/>
-            <a:ext cx="3291840" cy="365760"/>
+            <a:off x="1554480" y="2560320"/>
+            <a:ext cx="3657600" cy="402336"/>
           </a:xfrm>
           <a:prstGeom prst="roundRect">
             <a:avLst/>
@@ -3268,7 +3268,7 @@
           <a:solidFill>
             <a:srgbClr val="FFF3EB"/>
           </a:solidFill>
-          <a:ln w="12700">
+          <a:ln w="15240">
             <a:solidFill>
               <a:srgbClr val="FF6B00"/>
             </a:solidFill>
@@ -3289,11 +3289,11 @@
           </a:fontRef>
         </p:style>
         <p:txBody>
-          <a:bodyPr rtlCol="0" anchor="ctr" tIns="54864"/>
+          <a:bodyPr rtlCol="0" anchor="ctr" tIns="64008"/>
           <a:lstStyle/>
           <a:p>
             <a:pPr algn="ctr">
-              <a:defRPr sz="950" b="1">
+              <a:defRPr sz="1100" b="1">
                 <a:solidFill>
                   <a:srgbClr val="D95500"/>
                 </a:solidFill>
@@ -3314,8 +3314,8 @@
         </p:nvSpPr>
         <p:spPr>
           <a:xfrm>
-            <a:off x="1097280" y="3154680"/>
-            <a:ext cx="9144000" cy="1645920"/>
+            <a:off x="1554480" y="3127248"/>
+            <a:ext cx="9144000" cy="1828800"/>
           </a:xfrm>
           <a:prstGeom prst="rect">
             <a:avLst/>
@@ -3329,7 +3329,7 @@
           <a:lstStyle/>
           <a:p>
             <a:pPr>
-              <a:defRPr sz="4000" b="1">
+              <a:defRPr sz="4400" b="1">
                 <a:solidFill>
                   <a:srgbClr val="111827"/>
                 </a:solidFill>
@@ -3345,7 +3345,7 @@
               <a:spcBef>
                 <a:spcPts val="800"/>
               </a:spcBef>
-              <a:defRPr sz="2000" b="1">
+              <a:defRPr sz="2200" b="1">
                 <a:solidFill>
                   <a:srgbClr val="FF6B00"/>
                 </a:solidFill>
@@ -3366,8 +3366,8 @@
         </p:nvSpPr>
         <p:spPr>
           <a:xfrm>
-            <a:off x="1097280" y="4937760"/>
-            <a:ext cx="7315200" cy="1280160"/>
+            <a:off x="1554480" y="4983480"/>
+            <a:ext cx="7772400" cy="1280160"/>
           </a:xfrm>
           <a:prstGeom prst="rect">
             <a:avLst/>
@@ -3381,7 +3381,7 @@
           <a:lstStyle/>
           <a:p>
             <a:pPr>
-              <a:defRPr sz="1300" b="1">
+              <a:defRPr sz="1400" b="1">
                 <a:solidFill>
                   <a:srgbClr val="1E293B"/>
                 </a:solidFill>
@@ -3395,9 +3395,9 @@
           <a:p>
             <a:pPr>
               <a:spcBef>
-                <a:spcPts val="400"/>
-              </a:spcBef>
-              <a:defRPr sz="1100">
+                <a:spcPts val="500"/>
+              </a:spcBef>
+              <a:defRPr sz="1200">
                 <a:solidFill>
                   <a:srgbClr val="94A3B8"/>
                 </a:solidFill>
@@ -3426,8 +3426,8 @@
         </p:blipFill>
         <p:spPr>
           <a:xfrm>
-            <a:off x="9326880" y="3474720"/>
-            <a:ext cx="1828800" cy="1828800"/>
+            <a:off x="8961120" y="3474720"/>
+            <a:ext cx="1920240" cy="1920240"/>
           </a:xfrm>
           <a:prstGeom prst="rect">
             <a:avLst/>
@@ -3554,8 +3554,8 @@
         </p:blipFill>
         <p:spPr>
           <a:xfrm>
-            <a:off x="10241280" y="365760"/>
-            <a:ext cx="626012" cy="594360"/>
+            <a:off x="9509760" y="438912"/>
+            <a:ext cx="693429" cy="658368"/>
           </a:xfrm>
           <a:prstGeom prst="rect">
             <a:avLst/>
@@ -3570,8 +3570,8 @@
         </p:nvSpPr>
         <p:spPr>
           <a:xfrm>
-            <a:off x="731520" y="320040"/>
-            <a:ext cx="7315200" cy="320040"/>
+            <a:off x="1280160" y="438912"/>
+            <a:ext cx="7772400" cy="320040"/>
           </a:xfrm>
           <a:prstGeom prst="rect">
             <a:avLst/>
@@ -3585,7 +3585,7 @@
           <a:lstStyle/>
           <a:p>
             <a:pPr>
-              <a:defRPr sz="950" b="1">
+              <a:defRPr sz="1100" b="1">
                 <a:solidFill>
                   <a:srgbClr val="D95500"/>
                 </a:solidFill>
@@ -3606,8 +3606,8 @@
         </p:nvSpPr>
         <p:spPr>
           <a:xfrm>
-            <a:off x="731520" y="594360"/>
-            <a:ext cx="9144000" cy="731520"/>
+            <a:off x="1280160" y="749808"/>
+            <a:ext cx="8412480" cy="731520"/>
           </a:xfrm>
           <a:prstGeom prst="rect">
             <a:avLst/>
@@ -3621,7 +3621,7 @@
           <a:lstStyle/>
           <a:p>
             <a:pPr>
-              <a:defRPr sz="2400" b="1">
+              <a:defRPr sz="2600" b="1">
                 <a:solidFill>
                   <a:srgbClr val="111827"/>
                 </a:solidFill>
@@ -3642,8 +3642,8 @@
         </p:nvSpPr>
         <p:spPr>
           <a:xfrm>
-            <a:off x="731520" y="1353312"/>
-            <a:ext cx="4114800" cy="36576"/>
+            <a:off x="1280160" y="1536192"/>
+            <a:ext cx="4572000" cy="41148"/>
           </a:xfrm>
           <a:prstGeom prst="rect">
             <a:avLst/>
@@ -3685,8 +3685,8 @@
         </p:nvSpPr>
         <p:spPr>
           <a:xfrm>
-            <a:off x="731520" y="6446520"/>
-            <a:ext cx="10728655" cy="274320"/>
+            <a:off x="1280160" y="6291072"/>
+            <a:ext cx="9631375" cy="274320"/>
           </a:xfrm>
           <a:prstGeom prst="rect">
             <a:avLst/>
@@ -3700,7 +3700,7 @@
           <a:lstStyle/>
           <a:p>
             <a:pPr>
-              <a:defRPr sz="850">
+              <a:defRPr sz="950">
                 <a:solidFill>
                   <a:srgbClr val="94A3B8"/>
                 </a:solidFill>
@@ -3721,8 +3721,8 @@
         </p:nvSpPr>
         <p:spPr>
           <a:xfrm>
-            <a:off x="731520" y="1645920"/>
-            <a:ext cx="3456432" cy="4572000"/>
+            <a:off x="1280160" y="1755648"/>
+            <a:ext cx="2999232" cy="4462272"/>
           </a:xfrm>
           <a:prstGeom prst="roundRect">
             <a:avLst/>
@@ -3730,7 +3730,7 @@
           <a:solidFill>
             <a:srgbClr val="FFFFFF"/>
           </a:solidFill>
-          <a:ln w="12700">
+          <a:ln w="15240">
             <a:solidFill>
               <a:srgbClr val="E2E8F0"/>
             </a:solidFill>
@@ -3774,8 +3774,8 @@
         </p:blipFill>
         <p:spPr>
           <a:xfrm>
-            <a:off x="3364992" y="1828800"/>
-            <a:ext cx="640080" cy="640080"/>
+            <a:off x="3502152" y="1938528"/>
+            <a:ext cx="621792" cy="621792"/>
           </a:xfrm>
           <a:prstGeom prst="rect">
             <a:avLst/>
@@ -3790,8 +3790,8 @@
         </p:nvSpPr>
         <p:spPr>
           <a:xfrm>
-            <a:off x="960120" y="1874520"/>
-            <a:ext cx="2999232" cy="4114800"/>
+            <a:off x="1508760" y="1984248"/>
+            <a:ext cx="2542032" cy="4096512"/>
           </a:xfrm>
           <a:prstGeom prst="rect">
             <a:avLst/>
@@ -3805,7 +3805,7 @@
           <a:lstStyle/>
           <a:p>
             <a:pPr>
-              <a:defRPr sz="1150" b="1">
+              <a:defRPr sz="1200" b="1">
                 <a:solidFill>
                   <a:srgbClr val="1E293B"/>
                 </a:solidFill>
@@ -3821,30 +3821,30 @@
               <a:spcBef>
                 <a:spcPts val="200"/>
               </a:spcBef>
+              <a:defRPr sz="1400" b="1">
+                <a:solidFill>
+                  <a:srgbClr val="111827"/>
+                </a:solidFill>
+                <a:latin typeface="Arial Black"/>
+              </a:defRPr>
+            </a:pPr>
+            <a:r>
+              <a:t>Fundament &amp; Tractie</a:t>
+            </a:r>
+          </a:p>
+          <a:p>
+            <a:pPr>
+              <a:spcBef>
+                <a:spcPts val="400"/>
+              </a:spcBef>
               <a:defRPr sz="1300" b="1">
                 <a:solidFill>
-                  <a:srgbClr val="111827"/>
+                  <a:srgbClr val="FF6B00"/>
                 </a:solidFill>
                 <a:latin typeface="Arial Black"/>
               </a:defRPr>
             </a:pPr>
             <a:r>
-              <a:t>Fundament &amp; Tractie</a:t>
-            </a:r>
-          </a:p>
-          <a:p>
-            <a:pPr>
-              <a:spcBef>
-                <a:spcPts val="400"/>
-              </a:spcBef>
-              <a:defRPr sz="1200" b="1">
-                <a:solidFill>
-                  <a:srgbClr val="FF6B00"/>
-                </a:solidFill>
-                <a:latin typeface="Arial Black"/>
-              </a:defRPr>
-            </a:pPr>
-            <a:r>
               <a:t>Omzetdoel: €25.000 - €35.000</a:t>
             </a:r>
           </a:p>
@@ -3868,7 +3868,7 @@
               <a:spcBef>
                 <a:spcPts val="600"/>
               </a:spcBef>
-              <a:defRPr sz="950">
+              <a:defRPr sz="1100">
                 <a:solidFill>
                   <a:srgbClr val="475569"/>
                 </a:solidFill>
@@ -3884,7 +3884,7 @@
               <a:spcBef>
                 <a:spcPts val="600"/>
               </a:spcBef>
-              <a:defRPr sz="950">
+              <a:defRPr sz="1100">
                 <a:solidFill>
                   <a:srgbClr val="475569"/>
                 </a:solidFill>
@@ -3900,7 +3900,7 @@
               <a:spcBef>
                 <a:spcPts val="600"/>
               </a:spcBef>
-              <a:defRPr sz="950">
+              <a:defRPr sz="1100">
                 <a:solidFill>
                   <a:srgbClr val="475569"/>
                 </a:solidFill>
@@ -3916,7 +3916,7 @@
               <a:spcBef>
                 <a:spcPts val="600"/>
               </a:spcBef>
-              <a:defRPr sz="950">
+              <a:defRPr sz="1100">
                 <a:solidFill>
                   <a:srgbClr val="475569"/>
                 </a:solidFill>
@@ -3932,7 +3932,7 @@
               <a:spcBef>
                 <a:spcPts val="600"/>
               </a:spcBef>
-              <a:defRPr sz="950">
+              <a:defRPr sz="1100">
                 <a:solidFill>
                   <a:srgbClr val="475569"/>
                 </a:solidFill>
@@ -3953,8 +3953,8 @@
         </p:nvSpPr>
         <p:spPr>
           <a:xfrm>
-            <a:off x="4370832" y="1645920"/>
-            <a:ext cx="3456432" cy="4572000"/>
+            <a:off x="4590288" y="1755648"/>
+            <a:ext cx="2999232" cy="4462272"/>
           </a:xfrm>
           <a:prstGeom prst="roundRect">
             <a:avLst/>
@@ -3962,7 +3962,7 @@
           <a:solidFill>
             <a:srgbClr val="FFF8F2"/>
           </a:solidFill>
-          <a:ln w="12700">
+          <a:ln w="15240">
             <a:solidFill>
               <a:srgbClr val="FF6B00"/>
             </a:solidFill>
@@ -3998,8 +3998,8 @@
         </p:nvSpPr>
         <p:spPr>
           <a:xfrm>
-            <a:off x="4370832" y="1645920"/>
-            <a:ext cx="3456432" cy="73152"/>
+            <a:off x="4590288" y="1755648"/>
+            <a:ext cx="2999232" cy="73152"/>
           </a:xfrm>
           <a:prstGeom prst="rect">
             <a:avLst/>
@@ -4049,8 +4049,8 @@
         </p:blipFill>
         <p:spPr>
           <a:xfrm>
-            <a:off x="7004304" y="1828800"/>
-            <a:ext cx="640080" cy="640080"/>
+            <a:off x="6812280" y="1938528"/>
+            <a:ext cx="621792" cy="621792"/>
           </a:xfrm>
           <a:prstGeom prst="rect">
             <a:avLst/>
@@ -4065,8 +4065,8 @@
         </p:nvSpPr>
         <p:spPr>
           <a:xfrm>
-            <a:off x="4599432" y="1874520"/>
-            <a:ext cx="2999232" cy="4114800"/>
+            <a:off x="4818888" y="1984248"/>
+            <a:ext cx="2542032" cy="4096512"/>
           </a:xfrm>
           <a:prstGeom prst="rect">
             <a:avLst/>
@@ -4080,7 +4080,7 @@
           <a:lstStyle/>
           <a:p>
             <a:pPr>
-              <a:defRPr sz="1150" b="1">
+              <a:defRPr sz="1200" b="1">
                 <a:solidFill>
                   <a:srgbClr val="D95500"/>
                 </a:solidFill>
@@ -4096,30 +4096,30 @@
               <a:spcBef>
                 <a:spcPts val="200"/>
               </a:spcBef>
+              <a:defRPr sz="1400" b="1">
+                <a:solidFill>
+                  <a:srgbClr val="111827"/>
+                </a:solidFill>
+                <a:latin typeface="Arial Black"/>
+              </a:defRPr>
+            </a:pPr>
+            <a:r>
+              <a:t>Opschaling &amp; Abonnementen</a:t>
+            </a:r>
+          </a:p>
+          <a:p>
+            <a:pPr>
+              <a:spcBef>
+                <a:spcPts val="400"/>
+              </a:spcBef>
               <a:defRPr sz="1300" b="1">
                 <a:solidFill>
-                  <a:srgbClr val="111827"/>
+                  <a:srgbClr val="FF6B00"/>
                 </a:solidFill>
                 <a:latin typeface="Arial Black"/>
               </a:defRPr>
             </a:pPr>
             <a:r>
-              <a:t>Opschaling &amp; Abonnementen</a:t>
-            </a:r>
-          </a:p>
-          <a:p>
-            <a:pPr>
-              <a:spcBef>
-                <a:spcPts val="400"/>
-              </a:spcBef>
-              <a:defRPr sz="1200" b="1">
-                <a:solidFill>
-                  <a:srgbClr val="FF6B00"/>
-                </a:solidFill>
-                <a:latin typeface="Arial Black"/>
-              </a:defRPr>
-            </a:pPr>
-            <a:r>
               <a:t>Omzetdoel: €60.000 - €75.000</a:t>
             </a:r>
           </a:p>
@@ -4143,7 +4143,7 @@
               <a:spcBef>
                 <a:spcPts val="600"/>
               </a:spcBef>
-              <a:defRPr sz="950">
+              <a:defRPr sz="1100">
                 <a:solidFill>
                   <a:srgbClr val="475569"/>
                 </a:solidFill>
@@ -4159,7 +4159,7 @@
               <a:spcBef>
                 <a:spcPts val="600"/>
               </a:spcBef>
-              <a:defRPr sz="950">
+              <a:defRPr sz="1100">
                 <a:solidFill>
                   <a:srgbClr val="475569"/>
                 </a:solidFill>
@@ -4175,7 +4175,7 @@
               <a:spcBef>
                 <a:spcPts val="600"/>
               </a:spcBef>
-              <a:defRPr sz="950">
+              <a:defRPr sz="1100">
                 <a:solidFill>
                   <a:srgbClr val="475569"/>
                 </a:solidFill>
@@ -4191,7 +4191,7 @@
               <a:spcBef>
                 <a:spcPts val="600"/>
               </a:spcBef>
-              <a:defRPr sz="950">
+              <a:defRPr sz="1100">
                 <a:solidFill>
                   <a:srgbClr val="475569"/>
                 </a:solidFill>
@@ -4207,7 +4207,7 @@
               <a:spcBef>
                 <a:spcPts val="600"/>
               </a:spcBef>
-              <a:defRPr sz="950">
+              <a:defRPr sz="1100">
                 <a:solidFill>
                   <a:srgbClr val="475569"/>
                 </a:solidFill>
@@ -4228,8 +4228,8 @@
         </p:nvSpPr>
         <p:spPr>
           <a:xfrm>
-            <a:off x="8010144" y="1645920"/>
-            <a:ext cx="3456432" cy="4572000"/>
+            <a:off x="7900416" y="1755648"/>
+            <a:ext cx="2999232" cy="4462272"/>
           </a:xfrm>
           <a:prstGeom prst="roundRect">
             <a:avLst/>
@@ -4237,7 +4237,7 @@
           <a:solidFill>
             <a:srgbClr val="FFFFFF"/>
           </a:solidFill>
-          <a:ln w="12700">
+          <a:ln w="15240">
             <a:solidFill>
               <a:srgbClr val="E2E8F0"/>
             </a:solidFill>
@@ -4281,8 +4281,8 @@
         </p:blipFill>
         <p:spPr>
           <a:xfrm>
-            <a:off x="10643616" y="1828800"/>
-            <a:ext cx="640080" cy="640080"/>
+            <a:off x="10122408" y="1938528"/>
+            <a:ext cx="621792" cy="621792"/>
           </a:xfrm>
           <a:prstGeom prst="rect">
             <a:avLst/>
@@ -4297,8 +4297,8 @@
         </p:nvSpPr>
         <p:spPr>
           <a:xfrm>
-            <a:off x="8238744" y="1874520"/>
-            <a:ext cx="2999232" cy="4114800"/>
+            <a:off x="8129016" y="1984248"/>
+            <a:ext cx="2542032" cy="4096512"/>
           </a:xfrm>
           <a:prstGeom prst="rect">
             <a:avLst/>
@@ -4312,7 +4312,7 @@
           <a:lstStyle/>
           <a:p>
             <a:pPr>
-              <a:defRPr sz="1150" b="1">
+              <a:defRPr sz="1200" b="1">
                 <a:solidFill>
                   <a:srgbClr val="1E293B"/>
                 </a:solidFill>
@@ -4328,30 +4328,30 @@
               <a:spcBef>
                 <a:spcPts val="200"/>
               </a:spcBef>
+              <a:defRPr sz="1400" b="1">
+                <a:solidFill>
+                  <a:srgbClr val="111827"/>
+                </a:solidFill>
+                <a:latin typeface="Arial Black"/>
+              </a:defRPr>
+            </a:pPr>
+            <a:r>
+              <a:t>Landelijke Autoriteit</a:t>
+            </a:r>
+          </a:p>
+          <a:p>
+            <a:pPr>
+              <a:spcBef>
+                <a:spcPts val="400"/>
+              </a:spcBef>
               <a:defRPr sz="1300" b="1">
                 <a:solidFill>
-                  <a:srgbClr val="111827"/>
+                  <a:srgbClr val="FF6B00"/>
                 </a:solidFill>
                 <a:latin typeface="Arial Black"/>
               </a:defRPr>
             </a:pPr>
             <a:r>
-              <a:t>Landelijke Autoriteit</a:t>
-            </a:r>
-          </a:p>
-          <a:p>
-            <a:pPr>
-              <a:spcBef>
-                <a:spcPts val="400"/>
-              </a:spcBef>
-              <a:defRPr sz="1200" b="1">
-                <a:solidFill>
-                  <a:srgbClr val="FF6B00"/>
-                </a:solidFill>
-                <a:latin typeface="Arial Black"/>
-              </a:defRPr>
-            </a:pPr>
-            <a:r>
               <a:t>Omzetdoel: €100.000+</a:t>
             </a:r>
           </a:p>
@@ -4375,7 +4375,7 @@
               <a:spcBef>
                 <a:spcPts val="600"/>
               </a:spcBef>
-              <a:defRPr sz="950">
+              <a:defRPr sz="1100">
                 <a:solidFill>
                   <a:srgbClr val="475569"/>
                 </a:solidFill>
@@ -4391,7 +4391,7 @@
               <a:spcBef>
                 <a:spcPts val="600"/>
               </a:spcBef>
-              <a:defRPr sz="950">
+              <a:defRPr sz="1100">
                 <a:solidFill>
                   <a:srgbClr val="475569"/>
                 </a:solidFill>
@@ -4407,7 +4407,7 @@
               <a:spcBef>
                 <a:spcPts val="600"/>
               </a:spcBef>
-              <a:defRPr sz="950">
+              <a:defRPr sz="1100">
                 <a:solidFill>
                   <a:srgbClr val="475569"/>
                 </a:solidFill>
@@ -4423,7 +4423,7 @@
               <a:spcBef>
                 <a:spcPts val="600"/>
               </a:spcBef>
-              <a:defRPr sz="950">
+              <a:defRPr sz="1100">
                 <a:solidFill>
                   <a:srgbClr val="475569"/>
                 </a:solidFill>
@@ -4439,7 +4439,7 @@
               <a:spcBef>
                 <a:spcPts val="600"/>
               </a:spcBef>
-              <a:defRPr sz="950">
+              <a:defRPr sz="1100">
                 <a:solidFill>
                   <a:srgbClr val="475569"/>
                 </a:solidFill>
@@ -4572,8 +4572,8 @@
         </p:blipFill>
         <p:spPr>
           <a:xfrm>
-            <a:off x="10241280" y="365760"/>
-            <a:ext cx="626012" cy="594360"/>
+            <a:off x="9509760" y="438912"/>
+            <a:ext cx="693429" cy="658368"/>
           </a:xfrm>
           <a:prstGeom prst="rect">
             <a:avLst/>
@@ -4588,8 +4588,8 @@
         </p:nvSpPr>
         <p:spPr>
           <a:xfrm>
-            <a:off x="731520" y="320040"/>
-            <a:ext cx="7315200" cy="320040"/>
+            <a:off x="1280160" y="438912"/>
+            <a:ext cx="7772400" cy="320040"/>
           </a:xfrm>
           <a:prstGeom prst="rect">
             <a:avLst/>
@@ -4603,7 +4603,7 @@
           <a:lstStyle/>
           <a:p>
             <a:pPr>
-              <a:defRPr sz="950" b="1">
+              <a:defRPr sz="1100" b="1">
                 <a:solidFill>
                   <a:srgbClr val="D95500"/>
                 </a:solidFill>
@@ -4624,8 +4624,8 @@
         </p:nvSpPr>
         <p:spPr>
           <a:xfrm>
-            <a:off x="731520" y="594360"/>
-            <a:ext cx="9144000" cy="731520"/>
+            <a:off x="1280160" y="749808"/>
+            <a:ext cx="8412480" cy="731520"/>
           </a:xfrm>
           <a:prstGeom prst="rect">
             <a:avLst/>
@@ -4639,7 +4639,7 @@
           <a:lstStyle/>
           <a:p>
             <a:pPr>
-              <a:defRPr sz="2400" b="1">
+              <a:defRPr sz="2600" b="1">
                 <a:solidFill>
                   <a:srgbClr val="111827"/>
                 </a:solidFill>
@@ -4660,8 +4660,8 @@
         </p:nvSpPr>
         <p:spPr>
           <a:xfrm>
-            <a:off x="731520" y="1353312"/>
-            <a:ext cx="4114800" cy="36576"/>
+            <a:off x="1280160" y="1536192"/>
+            <a:ext cx="4572000" cy="41148"/>
           </a:xfrm>
           <a:prstGeom prst="rect">
             <a:avLst/>
@@ -4703,8 +4703,8 @@
         </p:nvSpPr>
         <p:spPr>
           <a:xfrm>
-            <a:off x="731520" y="6446520"/>
-            <a:ext cx="10728655" cy="274320"/>
+            <a:off x="1280160" y="6291072"/>
+            <a:ext cx="9631375" cy="274320"/>
           </a:xfrm>
           <a:prstGeom prst="rect">
             <a:avLst/>
@@ -4718,7 +4718,7 @@
           <a:lstStyle/>
           <a:p>
             <a:pPr>
-              <a:defRPr sz="850">
+              <a:defRPr sz="950">
                 <a:solidFill>
                   <a:srgbClr val="94A3B8"/>
                 </a:solidFill>
@@ -4739,8 +4739,8 @@
         </p:nvSpPr>
         <p:spPr>
           <a:xfrm>
-            <a:off x="731520" y="1645920"/>
-            <a:ext cx="6858000" cy="4572000"/>
+            <a:off x="1280160" y="1755648"/>
+            <a:ext cx="6263640" cy="4462272"/>
           </a:xfrm>
           <a:prstGeom prst="roundRect">
             <a:avLst/>
@@ -4748,7 +4748,7 @@
           <a:solidFill>
             <a:srgbClr val="FFFFFF"/>
           </a:solidFill>
-          <a:ln w="12700">
+          <a:ln w="15240">
             <a:solidFill>
               <a:srgbClr val="E2E8F0"/>
             </a:solidFill>
@@ -4784,8 +4784,8 @@
         </p:nvSpPr>
         <p:spPr>
           <a:xfrm>
-            <a:off x="731520" y="1645920"/>
-            <a:ext cx="6858000" cy="73152"/>
+            <a:off x="1280160" y="1755648"/>
+            <a:ext cx="6263640" cy="73152"/>
           </a:xfrm>
           <a:prstGeom prst="rect">
             <a:avLst/>
@@ -4835,7 +4835,7 @@
         </p:blipFill>
         <p:spPr>
           <a:xfrm>
-            <a:off x="1005840" y="2011680"/>
+            <a:off x="1600200" y="2057400"/>
             <a:ext cx="2011680" cy="1502866"/>
           </a:xfrm>
           <a:prstGeom prst="rect">
@@ -4851,8 +4851,8 @@
         </p:nvSpPr>
         <p:spPr>
           <a:xfrm>
-            <a:off x="3291840" y="1920240"/>
-            <a:ext cx="4023360" cy="3931920"/>
+            <a:off x="3840480" y="1965960"/>
+            <a:ext cx="3520440" cy="4096512"/>
           </a:xfrm>
           <a:prstGeom prst="rect">
             <a:avLst/>
@@ -4866,7 +4866,7 @@
           <a:lstStyle/>
           <a:p>
             <a:pPr>
-              <a:defRPr sz="1800" b="1">
+              <a:defRPr sz="2000" b="1">
                 <a:solidFill>
                   <a:srgbClr val="111827"/>
                 </a:solidFill>
@@ -4882,7 +4882,7 @@
               <a:spcBef>
                 <a:spcPts val="200"/>
               </a:spcBef>
-              <a:defRPr sz="1000" b="1">
+              <a:defRPr sz="1150" b="1">
                 <a:solidFill>
                   <a:srgbClr val="D95500"/>
                 </a:solidFill>
@@ -4898,7 +4898,7 @@
               <a:spcBef>
                 <a:spcPts val="1000"/>
               </a:spcBef>
-              <a:defRPr sz="1000" i="1">
+              <a:defRPr sz="1150" i="1">
                 <a:solidFill>
                   <a:srgbClr val="475569"/>
                 </a:solidFill>
@@ -4912,9 +4912,9 @@
           <a:p>
             <a:pPr>
               <a:spcBef>
-                <a:spcPts val="1200"/>
-              </a:spcBef>
-              <a:defRPr sz="950" b="1">
+                <a:spcPts val="1400"/>
+              </a:spcBef>
+              <a:defRPr sz="1050" b="1">
                 <a:solidFill>
                   <a:srgbClr val="D95500"/>
                 </a:solidFill>
@@ -4935,8 +4935,8 @@
         </p:nvSpPr>
         <p:spPr>
           <a:xfrm>
-            <a:off x="7818120" y="1645920"/>
-            <a:ext cx="3639312" cy="4572000"/>
+            <a:off x="7818120" y="1755648"/>
+            <a:ext cx="3090672" cy="4462272"/>
           </a:xfrm>
           <a:prstGeom prst="roundRect">
             <a:avLst/>
@@ -4944,7 +4944,7 @@
           <a:solidFill>
             <a:srgbClr val="FFFFFF"/>
           </a:solidFill>
-          <a:ln w="12700">
+          <a:ln w="15240">
             <a:solidFill>
               <a:srgbClr val="E2E8F0"/>
             </a:solidFill>
@@ -4980,8 +4980,8 @@
         </p:nvSpPr>
         <p:spPr>
           <a:xfrm>
-            <a:off x="7818120" y="1645920"/>
-            <a:ext cx="3639312" cy="73152"/>
+            <a:off x="7818120" y="1755648"/>
+            <a:ext cx="3090672" cy="73152"/>
           </a:xfrm>
           <a:prstGeom prst="rect">
             <a:avLst/>
@@ -5023,8 +5023,8 @@
         </p:nvSpPr>
         <p:spPr>
           <a:xfrm>
-            <a:off x="8092440" y="1920240"/>
-            <a:ext cx="3090672" cy="3931920"/>
+            <a:off x="8092440" y="1965960"/>
+            <a:ext cx="2542032" cy="4005072"/>
           </a:xfrm>
           <a:prstGeom prst="rect">
             <a:avLst/>
@@ -5038,7 +5038,7 @@
           <a:lstStyle/>
           <a:p>
             <a:pPr>
-              <a:defRPr sz="1400" b="1">
+              <a:defRPr sz="1500" b="1">
                 <a:solidFill>
                   <a:srgbClr val="111827"/>
                 </a:solidFill>
@@ -5054,7 +5054,7 @@
               <a:spcBef>
                 <a:spcPts val="600"/>
               </a:spcBef>
-              <a:defRPr sz="1000">
+              <a:defRPr sz="1150">
                 <a:solidFill>
                   <a:srgbClr val="475569"/>
                 </a:solidFill>
@@ -5070,7 +5070,7 @@
               <a:spcBef>
                 <a:spcPts val="600"/>
               </a:spcBef>
-              <a:defRPr sz="1000">
+              <a:defRPr sz="1150">
                 <a:solidFill>
                   <a:srgbClr val="475569"/>
                 </a:solidFill>
@@ -5086,7 +5086,7 @@
               <a:spcBef>
                 <a:spcPts val="600"/>
               </a:spcBef>
-              <a:defRPr sz="1000">
+              <a:defRPr sz="1150">
                 <a:solidFill>
                   <a:srgbClr val="475569"/>
                 </a:solidFill>
@@ -5102,7 +5102,7 @@
               <a:spcBef>
                 <a:spcPts val="600"/>
               </a:spcBef>
-              <a:defRPr sz="1000">
+              <a:defRPr sz="1150">
                 <a:solidFill>
                   <a:srgbClr val="475569"/>
                 </a:solidFill>
@@ -5131,8 +5131,8 @@
         </p:blipFill>
         <p:spPr>
           <a:xfrm>
-            <a:off x="8961120" y="4480560"/>
-            <a:ext cx="1371600" cy="1371600"/>
+            <a:off x="8641080" y="4297680"/>
+            <a:ext cx="1444752" cy="1444752"/>
           </a:xfrm>
           <a:prstGeom prst="rect">
             <a:avLst/>
@@ -5147,8 +5147,8 @@
         </p:nvSpPr>
         <p:spPr>
           <a:xfrm>
-            <a:off x="8092440" y="5943600"/>
-            <a:ext cx="3090672" cy="365760"/>
+            <a:off x="8001000" y="5806440"/>
+            <a:ext cx="2724912" cy="365760"/>
           </a:xfrm>
           <a:prstGeom prst="rect">
             <a:avLst/>
@@ -5162,7 +5162,7 @@
           <a:lstStyle/>
           <a:p>
             <a:pPr algn="ctr">
-              <a:defRPr sz="850">
+              <a:defRPr sz="950">
                 <a:solidFill>
                   <a:srgbClr val="94A3B8"/>
                 </a:solidFill>
@@ -5295,8 +5295,8 @@
         </p:blipFill>
         <p:spPr>
           <a:xfrm>
-            <a:off x="10241280" y="365760"/>
-            <a:ext cx="626012" cy="594360"/>
+            <a:off x="9509760" y="438912"/>
+            <a:ext cx="693429" cy="658368"/>
           </a:xfrm>
           <a:prstGeom prst="rect">
             <a:avLst/>
@@ -5311,8 +5311,8 @@
         </p:nvSpPr>
         <p:spPr>
           <a:xfrm>
-            <a:off x="731520" y="320040"/>
-            <a:ext cx="7315200" cy="320040"/>
+            <a:off x="1280160" y="438912"/>
+            <a:ext cx="7772400" cy="320040"/>
           </a:xfrm>
           <a:prstGeom prst="rect">
             <a:avLst/>
@@ -5326,7 +5326,7 @@
           <a:lstStyle/>
           <a:p>
             <a:pPr>
-              <a:defRPr sz="950" b="1">
+              <a:defRPr sz="1100" b="1">
                 <a:solidFill>
                   <a:srgbClr val="D95500"/>
                 </a:solidFill>
@@ -5347,8 +5347,8 @@
         </p:nvSpPr>
         <p:spPr>
           <a:xfrm>
-            <a:off x="731520" y="594360"/>
-            <a:ext cx="9144000" cy="731520"/>
+            <a:off x="1280160" y="749808"/>
+            <a:ext cx="8412480" cy="731520"/>
           </a:xfrm>
           <a:prstGeom prst="rect">
             <a:avLst/>
@@ -5362,7 +5362,7 @@
           <a:lstStyle/>
           <a:p>
             <a:pPr>
-              <a:defRPr sz="2400" b="1">
+              <a:defRPr sz="2600" b="1">
                 <a:solidFill>
                   <a:srgbClr val="111827"/>
                 </a:solidFill>
@@ -5383,8 +5383,8 @@
         </p:nvSpPr>
         <p:spPr>
           <a:xfrm>
-            <a:off x="731520" y="1353312"/>
-            <a:ext cx="4114800" cy="36576"/>
+            <a:off x="1280160" y="1536192"/>
+            <a:ext cx="4572000" cy="41148"/>
           </a:xfrm>
           <a:prstGeom prst="rect">
             <a:avLst/>
@@ -5426,8 +5426,8 @@
         </p:nvSpPr>
         <p:spPr>
           <a:xfrm>
-            <a:off x="731520" y="6446520"/>
-            <a:ext cx="10728655" cy="274320"/>
+            <a:off x="1280160" y="6291072"/>
+            <a:ext cx="9631375" cy="274320"/>
           </a:xfrm>
           <a:prstGeom prst="rect">
             <a:avLst/>
@@ -5441,7 +5441,7 @@
           <a:lstStyle/>
           <a:p>
             <a:pPr>
-              <a:defRPr sz="850">
+              <a:defRPr sz="950">
                 <a:solidFill>
                   <a:srgbClr val="94A3B8"/>
                 </a:solidFill>
@@ -5462,8 +5462,8 @@
         </p:nvSpPr>
         <p:spPr>
           <a:xfrm>
-            <a:off x="731520" y="1645920"/>
-            <a:ext cx="5257800" cy="2057400"/>
+            <a:off x="1280160" y="1755648"/>
+            <a:ext cx="4645152" cy="2121408"/>
           </a:xfrm>
           <a:prstGeom prst="roundRect">
             <a:avLst/>
@@ -5471,7 +5471,7 @@
           <a:solidFill>
             <a:srgbClr val="FFFFFF"/>
           </a:solidFill>
-          <a:ln w="12700">
+          <a:ln w="15240">
             <a:solidFill>
               <a:srgbClr val="E2E8F0"/>
             </a:solidFill>
@@ -5507,8 +5507,8 @@
         </p:nvSpPr>
         <p:spPr>
           <a:xfrm>
-            <a:off x="731520" y="1645920"/>
-            <a:ext cx="5257800" cy="73152"/>
+            <a:off x="1280160" y="1755648"/>
+            <a:ext cx="4645152" cy="73152"/>
           </a:xfrm>
           <a:prstGeom prst="rect">
             <a:avLst/>
@@ -5558,7 +5558,7 @@
         </p:blipFill>
         <p:spPr>
           <a:xfrm>
-            <a:off x="5166360" y="1874520"/>
+            <a:off x="5148072" y="1956816"/>
             <a:ext cx="594360" cy="594360"/>
           </a:xfrm>
           <a:prstGeom prst="rect">
@@ -5574,8 +5574,8 @@
         </p:nvSpPr>
         <p:spPr>
           <a:xfrm>
-            <a:off x="1005840" y="1874520"/>
-            <a:ext cx="4069080" cy="1600200"/>
+            <a:off x="1572768" y="1975104"/>
+            <a:ext cx="3639312" cy="1755648"/>
           </a:xfrm>
           <a:prstGeom prst="rect">
             <a:avLst/>
@@ -5589,7 +5589,7 @@
           <a:lstStyle/>
           <a:p>
             <a:pPr>
-              <a:defRPr sz="1300" b="1">
+              <a:defRPr sz="1400" b="1">
                 <a:solidFill>
                   <a:srgbClr val="D95500"/>
                 </a:solidFill>
@@ -5605,7 +5605,7 @@
               <a:spcBef>
                 <a:spcPts val="800"/>
               </a:spcBef>
-              <a:defRPr sz="1050">
+              <a:defRPr sz="1150">
                 <a:solidFill>
                   <a:srgbClr val="475569"/>
                 </a:solidFill>
@@ -5626,8 +5626,8 @@
         </p:nvSpPr>
         <p:spPr>
           <a:xfrm>
-            <a:off x="6172200" y="1645920"/>
-            <a:ext cx="5257800" cy="2057400"/>
+            <a:off x="6263640" y="1755648"/>
+            <a:ext cx="4645152" cy="2121408"/>
           </a:xfrm>
           <a:prstGeom prst="roundRect">
             <a:avLst/>
@@ -5635,7 +5635,7 @@
           <a:solidFill>
             <a:srgbClr val="FFFFFF"/>
           </a:solidFill>
-          <a:ln w="12700">
+          <a:ln w="15240">
             <a:solidFill>
               <a:srgbClr val="E2E8F0"/>
             </a:solidFill>
@@ -5671,8 +5671,8 @@
         </p:nvSpPr>
         <p:spPr>
           <a:xfrm>
-            <a:off x="6172200" y="1645920"/>
-            <a:ext cx="5257800" cy="73152"/>
+            <a:off x="6263640" y="1755648"/>
+            <a:ext cx="4645152" cy="73152"/>
           </a:xfrm>
           <a:prstGeom prst="rect">
             <a:avLst/>
@@ -5722,7 +5722,7 @@
         </p:blipFill>
         <p:spPr>
           <a:xfrm>
-            <a:off x="10607040" y="1874520"/>
+            <a:off x="10131552" y="1956816"/>
             <a:ext cx="594360" cy="594360"/>
           </a:xfrm>
           <a:prstGeom prst="rect">
@@ -5738,8 +5738,8 @@
         </p:nvSpPr>
         <p:spPr>
           <a:xfrm>
-            <a:off x="6446520" y="1874520"/>
-            <a:ext cx="4069080" cy="1600200"/>
+            <a:off x="6556248" y="1975104"/>
+            <a:ext cx="3639312" cy="1755648"/>
           </a:xfrm>
           <a:prstGeom prst="rect">
             <a:avLst/>
@@ -5753,7 +5753,7 @@
           <a:lstStyle/>
           <a:p>
             <a:pPr>
-              <a:defRPr sz="1300" b="1">
+              <a:defRPr sz="1400" b="1">
                 <a:solidFill>
                   <a:srgbClr val="D95500"/>
                 </a:solidFill>
@@ -5769,7 +5769,7 @@
               <a:spcBef>
                 <a:spcPts val="800"/>
               </a:spcBef>
-              <a:defRPr sz="1050">
+              <a:defRPr sz="1150">
                 <a:solidFill>
                   <a:srgbClr val="475569"/>
                 </a:solidFill>
@@ -5790,8 +5790,8 @@
         </p:nvSpPr>
         <p:spPr>
           <a:xfrm>
-            <a:off x="731520" y="3931920"/>
-            <a:ext cx="5257800" cy="2057400"/>
+            <a:off x="1280160" y="4096512"/>
+            <a:ext cx="4645152" cy="2121408"/>
           </a:xfrm>
           <a:prstGeom prst="roundRect">
             <a:avLst/>
@@ -5799,7 +5799,7 @@
           <a:solidFill>
             <a:srgbClr val="FFFFFF"/>
           </a:solidFill>
-          <a:ln w="12700">
+          <a:ln w="15240">
             <a:solidFill>
               <a:srgbClr val="E2E8F0"/>
             </a:solidFill>
@@ -5835,8 +5835,8 @@
         </p:nvSpPr>
         <p:spPr>
           <a:xfrm>
-            <a:off x="731520" y="3931920"/>
-            <a:ext cx="5257800" cy="73152"/>
+            <a:off x="1280160" y="4096512"/>
+            <a:ext cx="4645152" cy="73152"/>
           </a:xfrm>
           <a:prstGeom prst="rect">
             <a:avLst/>
@@ -5886,7 +5886,7 @@
         </p:blipFill>
         <p:spPr>
           <a:xfrm>
-            <a:off x="5166360" y="4160520"/>
+            <a:off x="5148072" y="4297680"/>
             <a:ext cx="594360" cy="594360"/>
           </a:xfrm>
           <a:prstGeom prst="rect">
@@ -5902,8 +5902,8 @@
         </p:nvSpPr>
         <p:spPr>
           <a:xfrm>
-            <a:off x="1005840" y="4160520"/>
-            <a:ext cx="4069080" cy="1600200"/>
+            <a:off x="1572768" y="4315968"/>
+            <a:ext cx="3639312" cy="1755648"/>
           </a:xfrm>
           <a:prstGeom prst="rect">
             <a:avLst/>
@@ -5917,7 +5917,7 @@
           <a:lstStyle/>
           <a:p>
             <a:pPr>
-              <a:defRPr sz="1300" b="1">
+              <a:defRPr sz="1400" b="1">
                 <a:solidFill>
                   <a:srgbClr val="D95500"/>
                 </a:solidFill>
@@ -5933,7 +5933,7 @@
               <a:spcBef>
                 <a:spcPts val="800"/>
               </a:spcBef>
-              <a:defRPr sz="1050">
+              <a:defRPr sz="1150">
                 <a:solidFill>
                   <a:srgbClr val="475569"/>
                 </a:solidFill>
@@ -5941,7 +5941,7 @@
               </a:defRPr>
             </a:pPr>
             <a:r>
-              <a:t>Wat begon als een bescheiden, gezellig tafeltennisclubje op de woensdagmorgen, is uitgegroeid tot een professionele partner voor bedrijfsvitaliteit en teambuilding.</a:t>
+              <a:t>Wat begon als een bescheiden clubje op de woensdagmorgen, is inmiddels uitgegroeid tot een professionele partner voor bedrijfsvitaliteit en teambuilding.</a:t>
             </a:r>
           </a:p>
         </p:txBody>
@@ -5954,8 +5954,8 @@
         </p:nvSpPr>
         <p:spPr>
           <a:xfrm>
-            <a:off x="6172200" y="3931920"/>
-            <a:ext cx="5257800" cy="2057400"/>
+            <a:off x="6263640" y="4096512"/>
+            <a:ext cx="4645152" cy="2121408"/>
           </a:xfrm>
           <a:prstGeom prst="roundRect">
             <a:avLst/>
@@ -5963,7 +5963,7 @@
           <a:solidFill>
             <a:srgbClr val="FFFFFF"/>
           </a:solidFill>
-          <a:ln w="12700">
+          <a:ln w="15240">
             <a:solidFill>
               <a:srgbClr val="E2E8F0"/>
             </a:solidFill>
@@ -5999,8 +5999,8 @@
         </p:nvSpPr>
         <p:spPr>
           <a:xfrm>
-            <a:off x="6172200" y="3931920"/>
-            <a:ext cx="5257800" cy="73152"/>
+            <a:off x="6263640" y="4096512"/>
+            <a:ext cx="4645152" cy="73152"/>
           </a:xfrm>
           <a:prstGeom prst="rect">
             <a:avLst/>
@@ -6050,7 +6050,7 @@
         </p:blipFill>
         <p:spPr>
           <a:xfrm>
-            <a:off x="10607040" y="4160520"/>
+            <a:off x="10131552" y="4297680"/>
             <a:ext cx="594360" cy="594360"/>
           </a:xfrm>
           <a:prstGeom prst="rect">
@@ -6066,8 +6066,8 @@
         </p:nvSpPr>
         <p:spPr>
           <a:xfrm>
-            <a:off x="6446520" y="4160520"/>
-            <a:ext cx="4069080" cy="1600200"/>
+            <a:off x="6556248" y="4315968"/>
+            <a:ext cx="3639312" cy="1755648"/>
           </a:xfrm>
           <a:prstGeom prst="rect">
             <a:avLst/>
@@ -6081,7 +6081,7 @@
           <a:lstStyle/>
           <a:p>
             <a:pPr>
-              <a:defRPr sz="1300" b="1">
+              <a:defRPr sz="1400" b="1">
                 <a:solidFill>
                   <a:srgbClr val="D95500"/>
                 </a:solidFill>
@@ -6097,7 +6097,7 @@
               <a:spcBef>
                 <a:spcPts val="800"/>
               </a:spcBef>
-              <a:defRPr sz="1050">
+              <a:defRPr sz="1150">
                 <a:solidFill>
                   <a:srgbClr val="475569"/>
                 </a:solidFill>
@@ -6105,7 +6105,7 @@
               </a:defRPr>
             </a:pPr>
             <a:r>
-              <a:t>Binnen 3 jaar uitgroeien tot de toonaangevende vitaliteitspartner in Nederland voor actieve bedrijfsevenementen met 100+ clinics per jaar en vaste partnerships.</a:t>
+              <a:t>Binnen 3 jaar uitgroeien tot de toonaangevende vitaliteitspartner in Nederland voor actieve bedrijfsevenementen met 100+ clinics per jaar.</a:t>
             </a:r>
           </a:p>
         </p:txBody>
@@ -6230,8 +6230,8 @@
         </p:blipFill>
         <p:spPr>
           <a:xfrm>
-            <a:off x="10241280" y="365760"/>
-            <a:ext cx="626012" cy="594360"/>
+            <a:off x="9509760" y="438912"/>
+            <a:ext cx="693429" cy="658368"/>
           </a:xfrm>
           <a:prstGeom prst="rect">
             <a:avLst/>
@@ -6246,8 +6246,8 @@
         </p:nvSpPr>
         <p:spPr>
           <a:xfrm>
-            <a:off x="731520" y="320040"/>
-            <a:ext cx="7315200" cy="320040"/>
+            <a:off x="1280160" y="438912"/>
+            <a:ext cx="7772400" cy="320040"/>
           </a:xfrm>
           <a:prstGeom prst="rect">
             <a:avLst/>
@@ -6261,7 +6261,7 @@
           <a:lstStyle/>
           <a:p>
             <a:pPr>
-              <a:defRPr sz="950" b="1">
+              <a:defRPr sz="1100" b="1">
                 <a:solidFill>
                   <a:srgbClr val="D95500"/>
                 </a:solidFill>
@@ -6282,8 +6282,8 @@
         </p:nvSpPr>
         <p:spPr>
           <a:xfrm>
-            <a:off x="731520" y="594360"/>
-            <a:ext cx="9144000" cy="731520"/>
+            <a:off x="1280160" y="749808"/>
+            <a:ext cx="8412480" cy="731520"/>
           </a:xfrm>
           <a:prstGeom prst="rect">
             <a:avLst/>
@@ -6297,7 +6297,7 @@
           <a:lstStyle/>
           <a:p>
             <a:pPr>
-              <a:defRPr sz="2400" b="1">
+              <a:defRPr sz="2600" b="1">
                 <a:solidFill>
                   <a:srgbClr val="111827"/>
                 </a:solidFill>
@@ -6318,8 +6318,8 @@
         </p:nvSpPr>
         <p:spPr>
           <a:xfrm>
-            <a:off x="731520" y="1353312"/>
-            <a:ext cx="4114800" cy="36576"/>
+            <a:off x="1280160" y="1536192"/>
+            <a:ext cx="4572000" cy="41148"/>
           </a:xfrm>
           <a:prstGeom prst="rect">
             <a:avLst/>
@@ -6361,8 +6361,8 @@
         </p:nvSpPr>
         <p:spPr>
           <a:xfrm>
-            <a:off x="731520" y="6446520"/>
-            <a:ext cx="10728655" cy="274320"/>
+            <a:off x="1280160" y="6291072"/>
+            <a:ext cx="9631375" cy="274320"/>
           </a:xfrm>
           <a:prstGeom prst="rect">
             <a:avLst/>
@@ -6376,7 +6376,7 @@
           <a:lstStyle/>
           <a:p>
             <a:pPr>
-              <a:defRPr sz="850">
+              <a:defRPr sz="950">
                 <a:solidFill>
                   <a:srgbClr val="94A3B8"/>
                 </a:solidFill>
@@ -6397,8 +6397,8 @@
         </p:nvSpPr>
         <p:spPr>
           <a:xfrm>
-            <a:off x="731520" y="1645920"/>
-            <a:ext cx="5257800" cy="4572000"/>
+            <a:off x="1280160" y="1755648"/>
+            <a:ext cx="4645152" cy="4462272"/>
           </a:xfrm>
           <a:prstGeom prst="roundRect">
             <a:avLst/>
@@ -6406,7 +6406,7 @@
           <a:solidFill>
             <a:srgbClr val="FFFAFA"/>
           </a:solidFill>
-          <a:ln w="12700">
+          <a:ln w="15240">
             <a:solidFill>
               <a:srgbClr val="FECACA"/>
             </a:solidFill>
@@ -6442,8 +6442,8 @@
         </p:nvSpPr>
         <p:spPr>
           <a:xfrm>
-            <a:off x="731520" y="1645920"/>
-            <a:ext cx="5257800" cy="73152"/>
+            <a:off x="1280160" y="1755648"/>
+            <a:ext cx="4645152" cy="73152"/>
           </a:xfrm>
           <a:prstGeom prst="rect">
             <a:avLst/>
@@ -6493,8 +6493,8 @@
         </p:blipFill>
         <p:spPr>
           <a:xfrm>
-            <a:off x="5303520" y="1783080"/>
-            <a:ext cx="548640" cy="548640"/>
+            <a:off x="5148072" y="1920240"/>
+            <a:ext cx="594360" cy="594360"/>
           </a:xfrm>
           <a:prstGeom prst="rect">
             <a:avLst/>
@@ -6509,8 +6509,8 @@
         </p:nvSpPr>
         <p:spPr>
           <a:xfrm>
-            <a:off x="1005840" y="1874519"/>
-            <a:ext cx="4709160" cy="4114800"/>
+            <a:off x="1600200" y="1965960"/>
+            <a:ext cx="3730752" cy="4005072"/>
           </a:xfrm>
           <a:prstGeom prst="rect">
             <a:avLst/>
@@ -6524,7 +6524,7 @@
           <a:lstStyle/>
           <a:p>
             <a:pPr>
-              <a:defRPr sz="1300">
+              <a:defRPr sz="1400">
                 <a:solidFill>
                   <a:srgbClr val="B91C1C"/>
                 </a:solidFill>
@@ -6538,9 +6538,9 @@
           <a:p>
             <a:pPr>
               <a:spcBef>
-                <a:spcPts val="800"/>
-              </a:spcBef>
-              <a:defRPr sz="1050">
+                <a:spcPts val="1000"/>
+              </a:spcBef>
+              <a:defRPr sz="1200">
                 <a:solidFill>
                   <a:srgbClr val="1E293B"/>
                 </a:solidFill>
@@ -6556,7 +6556,7 @@
               <a:spcBef>
                 <a:spcPts val="200"/>
               </a:spcBef>
-              <a:defRPr sz="950">
+              <a:defRPr sz="1100">
                 <a:solidFill>
                   <a:srgbClr val="475569"/>
                 </a:solidFill>
@@ -6564,15 +6564,15 @@
               </a:defRPr>
             </a:pPr>
             <a:r>
-              <a:t>Medewerkers zitten gemiddeld 8-10 uur per dag achter een beeldscherm. Energielevels dalen en verzuim stijgt.</a:t>
-            </a:r>
-          </a:p>
-          <a:p>
-            <a:pPr>
-              <a:spcBef>
-                <a:spcPts val="800"/>
-              </a:spcBef>
-              <a:defRPr sz="1050">
+              <a:t>Medewerkers zitten 8-10 uur per dag stil. Energielevels dalen en verzuim stijgt.</a:t>
+            </a:r>
+          </a:p>
+          <a:p>
+            <a:pPr>
+              <a:spcBef>
+                <a:spcPts val="1000"/>
+              </a:spcBef>
+              <a:defRPr sz="1200">
                 <a:solidFill>
                   <a:srgbClr val="1E293B"/>
                 </a:solidFill>
@@ -6588,7 +6588,7 @@
               <a:spcBef>
                 <a:spcPts val="200"/>
               </a:spcBef>
-              <a:defRPr sz="950">
+              <a:defRPr sz="1100">
                 <a:solidFill>
                   <a:srgbClr val="475569"/>
                 </a:solidFill>
@@ -6596,15 +6596,15 @@
               </a:defRPr>
             </a:pPr>
             <a:r>
-              <a:t>Collega's zien elkaar vaker via Zoom/Teams dan in het echt. Echte spontane verbinding en collegialiteit verdwijnt.</a:t>
-            </a:r>
-          </a:p>
-          <a:p>
-            <a:pPr>
-              <a:spcBef>
-                <a:spcPts val="800"/>
-              </a:spcBef>
-              <a:defRPr sz="1050">
+              <a:t>Collega's zien elkaar vaker via Zoom. Echte spontane collegialiteit verdwijnt.</a:t>
+            </a:r>
+          </a:p>
+          <a:p>
+            <a:pPr>
+              <a:spcBef>
+                <a:spcPts val="1000"/>
+              </a:spcBef>
+              <a:defRPr sz="1200">
                 <a:solidFill>
                   <a:srgbClr val="1E293B"/>
                 </a:solidFill>
@@ -6620,7 +6620,7 @@
               <a:spcBef>
                 <a:spcPts val="200"/>
               </a:spcBef>
-              <a:defRPr sz="950">
+              <a:defRPr sz="1100">
                 <a:solidFill>
                   <a:srgbClr val="475569"/>
                 </a:solidFill>
@@ -6628,15 +6628,15 @@
               </a:defRPr>
             </a:pPr>
             <a:r>
-              <a:t>Standaard borrels of ongemakkelijke workshops zorgen zelden voor blijvende energie of échte interactie.</a:t>
-            </a:r>
-          </a:p>
-          <a:p>
-            <a:pPr>
-              <a:spcBef>
-                <a:spcPts val="800"/>
-              </a:spcBef>
-              <a:defRPr sz="1050">
+              <a:t>Standaard borrels zorgen zelden voor blijvende energie of échte interactie.</a:t>
+            </a:r>
+          </a:p>
+          <a:p>
+            <a:pPr>
+              <a:spcBef>
+                <a:spcPts val="1000"/>
+              </a:spcBef>
+              <a:defRPr sz="1200">
                 <a:solidFill>
                   <a:srgbClr val="1E293B"/>
                 </a:solidFill>
@@ -6652,7 +6652,7 @@
               <a:spcBef>
                 <a:spcPts val="200"/>
               </a:spcBef>
-              <a:defRPr sz="950">
+              <a:defRPr sz="1100">
                 <a:solidFill>
                   <a:srgbClr val="475569"/>
                 </a:solidFill>
@@ -6660,7 +6660,7 @@
               </a:defRPr>
             </a:pPr>
             <a:r>
-              <a:t>Karten, padel of zeskamp sluit vaak collega's uit door conditieniveau, leeftijd of blessuregevoeligheid.</a:t>
+              <a:t>Karten of padel sluit vaak collega's uit door conditie of blessuregevoeligheid.</a:t>
             </a:r>
           </a:p>
         </p:txBody>
@@ -6673,8 +6673,8 @@
         </p:nvSpPr>
         <p:spPr>
           <a:xfrm>
-            <a:off x="6199632" y="1645920"/>
-            <a:ext cx="5257800" cy="4572000"/>
+            <a:off x="6263640" y="1755648"/>
+            <a:ext cx="4645152" cy="4462272"/>
           </a:xfrm>
           <a:prstGeom prst="roundRect">
             <a:avLst/>
@@ -6682,7 +6682,7 @@
           <a:solidFill>
             <a:srgbClr val="FFF8F2"/>
           </a:solidFill>
-          <a:ln w="12700">
+          <a:ln w="15240">
             <a:solidFill>
               <a:srgbClr val="FF6B00"/>
             </a:solidFill>
@@ -6718,8 +6718,8 @@
         </p:nvSpPr>
         <p:spPr>
           <a:xfrm>
-            <a:off x="6199632" y="1645920"/>
-            <a:ext cx="5257800" cy="73152"/>
+            <a:off x="6263640" y="1755648"/>
+            <a:ext cx="4645152" cy="73152"/>
           </a:xfrm>
           <a:prstGeom prst="rect">
             <a:avLst/>
@@ -6769,8 +6769,8 @@
         </p:blipFill>
         <p:spPr>
           <a:xfrm>
-            <a:off x="10744200" y="1783080"/>
-            <a:ext cx="548640" cy="548640"/>
+            <a:off x="10131552" y="1920240"/>
+            <a:ext cx="594360" cy="594360"/>
           </a:xfrm>
           <a:prstGeom prst="rect">
             <a:avLst/>
@@ -6785,8 +6785,8 @@
         </p:nvSpPr>
         <p:spPr>
           <a:xfrm>
-            <a:off x="6473952" y="1874519"/>
-            <a:ext cx="4709160" cy="4114800"/>
+            <a:off x="6583680" y="1965960"/>
+            <a:ext cx="3730752" cy="4005072"/>
           </a:xfrm>
           <a:prstGeom prst="rect">
             <a:avLst/>
@@ -6800,7 +6800,7 @@
           <a:lstStyle/>
           <a:p>
             <a:pPr>
-              <a:defRPr sz="1300">
+              <a:defRPr sz="1400">
                 <a:solidFill>
                   <a:srgbClr val="D95500"/>
                 </a:solidFill>
@@ -6814,9 +6814,9 @@
           <a:p>
             <a:pPr>
               <a:spcBef>
-                <a:spcPts val="800"/>
-              </a:spcBef>
-              <a:defRPr sz="1050">
+                <a:spcPts val="1000"/>
+              </a:spcBef>
+              <a:defRPr sz="1200">
                 <a:solidFill>
                   <a:srgbClr val="1E293B"/>
                 </a:solidFill>
@@ -6832,7 +6832,7 @@
               <a:spcBef>
                 <a:spcPts val="200"/>
               </a:spcBef>
-              <a:defRPr sz="950">
+              <a:defRPr sz="1100">
                 <a:solidFill>
                   <a:srgbClr val="475569"/>
                 </a:solidFill>
@@ -6840,15 +6840,15 @@
               </a:defRPr>
             </a:pPr>
             <a:r>
-              <a:t>Werkgevers investeren fors in preventieve vitaliteit, mentale fitheid en teambuilding met belastingvoordelen.</a:t>
-            </a:r>
-          </a:p>
-          <a:p>
-            <a:pPr>
-              <a:spcBef>
-                <a:spcPts val="800"/>
-              </a:spcBef>
-              <a:defRPr sz="1050">
+              <a:t>Werkgevers investeren fors in preventieve vitaliteit met belastingvoordelen.</a:t>
+            </a:r>
+          </a:p>
+          <a:p>
+            <a:pPr>
+              <a:spcBef>
+                <a:spcPts val="1000"/>
+              </a:spcBef>
+              <a:defRPr sz="1200">
                 <a:solidFill>
                   <a:srgbClr val="1E293B"/>
                 </a:solidFill>
@@ -6864,7 +6864,7 @@
               <a:spcBef>
                 <a:spcPts val="200"/>
               </a:spcBef>
-              <a:defRPr sz="950">
+              <a:defRPr sz="1100">
                 <a:solidFill>
                   <a:srgbClr val="475569"/>
                 </a:solidFill>
@@ -6872,15 +6872,15 @@
               </a:defRPr>
             </a:pPr>
             <a:r>
-              <a:t>Elk modern kantoor heeft of wil een tafeltennistafel, maar benut deze zelden optimaal voor gestructureerde team clinics.</a:t>
-            </a:r>
-          </a:p>
-          <a:p>
-            <a:pPr>
-              <a:spcBef>
-                <a:spcPts val="800"/>
-              </a:spcBef>
-              <a:defRPr sz="1050">
+              <a:t>Elk modern kantoor wil tafeltennis, maar benut het zelden gestructureerd.</a:t>
+            </a:r>
+          </a:p>
+          <a:p>
+            <a:pPr>
+              <a:spcBef>
+                <a:spcPts val="1000"/>
+              </a:spcBef>
+              <a:defRPr sz="1200">
                 <a:solidFill>
                   <a:srgbClr val="1E293B"/>
                 </a:solidFill>
@@ -6896,7 +6896,7 @@
               <a:spcBef>
                 <a:spcPts val="200"/>
               </a:spcBef>
-              <a:defRPr sz="950">
+              <a:defRPr sz="1100">
                 <a:solidFill>
                   <a:srgbClr val="475569"/>
                 </a:solidFill>
@@ -6904,15 +6904,15 @@
               </a:defRPr>
             </a:pPr>
             <a:r>
-              <a:t>Tafeltennis triggert bewezen neuroplasticiteit: snelle reflexen, focus en mentale ontlading binnen 5 minuten.</a:t>
-            </a:r>
-          </a:p>
-          <a:p>
-            <a:pPr>
-              <a:spcBef>
-                <a:spcPts val="800"/>
-              </a:spcBef>
-              <a:defRPr sz="1050">
+              <a:t>Bewezen neuroplasticiteit: snelle reflexen, focus en ontlading in 5 minuten.</a:t>
+            </a:r>
+          </a:p>
+          <a:p>
+            <a:pPr>
+              <a:spcBef>
+                <a:spcPts val="1000"/>
+              </a:spcBef>
+              <a:defRPr sz="1200">
                 <a:solidFill>
                   <a:srgbClr val="1E293B"/>
                 </a:solidFill>
@@ -6928,7 +6928,7 @@
               <a:spcBef>
                 <a:spcPts val="200"/>
               </a:spcBef>
-              <a:defRPr sz="950">
+              <a:defRPr sz="1100">
                 <a:solidFill>
                   <a:srgbClr val="475569"/>
                 </a:solidFill>
@@ -6936,7 +6936,7 @@
               </a:defRPr>
             </a:pPr>
             <a:r>
-              <a:t>Wij komen met mobiele wedstrijduitrusting naar de bedrijfskantine óf organiseren het in een sfeervolle zaal incl. borrel.</a:t>
+              <a:t>Mobiel speelklaar in bedrijfskantines óf in sfeervolle zalen incl. borrel.</a:t>
             </a:r>
           </a:p>
         </p:txBody>
@@ -7061,8 +7061,8 @@
         </p:blipFill>
         <p:spPr>
           <a:xfrm>
-            <a:off x="10241280" y="365760"/>
-            <a:ext cx="626012" cy="594360"/>
+            <a:off x="9509760" y="438912"/>
+            <a:ext cx="693429" cy="658368"/>
           </a:xfrm>
           <a:prstGeom prst="rect">
             <a:avLst/>
@@ -7077,8 +7077,8 @@
         </p:nvSpPr>
         <p:spPr>
           <a:xfrm>
-            <a:off x="731520" y="320040"/>
-            <a:ext cx="7315200" cy="320040"/>
+            <a:off x="1280160" y="438912"/>
+            <a:ext cx="7772400" cy="320040"/>
           </a:xfrm>
           <a:prstGeom prst="rect">
             <a:avLst/>
@@ -7092,7 +7092,7 @@
           <a:lstStyle/>
           <a:p>
             <a:pPr>
-              <a:defRPr sz="950" b="1">
+              <a:defRPr sz="1100" b="1">
                 <a:solidFill>
                   <a:srgbClr val="D95500"/>
                 </a:solidFill>
@@ -7113,8 +7113,8 @@
         </p:nvSpPr>
         <p:spPr>
           <a:xfrm>
-            <a:off x="731520" y="594360"/>
-            <a:ext cx="9144000" cy="731520"/>
+            <a:off x="1280160" y="749808"/>
+            <a:ext cx="8412480" cy="731520"/>
           </a:xfrm>
           <a:prstGeom prst="rect">
             <a:avLst/>
@@ -7128,7 +7128,7 @@
           <a:lstStyle/>
           <a:p>
             <a:pPr>
-              <a:defRPr sz="2400" b="1">
+              <a:defRPr sz="2600" b="1">
                 <a:solidFill>
                   <a:srgbClr val="111827"/>
                 </a:solidFill>
@@ -7149,8 +7149,8 @@
         </p:nvSpPr>
         <p:spPr>
           <a:xfrm>
-            <a:off x="731520" y="1353312"/>
-            <a:ext cx="4114800" cy="36576"/>
+            <a:off x="1280160" y="1536192"/>
+            <a:ext cx="4572000" cy="41148"/>
           </a:xfrm>
           <a:prstGeom prst="rect">
             <a:avLst/>
@@ -7192,8 +7192,8 @@
         </p:nvSpPr>
         <p:spPr>
           <a:xfrm>
-            <a:off x="731520" y="6446520"/>
-            <a:ext cx="10728655" cy="274320"/>
+            <a:off x="1280160" y="6291072"/>
+            <a:ext cx="9631375" cy="274320"/>
           </a:xfrm>
           <a:prstGeom prst="rect">
             <a:avLst/>
@@ -7207,7 +7207,7 @@
           <a:lstStyle/>
           <a:p>
             <a:pPr>
-              <a:defRPr sz="850">
+              <a:defRPr sz="950">
                 <a:solidFill>
                   <a:srgbClr val="94A3B8"/>
                 </a:solidFill>
@@ -7228,8 +7228,8 @@
         </p:nvSpPr>
         <p:spPr>
           <a:xfrm>
-            <a:off x="731520" y="1645920"/>
-            <a:ext cx="3456432" cy="4572000"/>
+            <a:off x="1280160" y="1755648"/>
+            <a:ext cx="2999232" cy="4462272"/>
           </a:xfrm>
           <a:prstGeom prst="roundRect">
             <a:avLst/>
@@ -7237,7 +7237,7 @@
           <a:solidFill>
             <a:srgbClr val="FFFFFF"/>
           </a:solidFill>
-          <a:ln w="12700">
+          <a:ln w="15240">
             <a:solidFill>
               <a:srgbClr val="E2E8F0"/>
             </a:solidFill>
@@ -7281,8 +7281,8 @@
         </p:blipFill>
         <p:spPr>
           <a:xfrm>
-            <a:off x="3319272" y="1828800"/>
-            <a:ext cx="685800" cy="685800"/>
+            <a:off x="3502152" y="1938528"/>
+            <a:ext cx="621792" cy="621792"/>
           </a:xfrm>
           <a:prstGeom prst="rect">
             <a:avLst/>
@@ -7297,8 +7297,8 @@
         </p:nvSpPr>
         <p:spPr>
           <a:xfrm>
-            <a:off x="960120" y="1874520"/>
-            <a:ext cx="2999232" cy="4114800"/>
+            <a:off x="1508760" y="1984248"/>
+            <a:ext cx="2542032" cy="4096512"/>
           </a:xfrm>
           <a:prstGeom prst="rect">
             <a:avLst/>
@@ -7312,7 +7312,7 @@
           <a:lstStyle/>
           <a:p>
             <a:pPr>
-              <a:defRPr sz="1150" b="1">
+              <a:defRPr sz="1250" b="1">
                 <a:solidFill>
                   <a:srgbClr val="1E293B"/>
                 </a:solidFill>
@@ -7328,7 +7328,7 @@
               <a:spcBef>
                 <a:spcPts val="400"/>
               </a:spcBef>
-              <a:defRPr sz="2600" b="1">
+              <a:defRPr sz="2800" b="1">
                 <a:solidFill>
                   <a:srgbClr val="111827"/>
                 </a:solidFill>
@@ -7344,7 +7344,7 @@
               <a:spcBef>
                 <a:spcPts val="200"/>
               </a:spcBef>
-              <a:defRPr sz="950">
+              <a:defRPr sz="1050">
                 <a:solidFill>
                   <a:srgbClr val="94A3B8"/>
                 </a:solidFill>
@@ -7375,7 +7375,7 @@
               <a:spcBef>
                 <a:spcPts val="600"/>
               </a:spcBef>
-              <a:defRPr sz="950">
+              <a:defRPr sz="1100">
                 <a:solidFill>
                   <a:srgbClr val="475569"/>
                 </a:solidFill>
@@ -7383,7 +7383,7 @@
               </a:defRPr>
             </a:pPr>
             <a:r>
-              <a:t>✓ Masterclass basistechniek &amp; effectspin</a:t>
+              <a:t>✓ Masterclass basistechniek &amp; spin</a:t>
             </a:r>
           </a:p>
           <a:p>
@@ -7391,7 +7391,7 @@
               <a:spcBef>
                 <a:spcPts val="600"/>
               </a:spcBef>
-              <a:defRPr sz="950">
+              <a:defRPr sz="1100">
                 <a:solidFill>
                   <a:srgbClr val="475569"/>
                 </a:solidFill>
@@ -7407,7 +7407,7 @@
               <a:spcBef>
                 <a:spcPts val="600"/>
               </a:spcBef>
-              <a:defRPr sz="950">
+              <a:defRPr sz="1100">
                 <a:solidFill>
                   <a:srgbClr val="475569"/>
                 </a:solidFill>
@@ -7415,7 +7415,7 @@
               </a:defRPr>
             </a:pPr>
             <a:r>
-              <a:t>✓ Professionele batjes &amp; ballen inbegrepen</a:t>
+              <a:t>✓ Professioneel materiaal inbegrepen</a:t>
             </a:r>
           </a:p>
           <a:p>
@@ -7423,7 +7423,7 @@
               <a:spcBef>
                 <a:spcPts val="600"/>
               </a:spcBef>
-              <a:defRPr sz="950">
+              <a:defRPr sz="1100">
                 <a:solidFill>
                   <a:srgbClr val="475569"/>
                 </a:solidFill>
@@ -7431,7 +7431,7 @@
               </a:defRPr>
             </a:pPr>
             <a:r>
-              <a:t>✓ Op eigen kantoor of sportlocatie</a:t>
+              <a:t>✓ Op kantoor of sportlocatie</a:t>
             </a:r>
           </a:p>
           <a:p>
@@ -7439,7 +7439,7 @@
               <a:spcBef>
                 <a:spcPts val="600"/>
               </a:spcBef>
-              <a:defRPr sz="950">
+              <a:defRPr sz="1100">
                 <a:solidFill>
                   <a:srgbClr val="475569"/>
                 </a:solidFill>
@@ -7447,7 +7447,7 @@
               </a:defRPr>
             </a:pPr>
             <a:r>
-              <a:t>✓ Ideaal voor afdelingen &amp; kleine teams</a:t>
+              <a:t>✓ Ideaal voor kleinere teams</a:t>
             </a:r>
           </a:p>
         </p:txBody>
@@ -7460,8 +7460,8 @@
         </p:nvSpPr>
         <p:spPr>
           <a:xfrm>
-            <a:off x="4370832" y="1645920"/>
-            <a:ext cx="3456432" cy="4572000"/>
+            <a:off x="4590288" y="1755648"/>
+            <a:ext cx="2999232" cy="4462272"/>
           </a:xfrm>
           <a:prstGeom prst="roundRect">
             <a:avLst/>
@@ -7469,7 +7469,7 @@
           <a:solidFill>
             <a:srgbClr val="FFF8F2"/>
           </a:solidFill>
-          <a:ln w="12700">
+          <a:ln w="15240">
             <a:solidFill>
               <a:srgbClr val="FF6B00"/>
             </a:solidFill>
@@ -7505,8 +7505,8 @@
         </p:nvSpPr>
         <p:spPr>
           <a:xfrm>
-            <a:off x="4370832" y="1645920"/>
-            <a:ext cx="3456432" cy="73152"/>
+            <a:off x="4590288" y="1755648"/>
+            <a:ext cx="2999232" cy="73152"/>
           </a:xfrm>
           <a:prstGeom prst="rect">
             <a:avLst/>
@@ -7556,8 +7556,8 @@
         </p:blipFill>
         <p:spPr>
           <a:xfrm>
-            <a:off x="6958584" y="1828800"/>
-            <a:ext cx="685800" cy="685800"/>
+            <a:off x="6812280" y="1938528"/>
+            <a:ext cx="621792" cy="621792"/>
           </a:xfrm>
           <a:prstGeom prst="rect">
             <a:avLst/>
@@ -7572,8 +7572,8 @@
         </p:nvSpPr>
         <p:spPr>
           <a:xfrm>
-            <a:off x="4599432" y="1874520"/>
-            <a:ext cx="2999232" cy="4114800"/>
+            <a:off x="4818888" y="1984248"/>
+            <a:ext cx="2542032" cy="4096512"/>
           </a:xfrm>
           <a:prstGeom prst="rect">
             <a:avLst/>
@@ -7587,7 +7587,7 @@
           <a:lstStyle/>
           <a:p>
             <a:pPr>
-              <a:defRPr sz="1150" b="1">
+              <a:defRPr sz="1250" b="1">
                 <a:solidFill>
                   <a:srgbClr val="D95500"/>
                 </a:solidFill>
@@ -7603,7 +7603,7 @@
               <a:spcBef>
                 <a:spcPts val="400"/>
               </a:spcBef>
-              <a:defRPr sz="2600" b="1">
+              <a:defRPr sz="2800" b="1">
                 <a:solidFill>
                   <a:srgbClr val="FF6B00"/>
                 </a:solidFill>
@@ -7619,7 +7619,7 @@
               <a:spcBef>
                 <a:spcPts val="200"/>
               </a:spcBef>
-              <a:defRPr sz="950">
+              <a:defRPr sz="1050">
                 <a:solidFill>
                   <a:srgbClr val="94A3B8"/>
                 </a:solidFill>
@@ -7650,7 +7650,7 @@
               <a:spcBef>
                 <a:spcPts val="600"/>
               </a:spcBef>
-              <a:defRPr sz="950">
+              <a:defRPr sz="1100">
                 <a:solidFill>
                   <a:srgbClr val="475569"/>
                 </a:solidFill>
@@ -7658,7 +7658,7 @@
               </a:defRPr>
             </a:pPr>
             <a:r>
-              <a:t>✓ Complete clinic + trickshots van Edward</a:t>
+              <a:t>✓ Complete clinic + trickshots Edward</a:t>
             </a:r>
           </a:p>
           <a:p>
@@ -7666,7 +7666,7 @@
               <a:spcBef>
                 <a:spcPts val="600"/>
               </a:spcBef>
-              <a:defRPr sz="950">
+              <a:defRPr sz="1100">
                 <a:solidFill>
                   <a:srgbClr val="475569"/>
                 </a:solidFill>
@@ -7674,7 +7674,7 @@
               </a:defRPr>
             </a:pPr>
             <a:r>
-              <a:t>✓ Volledig verzorgd bedrijfscompetitie toernooi</a:t>
+              <a:t>✓ Volledig verzorgd teamtoernooi</a:t>
             </a:r>
           </a:p>
           <a:p>
@@ -7682,7 +7682,7 @@
               <a:spcBef>
                 <a:spcPts val="600"/>
               </a:spcBef>
-              <a:defRPr sz="950">
+              <a:defRPr sz="1100">
                 <a:solidFill>
                   <a:srgbClr val="475569"/>
                 </a:solidFill>
@@ -7690,7 +7690,7 @@
               </a:defRPr>
             </a:pPr>
             <a:r>
-              <a:t>✓ Officiële TT Clinics wisseltrofee &amp; medailles</a:t>
+              <a:t>✓ Officiële wisseltrofee &amp; medailles</a:t>
             </a:r>
           </a:p>
           <a:p>
@@ -7698,7 +7698,7 @@
               <a:spcBef>
                 <a:spcPts val="600"/>
               </a:spcBef>
-              <a:defRPr sz="950">
+              <a:defRPr sz="1100">
                 <a:solidFill>
                   <a:srgbClr val="475569"/>
                 </a:solidFill>
@@ -7706,7 +7706,7 @@
               </a:defRPr>
             </a:pPr>
             <a:r>
-              <a:t>✓ Meest gekozen bedrijfsuitje &amp; kick-off</a:t>
+              <a:t>✓ Meest gekozen bedrijfsuitje</a:t>
             </a:r>
           </a:p>
           <a:p>
@@ -7714,7 +7714,7 @@
               <a:spcBef>
                 <a:spcPts val="600"/>
               </a:spcBef>
-              <a:defRPr sz="950">
+              <a:defRPr sz="1100">
                 <a:solidFill>
                   <a:srgbClr val="475569"/>
                 </a:solidFill>
@@ -7722,7 +7722,7 @@
               </a:defRPr>
             </a:pPr>
             <a:r>
-              <a:t>✓ Optioneel: borrel &amp; bittergarnituur arrangement</a:t>
+              <a:t>✓ Optioneel: borrel arrangement</a:t>
             </a:r>
           </a:p>
         </p:txBody>
@@ -7735,8 +7735,8 @@
         </p:nvSpPr>
         <p:spPr>
           <a:xfrm>
-            <a:off x="8010144" y="1645920"/>
-            <a:ext cx="3456432" cy="4572000"/>
+            <a:off x="7900416" y="1755648"/>
+            <a:ext cx="2999232" cy="4462272"/>
           </a:xfrm>
           <a:prstGeom prst="roundRect">
             <a:avLst/>
@@ -7744,7 +7744,7 @@
           <a:solidFill>
             <a:srgbClr val="FFFFFF"/>
           </a:solidFill>
-          <a:ln w="12700">
+          <a:ln w="15240">
             <a:solidFill>
               <a:srgbClr val="E2E8F0"/>
             </a:solidFill>
@@ -7788,8 +7788,8 @@
         </p:blipFill>
         <p:spPr>
           <a:xfrm>
-            <a:off x="10597896" y="1828800"/>
-            <a:ext cx="685800" cy="685800"/>
+            <a:off x="10122408" y="1938528"/>
+            <a:ext cx="621792" cy="621792"/>
           </a:xfrm>
           <a:prstGeom prst="rect">
             <a:avLst/>
@@ -7804,8 +7804,8 @@
         </p:nvSpPr>
         <p:spPr>
           <a:xfrm>
-            <a:off x="8238744" y="1874520"/>
-            <a:ext cx="2999232" cy="4114800"/>
+            <a:off x="8129016" y="1984248"/>
+            <a:ext cx="2542032" cy="4096512"/>
           </a:xfrm>
           <a:prstGeom prst="rect">
             <a:avLst/>
@@ -7819,7 +7819,7 @@
           <a:lstStyle/>
           <a:p>
             <a:pPr>
-              <a:defRPr sz="1150" b="1">
+              <a:defRPr sz="1250" b="1">
                 <a:solidFill>
                   <a:srgbClr val="1E293B"/>
                 </a:solidFill>
@@ -7835,7 +7835,7 @@
               <a:spcBef>
                 <a:spcPts val="400"/>
               </a:spcBef>
-              <a:defRPr sz="2600" b="1">
+              <a:defRPr sz="2800" b="1">
                 <a:solidFill>
                   <a:srgbClr val="111827"/>
                 </a:solidFill>
@@ -7851,7 +7851,7 @@
               <a:spcBef>
                 <a:spcPts val="200"/>
               </a:spcBef>
-              <a:defRPr sz="950">
+              <a:defRPr sz="1050">
                 <a:solidFill>
                   <a:srgbClr val="94A3B8"/>
                 </a:solidFill>
@@ -7882,7 +7882,7 @@
               <a:spcBef>
                 <a:spcPts val="600"/>
               </a:spcBef>
-              <a:defRPr sz="950">
+              <a:defRPr sz="1100">
                 <a:solidFill>
                   <a:srgbClr val="475569"/>
                 </a:solidFill>
@@ -7890,7 +7890,7 @@
               </a:defRPr>
             </a:pPr>
             <a:r>
-              <a:t>✓ Gezondheids- en vitaliteitsweken op kantoor</a:t>
+              <a:t>✓ Vitaliteitsweken op de werkvloer</a:t>
             </a:r>
           </a:p>
           <a:p>
@@ -7898,7 +7898,7 @@
               <a:spcBef>
                 <a:spcPts val="600"/>
               </a:spcBef>
-              <a:defRPr sz="950">
+              <a:defRPr sz="1100">
                 <a:solidFill>
                   <a:srgbClr val="475569"/>
                 </a:solidFill>
@@ -7906,7 +7906,7 @@
               </a:defRPr>
             </a:pPr>
             <a:r>
-              <a:t>✓ Meerdere trainers &amp; mobiele wedstrijdtafels</a:t>
+              <a:t>✓ Meerdere trainers &amp; mobiele tafels</a:t>
             </a:r>
           </a:p>
           <a:p>
@@ -7914,7 +7914,7 @@
               <a:spcBef>
                 <a:spcPts val="600"/>
               </a:spcBef>
-              <a:defRPr sz="950">
+              <a:defRPr sz="1100">
                 <a:solidFill>
                   <a:srgbClr val="475569"/>
                 </a:solidFill>
@@ -7922,7 +7922,7 @@
               </a:defRPr>
             </a:pPr>
             <a:r>
-              <a:t>✓ Bedrijfscompetitie opzet voor het hele jaar</a:t>
+              <a:t>✓ Jaarlange bedrijfscompetitie opzet</a:t>
             </a:r>
           </a:p>
           <a:p>
@@ -7930,7 +7930,7 @@
               <a:spcBef>
                 <a:spcPts val="600"/>
               </a:spcBef>
-              <a:defRPr sz="950">
+              <a:defRPr sz="1100">
                 <a:solidFill>
                   <a:srgbClr val="475569"/>
                 </a:solidFill>
@@ -7938,7 +7938,7 @@
               </a:defRPr>
             </a:pPr>
             <a:r>
-              <a:t>✓ Volledig afgestemd op corporate programma</a:t>
+              <a:t>✓ Afgestemd op corporate programma</a:t>
             </a:r>
           </a:p>
           <a:p>
@@ -7946,7 +7946,7 @@
               <a:spcBef>
                 <a:spcPts val="600"/>
               </a:spcBef>
-              <a:defRPr sz="950">
+              <a:defRPr sz="1100">
                 <a:solidFill>
                   <a:srgbClr val="475569"/>
                 </a:solidFill>
@@ -7954,7 +7954,7 @@
               </a:defRPr>
             </a:pPr>
             <a:r>
-              <a:t>✓ Grote organisaties &amp; evenementen</a:t>
+              <a:t>✓ Grote organisaties &amp; events</a:t>
             </a:r>
           </a:p>
         </p:txBody>
@@ -8079,8 +8079,8 @@
         </p:blipFill>
         <p:spPr>
           <a:xfrm>
-            <a:off x="10241280" y="365760"/>
-            <a:ext cx="626012" cy="594360"/>
+            <a:off x="9509760" y="438912"/>
+            <a:ext cx="693429" cy="658368"/>
           </a:xfrm>
           <a:prstGeom prst="rect">
             <a:avLst/>
@@ -8095,8 +8095,8 @@
         </p:nvSpPr>
         <p:spPr>
           <a:xfrm>
-            <a:off x="731520" y="320040"/>
-            <a:ext cx="7315200" cy="320040"/>
+            <a:off x="1280160" y="438912"/>
+            <a:ext cx="7772400" cy="320040"/>
           </a:xfrm>
           <a:prstGeom prst="rect">
             <a:avLst/>
@@ -8110,7 +8110,7 @@
           <a:lstStyle/>
           <a:p>
             <a:pPr>
-              <a:defRPr sz="950" b="1">
+              <a:defRPr sz="1100" b="1">
                 <a:solidFill>
                   <a:srgbClr val="D95500"/>
                 </a:solidFill>
@@ -8131,8 +8131,8 @@
         </p:nvSpPr>
         <p:spPr>
           <a:xfrm>
-            <a:off x="731520" y="594360"/>
-            <a:ext cx="9144000" cy="731520"/>
+            <a:off x="1280160" y="749808"/>
+            <a:ext cx="8412480" cy="731520"/>
           </a:xfrm>
           <a:prstGeom prst="rect">
             <a:avLst/>
@@ -8146,7 +8146,7 @@
           <a:lstStyle/>
           <a:p>
             <a:pPr>
-              <a:defRPr sz="2400" b="1">
+              <a:defRPr sz="2600" b="1">
                 <a:solidFill>
                   <a:srgbClr val="111827"/>
                 </a:solidFill>
@@ -8167,8 +8167,8 @@
         </p:nvSpPr>
         <p:spPr>
           <a:xfrm>
-            <a:off x="731520" y="1353312"/>
-            <a:ext cx="4114800" cy="36576"/>
+            <a:off x="1280160" y="1536192"/>
+            <a:ext cx="4572000" cy="41148"/>
           </a:xfrm>
           <a:prstGeom prst="rect">
             <a:avLst/>
@@ -8210,8 +8210,8 @@
         </p:nvSpPr>
         <p:spPr>
           <a:xfrm>
-            <a:off x="731520" y="6446520"/>
-            <a:ext cx="10728655" cy="274320"/>
+            <a:off x="1280160" y="6291072"/>
+            <a:ext cx="9631375" cy="274320"/>
           </a:xfrm>
           <a:prstGeom prst="rect">
             <a:avLst/>
@@ -8225,7 +8225,7 @@
           <a:lstStyle/>
           <a:p>
             <a:pPr>
-              <a:defRPr sz="850">
+              <a:defRPr sz="950">
                 <a:solidFill>
                   <a:srgbClr val="94A3B8"/>
                 </a:solidFill>
@@ -8246,8 +8246,8 @@
         </p:nvSpPr>
         <p:spPr>
           <a:xfrm>
-            <a:off x="731520" y="1645920"/>
-            <a:ext cx="5257800" cy="2057400"/>
+            <a:off x="1280160" y="1755648"/>
+            <a:ext cx="4645152" cy="2121408"/>
           </a:xfrm>
           <a:prstGeom prst="roundRect">
             <a:avLst/>
@@ -8255,7 +8255,7 @@
           <a:solidFill>
             <a:srgbClr val="FFFFFF"/>
           </a:solidFill>
-          <a:ln w="12700">
+          <a:ln w="15240">
             <a:solidFill>
               <a:srgbClr val="E2E8F0"/>
             </a:solidFill>
@@ -8291,8 +8291,8 @@
         </p:nvSpPr>
         <p:spPr>
           <a:xfrm>
-            <a:off x="731520" y="1645920"/>
-            <a:ext cx="5257800" cy="73152"/>
+            <a:off x="1280160" y="1755648"/>
+            <a:ext cx="4645152" cy="73152"/>
           </a:xfrm>
           <a:prstGeom prst="rect">
             <a:avLst/>
@@ -8342,7 +8342,7 @@
         </p:blipFill>
         <p:spPr>
           <a:xfrm>
-            <a:off x="1005840" y="1920240"/>
+            <a:off x="1536192" y="2048256"/>
             <a:ext cx="685800" cy="685800"/>
           </a:xfrm>
           <a:prstGeom prst="rect">
@@ -8358,8 +8358,8 @@
         </p:nvSpPr>
         <p:spPr>
           <a:xfrm>
-            <a:off x="1828800" y="1874520"/>
-            <a:ext cx="3931920" cy="1600200"/>
+            <a:off x="2395728" y="1993392"/>
+            <a:ext cx="3364992" cy="1755648"/>
           </a:xfrm>
           <a:prstGeom prst="rect">
             <a:avLst/>
@@ -8373,7 +8373,7 @@
           <a:lstStyle/>
           <a:p>
             <a:pPr>
-              <a:defRPr sz="1200" b="1">
+              <a:defRPr sz="1300" b="1">
                 <a:solidFill>
                   <a:srgbClr val="1E293B"/>
                 </a:solidFill>
@@ -8389,7 +8389,7 @@
               <a:spcBef>
                 <a:spcPts val="600"/>
               </a:spcBef>
-              <a:defRPr sz="1050">
+              <a:defRPr sz="1150">
                 <a:solidFill>
                   <a:srgbClr val="475569"/>
                 </a:solidFill>
@@ -8397,7 +8397,7 @@
               </a:defRPr>
             </a:pPr>
             <a:r>
-              <a:t>Geen fysiek overwicht of conditievereiste: stagiair en CEO staan direct op gelijk niveau tegenover elkaar aan tafel.</a:t>
+              <a:t>Geen fysiek overwicht vereist: stagiair en directielid staan direct op gelijk niveau tegenover elkaar aan tafel.</a:t>
             </a:r>
           </a:p>
         </p:txBody>
@@ -8410,8 +8410,8 @@
         </p:nvSpPr>
         <p:spPr>
           <a:xfrm>
-            <a:off x="6172200" y="1645920"/>
-            <a:ext cx="5257800" cy="2057400"/>
+            <a:off x="6263640" y="1755648"/>
+            <a:ext cx="4645152" cy="2121408"/>
           </a:xfrm>
           <a:prstGeom prst="roundRect">
             <a:avLst/>
@@ -8419,7 +8419,7 @@
           <a:solidFill>
             <a:srgbClr val="FFFFFF"/>
           </a:solidFill>
-          <a:ln w="12700">
+          <a:ln w="15240">
             <a:solidFill>
               <a:srgbClr val="E2E8F0"/>
             </a:solidFill>
@@ -8455,8 +8455,8 @@
         </p:nvSpPr>
         <p:spPr>
           <a:xfrm>
-            <a:off x="6172200" y="1645920"/>
-            <a:ext cx="5257800" cy="73152"/>
+            <a:off x="6263640" y="1755648"/>
+            <a:ext cx="4645152" cy="73152"/>
           </a:xfrm>
           <a:prstGeom prst="rect">
             <a:avLst/>
@@ -8506,7 +8506,7 @@
         </p:blipFill>
         <p:spPr>
           <a:xfrm>
-            <a:off x="6446520" y="1920240"/>
+            <a:off x="6519672" y="2048256"/>
             <a:ext cx="685800" cy="685800"/>
           </a:xfrm>
           <a:prstGeom prst="rect">
@@ -8522,8 +8522,8 @@
         </p:nvSpPr>
         <p:spPr>
           <a:xfrm>
-            <a:off x="7269480" y="1874520"/>
-            <a:ext cx="3931920" cy="1600200"/>
+            <a:off x="7379208" y="1993392"/>
+            <a:ext cx="3364992" cy="1755648"/>
           </a:xfrm>
           <a:prstGeom prst="rect">
             <a:avLst/>
@@ -8537,7 +8537,7 @@
           <a:lstStyle/>
           <a:p>
             <a:pPr>
-              <a:defRPr sz="1200" b="1">
+              <a:defRPr sz="1300" b="1">
                 <a:solidFill>
                   <a:srgbClr val="1E293B"/>
                 </a:solidFill>
@@ -8553,7 +8553,7 @@
               <a:spcBef>
                 <a:spcPts val="600"/>
               </a:spcBef>
-              <a:defRPr sz="1050">
+              <a:defRPr sz="1150">
                 <a:solidFill>
                   <a:srgbClr val="475569"/>
                 </a:solidFill>
@@ -8561,7 +8561,7 @@
               </a:defRPr>
             </a:pPr>
             <a:r>
-              <a:t>Activeert reflexen, hand-oogcoördinatie en breinplasticiteit. De ideale doorbreking van langdurige kantoor- en schermfocus.</a:t>
+              <a:t>Activeert reflexen, hand-oogcoördinatie en breinplasticiteit. De ideale doorbreking van langdurig schermwerk.</a:t>
             </a:r>
           </a:p>
         </p:txBody>
@@ -8574,8 +8574,8 @@
         </p:nvSpPr>
         <p:spPr>
           <a:xfrm>
-            <a:off x="731520" y="3931920"/>
-            <a:ext cx="5257800" cy="2057400"/>
+            <a:off x="1280160" y="4096512"/>
+            <a:ext cx="4645152" cy="2121408"/>
           </a:xfrm>
           <a:prstGeom prst="roundRect">
             <a:avLst/>
@@ -8583,7 +8583,7 @@
           <a:solidFill>
             <a:srgbClr val="FFFFFF"/>
           </a:solidFill>
-          <a:ln w="12700">
+          <a:ln w="15240">
             <a:solidFill>
               <a:srgbClr val="E2E8F0"/>
             </a:solidFill>
@@ -8619,8 +8619,8 @@
         </p:nvSpPr>
         <p:spPr>
           <a:xfrm>
-            <a:off x="731520" y="3931920"/>
-            <a:ext cx="5257800" cy="73152"/>
+            <a:off x="1280160" y="4096512"/>
+            <a:ext cx="4645152" cy="73152"/>
           </a:xfrm>
           <a:prstGeom prst="rect">
             <a:avLst/>
@@ -8670,7 +8670,7 @@
         </p:blipFill>
         <p:spPr>
           <a:xfrm>
-            <a:off x="1005840" y="4206240"/>
+            <a:off x="1536192" y="4389120"/>
             <a:ext cx="685800" cy="685800"/>
           </a:xfrm>
           <a:prstGeom prst="rect">
@@ -8686,8 +8686,8 @@
         </p:nvSpPr>
         <p:spPr>
           <a:xfrm>
-            <a:off x="1828800" y="4160520"/>
-            <a:ext cx="3931920" cy="1600200"/>
+            <a:off x="2395728" y="4334256"/>
+            <a:ext cx="3364992" cy="1755648"/>
           </a:xfrm>
           <a:prstGeom prst="rect">
             <a:avLst/>
@@ -8701,7 +8701,7 @@
           <a:lstStyle/>
           <a:p>
             <a:pPr>
-              <a:defRPr sz="1200" b="1">
+              <a:defRPr sz="1300" b="1">
                 <a:solidFill>
                   <a:srgbClr val="1E293B"/>
                 </a:solidFill>
@@ -8717,7 +8717,7 @@
               <a:spcBef>
                 <a:spcPts val="600"/>
               </a:spcBef>
-              <a:defRPr sz="1050">
+              <a:defRPr sz="1150">
                 <a:solidFill>
                   <a:srgbClr val="475569"/>
                 </a:solidFill>
@@ -8725,7 +8725,7 @@
               </a:defRPr>
             </a:pPr>
             <a:r>
-              <a:t>Binnen 2 minuten ontstaan er spannende rally's, spectaculaire punten en hilarische missers. Gegarandeerd positieve teamenergie.</a:t>
+              <a:t>Binnen 2 minuten ontstaan er spannende rally's, spectaculaire punten en hilarische missers. Gegarandeerd positieve energie.</a:t>
             </a:r>
           </a:p>
         </p:txBody>
@@ -8738,8 +8738,8 @@
         </p:nvSpPr>
         <p:spPr>
           <a:xfrm>
-            <a:off x="6172200" y="3931920"/>
-            <a:ext cx="5257800" cy="2057400"/>
+            <a:off x="6263640" y="4096512"/>
+            <a:ext cx="4645152" cy="2121408"/>
           </a:xfrm>
           <a:prstGeom prst="roundRect">
             <a:avLst/>
@@ -8747,7 +8747,7 @@
           <a:solidFill>
             <a:srgbClr val="FFFFFF"/>
           </a:solidFill>
-          <a:ln w="12700">
+          <a:ln w="15240">
             <a:solidFill>
               <a:srgbClr val="E2E8F0"/>
             </a:solidFill>
@@ -8783,8 +8783,8 @@
         </p:nvSpPr>
         <p:spPr>
           <a:xfrm>
-            <a:off x="6172200" y="3931920"/>
-            <a:ext cx="5257800" cy="73152"/>
+            <a:off x="6263640" y="4096512"/>
+            <a:ext cx="4645152" cy="73152"/>
           </a:xfrm>
           <a:prstGeom prst="rect">
             <a:avLst/>
@@ -8834,7 +8834,7 @@
         </p:blipFill>
         <p:spPr>
           <a:xfrm>
-            <a:off x="6446520" y="4206240"/>
+            <a:off x="6519672" y="4389120"/>
             <a:ext cx="685800" cy="685800"/>
           </a:xfrm>
           <a:prstGeom prst="rect">
@@ -8850,8 +8850,8 @@
         </p:nvSpPr>
         <p:spPr>
           <a:xfrm>
-            <a:off x="7269480" y="4160520"/>
-            <a:ext cx="3931920" cy="1600200"/>
+            <a:off x="7379208" y="4334256"/>
+            <a:ext cx="3364992" cy="1755648"/>
           </a:xfrm>
           <a:prstGeom prst="rect">
             <a:avLst/>
@@ -8865,7 +8865,7 @@
           <a:lstStyle/>
           <a:p>
             <a:pPr>
-              <a:defRPr sz="1200" b="1">
+              <a:defRPr sz="1300" b="1">
                 <a:solidFill>
                   <a:srgbClr val="1E293B"/>
                 </a:solidFill>
@@ -8881,7 +8881,7 @@
               <a:spcBef>
                 <a:spcPts val="600"/>
               </a:spcBef>
-              <a:defRPr sz="1050">
+              <a:defRPr sz="1150">
                 <a:solidFill>
                   <a:srgbClr val="475569"/>
                 </a:solidFill>
@@ -8889,7 +8889,7 @@
               </a:defRPr>
             </a:pPr>
             <a:r>
-              <a:t>Veilige binnensport zonder fysiek contact. Iedereen kan zorgeloos meedoen in normale vrijetijdskleding of sportoutfit.</a:t>
+              <a:t>Veilige binnensport zonder fysiek contact. Iedereen kan zorgeloos meedoen in normale vrijetijdskleding.</a:t>
             </a:r>
           </a:p>
         </p:txBody>
@@ -9014,8 +9014,8 @@
         </p:blipFill>
         <p:spPr>
           <a:xfrm>
-            <a:off x="10241280" y="365760"/>
-            <a:ext cx="626012" cy="594360"/>
+            <a:off x="9509760" y="438912"/>
+            <a:ext cx="693429" cy="658368"/>
           </a:xfrm>
           <a:prstGeom prst="rect">
             <a:avLst/>
@@ -9030,8 +9030,8 @@
         </p:nvSpPr>
         <p:spPr>
           <a:xfrm>
-            <a:off x="731520" y="320040"/>
-            <a:ext cx="7315200" cy="320040"/>
+            <a:off x="1280160" y="438912"/>
+            <a:ext cx="7772400" cy="320040"/>
           </a:xfrm>
           <a:prstGeom prst="rect">
             <a:avLst/>
@@ -9045,7 +9045,7 @@
           <a:lstStyle/>
           <a:p>
             <a:pPr>
-              <a:defRPr sz="950" b="1">
+              <a:defRPr sz="1100" b="1">
                 <a:solidFill>
                   <a:srgbClr val="D95500"/>
                 </a:solidFill>
@@ -9066,8 +9066,8 @@
         </p:nvSpPr>
         <p:spPr>
           <a:xfrm>
-            <a:off x="731520" y="594360"/>
-            <a:ext cx="9144000" cy="731520"/>
+            <a:off x="1280160" y="749808"/>
+            <a:ext cx="8412480" cy="731520"/>
           </a:xfrm>
           <a:prstGeom prst="rect">
             <a:avLst/>
@@ -9081,7 +9081,7 @@
           <a:lstStyle/>
           <a:p>
             <a:pPr>
-              <a:defRPr sz="2400" b="1">
+              <a:defRPr sz="2600" b="1">
                 <a:solidFill>
                   <a:srgbClr val="111827"/>
                 </a:solidFill>
@@ -9102,8 +9102,8 @@
         </p:nvSpPr>
         <p:spPr>
           <a:xfrm>
-            <a:off x="731520" y="1353312"/>
-            <a:ext cx="4114800" cy="36576"/>
+            <a:off x="1280160" y="1536192"/>
+            <a:ext cx="4572000" cy="41148"/>
           </a:xfrm>
           <a:prstGeom prst="rect">
             <a:avLst/>
@@ -9145,8 +9145,8 @@
         </p:nvSpPr>
         <p:spPr>
           <a:xfrm>
-            <a:off x="731520" y="6446520"/>
-            <a:ext cx="10728655" cy="274320"/>
+            <a:off x="1280160" y="6291072"/>
+            <a:ext cx="9631375" cy="274320"/>
           </a:xfrm>
           <a:prstGeom prst="rect">
             <a:avLst/>
@@ -9160,7 +9160,7 @@
           <a:lstStyle/>
           <a:p>
             <a:pPr>
-              <a:defRPr sz="850">
+              <a:defRPr sz="950">
                 <a:solidFill>
                   <a:srgbClr val="94A3B8"/>
                 </a:solidFill>
@@ -9181,8 +9181,8 @@
         </p:nvSpPr>
         <p:spPr>
           <a:xfrm>
-            <a:off x="731520" y="1645920"/>
-            <a:ext cx="5257800" cy="2057400"/>
+            <a:off x="1280160" y="1755648"/>
+            <a:ext cx="4645152" cy="2121408"/>
           </a:xfrm>
           <a:prstGeom prst="roundRect">
             <a:avLst/>
@@ -9190,7 +9190,7 @@
           <a:solidFill>
             <a:srgbClr val="FFFFFF"/>
           </a:solidFill>
-          <a:ln w="12700">
+          <a:ln w="15240">
             <a:solidFill>
               <a:srgbClr val="E2E8F0"/>
             </a:solidFill>
@@ -9226,8 +9226,8 @@
         </p:nvSpPr>
         <p:spPr>
           <a:xfrm>
-            <a:off x="1005840" y="1828800"/>
-            <a:ext cx="4709160" cy="1691640"/>
+            <a:off x="1554480" y="1938528"/>
+            <a:ext cx="4096512" cy="1847088"/>
           </a:xfrm>
           <a:prstGeom prst="rect">
             <a:avLst/>
@@ -9241,7 +9241,7 @@
           <a:lstStyle/>
           <a:p>
             <a:pPr>
-              <a:defRPr sz="1200" b="1">
+              <a:defRPr sz="1300" b="1">
                 <a:solidFill>
                   <a:srgbClr val="D95500"/>
                 </a:solidFill>
@@ -9257,7 +9257,7 @@
               <a:spcBef>
                 <a:spcPts val="100"/>
               </a:spcBef>
-              <a:defRPr sz="950">
+              <a:defRPr sz="1050">
                 <a:solidFill>
                   <a:srgbClr val="94A3B8"/>
                 </a:solidFill>
@@ -9273,7 +9273,7 @@
               <a:spcBef>
                 <a:spcPts val="300"/>
               </a:spcBef>
-              <a:defRPr sz="900">
+              <a:defRPr sz="1050">
                 <a:solidFill>
                   <a:srgbClr val="475569"/>
                 </a:solidFill>
@@ -9289,7 +9289,7 @@
               <a:spcBef>
                 <a:spcPts val="300"/>
               </a:spcBef>
-              <a:defRPr sz="900">
+              <a:defRPr sz="1050">
                 <a:solidFill>
                   <a:srgbClr val="475569"/>
                 </a:solidFill>
@@ -9297,7 +9297,7 @@
               </a:defRPr>
             </a:pPr>
             <a:r>
-              <a:t>• Jong &amp; dynamisch team dat competitie waardeert</a:t>
+              <a:t>• Jong &amp; dynamisch team dat gezonde competitie zoekt</a:t>
             </a:r>
           </a:p>
           <a:p>
@@ -9305,7 +9305,7 @@
               <a:spcBef>
                 <a:spcPts val="300"/>
               </a:spcBef>
-              <a:defRPr sz="900">
+              <a:defRPr sz="1050">
                 <a:solidFill>
                   <a:srgbClr val="475569"/>
                 </a:solidFill>
@@ -9313,7 +9313,7 @@
               </a:defRPr>
             </a:pPr>
             <a:r>
-              <a:t>• Zoeken informele, actieve vrijdagmiddag of kwartaalafsluiting</a:t>
+              <a:t>• Zoeken een energieke vrijdagmiddag of kwartaalafsluiting</a:t>
             </a:r>
           </a:p>
           <a:p>
@@ -9321,7 +9321,7 @@
               <a:spcBef>
                 <a:spcPts val="300"/>
               </a:spcBef>
-              <a:defRPr sz="900">
+              <a:defRPr sz="1050">
                 <a:solidFill>
                   <a:srgbClr val="475569"/>
                 </a:solidFill>
@@ -9329,7 +9329,7 @@
               </a:defRPr>
             </a:pPr>
             <a:r>
-              <a:t>• Vaak al een tafeltennistafel aanwezig op kantoor</a:t>
+              <a:t>• Vaak al een tafeltennistafel aanwezig op de werkvloer</a:t>
             </a:r>
           </a:p>
         </p:txBody>
@@ -9342,8 +9342,8 @@
         </p:nvSpPr>
         <p:spPr>
           <a:xfrm>
-            <a:off x="6172200" y="1645920"/>
-            <a:ext cx="5257800" cy="2057400"/>
+            <a:off x="6263640" y="1755648"/>
+            <a:ext cx="4645152" cy="2121408"/>
           </a:xfrm>
           <a:prstGeom prst="roundRect">
             <a:avLst/>
@@ -9351,7 +9351,7 @@
           <a:solidFill>
             <a:srgbClr val="FFFFFF"/>
           </a:solidFill>
-          <a:ln w="12700">
+          <a:ln w="15240">
             <a:solidFill>
               <a:srgbClr val="E2E8F0"/>
             </a:solidFill>
@@ -9387,8 +9387,8 @@
         </p:nvSpPr>
         <p:spPr>
           <a:xfrm>
-            <a:off x="6446520" y="1828800"/>
-            <a:ext cx="4709160" cy="1691640"/>
+            <a:off x="6537960" y="1938528"/>
+            <a:ext cx="4096512" cy="1847088"/>
           </a:xfrm>
           <a:prstGeom prst="rect">
             <a:avLst/>
@@ -9402,7 +9402,7 @@
           <a:lstStyle/>
           <a:p>
             <a:pPr>
-              <a:defRPr sz="1200" b="1">
+              <a:defRPr sz="1300" b="1">
                 <a:solidFill>
                   <a:srgbClr val="D95500"/>
                 </a:solidFill>
@@ -9418,7 +9418,7 @@
               <a:spcBef>
                 <a:spcPts val="100"/>
               </a:spcBef>
-              <a:defRPr sz="950">
+              <a:defRPr sz="1050">
                 <a:solidFill>
                   <a:srgbClr val="94A3B8"/>
                 </a:solidFill>
@@ -9434,7 +9434,7 @@
               <a:spcBef>
                 <a:spcPts val="300"/>
               </a:spcBef>
-              <a:defRPr sz="900">
+              <a:defRPr sz="1050">
                 <a:solidFill>
                   <a:srgbClr val="475569"/>
                 </a:solidFill>
@@ -9450,7 +9450,7 @@
               <a:spcBef>
                 <a:spcPts val="300"/>
               </a:spcBef>
-              <a:defRPr sz="900">
+              <a:defRPr sz="1050">
                 <a:solidFill>
                   <a:srgbClr val="475569"/>
                 </a:solidFill>
@@ -9458,7 +9458,7 @@
               </a:defRPr>
             </a:pPr>
             <a:r>
-              <a:t>• Teambuilding na reorganisaties of fusies</a:t>
+              <a:t>• Teambuilding na fusies, reorganisaties of projectstarts</a:t>
             </a:r>
           </a:p>
           <a:p>
@@ -9466,7 +9466,7 @@
               <a:spcBef>
                 <a:spcPts val="300"/>
               </a:spcBef>
-              <a:defRPr sz="900">
+              <a:defRPr sz="1050">
                 <a:solidFill>
                   <a:srgbClr val="475569"/>
                 </a:solidFill>
@@ -9482,7 +9482,7 @@
               <a:spcBef>
                 <a:spcPts val="300"/>
               </a:spcBef>
-              <a:defRPr sz="900">
+              <a:defRPr sz="1050">
                 <a:solidFill>
                   <a:srgbClr val="475569"/>
                 </a:solidFill>
@@ -9490,7 +9490,7 @@
               </a:defRPr>
             </a:pPr>
             <a:r>
-              <a:t>• Boeken vaak 'Company Battle' of maatwerk</a:t>
+              <a:t>• Boeken vaak de complete 'Company Battle' of maatwerk</a:t>
             </a:r>
           </a:p>
         </p:txBody>
@@ -9503,8 +9503,8 @@
         </p:nvSpPr>
         <p:spPr>
           <a:xfrm>
-            <a:off x="731520" y="3931920"/>
-            <a:ext cx="5257800" cy="2057400"/>
+            <a:off x="1280160" y="4096512"/>
+            <a:ext cx="4645152" cy="2121408"/>
           </a:xfrm>
           <a:prstGeom prst="roundRect">
             <a:avLst/>
@@ -9512,7 +9512,7 @@
           <a:solidFill>
             <a:srgbClr val="FFFFFF"/>
           </a:solidFill>
-          <a:ln w="12700">
+          <a:ln w="15240">
             <a:solidFill>
               <a:srgbClr val="E2E8F0"/>
             </a:solidFill>
@@ -9548,8 +9548,8 @@
         </p:nvSpPr>
         <p:spPr>
           <a:xfrm>
-            <a:off x="1005840" y="4114800"/>
-            <a:ext cx="4709160" cy="1691640"/>
+            <a:off x="1554480" y="4279392"/>
+            <a:ext cx="4096512" cy="1847088"/>
           </a:xfrm>
           <a:prstGeom prst="rect">
             <a:avLst/>
@@ -9563,7 +9563,7 @@
           <a:lstStyle/>
           <a:p>
             <a:pPr>
-              <a:defRPr sz="1200" b="1">
+              <a:defRPr sz="1300" b="1">
                 <a:solidFill>
                   <a:srgbClr val="D95500"/>
                 </a:solidFill>
@@ -9579,7 +9579,7 @@
               <a:spcBef>
                 <a:spcPts val="100"/>
               </a:spcBef>
-              <a:defRPr sz="950">
+              <a:defRPr sz="1050">
                 <a:solidFill>
                   <a:srgbClr val="94A3B8"/>
                 </a:solidFill>
@@ -9595,7 +9595,7 @@
               <a:spcBef>
                 <a:spcPts val="300"/>
               </a:spcBef>
-              <a:defRPr sz="900">
+              <a:defRPr sz="1050">
                 <a:solidFill>
                   <a:srgbClr val="475569"/>
                 </a:solidFill>
@@ -9611,7 +9611,7 @@
               <a:spcBef>
                 <a:spcPts val="300"/>
               </a:spcBef>
-              <a:defRPr sz="900">
+              <a:defRPr sz="1050">
                 <a:solidFill>
                   <a:srgbClr val="475569"/>
                 </a:solidFill>
@@ -9627,7 +9627,7 @@
               <a:spcBef>
                 <a:spcPts val="300"/>
               </a:spcBef>
-              <a:defRPr sz="900">
+              <a:defRPr sz="1050">
                 <a:solidFill>
                   <a:srgbClr val="475569"/>
                 </a:solidFill>
@@ -9635,7 +9635,7 @@
               </a:defRPr>
             </a:pPr>
             <a:r>
-              <a:t>• White-label of co-branded evenementen</a:t>
+              <a:t>• White-label of co-branded bedrijfsevenementen</a:t>
             </a:r>
           </a:p>
           <a:p>
@@ -9643,7 +9643,7 @@
               <a:spcBef>
                 <a:spcPts val="300"/>
               </a:spcBef>
-              <a:defRPr sz="900">
+              <a:defRPr sz="1050">
                 <a:solidFill>
                   <a:srgbClr val="475569"/>
                 </a:solidFill>
@@ -9664,8 +9664,8 @@
         </p:nvSpPr>
         <p:spPr>
           <a:xfrm>
-            <a:off x="6172200" y="3931920"/>
-            <a:ext cx="5257800" cy="2057400"/>
+            <a:off x="6263640" y="4096512"/>
+            <a:ext cx="4645152" cy="2121408"/>
           </a:xfrm>
           <a:prstGeom prst="roundRect">
             <a:avLst/>
@@ -9673,7 +9673,7 @@
           <a:solidFill>
             <a:srgbClr val="FFFFFF"/>
           </a:solidFill>
-          <a:ln w="12700">
+          <a:ln w="15240">
             <a:solidFill>
               <a:srgbClr val="E2E8F0"/>
             </a:solidFill>
@@ -9709,8 +9709,8 @@
         </p:nvSpPr>
         <p:spPr>
           <a:xfrm>
-            <a:off x="6446520" y="4114800"/>
-            <a:ext cx="4709160" cy="1691640"/>
+            <a:off x="6537960" y="4279392"/>
+            <a:ext cx="4096512" cy="1847088"/>
           </a:xfrm>
           <a:prstGeom prst="rect">
             <a:avLst/>
@@ -9724,7 +9724,7 @@
           <a:lstStyle/>
           <a:p>
             <a:pPr>
-              <a:defRPr sz="1200" b="1">
+              <a:defRPr sz="1300" b="1">
                 <a:solidFill>
                   <a:srgbClr val="D95500"/>
                 </a:solidFill>
@@ -9740,7 +9740,7 @@
               <a:spcBef>
                 <a:spcPts val="100"/>
               </a:spcBef>
-              <a:defRPr sz="950">
+              <a:defRPr sz="1050">
                 <a:solidFill>
                   <a:srgbClr val="94A3B8"/>
                 </a:solidFill>
@@ -9756,7 +9756,7 @@
               <a:spcBef>
                 <a:spcPts val="300"/>
               </a:spcBef>
-              <a:defRPr sz="900">
+              <a:defRPr sz="1050">
                 <a:solidFill>
                   <a:srgbClr val="475569"/>
                 </a:solidFill>
@@ -9772,7 +9772,7 @@
               <a:spcBef>
                 <a:spcPts val="300"/>
               </a:spcBef>
-              <a:defRPr sz="900">
+              <a:defRPr sz="1050">
                 <a:solidFill>
                   <a:srgbClr val="475569"/>
                 </a:solidFill>
@@ -9788,7 +9788,7 @@
               <a:spcBef>
                 <a:spcPts val="300"/>
               </a:spcBef>
-              <a:defRPr sz="900">
+              <a:defRPr sz="1050">
                 <a:solidFill>
                   <a:srgbClr val="475569"/>
                 </a:solidFill>
@@ -9796,7 +9796,7 @@
               </a:defRPr>
             </a:pPr>
             <a:r>
-              <a:t>• Ideale sponsormogelijkheden rondom de trofee</a:t>
+              <a:t>• Sponsormogelijkheden rondom de wisseltrofee</a:t>
             </a:r>
           </a:p>
           <a:p>
@@ -9804,7 +9804,7 @@
               <a:spcBef>
                 <a:spcPts val="300"/>
               </a:spcBef>
-              <a:defRPr sz="900">
+              <a:defRPr sz="1050">
                 <a:solidFill>
                   <a:srgbClr val="475569"/>
                 </a:solidFill>
@@ -9937,8 +9937,8 @@
         </p:blipFill>
         <p:spPr>
           <a:xfrm>
-            <a:off x="10241280" y="365760"/>
-            <a:ext cx="626012" cy="594360"/>
+            <a:off x="9509760" y="438912"/>
+            <a:ext cx="693429" cy="658368"/>
           </a:xfrm>
           <a:prstGeom prst="rect">
             <a:avLst/>
@@ -9953,8 +9953,8 @@
         </p:nvSpPr>
         <p:spPr>
           <a:xfrm>
-            <a:off x="731520" y="320040"/>
-            <a:ext cx="7315200" cy="320040"/>
+            <a:off x="1280160" y="438912"/>
+            <a:ext cx="7772400" cy="320040"/>
           </a:xfrm>
           <a:prstGeom prst="rect">
             <a:avLst/>
@@ -9968,7 +9968,7 @@
           <a:lstStyle/>
           <a:p>
             <a:pPr>
-              <a:defRPr sz="950" b="1">
+              <a:defRPr sz="1100" b="1">
                 <a:solidFill>
                   <a:srgbClr val="D95500"/>
                 </a:solidFill>
@@ -9989,8 +9989,8 @@
         </p:nvSpPr>
         <p:spPr>
           <a:xfrm>
-            <a:off x="731520" y="594360"/>
-            <a:ext cx="9144000" cy="731520"/>
+            <a:off x="1280160" y="749808"/>
+            <a:ext cx="8412480" cy="731520"/>
           </a:xfrm>
           <a:prstGeom prst="rect">
             <a:avLst/>
@@ -10004,7 +10004,7 @@
           <a:lstStyle/>
           <a:p>
             <a:pPr>
-              <a:defRPr sz="2400" b="1">
+              <a:defRPr sz="2600" b="1">
                 <a:solidFill>
                   <a:srgbClr val="111827"/>
                 </a:solidFill>
@@ -10025,8 +10025,8 @@
         </p:nvSpPr>
         <p:spPr>
           <a:xfrm>
-            <a:off x="731520" y="1353312"/>
-            <a:ext cx="4114800" cy="36576"/>
+            <a:off x="1280160" y="1536192"/>
+            <a:ext cx="4572000" cy="41148"/>
           </a:xfrm>
           <a:prstGeom prst="rect">
             <a:avLst/>
@@ -10068,8 +10068,8 @@
         </p:nvSpPr>
         <p:spPr>
           <a:xfrm>
-            <a:off x="731520" y="6446520"/>
-            <a:ext cx="10728655" cy="274320"/>
+            <a:off x="1280160" y="6291072"/>
+            <a:ext cx="9631375" cy="274320"/>
           </a:xfrm>
           <a:prstGeom prst="rect">
             <a:avLst/>
@@ -10083,7 +10083,7 @@
           <a:lstStyle/>
           <a:p>
             <a:pPr>
-              <a:defRPr sz="850">
+              <a:defRPr sz="950">
                 <a:solidFill>
                   <a:srgbClr val="94A3B8"/>
                 </a:solidFill>
@@ -10104,8 +10104,8 @@
         </p:nvSpPr>
         <p:spPr>
           <a:xfrm>
-            <a:off x="731520" y="1645920"/>
-            <a:ext cx="3456432" cy="4572000"/>
+            <a:off x="1280160" y="1755648"/>
+            <a:ext cx="2999232" cy="4462272"/>
           </a:xfrm>
           <a:prstGeom prst="roundRect">
             <a:avLst/>
@@ -10113,7 +10113,7 @@
           <a:solidFill>
             <a:srgbClr val="FFFFFF"/>
           </a:solidFill>
-          <a:ln w="12700">
+          <a:ln w="15240">
             <a:solidFill>
               <a:srgbClr val="E2E8F0"/>
             </a:solidFill>
@@ -10149,8 +10149,8 @@
         </p:nvSpPr>
         <p:spPr>
           <a:xfrm>
-            <a:off x="731520" y="1645920"/>
-            <a:ext cx="3456432" cy="73152"/>
+            <a:off x="1280160" y="1755648"/>
+            <a:ext cx="2999232" cy="73152"/>
           </a:xfrm>
           <a:prstGeom prst="rect">
             <a:avLst/>
@@ -10200,8 +10200,8 @@
         </p:blipFill>
         <p:spPr>
           <a:xfrm>
-            <a:off x="3364992" y="1828800"/>
-            <a:ext cx="640080" cy="640080"/>
+            <a:off x="3502152" y="1938528"/>
+            <a:ext cx="621792" cy="621792"/>
           </a:xfrm>
           <a:prstGeom prst="rect">
             <a:avLst/>
@@ -10216,8 +10216,8 @@
         </p:nvSpPr>
         <p:spPr>
           <a:xfrm>
-            <a:off x="960120" y="1874520"/>
-            <a:ext cx="2999232" cy="4114800"/>
+            <a:off x="1508760" y="1984248"/>
+            <a:ext cx="2542032" cy="4096512"/>
           </a:xfrm>
           <a:prstGeom prst="rect">
             <a:avLst/>
@@ -10231,7 +10231,7 @@
           <a:lstStyle/>
           <a:p>
             <a:pPr>
-              <a:defRPr sz="1100" b="1">
+              <a:defRPr sz="1200" b="1">
                 <a:solidFill>
                   <a:srgbClr val="D95500"/>
                 </a:solidFill>
@@ -10247,7 +10247,7 @@
               <a:spcBef>
                 <a:spcPts val="200"/>
               </a:spcBef>
-              <a:defRPr sz="950">
+              <a:defRPr sz="1050">
                 <a:solidFill>
                   <a:srgbClr val="94A3B8"/>
                 </a:solidFill>
@@ -10278,7 +10278,7 @@
               <a:spcBef>
                 <a:spcPts val="800"/>
               </a:spcBef>
-              <a:defRPr sz="950">
+              <a:defRPr sz="1100">
                 <a:solidFill>
                   <a:srgbClr val="475569"/>
                 </a:solidFill>
@@ -10294,7 +10294,7 @@
               <a:spcBef>
                 <a:spcPts val="800"/>
               </a:spcBef>
-              <a:defRPr sz="950">
+              <a:defRPr sz="1100">
                 <a:solidFill>
                   <a:srgbClr val="475569"/>
                 </a:solidFill>
@@ -10302,7 +10302,7 @@
               </a:defRPr>
             </a:pPr>
             <a:r>
-              <a:t>• Hoge brutomarge (80-85%): materiaal is reeds aangeschaft, hoofdkost is tijd &amp; reiskosten.</a:t>
+              <a:t>• Hoge brutomarge (80-85%): materiaal reeds in bezit, minimale variabele kosten.</a:t>
             </a:r>
           </a:p>
           <a:p>
@@ -10310,7 +10310,7 @@
               <a:spcBef>
                 <a:spcPts val="800"/>
               </a:spcBef>
-              <a:defRPr sz="950">
+              <a:defRPr sz="1100">
                 <a:solidFill>
                   <a:srgbClr val="475569"/>
                 </a:solidFill>
@@ -10318,7 +10318,7 @@
               </a:defRPr>
             </a:pPr>
             <a:r>
-              <a:t>• Opschaling: 2e trainer toevoegen bij groepen &gt; 12 personen (+€250-€350 opslag).</a:t>
+              <a:t>• Opschaling: 2e trainer toevoegen bij groepen &gt; 12 personen (+€250-€350).</a:t>
             </a:r>
           </a:p>
         </p:txBody>
@@ -10331,8 +10331,8 @@
         </p:nvSpPr>
         <p:spPr>
           <a:xfrm>
-            <a:off x="4370832" y="1645920"/>
-            <a:ext cx="3456432" cy="4572000"/>
+            <a:off x="4590288" y="1755648"/>
+            <a:ext cx="2999232" cy="4462272"/>
           </a:xfrm>
           <a:prstGeom prst="roundRect">
             <a:avLst/>
@@ -10340,7 +10340,7 @@
           <a:solidFill>
             <a:srgbClr val="FFFFFF"/>
           </a:solidFill>
-          <a:ln w="12700">
+          <a:ln w="15240">
             <a:solidFill>
               <a:srgbClr val="E2E8F0"/>
             </a:solidFill>
@@ -10376,8 +10376,8 @@
         </p:nvSpPr>
         <p:spPr>
           <a:xfrm>
-            <a:off x="4370832" y="1645920"/>
-            <a:ext cx="3456432" cy="73152"/>
+            <a:off x="4590288" y="1755648"/>
+            <a:ext cx="2999232" cy="73152"/>
           </a:xfrm>
           <a:prstGeom prst="rect">
             <a:avLst/>
@@ -10427,8 +10427,8 @@
         </p:blipFill>
         <p:spPr>
           <a:xfrm>
-            <a:off x="7004304" y="1828800"/>
-            <a:ext cx="640080" cy="640080"/>
+            <a:off x="6812280" y="1938528"/>
+            <a:ext cx="621792" cy="621792"/>
           </a:xfrm>
           <a:prstGeom prst="rect">
             <a:avLst/>
@@ -10443,8 +10443,8 @@
         </p:nvSpPr>
         <p:spPr>
           <a:xfrm>
-            <a:off x="4599432" y="1874520"/>
-            <a:ext cx="2999232" cy="4114800"/>
+            <a:off x="4818888" y="1984248"/>
+            <a:ext cx="2542032" cy="4096512"/>
           </a:xfrm>
           <a:prstGeom prst="rect">
             <a:avLst/>
@@ -10458,7 +10458,7 @@
           <a:lstStyle/>
           <a:p>
             <a:pPr>
-              <a:defRPr sz="1100" b="1">
+              <a:defRPr sz="1200" b="1">
                 <a:solidFill>
                   <a:srgbClr val="D95500"/>
                 </a:solidFill>
@@ -10474,7 +10474,7 @@
               <a:spcBef>
                 <a:spcPts val="200"/>
               </a:spcBef>
-              <a:defRPr sz="950">
+              <a:defRPr sz="1050">
                 <a:solidFill>
                   <a:srgbClr val="94A3B8"/>
                 </a:solidFill>
@@ -10505,7 +10505,7 @@
               <a:spcBef>
                 <a:spcPts val="800"/>
               </a:spcBef>
-              <a:defRPr sz="950">
+              <a:defRPr sz="1100">
                 <a:solidFill>
                   <a:srgbClr val="475569"/>
                 </a:solidFill>
@@ -10521,7 +10521,7 @@
               <a:spcBef>
                 <a:spcPts val="800"/>
               </a:spcBef>
-              <a:defRPr sz="950">
+              <a:defRPr sz="1100">
                 <a:solidFill>
                   <a:srgbClr val="475569"/>
                 </a:solidFill>
@@ -10529,7 +10529,7 @@
               </a:defRPr>
             </a:pPr>
             <a:r>
-              <a:t>• Gepersonaliseerde TT Clinics batjes met bedrijfslogo als blijvend aandenken.</a:t>
+              <a:t>• Gepersonaliseerde TT Clinics batjes met bedrijfslogo als aandenken.</a:t>
             </a:r>
           </a:p>
           <a:p>
@@ -10537,7 +10537,7 @@
               <a:spcBef>
                 <a:spcPts val="800"/>
               </a:spcBef>
-              <a:defRPr sz="950">
+              <a:defRPr sz="1100">
                 <a:solidFill>
                   <a:srgbClr val="475569"/>
                 </a:solidFill>
@@ -10545,7 +10545,7 @@
               </a:defRPr>
             </a:pPr>
             <a:r>
-              <a:t>• Professionele aftermovie / fotoreportage van het toernooi voor interne communicatie.</a:t>
+              <a:t>• Professionele aftermovie / fotoreportage voor interne communicatie.</a:t>
             </a:r>
           </a:p>
         </p:txBody>
@@ -10558,8 +10558,8 @@
         </p:nvSpPr>
         <p:spPr>
           <a:xfrm>
-            <a:off x="8010144" y="1645920"/>
-            <a:ext cx="3456432" cy="4572000"/>
+            <a:off x="7900416" y="1755648"/>
+            <a:ext cx="2999232" cy="4462272"/>
           </a:xfrm>
           <a:prstGeom prst="roundRect">
             <a:avLst/>
@@ -10567,7 +10567,7 @@
           <a:solidFill>
             <a:srgbClr val="FFFFFF"/>
           </a:solidFill>
-          <a:ln w="12700">
+          <a:ln w="15240">
             <a:solidFill>
               <a:srgbClr val="E2E8F0"/>
             </a:solidFill>
@@ -10603,8 +10603,8 @@
         </p:nvSpPr>
         <p:spPr>
           <a:xfrm>
-            <a:off x="8010144" y="1645920"/>
-            <a:ext cx="3456432" cy="73152"/>
+            <a:off x="7900416" y="1755648"/>
+            <a:ext cx="2999232" cy="73152"/>
           </a:xfrm>
           <a:prstGeom prst="rect">
             <a:avLst/>
@@ -10654,8 +10654,8 @@
         </p:blipFill>
         <p:spPr>
           <a:xfrm>
-            <a:off x="10643616" y="1828800"/>
-            <a:ext cx="640080" cy="640080"/>
+            <a:off x="10122408" y="1938528"/>
+            <a:ext cx="621792" cy="621792"/>
           </a:xfrm>
           <a:prstGeom prst="rect">
             <a:avLst/>
@@ -10670,8 +10670,8 @@
         </p:nvSpPr>
         <p:spPr>
           <a:xfrm>
-            <a:off x="8238744" y="1874520"/>
-            <a:ext cx="2999232" cy="4114800"/>
+            <a:off x="8129016" y="1984248"/>
+            <a:ext cx="2542032" cy="4096512"/>
           </a:xfrm>
           <a:prstGeom prst="rect">
             <a:avLst/>
@@ -10685,7 +10685,7 @@
           <a:lstStyle/>
           <a:p>
             <a:pPr>
-              <a:defRPr sz="1100" b="1">
+              <a:defRPr sz="1200" b="1">
                 <a:solidFill>
                   <a:srgbClr val="D95500"/>
                 </a:solidFill>
@@ -10701,7 +10701,7 @@
               <a:spcBef>
                 <a:spcPts val="200"/>
               </a:spcBef>
-              <a:defRPr sz="950">
+              <a:defRPr sz="1050">
                 <a:solidFill>
                   <a:srgbClr val="94A3B8"/>
                 </a:solidFill>
@@ -10732,7 +10732,7 @@
               <a:spcBef>
                 <a:spcPts val="800"/>
               </a:spcBef>
-              <a:defRPr sz="950">
+              <a:defRPr sz="1100">
                 <a:solidFill>
                   <a:srgbClr val="475569"/>
                 </a:solidFill>
@@ -10740,7 +10740,7 @@
               </a:defRPr>
             </a:pPr>
             <a:r>
-              <a:t>• Jaarlijkse interne kantoorcompetitie: 4 kwartaalrondes met finale dag.</a:t>
+              <a:t>• Jaarlijkse interne kantoorcompetitie: 4 kwartaalrondes met finaledag.</a:t>
             </a:r>
           </a:p>
           <a:p>
@@ -10748,7 +10748,7 @@
               <a:spcBef>
                 <a:spcPts val="800"/>
               </a:spcBef>
-              <a:defRPr sz="950">
+              <a:defRPr sz="1100">
                 <a:solidFill>
                   <a:srgbClr val="475569"/>
                 </a:solidFill>
@@ -10756,7 +10756,7 @@
               </a:defRPr>
             </a:pPr>
             <a:r>
-              <a:t>• Maandelijkse vitaliteitsclinic als vast onderdeel van het bedrijfsprogramma.</a:t>
+              <a:t>• Maandelijkse vitaliteitsclinic als vast onderdeel van het programma.</a:t>
             </a:r>
           </a:p>
           <a:p>
@@ -10764,7 +10764,7 @@
               <a:spcBef>
                 <a:spcPts val="800"/>
               </a:spcBef>
-              <a:defRPr sz="950">
+              <a:defRPr sz="1100">
                 <a:solidFill>
                   <a:srgbClr val="475569"/>
                 </a:solidFill>
@@ -10772,7 +10772,7 @@
               </a:defRPr>
             </a:pPr>
             <a:r>
-              <a:t>• Voorspelbare cashflow en langdurige klantrelaties met vaste bedrijven.</a:t>
+              <a:t>• Voorspelbare cashflow en langdurige relaties met vaste bedrijven.</a:t>
             </a:r>
           </a:p>
         </p:txBody>
@@ -10897,8 +10897,8 @@
         </p:blipFill>
         <p:spPr>
           <a:xfrm>
-            <a:off x="10241280" y="365760"/>
-            <a:ext cx="626012" cy="594360"/>
+            <a:off x="9509760" y="438912"/>
+            <a:ext cx="693429" cy="658368"/>
           </a:xfrm>
           <a:prstGeom prst="rect">
             <a:avLst/>
@@ -10913,8 +10913,8 @@
         </p:nvSpPr>
         <p:spPr>
           <a:xfrm>
-            <a:off x="731520" y="320040"/>
-            <a:ext cx="7315200" cy="320040"/>
+            <a:off x="1280160" y="438912"/>
+            <a:ext cx="7772400" cy="320040"/>
           </a:xfrm>
           <a:prstGeom prst="rect">
             <a:avLst/>
@@ -10928,7 +10928,7 @@
           <a:lstStyle/>
           <a:p>
             <a:pPr>
-              <a:defRPr sz="950" b="1">
+              <a:defRPr sz="1100" b="1">
                 <a:solidFill>
                   <a:srgbClr val="D95500"/>
                 </a:solidFill>
@@ -10949,8 +10949,8 @@
         </p:nvSpPr>
         <p:spPr>
           <a:xfrm>
-            <a:off x="731520" y="594360"/>
-            <a:ext cx="9144000" cy="731520"/>
+            <a:off x="1280160" y="749808"/>
+            <a:ext cx="8412480" cy="731520"/>
           </a:xfrm>
           <a:prstGeom prst="rect">
             <a:avLst/>
@@ -10964,7 +10964,7 @@
           <a:lstStyle/>
           <a:p>
             <a:pPr>
-              <a:defRPr sz="2400" b="1">
+              <a:defRPr sz="2600" b="1">
                 <a:solidFill>
                   <a:srgbClr val="111827"/>
                 </a:solidFill>
@@ -10985,8 +10985,8 @@
         </p:nvSpPr>
         <p:spPr>
           <a:xfrm>
-            <a:off x="731520" y="1353312"/>
-            <a:ext cx="4114800" cy="36576"/>
+            <a:off x="1280160" y="1536192"/>
+            <a:ext cx="4572000" cy="41148"/>
           </a:xfrm>
           <a:prstGeom prst="rect">
             <a:avLst/>
@@ -11028,8 +11028,8 @@
         </p:nvSpPr>
         <p:spPr>
           <a:xfrm>
-            <a:off x="731520" y="6446520"/>
-            <a:ext cx="10728655" cy="274320"/>
+            <a:off x="1280160" y="6291072"/>
+            <a:ext cx="9631375" cy="274320"/>
           </a:xfrm>
           <a:prstGeom prst="rect">
             <a:avLst/>
@@ -11043,7 +11043,7 @@
           <a:lstStyle/>
           <a:p>
             <a:pPr>
-              <a:defRPr sz="850">
+              <a:defRPr sz="950">
                 <a:solidFill>
                   <a:srgbClr val="94A3B8"/>
                 </a:solidFill>
@@ -11064,8 +11064,8 @@
         </p:nvSpPr>
         <p:spPr>
           <a:xfrm>
-            <a:off x="731520" y="1645920"/>
-            <a:ext cx="5257800" cy="2057400"/>
+            <a:off x="1280160" y="1755648"/>
+            <a:ext cx="4645152" cy="2121408"/>
           </a:xfrm>
           <a:prstGeom prst="roundRect">
             <a:avLst/>
@@ -11073,7 +11073,7 @@
           <a:solidFill>
             <a:srgbClr val="FFFFFF"/>
           </a:solidFill>
-          <a:ln w="12700">
+          <a:ln w="15240">
             <a:solidFill>
               <a:srgbClr val="E2E8F0"/>
             </a:solidFill>
@@ -11109,8 +11109,8 @@
         </p:nvSpPr>
         <p:spPr>
           <a:xfrm>
-            <a:off x="1005840" y="1828800"/>
-            <a:ext cx="4709160" cy="1691640"/>
+            <a:off x="1554480" y="1938528"/>
+            <a:ext cx="4096512" cy="1847088"/>
           </a:xfrm>
           <a:prstGeom prst="rect">
             <a:avLst/>
@@ -11124,7 +11124,7 @@
           <a:lstStyle/>
           <a:p>
             <a:pPr>
-              <a:defRPr sz="1200" b="1">
+              <a:defRPr sz="1300" b="1">
                 <a:solidFill>
                   <a:srgbClr val="1E293B"/>
                 </a:solidFill>
@@ -11140,7 +11140,7 @@
               <a:spcBef>
                 <a:spcPts val="100"/>
               </a:spcBef>
-              <a:defRPr sz="950">
+              <a:defRPr sz="1050">
                 <a:solidFill>
                   <a:srgbClr val="D95500"/>
                 </a:solidFill>
@@ -11156,7 +11156,7 @@
               <a:spcBef>
                 <a:spcPts val="300"/>
               </a:spcBef>
-              <a:defRPr sz="900">
+              <a:defRPr sz="1050">
                 <a:solidFill>
                   <a:srgbClr val="475569"/>
                 </a:solidFill>
@@ -11164,7 +11164,7 @@
               </a:defRPr>
             </a:pPr>
             <a:r>
-              <a:t>• Hoog scoren op zoektermen als 'bedrijfsuitje tafeltennis', 'sportieve teamclinic', 'vitaliteitsdag kantoor'.</a:t>
+              <a:t>• Hoog scoren op 'bedrijfsuitje tafeltennis', 'sportieve teamclinic'.</a:t>
             </a:r>
           </a:p>
           <a:p>
@@ -11172,7 +11172,7 @@
               <a:spcBef>
                 <a:spcPts val="300"/>
               </a:spcBef>
-              <a:defRPr sz="900">
+              <a:defRPr sz="1050">
                 <a:solidFill>
                   <a:srgbClr val="475569"/>
                 </a:solidFill>
@@ -11188,7 +11188,7 @@
               <a:spcBef>
                 <a:spcPts val="300"/>
               </a:spcBef>
-              <a:defRPr sz="900">
+              <a:defRPr sz="1050">
                 <a:solidFill>
                   <a:srgbClr val="475569"/>
                 </a:solidFill>
@@ -11196,7 +11196,7 @@
               </a:defRPr>
             </a:pPr>
             <a:r>
-              <a:t>• Social proof: reviews, foto's en video-impressies van gespeelde toernooien.</a:t>
+              <a:t>• Social proof: reviews, foto's en impressies van gespeelde clinics.</a:t>
             </a:r>
           </a:p>
         </p:txBody>
@@ -11209,8 +11209,8 @@
         </p:nvSpPr>
         <p:spPr>
           <a:xfrm>
-            <a:off x="6172200" y="1645920"/>
-            <a:ext cx="5257800" cy="2057400"/>
+            <a:off x="6263640" y="1755648"/>
+            <a:ext cx="4645152" cy="2121408"/>
           </a:xfrm>
           <a:prstGeom prst="roundRect">
             <a:avLst/>
@@ -11218,7 +11218,7 @@
           <a:solidFill>
             <a:srgbClr val="FFFFFF"/>
           </a:solidFill>
-          <a:ln w="12700">
+          <a:ln w="15240">
             <a:solidFill>
               <a:srgbClr val="E2E8F0"/>
             </a:solidFill>
@@ -11254,8 +11254,8 @@
         </p:nvSpPr>
         <p:spPr>
           <a:xfrm>
-            <a:off x="6446520" y="1828800"/>
-            <a:ext cx="4709160" cy="1691640"/>
+            <a:off x="6537960" y="1938528"/>
+            <a:ext cx="4096512" cy="1847088"/>
           </a:xfrm>
           <a:prstGeom prst="rect">
             <a:avLst/>
@@ -11269,7 +11269,7 @@
           <a:lstStyle/>
           <a:p>
             <a:pPr>
-              <a:defRPr sz="1200" b="1">
+              <a:defRPr sz="1300" b="1">
                 <a:solidFill>
                   <a:srgbClr val="1E293B"/>
                 </a:solidFill>
@@ -11285,7 +11285,7 @@
               <a:spcBef>
                 <a:spcPts val="100"/>
               </a:spcBef>
-              <a:defRPr sz="950">
+              <a:defRPr sz="1050">
                 <a:solidFill>
                   <a:srgbClr val="D95500"/>
                 </a:solidFill>
@@ -11301,7 +11301,7 @@
               <a:spcBef>
                 <a:spcPts val="300"/>
               </a:spcBef>
-              <a:defRPr sz="900">
+              <a:defRPr sz="1050">
                 <a:solidFill>
                   <a:srgbClr val="475569"/>
                 </a:solidFill>
@@ -11309,7 +11309,7 @@
               </a:defRPr>
             </a:pPr>
             <a:r>
-              <a:t>• Korte dynamische video-reels van clinics: sfeer, tricks en juichende collega's.</a:t>
+              <a:t>• Korte video-reels van toernooien: tricks en juichende collega's.</a:t>
             </a:r>
           </a:p>
           <a:p>
@@ -11317,7 +11317,7 @@
               <a:spcBef>
                 <a:spcPts val="300"/>
               </a:spcBef>
-              <a:defRPr sz="900">
+              <a:defRPr sz="1050">
                 <a:solidFill>
                   <a:srgbClr val="475569"/>
                 </a:solidFill>
@@ -11325,7 +11325,7 @@
               </a:defRPr>
             </a:pPr>
             <a:r>
-              <a:t>• Artikelen over schermmoeheid, micro-pauzes en de voordelen van tafeltennis voor de hersenen.</a:t>
+              <a:t>• Artikelen over schermmoeheid, focus en vitaliteit op het werk.</a:t>
             </a:r>
           </a:p>
           <a:p>
@@ -11333,7 +11333,7 @@
               <a:spcBef>
                 <a:spcPts val="300"/>
               </a:spcBef>
-              <a:defRPr sz="900">
+              <a:defRPr sz="1050">
                 <a:solidFill>
                   <a:srgbClr val="475569"/>
                 </a:solidFill>
@@ -11341,7 +11341,7 @@
               </a:defRPr>
             </a:pPr>
             <a:r>
-              <a:t>• Direct benaderen van HR-managers, Office Managers en Event Coördinatoren.</a:t>
+              <a:t>• Direct contact leggen met HR-managers en Event Coördinatoren.</a:t>
             </a:r>
           </a:p>
         </p:txBody>
@@ -11354,8 +11354,8 @@
         </p:nvSpPr>
         <p:spPr>
           <a:xfrm>
-            <a:off x="731520" y="3931920"/>
-            <a:ext cx="5257800" cy="2057400"/>
+            <a:off x="1280160" y="4096512"/>
+            <a:ext cx="4645152" cy="2121408"/>
           </a:xfrm>
           <a:prstGeom prst="roundRect">
             <a:avLst/>
@@ -11363,7 +11363,7 @@
           <a:solidFill>
             <a:srgbClr val="FFFFFF"/>
           </a:solidFill>
-          <a:ln w="12700">
+          <a:ln w="15240">
             <a:solidFill>
               <a:srgbClr val="E2E8F0"/>
             </a:solidFill>
@@ -11399,8 +11399,8 @@
         </p:nvSpPr>
         <p:spPr>
           <a:xfrm>
-            <a:off x="1005840" y="4114800"/>
-            <a:ext cx="4709160" cy="1691640"/>
+            <a:off x="1554480" y="4279392"/>
+            <a:ext cx="4096512" cy="1847088"/>
           </a:xfrm>
           <a:prstGeom prst="rect">
             <a:avLst/>
@@ -11414,7 +11414,7 @@
           <a:lstStyle/>
           <a:p>
             <a:pPr>
-              <a:defRPr sz="1200" b="1">
+              <a:defRPr sz="1300" b="1">
                 <a:solidFill>
                   <a:srgbClr val="1E293B"/>
                 </a:solidFill>
@@ -11430,7 +11430,7 @@
               <a:spcBef>
                 <a:spcPts val="100"/>
               </a:spcBef>
-              <a:defRPr sz="950">
+              <a:defRPr sz="1050">
                 <a:solidFill>
                   <a:srgbClr val="D95500"/>
                 </a:solidFill>
@@ -11446,7 +11446,7 @@
               <a:spcBef>
                 <a:spcPts val="300"/>
               </a:spcBef>
-              <a:defRPr sz="900">
+              <a:defRPr sz="1050">
                 <a:solidFill>
                   <a:srgbClr val="475569"/>
                 </a:solidFill>
@@ -11454,7 +11454,7 @@
               </a:defRPr>
             </a:pPr>
             <a:r>
-              <a:t>• Deelnemers aan een clinic zijn managers of medewerkers bij andere projecten/bedrijven.</a:t>
+              <a:t>• Deelnemers aan een clinic zijn ambassadeurs bij andere teams/bedrijven.</a:t>
             </a:r>
           </a:p>
           <a:p>
@@ -11462,7 +11462,7 @@
               <a:spcBef>
                 <a:spcPts val="300"/>
               </a:spcBef>
-              <a:defRPr sz="900">
+              <a:defRPr sz="1050">
                 <a:solidFill>
                   <a:srgbClr val="475569"/>
                 </a:solidFill>
@@ -11470,7 +11470,7 @@
               </a:defRPr>
             </a:pPr>
             <a:r>
-              <a:t>• Iedere clinic levert direct nieuwe ambassadeurs en doorverwijzingen op.</a:t>
+              <a:t>• Iedere clinic levert direct nieuwe doorverwijzingen op.</a:t>
             </a:r>
           </a:p>
           <a:p>
@@ -11478,7 +11478,7 @@
               <a:spcBef>
                 <a:spcPts val="300"/>
               </a:spcBef>
-              <a:defRPr sz="900">
+              <a:defRPr sz="1050">
                 <a:solidFill>
                   <a:srgbClr val="475569"/>
                 </a:solidFill>
@@ -11499,8 +11499,8 @@
         </p:nvSpPr>
         <p:spPr>
           <a:xfrm>
-            <a:off x="6172200" y="3931920"/>
-            <a:ext cx="5257800" cy="2057400"/>
+            <a:off x="6263640" y="4096512"/>
+            <a:ext cx="4645152" cy="2121408"/>
           </a:xfrm>
           <a:prstGeom prst="roundRect">
             <a:avLst/>
@@ -11508,7 +11508,7 @@
           <a:solidFill>
             <a:srgbClr val="FFFFFF"/>
           </a:solidFill>
-          <a:ln w="12700">
+          <a:ln w="15240">
             <a:solidFill>
               <a:srgbClr val="E2E8F0"/>
             </a:solidFill>
@@ -11544,8 +11544,8 @@
         </p:nvSpPr>
         <p:spPr>
           <a:xfrm>
-            <a:off x="6446520" y="4114800"/>
-            <a:ext cx="4709160" cy="1691640"/>
+            <a:off x="6537960" y="4279392"/>
+            <a:ext cx="4096512" cy="1847088"/>
           </a:xfrm>
           <a:prstGeom prst="rect">
             <a:avLst/>
@@ -11559,7 +11559,7 @@
           <a:lstStyle/>
           <a:p>
             <a:pPr>
-              <a:defRPr sz="1200" b="1">
+              <a:defRPr sz="1300" b="1">
                 <a:solidFill>
                   <a:srgbClr val="1E293B"/>
                 </a:solidFill>
@@ -11575,7 +11575,7 @@
               <a:spcBef>
                 <a:spcPts val="100"/>
               </a:spcBef>
-              <a:defRPr sz="950">
+              <a:defRPr sz="1050">
                 <a:solidFill>
                   <a:srgbClr val="D95500"/>
                 </a:solidFill>
@@ -11591,7 +11591,7 @@
               <a:spcBef>
                 <a:spcPts val="300"/>
               </a:spcBef>
-              <a:defRPr sz="900">
+              <a:defRPr sz="1050">
                 <a:solidFill>
                   <a:srgbClr val="475569"/>
                 </a:solidFill>
@@ -11607,7 +11607,7 @@
               <a:spcBef>
                 <a:spcPts val="300"/>
               </a:spcBef>
-              <a:defRPr sz="900">
+              <a:defRPr sz="1050">
                 <a:solidFill>
                   <a:srgbClr val="475569"/>
                 </a:solidFill>
@@ -11615,7 +11615,7 @@
               </a:defRPr>
             </a:pPr>
             <a:r>
-              <a:t>• Koppeling met cateringbedrijven en evenementenlocaties voor complete dagarrangementen.</a:t>
+              <a:t>• Koppeling met cateringbedrijven voor complete dagarrangementen.</a:t>
             </a:r>
           </a:p>
           <a:p>
@@ -11623,7 +11623,7 @@
               <a:spcBef>
                 <a:spcPts val="300"/>
               </a:spcBef>
-              <a:defRPr sz="900">
+              <a:defRPr sz="1050">
                 <a:solidFill>
                   <a:srgbClr val="475569"/>
                 </a:solidFill>
@@ -11631,7 +11631,7 @@
               </a:defRPr>
             </a:pPr>
             <a:r>
-              <a:t>• Actieve aanwezigheid bij lokale business clubs en netwerklunches.</a:t>
+              <a:t>• Aanwezigheid bij lokale business clubs en netwerklunches.</a:t>
             </a:r>
           </a:p>
         </p:txBody>
@@ -11756,8 +11756,8 @@
         </p:blipFill>
         <p:spPr>
           <a:xfrm>
-            <a:off x="10241280" y="365760"/>
-            <a:ext cx="626012" cy="594360"/>
+            <a:off x="9509760" y="438912"/>
+            <a:ext cx="693429" cy="658368"/>
           </a:xfrm>
           <a:prstGeom prst="rect">
             <a:avLst/>
@@ -11772,8 +11772,8 @@
         </p:nvSpPr>
         <p:spPr>
           <a:xfrm>
-            <a:off x="731520" y="320040"/>
-            <a:ext cx="7315200" cy="320040"/>
+            <a:off x="1280160" y="438912"/>
+            <a:ext cx="7772400" cy="320040"/>
           </a:xfrm>
           <a:prstGeom prst="rect">
             <a:avLst/>
@@ -11787,7 +11787,7 @@
           <a:lstStyle/>
           <a:p>
             <a:pPr>
-              <a:defRPr sz="950" b="1">
+              <a:defRPr sz="1100" b="1">
                 <a:solidFill>
                   <a:srgbClr val="D95500"/>
                 </a:solidFill>
@@ -11808,8 +11808,8 @@
         </p:nvSpPr>
         <p:spPr>
           <a:xfrm>
-            <a:off x="731520" y="594360"/>
-            <a:ext cx="9144000" cy="731520"/>
+            <a:off x="1280160" y="749808"/>
+            <a:ext cx="8412480" cy="731520"/>
           </a:xfrm>
           <a:prstGeom prst="rect">
             <a:avLst/>
@@ -11823,7 +11823,7 @@
           <a:lstStyle/>
           <a:p>
             <a:pPr>
-              <a:defRPr sz="2400" b="1">
+              <a:defRPr sz="2600" b="1">
                 <a:solidFill>
                   <a:srgbClr val="111827"/>
                 </a:solidFill>
@@ -11844,8 +11844,8 @@
         </p:nvSpPr>
         <p:spPr>
           <a:xfrm>
-            <a:off x="731520" y="1353312"/>
-            <a:ext cx="4114800" cy="36576"/>
+            <a:off x="1280160" y="1536192"/>
+            <a:ext cx="4572000" cy="41148"/>
           </a:xfrm>
           <a:prstGeom prst="rect">
             <a:avLst/>
@@ -11887,8 +11887,8 @@
         </p:nvSpPr>
         <p:spPr>
           <a:xfrm>
-            <a:off x="731520" y="6446520"/>
-            <a:ext cx="10728655" cy="274320"/>
+            <a:off x="1280160" y="6291072"/>
+            <a:ext cx="9631375" cy="274320"/>
           </a:xfrm>
           <a:prstGeom prst="rect">
             <a:avLst/>
@@ -11902,7 +11902,7 @@
           <a:lstStyle/>
           <a:p>
             <a:pPr>
-              <a:defRPr sz="850">
+              <a:defRPr sz="950">
                 <a:solidFill>
                   <a:srgbClr val="94A3B8"/>
                 </a:solidFill>
@@ -11923,8 +11923,8 @@
         </p:nvSpPr>
         <p:spPr>
           <a:xfrm>
-            <a:off x="731520" y="1645920"/>
-            <a:ext cx="5257800" cy="2057400"/>
+            <a:off x="1280160" y="1755648"/>
+            <a:ext cx="4645152" cy="2121408"/>
           </a:xfrm>
           <a:prstGeom prst="roundRect">
             <a:avLst/>
@@ -11932,7 +11932,7 @@
           <a:solidFill>
             <a:srgbClr val="FFFFFF"/>
           </a:solidFill>
-          <a:ln w="12700">
+          <a:ln w="15240">
             <a:solidFill>
               <a:srgbClr val="E2E8F0"/>
             </a:solidFill>
@@ -11968,8 +11968,8 @@
         </p:nvSpPr>
         <p:spPr>
           <a:xfrm>
-            <a:off x="1005840" y="1828800"/>
-            <a:ext cx="4709160" cy="1691640"/>
+            <a:off x="1554480" y="1938528"/>
+            <a:ext cx="4096512" cy="1847088"/>
           </a:xfrm>
           <a:prstGeom prst="rect">
             <a:avLst/>
@@ -11983,7 +11983,7 @@
           <a:lstStyle/>
           <a:p>
             <a:pPr>
-              <a:defRPr sz="1200" b="1">
+              <a:defRPr sz="1300" b="1">
                 <a:solidFill>
                   <a:srgbClr val="D95500"/>
                 </a:solidFill>
@@ -11999,7 +11999,7 @@
               <a:spcBef>
                 <a:spcPts val="100"/>
               </a:spcBef>
-              <a:defRPr sz="950">
+              <a:defRPr sz="1050">
                 <a:solidFill>
                   <a:srgbClr val="94A3B8"/>
                 </a:solidFill>
@@ -12015,7 +12015,7 @@
               <a:spcBef>
                 <a:spcPts val="300"/>
               </a:spcBef>
-              <a:defRPr sz="900">
+              <a:defRPr sz="1050">
                 <a:solidFill>
                   <a:srgbClr val="475569"/>
                 </a:solidFill>
@@ -12023,7 +12023,7 @@
               </a:defRPr>
             </a:pPr>
             <a:r>
-              <a:t>• Mobiele ITTF-goedgekeurde wedstrijdtafels en mobiele netsets.</a:t>
+              <a:t>• Mobiele ITTF-wedstrijdtafels en mobiele netsets.</a:t>
             </a:r>
           </a:p>
           <a:p>
@@ -12031,7 +12031,7 @@
               <a:spcBef>
                 <a:spcPts val="300"/>
               </a:spcBef>
-              <a:defRPr sz="900">
+              <a:defRPr sz="1050">
                 <a:solidFill>
                   <a:srgbClr val="475569"/>
                 </a:solidFill>
@@ -12039,7 +12039,7 @@
               </a:defRPr>
             </a:pPr>
             <a:r>
-              <a:t>• Hoogwaardige trainingsbatjes met professionele rubbers (maximale controle en spin).</a:t>
+              <a:t>• Trainingsbatjes met professionele rubbers (controle en effect).</a:t>
             </a:r>
           </a:p>
           <a:p>
@@ -12047,7 +12047,7 @@
               <a:spcBef>
                 <a:spcPts val="300"/>
               </a:spcBef>
-              <a:defRPr sz="900">
+              <a:defRPr sz="1050">
                 <a:solidFill>
                   <a:srgbClr val="475569"/>
                 </a:solidFill>
@@ -12055,7 +12055,7 @@
               </a:defRPr>
             </a:pPr>
             <a:r>
-              <a:t>• Officiële 3-sterren wedstrijdballen met TT Clinics logobedrukking.</a:t>
+              <a:t>• Officiële 3-sterren wedstrijdballen met TT Clinics opdruk.</a:t>
             </a:r>
           </a:p>
           <a:p>
@@ -12063,7 +12063,7 @@
               <a:spcBef>
                 <a:spcPts val="300"/>
               </a:spcBef>
-              <a:defRPr sz="900">
+              <a:defRPr sz="1050">
                 <a:solidFill>
                   <a:srgbClr val="475569"/>
                 </a:solidFill>
@@ -12084,8 +12084,8 @@
         </p:nvSpPr>
         <p:spPr>
           <a:xfrm>
-            <a:off x="6172200" y="1645920"/>
-            <a:ext cx="5257800" cy="2057400"/>
+            <a:off x="6263640" y="1755648"/>
+            <a:ext cx="4645152" cy="2121408"/>
           </a:xfrm>
           <a:prstGeom prst="roundRect">
             <a:avLst/>
@@ -12093,7 +12093,7 @@
           <a:solidFill>
             <a:srgbClr val="FFFFFF"/>
           </a:solidFill>
-          <a:ln w="12700">
+          <a:ln w="15240">
             <a:solidFill>
               <a:srgbClr val="E2E8F0"/>
             </a:solidFill>
@@ -12129,8 +12129,8 @@
         </p:nvSpPr>
         <p:spPr>
           <a:xfrm>
-            <a:off x="6446520" y="1828800"/>
-            <a:ext cx="4709160" cy="1691640"/>
+            <a:off x="6537960" y="1938528"/>
+            <a:ext cx="4096512" cy="1847088"/>
           </a:xfrm>
           <a:prstGeom prst="rect">
             <a:avLst/>
@@ -12144,7 +12144,7 @@
           <a:lstStyle/>
           <a:p>
             <a:pPr>
-              <a:defRPr sz="1200" b="1">
+              <a:defRPr sz="1300" b="1">
                 <a:solidFill>
                   <a:srgbClr val="D95500"/>
                 </a:solidFill>
@@ -12160,7 +12160,7 @@
               <a:spcBef>
                 <a:spcPts val="100"/>
               </a:spcBef>
-              <a:defRPr sz="950">
+              <a:defRPr sz="1050">
                 <a:solidFill>
                   <a:srgbClr val="94A3B8"/>
                 </a:solidFill>
@@ -12176,7 +12176,7 @@
               <a:spcBef>
                 <a:spcPts val="300"/>
               </a:spcBef>
-              <a:defRPr sz="900">
+              <a:defRPr sz="1050">
                 <a:solidFill>
                   <a:srgbClr val="475569"/>
                 </a:solidFill>
@@ -12184,7 +12184,7 @@
               </a:defRPr>
             </a:pPr>
             <a:r>
-              <a:t>• Kantoor/Bedrijfskantine: Transformatie in 20 minuten tot toernooiarena.</a:t>
+              <a:t>• Kantoor: In 20 minuten transformeren we elke kantine tot arena.</a:t>
             </a:r>
           </a:p>
           <a:p>
@@ -12192,7 +12192,7 @@
               <a:spcBef>
                 <a:spcPts val="300"/>
               </a:spcBef>
-              <a:defRPr sz="900">
+              <a:defRPr sz="1050">
                 <a:solidFill>
                   <a:srgbClr val="475569"/>
                 </a:solidFill>
@@ -12200,7 +12200,7 @@
               </a:defRPr>
             </a:pPr>
             <a:r>
-              <a:t>• Sportaccommodaties: Vaste afspraken met zalen inclusief kleedkamers en afsluitende borrel.</a:t>
+              <a:t>• Sportaccommodaties: Vaste zalen incl. douches en afsluitende borrel.</a:t>
             </a:r>
           </a:p>
           <a:p>
@@ -12208,7 +12208,7 @@
               <a:spcBef>
                 <a:spcPts val="300"/>
               </a:spcBef>
-              <a:defRPr sz="900">
+              <a:defRPr sz="1050">
                 <a:solidFill>
                   <a:srgbClr val="475569"/>
                 </a:solidFill>
@@ -12216,7 +12216,7 @@
               </a:defRPr>
             </a:pPr>
             <a:r>
-              <a:t>• Outdoor opties: Bij mooi weer op buitenpleinen of dakterrassen.</a:t>
+              <a:t>• Outdoor: Bij mooi weer op buitenpleinen of dakterrassen.</a:t>
             </a:r>
           </a:p>
         </p:txBody>
@@ -12229,8 +12229,8 @@
         </p:nvSpPr>
         <p:spPr>
           <a:xfrm>
-            <a:off x="731520" y="3931920"/>
-            <a:ext cx="5257800" cy="2057400"/>
+            <a:off x="1280160" y="4096512"/>
+            <a:ext cx="4645152" cy="2121408"/>
           </a:xfrm>
           <a:prstGeom prst="roundRect">
             <a:avLst/>
@@ -12238,7 +12238,7 @@
           <a:solidFill>
             <a:srgbClr val="FFFFFF"/>
           </a:solidFill>
-          <a:ln w="12700">
+          <a:ln w="15240">
             <a:solidFill>
               <a:srgbClr val="E2E8F0"/>
             </a:solidFill>
@@ -12274,8 +12274,8 @@
         </p:nvSpPr>
         <p:spPr>
           <a:xfrm>
-            <a:off x="1005840" y="4114800"/>
-            <a:ext cx="4709160" cy="1691640"/>
+            <a:off x="1554480" y="4279392"/>
+            <a:ext cx="4096512" cy="1847088"/>
           </a:xfrm>
           <a:prstGeom prst="rect">
             <a:avLst/>
@@ -12289,7 +12289,7 @@
           <a:lstStyle/>
           <a:p>
             <a:pPr>
-              <a:defRPr sz="1200" b="1">
+              <a:defRPr sz="1300" b="1">
                 <a:solidFill>
                   <a:srgbClr val="D95500"/>
                 </a:solidFill>
@@ -12305,7 +12305,7 @@
               <a:spcBef>
                 <a:spcPts val="100"/>
               </a:spcBef>
-              <a:defRPr sz="950">
+              <a:defRPr sz="1050">
                 <a:solidFill>
                   <a:srgbClr val="94A3B8"/>
                 </a:solidFill>
@@ -12321,7 +12321,7 @@
               <a:spcBef>
                 <a:spcPts val="300"/>
               </a:spcBef>
-              <a:defRPr sz="900">
+              <a:defRPr sz="1050">
                 <a:solidFill>
                   <a:srgbClr val="475569"/>
                 </a:solidFill>
@@ -12329,7 +12329,7 @@
               </a:defRPr>
             </a:pPr>
             <a:r>
-              <a:t>• Edward Westhoff als hoofdtrainer en hét vertrouwde gezicht van TT Clinics.</a:t>
+              <a:t>• Edward Westhoff als hoofdtrainer en het vertrouwde gezicht.</a:t>
             </a:r>
           </a:p>
           <a:p>
@@ -12337,7 +12337,7 @@
               <a:spcBef>
                 <a:spcPts val="300"/>
               </a:spcBef>
-              <a:defRPr sz="900">
+              <a:defRPr sz="1050">
                 <a:solidFill>
                   <a:srgbClr val="475569"/>
                 </a:solidFill>
@@ -12345,7 +12345,7 @@
               </a:defRPr>
             </a:pPr>
             <a:r>
-              <a:t>• Pool van ervaren competitiespelers en gediplomeerde trainers voor piekmomenten.</a:t>
+              <a:t>• Pool van ervaren competitiespelers voor grotere groepen.</a:t>
             </a:r>
           </a:p>
           <a:p>
@@ -12353,7 +12353,7 @@
               <a:spcBef>
                 <a:spcPts val="300"/>
               </a:spcBef>
-              <a:defRPr sz="900">
+              <a:defRPr sz="1050">
                 <a:solidFill>
                   <a:srgbClr val="475569"/>
                 </a:solidFill>
@@ -12361,7 +12361,7 @@
               </a:defRPr>
             </a:pPr>
             <a:r>
-              <a:t>• Standaard clinic-draaiboek garandeert consistente kwaliteit en enthousiasme.</a:t>
+              <a:t>• Standaard clinic-draaiboek garandeert consistente kwaliteit.</a:t>
             </a:r>
           </a:p>
         </p:txBody>
@@ -12374,8 +12374,8 @@
         </p:nvSpPr>
         <p:spPr>
           <a:xfrm>
-            <a:off x="6172200" y="3931920"/>
-            <a:ext cx="5257800" cy="2057400"/>
+            <a:off x="6263640" y="4096512"/>
+            <a:ext cx="4645152" cy="2121408"/>
           </a:xfrm>
           <a:prstGeom prst="roundRect">
             <a:avLst/>
@@ -12383,7 +12383,7 @@
           <a:solidFill>
             <a:srgbClr val="FFFFFF"/>
           </a:solidFill>
-          <a:ln w="12700">
+          <a:ln w="15240">
             <a:solidFill>
               <a:srgbClr val="E2E8F0"/>
             </a:solidFill>
@@ -12419,8 +12419,8 @@
         </p:nvSpPr>
         <p:spPr>
           <a:xfrm>
-            <a:off x="6446520" y="4114800"/>
-            <a:ext cx="4709160" cy="1691640"/>
+            <a:off x="6537960" y="4279392"/>
+            <a:ext cx="4096512" cy="1847088"/>
           </a:xfrm>
           <a:prstGeom prst="rect">
             <a:avLst/>
@@ -12434,7 +12434,7 @@
           <a:lstStyle/>
           <a:p>
             <a:pPr>
-              <a:defRPr sz="1200" b="1">
+              <a:defRPr sz="1300" b="1">
                 <a:solidFill>
                   <a:srgbClr val="D95500"/>
                 </a:solidFill>
@@ -12450,7 +12450,7 @@
               <a:spcBef>
                 <a:spcPts val="100"/>
               </a:spcBef>
-              <a:defRPr sz="950">
+              <a:defRPr sz="1050">
                 <a:solidFill>
                   <a:srgbClr val="94A3B8"/>
                 </a:solidFill>
@@ -12466,7 +12466,7 @@
               <a:spcBef>
                 <a:spcPts val="300"/>
               </a:spcBef>
-              <a:defRPr sz="900">
+              <a:defRPr sz="1050">
                 <a:solidFill>
                   <a:srgbClr val="475569"/>
                 </a:solidFill>
@@ -12474,7 +12474,7 @@
               </a:defRPr>
             </a:pPr>
             <a:r>
-              <a:t>• Binnen 24 uur persoonlijk contact en offerte op maat.</a:t>
+              <a:t>• Binnen 24 uur persoonlijk contact en heldere offerte op maat.</a:t>
             </a:r>
           </a:p>
           <a:p>
@@ -12482,7 +12482,7 @@
               <a:spcBef>
                 <a:spcPts val="300"/>
               </a:spcBef>
-              <a:defRPr sz="900">
+              <a:defRPr sz="1050">
                 <a:solidFill>
                   <a:srgbClr val="475569"/>
                 </a:solidFill>
@@ -12490,7 +12490,7 @@
               </a:defRPr>
             </a:pPr>
             <a:r>
-              <a:t>• Voorbereiding: Inventarisatie van ruimte en specifieke wensen.</a:t>
+              <a:t>• Voorbereiding: Inventarisatie van ruimte en teamwensen.</a:t>
             </a:r>
           </a:p>
           <a:p>
@@ -12498,7 +12498,7 @@
               <a:spcBef>
                 <a:spcPts val="300"/>
               </a:spcBef>
-              <a:defRPr sz="900">
+              <a:defRPr sz="1050">
                 <a:solidFill>
                   <a:srgbClr val="475569"/>
                 </a:solidFill>
@@ -12506,7 +12506,7 @@
               </a:defRPr>
             </a:pPr>
             <a:r>
-              <a:t>• Uitvoering: Complete toernooileiding, muziek, coaching en prijsuitreiking.</a:t>
+              <a:t>• Uitvoering: Complete toernooileiding, muziek en prijsuitreiking.</a:t>
             </a:r>
           </a:p>
           <a:p>
@@ -12514,7 +12514,7 @@
               <a:spcBef>
                 <a:spcPts val="300"/>
               </a:spcBef>
-              <a:defRPr sz="900">
+              <a:defRPr sz="1050">
                 <a:solidFill>
                   <a:srgbClr val="475569"/>
                 </a:solidFill>
@@ -12522,7 +12522,7 @@
               </a:defRPr>
             </a:pPr>
             <a:r>
-              <a:t>• Nazorg: Foto's toesturen en evaluatiegesprek voor vervolgclinic.</a:t>
+              <a:t>• Nazorg: Foto's toesturen en evaluatie voor vervolgclinic.</a:t>
             </a:r>
           </a:p>
         </p:txBody>

</xml_diff>

<commit_message>
Align icons with website SVG style, enlarge Edward photo and typography, and increase slide inner margins
</commit_message>
<xml_diff>
--- a/TT_Clinics_Bedrijfsplan.pptx
+++ b/TT_Clinics_Bedrijfsplan.pptx
@@ -3243,7 +3243,7 @@
         </p:blipFill>
         <p:spPr>
           <a:xfrm>
-            <a:off x="1554480" y="1005840"/>
+            <a:off x="1737360" y="1005840"/>
             <a:ext cx="1348334" cy="1280160"/>
           </a:xfrm>
           <a:prstGeom prst="rect">
@@ -3259,8 +3259,8 @@
         </p:nvSpPr>
         <p:spPr>
           <a:xfrm>
-            <a:off x="1554480" y="2560320"/>
-            <a:ext cx="3657600" cy="402336"/>
+            <a:off x="1737360" y="2560320"/>
+            <a:ext cx="3840480" cy="420624"/>
           </a:xfrm>
           <a:prstGeom prst="roundRect">
             <a:avLst/>
@@ -3289,11 +3289,11 @@
           </a:fontRef>
         </p:style>
         <p:txBody>
-          <a:bodyPr rtlCol="0" anchor="ctr" tIns="64008"/>
+          <a:bodyPr rtlCol="0" anchor="ctr" tIns="73152"/>
           <a:lstStyle/>
           <a:p>
             <a:pPr algn="ctr">
-              <a:defRPr sz="1100" b="1">
+              <a:defRPr sz="1150" b="1">
                 <a:solidFill>
                   <a:srgbClr val="D95500"/>
                 </a:solidFill>
@@ -3314,8 +3314,8 @@
         </p:nvSpPr>
         <p:spPr>
           <a:xfrm>
-            <a:off x="1554480" y="3127248"/>
-            <a:ext cx="9144000" cy="1828800"/>
+            <a:off x="1737360" y="3127248"/>
+            <a:ext cx="8686800" cy="1828800"/>
           </a:xfrm>
           <a:prstGeom prst="rect">
             <a:avLst/>
@@ -3329,7 +3329,7 @@
           <a:lstStyle/>
           <a:p>
             <a:pPr>
-              <a:defRPr sz="4400" b="1">
+              <a:defRPr sz="4600" b="1">
                 <a:solidFill>
                   <a:srgbClr val="111827"/>
                 </a:solidFill>
@@ -3366,7 +3366,7 @@
         </p:nvSpPr>
         <p:spPr>
           <a:xfrm>
-            <a:off x="1554480" y="4983480"/>
+            <a:off x="1737360" y="4983480"/>
             <a:ext cx="7772400" cy="1280160"/>
           </a:xfrm>
           <a:prstGeom prst="rect">
@@ -3426,8 +3426,8 @@
         </p:blipFill>
         <p:spPr>
           <a:xfrm>
-            <a:off x="8961120" y="3474720"/>
-            <a:ext cx="1920240" cy="1920240"/>
+            <a:off x="8686800" y="3291840"/>
+            <a:ext cx="2011680" cy="2011680"/>
           </a:xfrm>
           <a:prstGeom prst="rect">
             <a:avLst/>
@@ -3554,8 +3554,8 @@
         </p:blipFill>
         <p:spPr>
           <a:xfrm>
-            <a:off x="9509760" y="438912"/>
-            <a:ext cx="693429" cy="658368"/>
+            <a:off x="9144000" y="438912"/>
+            <a:ext cx="722322" cy="685800"/>
           </a:xfrm>
           <a:prstGeom prst="rect">
             <a:avLst/>
@@ -3570,8 +3570,8 @@
         </p:nvSpPr>
         <p:spPr>
           <a:xfrm>
-            <a:off x="1280160" y="438912"/>
-            <a:ext cx="7772400" cy="320040"/>
+            <a:off x="1600200" y="438912"/>
+            <a:ext cx="7315200" cy="320040"/>
           </a:xfrm>
           <a:prstGeom prst="rect">
             <a:avLst/>
@@ -3585,7 +3585,7 @@
           <a:lstStyle/>
           <a:p>
             <a:pPr>
-              <a:defRPr sz="1100" b="1">
+              <a:defRPr sz="1150" b="1">
                 <a:solidFill>
                   <a:srgbClr val="D95500"/>
                 </a:solidFill>
@@ -3606,8 +3606,8 @@
         </p:nvSpPr>
         <p:spPr>
           <a:xfrm>
-            <a:off x="1280160" y="749808"/>
-            <a:ext cx="8412480" cy="731520"/>
+            <a:off x="1600200" y="749808"/>
+            <a:ext cx="7589520" cy="731520"/>
           </a:xfrm>
           <a:prstGeom prst="rect">
             <a:avLst/>
@@ -3642,8 +3642,8 @@
         </p:nvSpPr>
         <p:spPr>
           <a:xfrm>
-            <a:off x="1280160" y="1536192"/>
-            <a:ext cx="4572000" cy="41148"/>
+            <a:off x="1600200" y="1536192"/>
+            <a:ext cx="4389120" cy="41148"/>
           </a:xfrm>
           <a:prstGeom prst="rect">
             <a:avLst/>
@@ -3685,8 +3685,8 @@
         </p:nvSpPr>
         <p:spPr>
           <a:xfrm>
-            <a:off x="1280160" y="6291072"/>
-            <a:ext cx="9631375" cy="274320"/>
+            <a:off x="1600200" y="6291072"/>
+            <a:ext cx="8991295" cy="274320"/>
           </a:xfrm>
           <a:prstGeom prst="rect">
             <a:avLst/>
@@ -3721,8 +3721,8 @@
         </p:nvSpPr>
         <p:spPr>
           <a:xfrm>
-            <a:off x="1280160" y="1755648"/>
-            <a:ext cx="2999232" cy="4462272"/>
+            <a:off x="1600200" y="1783080"/>
+            <a:ext cx="2788920" cy="4389120"/>
           </a:xfrm>
           <a:prstGeom prst="roundRect">
             <a:avLst/>
@@ -3774,7 +3774,7 @@
         </p:blipFill>
         <p:spPr>
           <a:xfrm>
-            <a:off x="3502152" y="1938528"/>
+            <a:off x="3611880" y="1965960"/>
             <a:ext cx="621792" cy="621792"/>
           </a:xfrm>
           <a:prstGeom prst="rect">
@@ -3790,8 +3790,8 @@
         </p:nvSpPr>
         <p:spPr>
           <a:xfrm>
-            <a:off x="1508760" y="1984248"/>
-            <a:ext cx="2542032" cy="4096512"/>
+            <a:off x="1828800" y="2011680"/>
+            <a:ext cx="2331720" cy="4023360"/>
           </a:xfrm>
           <a:prstGeom prst="rect">
             <a:avLst/>
@@ -3860,7 +3860,7 @@
               </a:defRPr>
             </a:pPr>
             <a:r>
-              <a:t>——————————————————————</a:t>
+              <a:t>————————————————————</a:t>
             </a:r>
           </a:p>
           <a:p>
@@ -3953,8 +3953,8 @@
         </p:nvSpPr>
         <p:spPr>
           <a:xfrm>
-            <a:off x="4590288" y="1755648"/>
-            <a:ext cx="2999232" cy="4462272"/>
+            <a:off x="4700016" y="1783080"/>
+            <a:ext cx="2788920" cy="4389120"/>
           </a:xfrm>
           <a:prstGeom prst="roundRect">
             <a:avLst/>
@@ -3998,8 +3998,8 @@
         </p:nvSpPr>
         <p:spPr>
           <a:xfrm>
-            <a:off x="4590288" y="1755648"/>
-            <a:ext cx="2999232" cy="73152"/>
+            <a:off x="4700016" y="1783080"/>
+            <a:ext cx="2788920" cy="73152"/>
           </a:xfrm>
           <a:prstGeom prst="rect">
             <a:avLst/>
@@ -4049,7 +4049,7 @@
         </p:blipFill>
         <p:spPr>
           <a:xfrm>
-            <a:off x="6812280" y="1938528"/>
+            <a:off x="6711696" y="1965960"/>
             <a:ext cx="621792" cy="621792"/>
           </a:xfrm>
           <a:prstGeom prst="rect">
@@ -4065,8 +4065,8 @@
         </p:nvSpPr>
         <p:spPr>
           <a:xfrm>
-            <a:off x="4818888" y="1984248"/>
-            <a:ext cx="2542032" cy="4096512"/>
+            <a:off x="4928616" y="2011680"/>
+            <a:ext cx="2331720" cy="4023360"/>
           </a:xfrm>
           <a:prstGeom prst="rect">
             <a:avLst/>
@@ -4135,7 +4135,7 @@
               </a:defRPr>
             </a:pPr>
             <a:r>
-              <a:t>——————————————————————</a:t>
+              <a:t>————————————————————</a:t>
             </a:r>
           </a:p>
           <a:p>
@@ -4228,8 +4228,8 @@
         </p:nvSpPr>
         <p:spPr>
           <a:xfrm>
-            <a:off x="7900416" y="1755648"/>
-            <a:ext cx="2999232" cy="4462272"/>
+            <a:off x="7799832" y="1783080"/>
+            <a:ext cx="2788920" cy="4389120"/>
           </a:xfrm>
           <a:prstGeom prst="roundRect">
             <a:avLst/>
@@ -4281,7 +4281,7 @@
         </p:blipFill>
         <p:spPr>
           <a:xfrm>
-            <a:off x="10122408" y="1938528"/>
+            <a:off x="9811512" y="1965960"/>
             <a:ext cx="621792" cy="621792"/>
           </a:xfrm>
           <a:prstGeom prst="rect">
@@ -4297,8 +4297,8 @@
         </p:nvSpPr>
         <p:spPr>
           <a:xfrm>
-            <a:off x="8129016" y="1984248"/>
-            <a:ext cx="2542032" cy="4096512"/>
+            <a:off x="8028432" y="2011680"/>
+            <a:ext cx="2331720" cy="4023360"/>
           </a:xfrm>
           <a:prstGeom prst="rect">
             <a:avLst/>
@@ -4367,7 +4367,7 @@
               </a:defRPr>
             </a:pPr>
             <a:r>
-              <a:t>——————————————————————</a:t>
+              <a:t>————————————————————</a:t>
             </a:r>
           </a:p>
           <a:p>
@@ -4572,8 +4572,8 @@
         </p:blipFill>
         <p:spPr>
           <a:xfrm>
-            <a:off x="9509760" y="438912"/>
-            <a:ext cx="693429" cy="658368"/>
+            <a:off x="9144000" y="438912"/>
+            <a:ext cx="722322" cy="685800"/>
           </a:xfrm>
           <a:prstGeom prst="rect">
             <a:avLst/>
@@ -4588,8 +4588,8 @@
         </p:nvSpPr>
         <p:spPr>
           <a:xfrm>
-            <a:off x="1280160" y="438912"/>
-            <a:ext cx="7772400" cy="320040"/>
+            <a:off x="1600200" y="438912"/>
+            <a:ext cx="7315200" cy="320040"/>
           </a:xfrm>
           <a:prstGeom prst="rect">
             <a:avLst/>
@@ -4603,7 +4603,7 @@
           <a:lstStyle/>
           <a:p>
             <a:pPr>
-              <a:defRPr sz="1100" b="1">
+              <a:defRPr sz="1150" b="1">
                 <a:solidFill>
                   <a:srgbClr val="D95500"/>
                 </a:solidFill>
@@ -4624,8 +4624,8 @@
         </p:nvSpPr>
         <p:spPr>
           <a:xfrm>
-            <a:off x="1280160" y="749808"/>
-            <a:ext cx="8412480" cy="731520"/>
+            <a:off x="1600200" y="749808"/>
+            <a:ext cx="7589520" cy="731520"/>
           </a:xfrm>
           <a:prstGeom prst="rect">
             <a:avLst/>
@@ -4660,8 +4660,8 @@
         </p:nvSpPr>
         <p:spPr>
           <a:xfrm>
-            <a:off x="1280160" y="1536192"/>
-            <a:ext cx="4572000" cy="41148"/>
+            <a:off x="1600200" y="1536192"/>
+            <a:ext cx="4389120" cy="41148"/>
           </a:xfrm>
           <a:prstGeom prst="rect">
             <a:avLst/>
@@ -4703,8 +4703,8 @@
         </p:nvSpPr>
         <p:spPr>
           <a:xfrm>
-            <a:off x="1280160" y="6291072"/>
-            <a:ext cx="9631375" cy="274320"/>
+            <a:off x="1600200" y="6291072"/>
+            <a:ext cx="8991295" cy="274320"/>
           </a:xfrm>
           <a:prstGeom prst="rect">
             <a:avLst/>
@@ -4739,8 +4739,8 @@
         </p:nvSpPr>
         <p:spPr>
           <a:xfrm>
-            <a:off x="1280160" y="1755648"/>
-            <a:ext cx="6263640" cy="4462272"/>
+            <a:off x="1600200" y="1783080"/>
+            <a:ext cx="5852160" cy="4389120"/>
           </a:xfrm>
           <a:prstGeom prst="roundRect">
             <a:avLst/>
@@ -4784,8 +4784,8 @@
         </p:nvSpPr>
         <p:spPr>
           <a:xfrm>
-            <a:off x="1280160" y="1755648"/>
-            <a:ext cx="6263640" cy="73152"/>
+            <a:off x="1600200" y="1783080"/>
+            <a:ext cx="5852160" cy="73152"/>
           </a:xfrm>
           <a:prstGeom prst="rect">
             <a:avLst/>
@@ -4835,8 +4835,8 @@
         </p:blipFill>
         <p:spPr>
           <a:xfrm>
-            <a:off x="1600200" y="2057400"/>
-            <a:ext cx="2011680" cy="1502866"/>
+            <a:off x="1920240" y="2148840"/>
+            <a:ext cx="2331720" cy="1741959"/>
           </a:xfrm>
           <a:prstGeom prst="rect">
             <a:avLst/>
@@ -4851,8 +4851,8 @@
         </p:nvSpPr>
         <p:spPr>
           <a:xfrm>
-            <a:off x="3840480" y="1965960"/>
-            <a:ext cx="3520440" cy="4096512"/>
+            <a:off x="4480560" y="2011680"/>
+            <a:ext cx="2788920" cy="4023360"/>
           </a:xfrm>
           <a:prstGeom prst="rect">
             <a:avLst/>
@@ -4866,7 +4866,7 @@
           <a:lstStyle/>
           <a:p>
             <a:pPr>
-              <a:defRPr sz="2000" b="1">
+              <a:defRPr sz="2200" b="1">
                 <a:solidFill>
                   <a:srgbClr val="111827"/>
                 </a:solidFill>
@@ -4882,7 +4882,7 @@
               <a:spcBef>
                 <a:spcPts val="200"/>
               </a:spcBef>
-              <a:defRPr sz="1150" b="1">
+              <a:defRPr sz="1200" b="1">
                 <a:solidFill>
                   <a:srgbClr val="D95500"/>
                 </a:solidFill>
@@ -4914,7 +4914,7 @@
               <a:spcBef>
                 <a:spcPts val="1400"/>
               </a:spcBef>
-              <a:defRPr sz="1050" b="1">
+              <a:defRPr sz="1100" b="1">
                 <a:solidFill>
                   <a:srgbClr val="D95500"/>
                 </a:solidFill>
@@ -4935,8 +4935,8 @@
         </p:nvSpPr>
         <p:spPr>
           <a:xfrm>
-            <a:off x="7818120" y="1755648"/>
-            <a:ext cx="3090672" cy="4462272"/>
+            <a:off x="7754112" y="1783080"/>
+            <a:ext cx="2834640" cy="4389120"/>
           </a:xfrm>
           <a:prstGeom prst="roundRect">
             <a:avLst/>
@@ -4980,8 +4980,8 @@
         </p:nvSpPr>
         <p:spPr>
           <a:xfrm>
-            <a:off x="7818120" y="1755648"/>
-            <a:ext cx="3090672" cy="73152"/>
+            <a:off x="7754112" y="1783080"/>
+            <a:ext cx="2834640" cy="73152"/>
           </a:xfrm>
           <a:prstGeom prst="rect">
             <a:avLst/>
@@ -5023,8 +5023,8 @@
         </p:nvSpPr>
         <p:spPr>
           <a:xfrm>
-            <a:off x="8092440" y="1965960"/>
-            <a:ext cx="2542032" cy="4005072"/>
+            <a:off x="8010144" y="2011680"/>
+            <a:ext cx="2322576" cy="4023360"/>
           </a:xfrm>
           <a:prstGeom prst="rect">
             <a:avLst/>
@@ -5038,7 +5038,7 @@
           <a:lstStyle/>
           <a:p>
             <a:pPr>
-              <a:defRPr sz="1500" b="1">
+              <a:defRPr sz="1600" b="1">
                 <a:solidFill>
                   <a:srgbClr val="111827"/>
                 </a:solidFill>
@@ -5054,7 +5054,7 @@
               <a:spcBef>
                 <a:spcPts val="600"/>
               </a:spcBef>
-              <a:defRPr sz="1150">
+              <a:defRPr sz="1200">
                 <a:solidFill>
                   <a:srgbClr val="475569"/>
                 </a:solidFill>
@@ -5070,7 +5070,7 @@
               <a:spcBef>
                 <a:spcPts val="600"/>
               </a:spcBef>
-              <a:defRPr sz="1150">
+              <a:defRPr sz="1200">
                 <a:solidFill>
                   <a:srgbClr val="475569"/>
                 </a:solidFill>
@@ -5086,7 +5086,7 @@
               <a:spcBef>
                 <a:spcPts val="600"/>
               </a:spcBef>
-              <a:defRPr sz="1150">
+              <a:defRPr sz="1200">
                 <a:solidFill>
                   <a:srgbClr val="475569"/>
                 </a:solidFill>
@@ -5102,7 +5102,7 @@
               <a:spcBef>
                 <a:spcPts val="600"/>
               </a:spcBef>
-              <a:defRPr sz="1150">
+              <a:defRPr sz="1200">
                 <a:solidFill>
                   <a:srgbClr val="475569"/>
                 </a:solidFill>
@@ -5110,7 +5110,7 @@
               </a:defRPr>
             </a:pPr>
             <a:r>
-              <a:t>Locaties: Op kantoor &amp; sportzalen</a:t>
+              <a:t>Locaties: Kantoor &amp; sportzalen</a:t>
             </a:r>
           </a:p>
         </p:txBody>
@@ -5131,7 +5131,7 @@
         </p:blipFill>
         <p:spPr>
           <a:xfrm>
-            <a:off x="8641080" y="4297680"/>
+            <a:off x="8439912" y="4297680"/>
             <a:ext cx="1444752" cy="1444752"/>
           </a:xfrm>
           <a:prstGeom prst="rect">
@@ -5147,8 +5147,8 @@
         </p:nvSpPr>
         <p:spPr>
           <a:xfrm>
-            <a:off x="8001000" y="5806440"/>
-            <a:ext cx="2724912" cy="365760"/>
+            <a:off x="7845552" y="5806440"/>
+            <a:ext cx="2651760" cy="365760"/>
           </a:xfrm>
           <a:prstGeom prst="rect">
             <a:avLst/>
@@ -5295,8 +5295,8 @@
         </p:blipFill>
         <p:spPr>
           <a:xfrm>
-            <a:off x="9509760" y="438912"/>
-            <a:ext cx="693429" cy="658368"/>
+            <a:off x="9144000" y="438912"/>
+            <a:ext cx="722322" cy="685800"/>
           </a:xfrm>
           <a:prstGeom prst="rect">
             <a:avLst/>
@@ -5311,8 +5311,8 @@
         </p:nvSpPr>
         <p:spPr>
           <a:xfrm>
-            <a:off x="1280160" y="438912"/>
-            <a:ext cx="7772400" cy="320040"/>
+            <a:off x="1600200" y="438912"/>
+            <a:ext cx="7315200" cy="320040"/>
           </a:xfrm>
           <a:prstGeom prst="rect">
             <a:avLst/>
@@ -5326,7 +5326,7 @@
           <a:lstStyle/>
           <a:p>
             <a:pPr>
-              <a:defRPr sz="1100" b="1">
+              <a:defRPr sz="1150" b="1">
                 <a:solidFill>
                   <a:srgbClr val="D95500"/>
                 </a:solidFill>
@@ -5347,8 +5347,8 @@
         </p:nvSpPr>
         <p:spPr>
           <a:xfrm>
-            <a:off x="1280160" y="749808"/>
-            <a:ext cx="8412480" cy="731520"/>
+            <a:off x="1600200" y="749808"/>
+            <a:ext cx="7589520" cy="731520"/>
           </a:xfrm>
           <a:prstGeom prst="rect">
             <a:avLst/>
@@ -5383,8 +5383,8 @@
         </p:nvSpPr>
         <p:spPr>
           <a:xfrm>
-            <a:off x="1280160" y="1536192"/>
-            <a:ext cx="4572000" cy="41148"/>
+            <a:off x="1600200" y="1536192"/>
+            <a:ext cx="4389120" cy="41148"/>
           </a:xfrm>
           <a:prstGeom prst="rect">
             <a:avLst/>
@@ -5426,8 +5426,8 @@
         </p:nvSpPr>
         <p:spPr>
           <a:xfrm>
-            <a:off x="1280160" y="6291072"/>
-            <a:ext cx="9631375" cy="274320"/>
+            <a:off x="1600200" y="6291072"/>
+            <a:ext cx="8991295" cy="274320"/>
           </a:xfrm>
           <a:prstGeom prst="rect">
             <a:avLst/>
@@ -5462,8 +5462,8 @@
         </p:nvSpPr>
         <p:spPr>
           <a:xfrm>
-            <a:off x="1280160" y="1755648"/>
-            <a:ext cx="4645152" cy="2121408"/>
+            <a:off x="1600200" y="1783080"/>
+            <a:ext cx="4297680" cy="2084831"/>
           </a:xfrm>
           <a:prstGeom prst="roundRect">
             <a:avLst/>
@@ -5507,8 +5507,8 @@
         </p:nvSpPr>
         <p:spPr>
           <a:xfrm>
-            <a:off x="1280160" y="1755648"/>
-            <a:ext cx="4645152" cy="73152"/>
+            <a:off x="1600200" y="1783080"/>
+            <a:ext cx="4297680" cy="73152"/>
           </a:xfrm>
           <a:prstGeom prst="rect">
             <a:avLst/>
@@ -5558,8 +5558,8 @@
         </p:blipFill>
         <p:spPr>
           <a:xfrm>
-            <a:off x="5148072" y="1956816"/>
-            <a:ext cx="594360" cy="594360"/>
+            <a:off x="5120640" y="1984248"/>
+            <a:ext cx="621792" cy="621792"/>
           </a:xfrm>
           <a:prstGeom prst="rect">
             <a:avLst/>
@@ -5574,8 +5574,8 @@
         </p:nvSpPr>
         <p:spPr>
           <a:xfrm>
-            <a:off x="1572768" y="1975104"/>
-            <a:ext cx="3639312" cy="1755648"/>
+            <a:off x="1892808" y="2002536"/>
+            <a:ext cx="3246120" cy="1764791"/>
           </a:xfrm>
           <a:prstGeom prst="rect">
             <a:avLst/>
@@ -5605,7 +5605,7 @@
               <a:spcBef>
                 <a:spcPts val="800"/>
               </a:spcBef>
-              <a:defRPr sz="1150">
+              <a:defRPr sz="1200">
                 <a:solidFill>
                   <a:srgbClr val="475569"/>
                 </a:solidFill>
@@ -5626,8 +5626,8 @@
         </p:nvSpPr>
         <p:spPr>
           <a:xfrm>
-            <a:off x="6263640" y="1755648"/>
-            <a:ext cx="4645152" cy="2121408"/>
+            <a:off x="6293815" y="1783080"/>
+            <a:ext cx="4297680" cy="2084831"/>
           </a:xfrm>
           <a:prstGeom prst="roundRect">
             <a:avLst/>
@@ -5671,8 +5671,8 @@
         </p:nvSpPr>
         <p:spPr>
           <a:xfrm>
-            <a:off x="6263640" y="1755648"/>
-            <a:ext cx="4645152" cy="73152"/>
+            <a:off x="6293815" y="1783080"/>
+            <a:ext cx="4297680" cy="73152"/>
           </a:xfrm>
           <a:prstGeom prst="rect">
             <a:avLst/>
@@ -5722,8 +5722,8 @@
         </p:blipFill>
         <p:spPr>
           <a:xfrm>
-            <a:off x="10131552" y="1956816"/>
-            <a:ext cx="594360" cy="594360"/>
+            <a:off x="9814255" y="1984248"/>
+            <a:ext cx="621792" cy="621792"/>
           </a:xfrm>
           <a:prstGeom prst="rect">
             <a:avLst/>
@@ -5738,8 +5738,8 @@
         </p:nvSpPr>
         <p:spPr>
           <a:xfrm>
-            <a:off x="6556248" y="1975104"/>
-            <a:ext cx="3639312" cy="1755648"/>
+            <a:off x="6586423" y="2002536"/>
+            <a:ext cx="3246120" cy="1764791"/>
           </a:xfrm>
           <a:prstGeom prst="rect">
             <a:avLst/>
@@ -5769,7 +5769,7 @@
               <a:spcBef>
                 <a:spcPts val="800"/>
               </a:spcBef>
-              <a:defRPr sz="1150">
+              <a:defRPr sz="1200">
                 <a:solidFill>
                   <a:srgbClr val="475569"/>
                 </a:solidFill>
@@ -5790,8 +5790,8 @@
         </p:nvSpPr>
         <p:spPr>
           <a:xfrm>
-            <a:off x="1280160" y="4096512"/>
-            <a:ext cx="4645152" cy="2121408"/>
+            <a:off x="1600200" y="4087367"/>
+            <a:ext cx="4297680" cy="2084831"/>
           </a:xfrm>
           <a:prstGeom prst="roundRect">
             <a:avLst/>
@@ -5835,8 +5835,8 @@
         </p:nvSpPr>
         <p:spPr>
           <a:xfrm>
-            <a:off x="1280160" y="4096512"/>
-            <a:ext cx="4645152" cy="73152"/>
+            <a:off x="1600200" y="4087367"/>
+            <a:ext cx="4297680" cy="73152"/>
           </a:xfrm>
           <a:prstGeom prst="rect">
             <a:avLst/>
@@ -5886,8 +5886,8 @@
         </p:blipFill>
         <p:spPr>
           <a:xfrm>
-            <a:off x="5148072" y="4297680"/>
-            <a:ext cx="594360" cy="594360"/>
+            <a:off x="5120640" y="4288535"/>
+            <a:ext cx="621792" cy="621792"/>
           </a:xfrm>
           <a:prstGeom prst="rect">
             <a:avLst/>
@@ -5902,8 +5902,8 @@
         </p:nvSpPr>
         <p:spPr>
           <a:xfrm>
-            <a:off x="1572768" y="4315968"/>
-            <a:ext cx="3639312" cy="1755648"/>
+            <a:off x="1892808" y="4306823"/>
+            <a:ext cx="3246120" cy="1764791"/>
           </a:xfrm>
           <a:prstGeom prst="rect">
             <a:avLst/>
@@ -5933,7 +5933,7 @@
               <a:spcBef>
                 <a:spcPts val="800"/>
               </a:spcBef>
-              <a:defRPr sz="1150">
+              <a:defRPr sz="1200">
                 <a:solidFill>
                   <a:srgbClr val="475569"/>
                 </a:solidFill>
@@ -5954,8 +5954,8 @@
         </p:nvSpPr>
         <p:spPr>
           <a:xfrm>
-            <a:off x="6263640" y="4096512"/>
-            <a:ext cx="4645152" cy="2121408"/>
+            <a:off x="6293815" y="4087367"/>
+            <a:ext cx="4297680" cy="2084831"/>
           </a:xfrm>
           <a:prstGeom prst="roundRect">
             <a:avLst/>
@@ -5999,8 +5999,8 @@
         </p:nvSpPr>
         <p:spPr>
           <a:xfrm>
-            <a:off x="6263640" y="4096512"/>
-            <a:ext cx="4645152" cy="73152"/>
+            <a:off x="6293815" y="4087367"/>
+            <a:ext cx="4297680" cy="73152"/>
           </a:xfrm>
           <a:prstGeom prst="rect">
             <a:avLst/>
@@ -6050,8 +6050,8 @@
         </p:blipFill>
         <p:spPr>
           <a:xfrm>
-            <a:off x="10131552" y="4297680"/>
-            <a:ext cx="594360" cy="594360"/>
+            <a:off x="9814255" y="4288535"/>
+            <a:ext cx="621792" cy="621792"/>
           </a:xfrm>
           <a:prstGeom prst="rect">
             <a:avLst/>
@@ -6066,8 +6066,8 @@
         </p:nvSpPr>
         <p:spPr>
           <a:xfrm>
-            <a:off x="6556248" y="4315968"/>
-            <a:ext cx="3639312" cy="1755648"/>
+            <a:off x="6586423" y="4306823"/>
+            <a:ext cx="3246120" cy="1764791"/>
           </a:xfrm>
           <a:prstGeom prst="rect">
             <a:avLst/>
@@ -6097,7 +6097,7 @@
               <a:spcBef>
                 <a:spcPts val="800"/>
               </a:spcBef>
-              <a:defRPr sz="1150">
+              <a:defRPr sz="1200">
                 <a:solidFill>
                   <a:srgbClr val="475569"/>
                 </a:solidFill>
@@ -6230,8 +6230,8 @@
         </p:blipFill>
         <p:spPr>
           <a:xfrm>
-            <a:off x="9509760" y="438912"/>
-            <a:ext cx="693429" cy="658368"/>
+            <a:off x="9144000" y="438912"/>
+            <a:ext cx="722322" cy="685800"/>
           </a:xfrm>
           <a:prstGeom prst="rect">
             <a:avLst/>
@@ -6246,8 +6246,8 @@
         </p:nvSpPr>
         <p:spPr>
           <a:xfrm>
-            <a:off x="1280160" y="438912"/>
-            <a:ext cx="7772400" cy="320040"/>
+            <a:off x="1600200" y="438912"/>
+            <a:ext cx="7315200" cy="320040"/>
           </a:xfrm>
           <a:prstGeom prst="rect">
             <a:avLst/>
@@ -6261,7 +6261,7 @@
           <a:lstStyle/>
           <a:p>
             <a:pPr>
-              <a:defRPr sz="1100" b="1">
+              <a:defRPr sz="1150" b="1">
                 <a:solidFill>
                   <a:srgbClr val="D95500"/>
                 </a:solidFill>
@@ -6282,8 +6282,8 @@
         </p:nvSpPr>
         <p:spPr>
           <a:xfrm>
-            <a:off x="1280160" y="749808"/>
-            <a:ext cx="8412480" cy="731520"/>
+            <a:off x="1600200" y="749808"/>
+            <a:ext cx="7589520" cy="731520"/>
           </a:xfrm>
           <a:prstGeom prst="rect">
             <a:avLst/>
@@ -6318,8 +6318,8 @@
         </p:nvSpPr>
         <p:spPr>
           <a:xfrm>
-            <a:off x="1280160" y="1536192"/>
-            <a:ext cx="4572000" cy="41148"/>
+            <a:off x="1600200" y="1536192"/>
+            <a:ext cx="4389120" cy="41148"/>
           </a:xfrm>
           <a:prstGeom prst="rect">
             <a:avLst/>
@@ -6361,8 +6361,8 @@
         </p:nvSpPr>
         <p:spPr>
           <a:xfrm>
-            <a:off x="1280160" y="6291072"/>
-            <a:ext cx="9631375" cy="274320"/>
+            <a:off x="1600200" y="6291072"/>
+            <a:ext cx="8991295" cy="274320"/>
           </a:xfrm>
           <a:prstGeom prst="rect">
             <a:avLst/>
@@ -6397,8 +6397,8 @@
         </p:nvSpPr>
         <p:spPr>
           <a:xfrm>
-            <a:off x="1280160" y="1755648"/>
-            <a:ext cx="4645152" cy="4462272"/>
+            <a:off x="1600200" y="1783080"/>
+            <a:ext cx="4297680" cy="4389120"/>
           </a:xfrm>
           <a:prstGeom prst="roundRect">
             <a:avLst/>
@@ -6442,8 +6442,8 @@
         </p:nvSpPr>
         <p:spPr>
           <a:xfrm>
-            <a:off x="1280160" y="1755648"/>
-            <a:ext cx="4645152" cy="73152"/>
+            <a:off x="1600200" y="1783080"/>
+            <a:ext cx="4297680" cy="73152"/>
           </a:xfrm>
           <a:prstGeom prst="rect">
             <a:avLst/>
@@ -6493,8 +6493,8 @@
         </p:blipFill>
         <p:spPr>
           <a:xfrm>
-            <a:off x="5148072" y="1920240"/>
-            <a:ext cx="594360" cy="594360"/>
+            <a:off x="5120640" y="1920240"/>
+            <a:ext cx="621792" cy="621792"/>
           </a:xfrm>
           <a:prstGeom prst="rect">
             <a:avLst/>
@@ -6509,8 +6509,8 @@
         </p:nvSpPr>
         <p:spPr>
           <a:xfrm>
-            <a:off x="1600200" y="1965960"/>
-            <a:ext cx="3730752" cy="4005072"/>
+            <a:off x="1920240" y="1965960"/>
+            <a:ext cx="3474720" cy="4023360"/>
           </a:xfrm>
           <a:prstGeom prst="rect">
             <a:avLst/>
@@ -6524,7 +6524,7 @@
           <a:lstStyle/>
           <a:p>
             <a:pPr>
-              <a:defRPr sz="1400">
+              <a:defRPr sz="1450">
                 <a:solidFill>
                   <a:srgbClr val="B91C1C"/>
                 </a:solidFill>
@@ -6673,8 +6673,8 @@
         </p:nvSpPr>
         <p:spPr>
           <a:xfrm>
-            <a:off x="6263640" y="1755648"/>
-            <a:ext cx="4645152" cy="4462272"/>
+            <a:off x="6293815" y="1783080"/>
+            <a:ext cx="4297680" cy="4389120"/>
           </a:xfrm>
           <a:prstGeom prst="roundRect">
             <a:avLst/>
@@ -6718,8 +6718,8 @@
         </p:nvSpPr>
         <p:spPr>
           <a:xfrm>
-            <a:off x="6263640" y="1755648"/>
-            <a:ext cx="4645152" cy="73152"/>
+            <a:off x="6293815" y="1783080"/>
+            <a:ext cx="4297680" cy="73152"/>
           </a:xfrm>
           <a:prstGeom prst="rect">
             <a:avLst/>
@@ -6769,8 +6769,8 @@
         </p:blipFill>
         <p:spPr>
           <a:xfrm>
-            <a:off x="10131552" y="1920240"/>
-            <a:ext cx="594360" cy="594360"/>
+            <a:off x="9814255" y="1920240"/>
+            <a:ext cx="621792" cy="621792"/>
           </a:xfrm>
           <a:prstGeom prst="rect">
             <a:avLst/>
@@ -6785,8 +6785,8 @@
         </p:nvSpPr>
         <p:spPr>
           <a:xfrm>
-            <a:off x="6583680" y="1965960"/>
-            <a:ext cx="3730752" cy="4005072"/>
+            <a:off x="6613855" y="1965960"/>
+            <a:ext cx="3474720" cy="4023360"/>
           </a:xfrm>
           <a:prstGeom prst="rect">
             <a:avLst/>
@@ -6800,7 +6800,7 @@
           <a:lstStyle/>
           <a:p>
             <a:pPr>
-              <a:defRPr sz="1400">
+              <a:defRPr sz="1450">
                 <a:solidFill>
                   <a:srgbClr val="D95500"/>
                 </a:solidFill>
@@ -7061,8 +7061,8 @@
         </p:blipFill>
         <p:spPr>
           <a:xfrm>
-            <a:off x="9509760" y="438912"/>
-            <a:ext cx="693429" cy="658368"/>
+            <a:off x="9144000" y="438912"/>
+            <a:ext cx="722322" cy="685800"/>
           </a:xfrm>
           <a:prstGeom prst="rect">
             <a:avLst/>
@@ -7077,8 +7077,8 @@
         </p:nvSpPr>
         <p:spPr>
           <a:xfrm>
-            <a:off x="1280160" y="438912"/>
-            <a:ext cx="7772400" cy="320040"/>
+            <a:off x="1600200" y="438912"/>
+            <a:ext cx="7315200" cy="320040"/>
           </a:xfrm>
           <a:prstGeom prst="rect">
             <a:avLst/>
@@ -7092,7 +7092,7 @@
           <a:lstStyle/>
           <a:p>
             <a:pPr>
-              <a:defRPr sz="1100" b="1">
+              <a:defRPr sz="1150" b="1">
                 <a:solidFill>
                   <a:srgbClr val="D95500"/>
                 </a:solidFill>
@@ -7113,8 +7113,8 @@
         </p:nvSpPr>
         <p:spPr>
           <a:xfrm>
-            <a:off x="1280160" y="749808"/>
-            <a:ext cx="8412480" cy="731520"/>
+            <a:off x="1600200" y="749808"/>
+            <a:ext cx="7589520" cy="731520"/>
           </a:xfrm>
           <a:prstGeom prst="rect">
             <a:avLst/>
@@ -7149,8 +7149,8 @@
         </p:nvSpPr>
         <p:spPr>
           <a:xfrm>
-            <a:off x="1280160" y="1536192"/>
-            <a:ext cx="4572000" cy="41148"/>
+            <a:off x="1600200" y="1536192"/>
+            <a:ext cx="4389120" cy="41148"/>
           </a:xfrm>
           <a:prstGeom prst="rect">
             <a:avLst/>
@@ -7192,8 +7192,8 @@
         </p:nvSpPr>
         <p:spPr>
           <a:xfrm>
-            <a:off x="1280160" y="6291072"/>
-            <a:ext cx="9631375" cy="274320"/>
+            <a:off x="1600200" y="6291072"/>
+            <a:ext cx="8991295" cy="274320"/>
           </a:xfrm>
           <a:prstGeom prst="rect">
             <a:avLst/>
@@ -7228,8 +7228,8 @@
         </p:nvSpPr>
         <p:spPr>
           <a:xfrm>
-            <a:off x="1280160" y="1755648"/>
-            <a:ext cx="2999232" cy="4462272"/>
+            <a:off x="1600200" y="1783080"/>
+            <a:ext cx="2788920" cy="4389120"/>
           </a:xfrm>
           <a:prstGeom prst="roundRect">
             <a:avLst/>
@@ -7281,7 +7281,7 @@
         </p:blipFill>
         <p:spPr>
           <a:xfrm>
-            <a:off x="3502152" y="1938528"/>
+            <a:off x="3611880" y="1965960"/>
             <a:ext cx="621792" cy="621792"/>
           </a:xfrm>
           <a:prstGeom prst="rect">
@@ -7297,8 +7297,8 @@
         </p:nvSpPr>
         <p:spPr>
           <a:xfrm>
-            <a:off x="1508760" y="1984248"/>
-            <a:ext cx="2542032" cy="4096512"/>
+            <a:off x="1828800" y="2011680"/>
+            <a:ext cx="2331720" cy="4023360"/>
           </a:xfrm>
           <a:prstGeom prst="rect">
             <a:avLst/>
@@ -7312,7 +7312,7 @@
           <a:lstStyle/>
           <a:p>
             <a:pPr>
-              <a:defRPr sz="1250" b="1">
+              <a:defRPr sz="1200" b="1">
                 <a:solidFill>
                   <a:srgbClr val="1E293B"/>
                 </a:solidFill>
@@ -7367,7 +7367,7 @@
               </a:defRPr>
             </a:pPr>
             <a:r>
-              <a:t>——————————————————————</a:t>
+              <a:t>————————————————————</a:t>
             </a:r>
           </a:p>
           <a:p>
@@ -7460,8 +7460,8 @@
         </p:nvSpPr>
         <p:spPr>
           <a:xfrm>
-            <a:off x="4590288" y="1755648"/>
-            <a:ext cx="2999232" cy="4462272"/>
+            <a:off x="4700016" y="1783080"/>
+            <a:ext cx="2788920" cy="4389120"/>
           </a:xfrm>
           <a:prstGeom prst="roundRect">
             <a:avLst/>
@@ -7505,8 +7505,8 @@
         </p:nvSpPr>
         <p:spPr>
           <a:xfrm>
-            <a:off x="4590288" y="1755648"/>
-            <a:ext cx="2999232" cy="73152"/>
+            <a:off x="4700016" y="1783080"/>
+            <a:ext cx="2788920" cy="73152"/>
           </a:xfrm>
           <a:prstGeom prst="rect">
             <a:avLst/>
@@ -7556,7 +7556,7 @@
         </p:blipFill>
         <p:spPr>
           <a:xfrm>
-            <a:off x="6812280" y="1938528"/>
+            <a:off x="6711696" y="1965960"/>
             <a:ext cx="621792" cy="621792"/>
           </a:xfrm>
           <a:prstGeom prst="rect">
@@ -7572,8 +7572,8 @@
         </p:nvSpPr>
         <p:spPr>
           <a:xfrm>
-            <a:off x="4818888" y="1984248"/>
-            <a:ext cx="2542032" cy="4096512"/>
+            <a:off x="4928616" y="2011680"/>
+            <a:ext cx="2331720" cy="4023360"/>
           </a:xfrm>
           <a:prstGeom prst="rect">
             <a:avLst/>
@@ -7587,7 +7587,7 @@
           <a:lstStyle/>
           <a:p>
             <a:pPr>
-              <a:defRPr sz="1250" b="1">
+              <a:defRPr sz="1200" b="1">
                 <a:solidFill>
                   <a:srgbClr val="D95500"/>
                 </a:solidFill>
@@ -7642,7 +7642,7 @@
               </a:defRPr>
             </a:pPr>
             <a:r>
-              <a:t>——————————————————————</a:t>
+              <a:t>————————————————————</a:t>
             </a:r>
           </a:p>
           <a:p>
@@ -7735,8 +7735,8 @@
         </p:nvSpPr>
         <p:spPr>
           <a:xfrm>
-            <a:off x="7900416" y="1755648"/>
-            <a:ext cx="2999232" cy="4462272"/>
+            <a:off x="7799832" y="1783080"/>
+            <a:ext cx="2788920" cy="4389120"/>
           </a:xfrm>
           <a:prstGeom prst="roundRect">
             <a:avLst/>
@@ -7788,7 +7788,7 @@
         </p:blipFill>
         <p:spPr>
           <a:xfrm>
-            <a:off x="10122408" y="1938528"/>
+            <a:off x="9811512" y="1965960"/>
             <a:ext cx="621792" cy="621792"/>
           </a:xfrm>
           <a:prstGeom prst="rect">
@@ -7804,8 +7804,8 @@
         </p:nvSpPr>
         <p:spPr>
           <a:xfrm>
-            <a:off x="8129016" y="1984248"/>
-            <a:ext cx="2542032" cy="4096512"/>
+            <a:off x="8028432" y="2011680"/>
+            <a:ext cx="2331720" cy="4023360"/>
           </a:xfrm>
           <a:prstGeom prst="rect">
             <a:avLst/>
@@ -7819,7 +7819,7 @@
           <a:lstStyle/>
           <a:p>
             <a:pPr>
-              <a:defRPr sz="1250" b="1">
+              <a:defRPr sz="1200" b="1">
                 <a:solidFill>
                   <a:srgbClr val="1E293B"/>
                 </a:solidFill>
@@ -7874,7 +7874,7 @@
               </a:defRPr>
             </a:pPr>
             <a:r>
-              <a:t>——————————————————————</a:t>
+              <a:t>————————————————————</a:t>
             </a:r>
           </a:p>
           <a:p>
@@ -8079,8 +8079,8 @@
         </p:blipFill>
         <p:spPr>
           <a:xfrm>
-            <a:off x="9509760" y="438912"/>
-            <a:ext cx="693429" cy="658368"/>
+            <a:off x="9144000" y="438912"/>
+            <a:ext cx="722322" cy="685800"/>
           </a:xfrm>
           <a:prstGeom prst="rect">
             <a:avLst/>
@@ -8095,8 +8095,8 @@
         </p:nvSpPr>
         <p:spPr>
           <a:xfrm>
-            <a:off x="1280160" y="438912"/>
-            <a:ext cx="7772400" cy="320040"/>
+            <a:off x="1600200" y="438912"/>
+            <a:ext cx="7315200" cy="320040"/>
           </a:xfrm>
           <a:prstGeom prst="rect">
             <a:avLst/>
@@ -8110,7 +8110,7 @@
           <a:lstStyle/>
           <a:p>
             <a:pPr>
-              <a:defRPr sz="1100" b="1">
+              <a:defRPr sz="1150" b="1">
                 <a:solidFill>
                   <a:srgbClr val="D95500"/>
                 </a:solidFill>
@@ -8131,8 +8131,8 @@
         </p:nvSpPr>
         <p:spPr>
           <a:xfrm>
-            <a:off x="1280160" y="749808"/>
-            <a:ext cx="8412480" cy="731520"/>
+            <a:off x="1600200" y="749808"/>
+            <a:ext cx="7589520" cy="731520"/>
           </a:xfrm>
           <a:prstGeom prst="rect">
             <a:avLst/>
@@ -8167,8 +8167,8 @@
         </p:nvSpPr>
         <p:spPr>
           <a:xfrm>
-            <a:off x="1280160" y="1536192"/>
-            <a:ext cx="4572000" cy="41148"/>
+            <a:off x="1600200" y="1536192"/>
+            <a:ext cx="4389120" cy="41148"/>
           </a:xfrm>
           <a:prstGeom prst="rect">
             <a:avLst/>
@@ -8210,8 +8210,8 @@
         </p:nvSpPr>
         <p:spPr>
           <a:xfrm>
-            <a:off x="1280160" y="6291072"/>
-            <a:ext cx="9631375" cy="274320"/>
+            <a:off x="1600200" y="6291072"/>
+            <a:ext cx="8991295" cy="274320"/>
           </a:xfrm>
           <a:prstGeom prst="rect">
             <a:avLst/>
@@ -8246,8 +8246,8 @@
         </p:nvSpPr>
         <p:spPr>
           <a:xfrm>
-            <a:off x="1280160" y="1755648"/>
-            <a:ext cx="4645152" cy="2121408"/>
+            <a:off x="1600200" y="1783080"/>
+            <a:ext cx="4297680" cy="2084831"/>
           </a:xfrm>
           <a:prstGeom prst="roundRect">
             <a:avLst/>
@@ -8291,8 +8291,8 @@
         </p:nvSpPr>
         <p:spPr>
           <a:xfrm>
-            <a:off x="1280160" y="1755648"/>
-            <a:ext cx="4645152" cy="73152"/>
+            <a:off x="1600200" y="1783080"/>
+            <a:ext cx="4297680" cy="73152"/>
           </a:xfrm>
           <a:prstGeom prst="rect">
             <a:avLst/>
@@ -8342,8 +8342,8 @@
         </p:blipFill>
         <p:spPr>
           <a:xfrm>
-            <a:off x="1536192" y="2048256"/>
-            <a:ext cx="685800" cy="685800"/>
+            <a:off x="1856232" y="2075688"/>
+            <a:ext cx="658368" cy="658368"/>
           </a:xfrm>
           <a:prstGeom prst="rect">
             <a:avLst/>
@@ -8358,8 +8358,8 @@
         </p:nvSpPr>
         <p:spPr>
           <a:xfrm>
-            <a:off x="2395728" y="1993392"/>
-            <a:ext cx="3364992" cy="1755648"/>
+            <a:off x="2679192" y="2020824"/>
+            <a:ext cx="3063240" cy="1719071"/>
           </a:xfrm>
           <a:prstGeom prst="rect">
             <a:avLst/>
@@ -8410,8 +8410,8 @@
         </p:nvSpPr>
         <p:spPr>
           <a:xfrm>
-            <a:off x="6263640" y="1755648"/>
-            <a:ext cx="4645152" cy="2121408"/>
+            <a:off x="6293815" y="1783080"/>
+            <a:ext cx="4297680" cy="2084831"/>
           </a:xfrm>
           <a:prstGeom prst="roundRect">
             <a:avLst/>
@@ -8455,8 +8455,8 @@
         </p:nvSpPr>
         <p:spPr>
           <a:xfrm>
-            <a:off x="6263640" y="1755648"/>
-            <a:ext cx="4645152" cy="73152"/>
+            <a:off x="6293815" y="1783080"/>
+            <a:ext cx="4297680" cy="73152"/>
           </a:xfrm>
           <a:prstGeom prst="rect">
             <a:avLst/>
@@ -8506,8 +8506,8 @@
         </p:blipFill>
         <p:spPr>
           <a:xfrm>
-            <a:off x="6519672" y="2048256"/>
-            <a:ext cx="685800" cy="685800"/>
+            <a:off x="6549847" y="2075688"/>
+            <a:ext cx="658368" cy="658368"/>
           </a:xfrm>
           <a:prstGeom prst="rect">
             <a:avLst/>
@@ -8522,8 +8522,8 @@
         </p:nvSpPr>
         <p:spPr>
           <a:xfrm>
-            <a:off x="7379208" y="1993392"/>
-            <a:ext cx="3364992" cy="1755648"/>
+            <a:off x="7372807" y="2020824"/>
+            <a:ext cx="3063240" cy="1719071"/>
           </a:xfrm>
           <a:prstGeom prst="rect">
             <a:avLst/>
@@ -8574,8 +8574,8 @@
         </p:nvSpPr>
         <p:spPr>
           <a:xfrm>
-            <a:off x="1280160" y="4096512"/>
-            <a:ext cx="4645152" cy="2121408"/>
+            <a:off x="1600200" y="4087367"/>
+            <a:ext cx="4297680" cy="2084831"/>
           </a:xfrm>
           <a:prstGeom prst="roundRect">
             <a:avLst/>
@@ -8619,8 +8619,8 @@
         </p:nvSpPr>
         <p:spPr>
           <a:xfrm>
-            <a:off x="1280160" y="4096512"/>
-            <a:ext cx="4645152" cy="73152"/>
+            <a:off x="1600200" y="4087367"/>
+            <a:ext cx="4297680" cy="73152"/>
           </a:xfrm>
           <a:prstGeom prst="rect">
             <a:avLst/>
@@ -8670,8 +8670,8 @@
         </p:blipFill>
         <p:spPr>
           <a:xfrm>
-            <a:off x="1536192" y="4389120"/>
-            <a:ext cx="685800" cy="685800"/>
+            <a:off x="1856232" y="4379975"/>
+            <a:ext cx="658368" cy="658368"/>
           </a:xfrm>
           <a:prstGeom prst="rect">
             <a:avLst/>
@@ -8686,8 +8686,8 @@
         </p:nvSpPr>
         <p:spPr>
           <a:xfrm>
-            <a:off x="2395728" y="4334256"/>
-            <a:ext cx="3364992" cy="1755648"/>
+            <a:off x="2679192" y="4325111"/>
+            <a:ext cx="3063240" cy="1719071"/>
           </a:xfrm>
           <a:prstGeom prst="rect">
             <a:avLst/>
@@ -8738,8 +8738,8 @@
         </p:nvSpPr>
         <p:spPr>
           <a:xfrm>
-            <a:off x="6263640" y="4096512"/>
-            <a:ext cx="4645152" cy="2121408"/>
+            <a:off x="6293815" y="4087367"/>
+            <a:ext cx="4297680" cy="2084831"/>
           </a:xfrm>
           <a:prstGeom prst="roundRect">
             <a:avLst/>
@@ -8783,8 +8783,8 @@
         </p:nvSpPr>
         <p:spPr>
           <a:xfrm>
-            <a:off x="6263640" y="4096512"/>
-            <a:ext cx="4645152" cy="73152"/>
+            <a:off x="6293815" y="4087367"/>
+            <a:ext cx="4297680" cy="73152"/>
           </a:xfrm>
           <a:prstGeom prst="rect">
             <a:avLst/>
@@ -8834,8 +8834,8 @@
         </p:blipFill>
         <p:spPr>
           <a:xfrm>
-            <a:off x="6519672" y="4389120"/>
-            <a:ext cx="685800" cy="685800"/>
+            <a:off x="6549847" y="4379975"/>
+            <a:ext cx="658368" cy="658368"/>
           </a:xfrm>
           <a:prstGeom prst="rect">
             <a:avLst/>
@@ -8850,8 +8850,8 @@
         </p:nvSpPr>
         <p:spPr>
           <a:xfrm>
-            <a:off x="7379208" y="4334256"/>
-            <a:ext cx="3364992" cy="1755648"/>
+            <a:off x="7372807" y="4325111"/>
+            <a:ext cx="3063240" cy="1719071"/>
           </a:xfrm>
           <a:prstGeom prst="rect">
             <a:avLst/>
@@ -9014,8 +9014,8 @@
         </p:blipFill>
         <p:spPr>
           <a:xfrm>
-            <a:off x="9509760" y="438912"/>
-            <a:ext cx="693429" cy="658368"/>
+            <a:off x="9144000" y="438912"/>
+            <a:ext cx="722322" cy="685800"/>
           </a:xfrm>
           <a:prstGeom prst="rect">
             <a:avLst/>
@@ -9030,8 +9030,8 @@
         </p:nvSpPr>
         <p:spPr>
           <a:xfrm>
-            <a:off x="1280160" y="438912"/>
-            <a:ext cx="7772400" cy="320040"/>
+            <a:off x="1600200" y="438912"/>
+            <a:ext cx="7315200" cy="320040"/>
           </a:xfrm>
           <a:prstGeom prst="rect">
             <a:avLst/>
@@ -9045,7 +9045,7 @@
           <a:lstStyle/>
           <a:p>
             <a:pPr>
-              <a:defRPr sz="1100" b="1">
+              <a:defRPr sz="1150" b="1">
                 <a:solidFill>
                   <a:srgbClr val="D95500"/>
                 </a:solidFill>
@@ -9066,8 +9066,8 @@
         </p:nvSpPr>
         <p:spPr>
           <a:xfrm>
-            <a:off x="1280160" y="749808"/>
-            <a:ext cx="8412480" cy="731520"/>
+            <a:off x="1600200" y="749808"/>
+            <a:ext cx="7589520" cy="731520"/>
           </a:xfrm>
           <a:prstGeom prst="rect">
             <a:avLst/>
@@ -9102,8 +9102,8 @@
         </p:nvSpPr>
         <p:spPr>
           <a:xfrm>
-            <a:off x="1280160" y="1536192"/>
-            <a:ext cx="4572000" cy="41148"/>
+            <a:off x="1600200" y="1536192"/>
+            <a:ext cx="4389120" cy="41148"/>
           </a:xfrm>
           <a:prstGeom prst="rect">
             <a:avLst/>
@@ -9145,8 +9145,8 @@
         </p:nvSpPr>
         <p:spPr>
           <a:xfrm>
-            <a:off x="1280160" y="6291072"/>
-            <a:ext cx="9631375" cy="274320"/>
+            <a:off x="1600200" y="6291072"/>
+            <a:ext cx="8991295" cy="274320"/>
           </a:xfrm>
           <a:prstGeom prst="rect">
             <a:avLst/>
@@ -9181,8 +9181,8 @@
         </p:nvSpPr>
         <p:spPr>
           <a:xfrm>
-            <a:off x="1280160" y="1755648"/>
-            <a:ext cx="4645152" cy="2121408"/>
+            <a:off x="1600200" y="1783080"/>
+            <a:ext cx="4297680" cy="2084831"/>
           </a:xfrm>
           <a:prstGeom prst="roundRect">
             <a:avLst/>
@@ -9226,8 +9226,8 @@
         </p:nvSpPr>
         <p:spPr>
           <a:xfrm>
-            <a:off x="1554480" y="1938528"/>
-            <a:ext cx="4096512" cy="1847088"/>
+            <a:off x="1874520" y="1965960"/>
+            <a:ext cx="3749040" cy="1810511"/>
           </a:xfrm>
           <a:prstGeom prst="rect">
             <a:avLst/>
@@ -9342,8 +9342,8 @@
         </p:nvSpPr>
         <p:spPr>
           <a:xfrm>
-            <a:off x="6263640" y="1755648"/>
-            <a:ext cx="4645152" cy="2121408"/>
+            <a:off x="6293815" y="1783080"/>
+            <a:ext cx="4297680" cy="2084831"/>
           </a:xfrm>
           <a:prstGeom prst="roundRect">
             <a:avLst/>
@@ -9387,8 +9387,8 @@
         </p:nvSpPr>
         <p:spPr>
           <a:xfrm>
-            <a:off x="6537960" y="1938528"/>
-            <a:ext cx="4096512" cy="1847088"/>
+            <a:off x="6568135" y="1965960"/>
+            <a:ext cx="3749040" cy="1810511"/>
           </a:xfrm>
           <a:prstGeom prst="rect">
             <a:avLst/>
@@ -9503,8 +9503,8 @@
         </p:nvSpPr>
         <p:spPr>
           <a:xfrm>
-            <a:off x="1280160" y="4096512"/>
-            <a:ext cx="4645152" cy="2121408"/>
+            <a:off x="1600200" y="4087367"/>
+            <a:ext cx="4297680" cy="2084831"/>
           </a:xfrm>
           <a:prstGeom prst="roundRect">
             <a:avLst/>
@@ -9548,8 +9548,8 @@
         </p:nvSpPr>
         <p:spPr>
           <a:xfrm>
-            <a:off x="1554480" y="4279392"/>
-            <a:ext cx="4096512" cy="1847088"/>
+            <a:off x="1874520" y="4270247"/>
+            <a:ext cx="3749040" cy="1810511"/>
           </a:xfrm>
           <a:prstGeom prst="rect">
             <a:avLst/>
@@ -9664,8 +9664,8 @@
         </p:nvSpPr>
         <p:spPr>
           <a:xfrm>
-            <a:off x="6263640" y="4096512"/>
-            <a:ext cx="4645152" cy="2121408"/>
+            <a:off x="6293815" y="4087367"/>
+            <a:ext cx="4297680" cy="2084831"/>
           </a:xfrm>
           <a:prstGeom prst="roundRect">
             <a:avLst/>
@@ -9709,8 +9709,8 @@
         </p:nvSpPr>
         <p:spPr>
           <a:xfrm>
-            <a:off x="6537960" y="4279392"/>
-            <a:ext cx="4096512" cy="1847088"/>
+            <a:off x="6568135" y="4270247"/>
+            <a:ext cx="3749040" cy="1810511"/>
           </a:xfrm>
           <a:prstGeom prst="rect">
             <a:avLst/>
@@ -9937,8 +9937,8 @@
         </p:blipFill>
         <p:spPr>
           <a:xfrm>
-            <a:off x="9509760" y="438912"/>
-            <a:ext cx="693429" cy="658368"/>
+            <a:off x="9144000" y="438912"/>
+            <a:ext cx="722322" cy="685800"/>
           </a:xfrm>
           <a:prstGeom prst="rect">
             <a:avLst/>
@@ -9953,8 +9953,8 @@
         </p:nvSpPr>
         <p:spPr>
           <a:xfrm>
-            <a:off x="1280160" y="438912"/>
-            <a:ext cx="7772400" cy="320040"/>
+            <a:off x="1600200" y="438912"/>
+            <a:ext cx="7315200" cy="320040"/>
           </a:xfrm>
           <a:prstGeom prst="rect">
             <a:avLst/>
@@ -9968,7 +9968,7 @@
           <a:lstStyle/>
           <a:p>
             <a:pPr>
-              <a:defRPr sz="1100" b="1">
+              <a:defRPr sz="1150" b="1">
                 <a:solidFill>
                   <a:srgbClr val="D95500"/>
                 </a:solidFill>
@@ -9989,8 +9989,8 @@
         </p:nvSpPr>
         <p:spPr>
           <a:xfrm>
-            <a:off x="1280160" y="749808"/>
-            <a:ext cx="8412480" cy="731520"/>
+            <a:off x="1600200" y="749808"/>
+            <a:ext cx="7589520" cy="731520"/>
           </a:xfrm>
           <a:prstGeom prst="rect">
             <a:avLst/>
@@ -10025,8 +10025,8 @@
         </p:nvSpPr>
         <p:spPr>
           <a:xfrm>
-            <a:off x="1280160" y="1536192"/>
-            <a:ext cx="4572000" cy="41148"/>
+            <a:off x="1600200" y="1536192"/>
+            <a:ext cx="4389120" cy="41148"/>
           </a:xfrm>
           <a:prstGeom prst="rect">
             <a:avLst/>
@@ -10068,8 +10068,8 @@
         </p:nvSpPr>
         <p:spPr>
           <a:xfrm>
-            <a:off x="1280160" y="6291072"/>
-            <a:ext cx="9631375" cy="274320"/>
+            <a:off x="1600200" y="6291072"/>
+            <a:ext cx="8991295" cy="274320"/>
           </a:xfrm>
           <a:prstGeom prst="rect">
             <a:avLst/>
@@ -10104,8 +10104,8 @@
         </p:nvSpPr>
         <p:spPr>
           <a:xfrm>
-            <a:off x="1280160" y="1755648"/>
-            <a:ext cx="2999232" cy="4462272"/>
+            <a:off x="1600200" y="1783080"/>
+            <a:ext cx="2788920" cy="4389120"/>
           </a:xfrm>
           <a:prstGeom prst="roundRect">
             <a:avLst/>
@@ -10149,8 +10149,8 @@
         </p:nvSpPr>
         <p:spPr>
           <a:xfrm>
-            <a:off x="1280160" y="1755648"/>
-            <a:ext cx="2999232" cy="73152"/>
+            <a:off x="1600200" y="1783080"/>
+            <a:ext cx="2788920" cy="73152"/>
           </a:xfrm>
           <a:prstGeom prst="rect">
             <a:avLst/>
@@ -10200,7 +10200,7 @@
         </p:blipFill>
         <p:spPr>
           <a:xfrm>
-            <a:off x="3502152" y="1938528"/>
+            <a:off x="3611880" y="1965960"/>
             <a:ext cx="621792" cy="621792"/>
           </a:xfrm>
           <a:prstGeom prst="rect">
@@ -10216,8 +10216,8 @@
         </p:nvSpPr>
         <p:spPr>
           <a:xfrm>
-            <a:off x="1508760" y="1984248"/>
-            <a:ext cx="2542032" cy="4096512"/>
+            <a:off x="1828800" y="2011680"/>
+            <a:ext cx="2331720" cy="4023360"/>
           </a:xfrm>
           <a:prstGeom prst="rect">
             <a:avLst/>
@@ -10231,7 +10231,7 @@
           <a:lstStyle/>
           <a:p>
             <a:pPr>
-              <a:defRPr sz="1200" b="1">
+              <a:defRPr sz="1150" b="1">
                 <a:solidFill>
                   <a:srgbClr val="D95500"/>
                 </a:solidFill>
@@ -10270,7 +10270,7 @@
               </a:defRPr>
             </a:pPr>
             <a:r>
-              <a:t>——————————————————————</a:t>
+              <a:t>————————————————————</a:t>
             </a:r>
           </a:p>
           <a:p>
@@ -10331,8 +10331,8 @@
         </p:nvSpPr>
         <p:spPr>
           <a:xfrm>
-            <a:off x="4590288" y="1755648"/>
-            <a:ext cx="2999232" cy="4462272"/>
+            <a:off x="4700016" y="1783080"/>
+            <a:ext cx="2788920" cy="4389120"/>
           </a:xfrm>
           <a:prstGeom prst="roundRect">
             <a:avLst/>
@@ -10376,8 +10376,8 @@
         </p:nvSpPr>
         <p:spPr>
           <a:xfrm>
-            <a:off x="4590288" y="1755648"/>
-            <a:ext cx="2999232" cy="73152"/>
+            <a:off x="4700016" y="1783080"/>
+            <a:ext cx="2788920" cy="73152"/>
           </a:xfrm>
           <a:prstGeom prst="rect">
             <a:avLst/>
@@ -10427,7 +10427,7 @@
         </p:blipFill>
         <p:spPr>
           <a:xfrm>
-            <a:off x="6812280" y="1938528"/>
+            <a:off x="6711696" y="1965960"/>
             <a:ext cx="621792" cy="621792"/>
           </a:xfrm>
           <a:prstGeom prst="rect">
@@ -10443,8 +10443,8 @@
         </p:nvSpPr>
         <p:spPr>
           <a:xfrm>
-            <a:off x="4818888" y="1984248"/>
-            <a:ext cx="2542032" cy="4096512"/>
+            <a:off x="4928616" y="2011680"/>
+            <a:ext cx="2331720" cy="4023360"/>
           </a:xfrm>
           <a:prstGeom prst="rect">
             <a:avLst/>
@@ -10458,7 +10458,7 @@
           <a:lstStyle/>
           <a:p>
             <a:pPr>
-              <a:defRPr sz="1200" b="1">
+              <a:defRPr sz="1150" b="1">
                 <a:solidFill>
                   <a:srgbClr val="D95500"/>
                 </a:solidFill>
@@ -10497,7 +10497,7 @@
               </a:defRPr>
             </a:pPr>
             <a:r>
-              <a:t>——————————————————————</a:t>
+              <a:t>————————————————————</a:t>
             </a:r>
           </a:p>
           <a:p>
@@ -10558,8 +10558,8 @@
         </p:nvSpPr>
         <p:spPr>
           <a:xfrm>
-            <a:off x="7900416" y="1755648"/>
-            <a:ext cx="2999232" cy="4462272"/>
+            <a:off x="7799832" y="1783080"/>
+            <a:ext cx="2788920" cy="4389120"/>
           </a:xfrm>
           <a:prstGeom prst="roundRect">
             <a:avLst/>
@@ -10603,8 +10603,8 @@
         </p:nvSpPr>
         <p:spPr>
           <a:xfrm>
-            <a:off x="7900416" y="1755648"/>
-            <a:ext cx="2999232" cy="73152"/>
+            <a:off x="7799832" y="1783080"/>
+            <a:ext cx="2788920" cy="73152"/>
           </a:xfrm>
           <a:prstGeom prst="rect">
             <a:avLst/>
@@ -10654,7 +10654,7 @@
         </p:blipFill>
         <p:spPr>
           <a:xfrm>
-            <a:off x="10122408" y="1938528"/>
+            <a:off x="9811512" y="1965960"/>
             <a:ext cx="621792" cy="621792"/>
           </a:xfrm>
           <a:prstGeom prst="rect">
@@ -10670,8 +10670,8 @@
         </p:nvSpPr>
         <p:spPr>
           <a:xfrm>
-            <a:off x="8129016" y="1984248"/>
-            <a:ext cx="2542032" cy="4096512"/>
+            <a:off x="8028432" y="2011680"/>
+            <a:ext cx="2331720" cy="4023360"/>
           </a:xfrm>
           <a:prstGeom prst="rect">
             <a:avLst/>
@@ -10685,7 +10685,7 @@
           <a:lstStyle/>
           <a:p>
             <a:pPr>
-              <a:defRPr sz="1200" b="1">
+              <a:defRPr sz="1150" b="1">
                 <a:solidFill>
                   <a:srgbClr val="D95500"/>
                 </a:solidFill>
@@ -10724,7 +10724,7 @@
               </a:defRPr>
             </a:pPr>
             <a:r>
-              <a:t>——————————————————————</a:t>
+              <a:t>————————————————————</a:t>
             </a:r>
           </a:p>
           <a:p>
@@ -10897,8 +10897,8 @@
         </p:blipFill>
         <p:spPr>
           <a:xfrm>
-            <a:off x="9509760" y="438912"/>
-            <a:ext cx="693429" cy="658368"/>
+            <a:off x="9144000" y="438912"/>
+            <a:ext cx="722322" cy="685800"/>
           </a:xfrm>
           <a:prstGeom prst="rect">
             <a:avLst/>
@@ -10913,8 +10913,8 @@
         </p:nvSpPr>
         <p:spPr>
           <a:xfrm>
-            <a:off x="1280160" y="438912"/>
-            <a:ext cx="7772400" cy="320040"/>
+            <a:off x="1600200" y="438912"/>
+            <a:ext cx="7315200" cy="320040"/>
           </a:xfrm>
           <a:prstGeom prst="rect">
             <a:avLst/>
@@ -10928,7 +10928,7 @@
           <a:lstStyle/>
           <a:p>
             <a:pPr>
-              <a:defRPr sz="1100" b="1">
+              <a:defRPr sz="1150" b="1">
                 <a:solidFill>
                   <a:srgbClr val="D95500"/>
                 </a:solidFill>
@@ -10949,8 +10949,8 @@
         </p:nvSpPr>
         <p:spPr>
           <a:xfrm>
-            <a:off x="1280160" y="749808"/>
-            <a:ext cx="8412480" cy="731520"/>
+            <a:off x="1600200" y="749808"/>
+            <a:ext cx="7589520" cy="731520"/>
           </a:xfrm>
           <a:prstGeom prst="rect">
             <a:avLst/>
@@ -10985,8 +10985,8 @@
         </p:nvSpPr>
         <p:spPr>
           <a:xfrm>
-            <a:off x="1280160" y="1536192"/>
-            <a:ext cx="4572000" cy="41148"/>
+            <a:off x="1600200" y="1536192"/>
+            <a:ext cx="4389120" cy="41148"/>
           </a:xfrm>
           <a:prstGeom prst="rect">
             <a:avLst/>
@@ -11028,8 +11028,8 @@
         </p:nvSpPr>
         <p:spPr>
           <a:xfrm>
-            <a:off x="1280160" y="6291072"/>
-            <a:ext cx="9631375" cy="274320"/>
+            <a:off x="1600200" y="6291072"/>
+            <a:ext cx="8991295" cy="274320"/>
           </a:xfrm>
           <a:prstGeom prst="rect">
             <a:avLst/>
@@ -11064,8 +11064,8 @@
         </p:nvSpPr>
         <p:spPr>
           <a:xfrm>
-            <a:off x="1280160" y="1755648"/>
-            <a:ext cx="4645152" cy="2121408"/>
+            <a:off x="1600200" y="1783080"/>
+            <a:ext cx="4297680" cy="2084831"/>
           </a:xfrm>
           <a:prstGeom prst="roundRect">
             <a:avLst/>
@@ -11109,8 +11109,8 @@
         </p:nvSpPr>
         <p:spPr>
           <a:xfrm>
-            <a:off x="1554480" y="1938528"/>
-            <a:ext cx="4096512" cy="1847088"/>
+            <a:off x="1874520" y="1965960"/>
+            <a:ext cx="3749040" cy="1810511"/>
           </a:xfrm>
           <a:prstGeom prst="rect">
             <a:avLst/>
@@ -11209,8 +11209,8 @@
         </p:nvSpPr>
         <p:spPr>
           <a:xfrm>
-            <a:off x="6263640" y="1755648"/>
-            <a:ext cx="4645152" cy="2121408"/>
+            <a:off x="6293815" y="1783080"/>
+            <a:ext cx="4297680" cy="2084831"/>
           </a:xfrm>
           <a:prstGeom prst="roundRect">
             <a:avLst/>
@@ -11254,8 +11254,8 @@
         </p:nvSpPr>
         <p:spPr>
           <a:xfrm>
-            <a:off x="6537960" y="1938528"/>
-            <a:ext cx="4096512" cy="1847088"/>
+            <a:off x="6568135" y="1965960"/>
+            <a:ext cx="3749040" cy="1810511"/>
           </a:xfrm>
           <a:prstGeom prst="rect">
             <a:avLst/>
@@ -11354,8 +11354,8 @@
         </p:nvSpPr>
         <p:spPr>
           <a:xfrm>
-            <a:off x="1280160" y="4096512"/>
-            <a:ext cx="4645152" cy="2121408"/>
+            <a:off x="1600200" y="4087367"/>
+            <a:ext cx="4297680" cy="2084831"/>
           </a:xfrm>
           <a:prstGeom prst="roundRect">
             <a:avLst/>
@@ -11399,8 +11399,8 @@
         </p:nvSpPr>
         <p:spPr>
           <a:xfrm>
-            <a:off x="1554480" y="4279392"/>
-            <a:ext cx="4096512" cy="1847088"/>
+            <a:off x="1874520" y="4270247"/>
+            <a:ext cx="3749040" cy="1810511"/>
           </a:xfrm>
           <a:prstGeom prst="rect">
             <a:avLst/>
@@ -11499,8 +11499,8 @@
         </p:nvSpPr>
         <p:spPr>
           <a:xfrm>
-            <a:off x="6263640" y="4096512"/>
-            <a:ext cx="4645152" cy="2121408"/>
+            <a:off x="6293815" y="4087367"/>
+            <a:ext cx="4297680" cy="2084831"/>
           </a:xfrm>
           <a:prstGeom prst="roundRect">
             <a:avLst/>
@@ -11544,8 +11544,8 @@
         </p:nvSpPr>
         <p:spPr>
           <a:xfrm>
-            <a:off x="6537960" y="4279392"/>
-            <a:ext cx="4096512" cy="1847088"/>
+            <a:off x="6568135" y="4270247"/>
+            <a:ext cx="3749040" cy="1810511"/>
           </a:xfrm>
           <a:prstGeom prst="rect">
             <a:avLst/>
@@ -11756,8 +11756,8 @@
         </p:blipFill>
         <p:spPr>
           <a:xfrm>
-            <a:off x="9509760" y="438912"/>
-            <a:ext cx="693429" cy="658368"/>
+            <a:off x="9144000" y="438912"/>
+            <a:ext cx="722322" cy="685800"/>
           </a:xfrm>
           <a:prstGeom prst="rect">
             <a:avLst/>
@@ -11772,8 +11772,8 @@
         </p:nvSpPr>
         <p:spPr>
           <a:xfrm>
-            <a:off x="1280160" y="438912"/>
-            <a:ext cx="7772400" cy="320040"/>
+            <a:off x="1600200" y="438912"/>
+            <a:ext cx="7315200" cy="320040"/>
           </a:xfrm>
           <a:prstGeom prst="rect">
             <a:avLst/>
@@ -11787,7 +11787,7 @@
           <a:lstStyle/>
           <a:p>
             <a:pPr>
-              <a:defRPr sz="1100" b="1">
+              <a:defRPr sz="1150" b="1">
                 <a:solidFill>
                   <a:srgbClr val="D95500"/>
                 </a:solidFill>
@@ -11808,8 +11808,8 @@
         </p:nvSpPr>
         <p:spPr>
           <a:xfrm>
-            <a:off x="1280160" y="749808"/>
-            <a:ext cx="8412480" cy="731520"/>
+            <a:off x="1600200" y="749808"/>
+            <a:ext cx="7589520" cy="731520"/>
           </a:xfrm>
           <a:prstGeom prst="rect">
             <a:avLst/>
@@ -11844,8 +11844,8 @@
         </p:nvSpPr>
         <p:spPr>
           <a:xfrm>
-            <a:off x="1280160" y="1536192"/>
-            <a:ext cx="4572000" cy="41148"/>
+            <a:off x="1600200" y="1536192"/>
+            <a:ext cx="4389120" cy="41148"/>
           </a:xfrm>
           <a:prstGeom prst="rect">
             <a:avLst/>
@@ -11887,8 +11887,8 @@
         </p:nvSpPr>
         <p:spPr>
           <a:xfrm>
-            <a:off x="1280160" y="6291072"/>
-            <a:ext cx="9631375" cy="274320"/>
+            <a:off x="1600200" y="6291072"/>
+            <a:ext cx="8991295" cy="274320"/>
           </a:xfrm>
           <a:prstGeom prst="rect">
             <a:avLst/>
@@ -11923,8 +11923,8 @@
         </p:nvSpPr>
         <p:spPr>
           <a:xfrm>
-            <a:off x="1280160" y="1755648"/>
-            <a:ext cx="4645152" cy="2121408"/>
+            <a:off x="1600200" y="1783080"/>
+            <a:ext cx="4297680" cy="2084831"/>
           </a:xfrm>
           <a:prstGeom prst="roundRect">
             <a:avLst/>
@@ -11968,8 +11968,8 @@
         </p:nvSpPr>
         <p:spPr>
           <a:xfrm>
-            <a:off x="1554480" y="1938528"/>
-            <a:ext cx="4096512" cy="1847088"/>
+            <a:off x="1874520" y="1965960"/>
+            <a:ext cx="3749040" cy="1810511"/>
           </a:xfrm>
           <a:prstGeom prst="rect">
             <a:avLst/>
@@ -12084,8 +12084,8 @@
         </p:nvSpPr>
         <p:spPr>
           <a:xfrm>
-            <a:off x="6263640" y="1755648"/>
-            <a:ext cx="4645152" cy="2121408"/>
+            <a:off x="6293815" y="1783080"/>
+            <a:ext cx="4297680" cy="2084831"/>
           </a:xfrm>
           <a:prstGeom prst="roundRect">
             <a:avLst/>
@@ -12129,8 +12129,8 @@
         </p:nvSpPr>
         <p:spPr>
           <a:xfrm>
-            <a:off x="6537960" y="1938528"/>
-            <a:ext cx="4096512" cy="1847088"/>
+            <a:off x="6568135" y="1965960"/>
+            <a:ext cx="3749040" cy="1810511"/>
           </a:xfrm>
           <a:prstGeom prst="rect">
             <a:avLst/>
@@ -12229,8 +12229,8 @@
         </p:nvSpPr>
         <p:spPr>
           <a:xfrm>
-            <a:off x="1280160" y="4096512"/>
-            <a:ext cx="4645152" cy="2121408"/>
+            <a:off x="1600200" y="4087367"/>
+            <a:ext cx="4297680" cy="2084831"/>
           </a:xfrm>
           <a:prstGeom prst="roundRect">
             <a:avLst/>
@@ -12274,8 +12274,8 @@
         </p:nvSpPr>
         <p:spPr>
           <a:xfrm>
-            <a:off x="1554480" y="4279392"/>
-            <a:ext cx="4096512" cy="1847088"/>
+            <a:off x="1874520" y="4270247"/>
+            <a:ext cx="3749040" cy="1810511"/>
           </a:xfrm>
           <a:prstGeom prst="rect">
             <a:avLst/>
@@ -12374,8 +12374,8 @@
         </p:nvSpPr>
         <p:spPr>
           <a:xfrm>
-            <a:off x="6263640" y="4096512"/>
-            <a:ext cx="4645152" cy="2121408"/>
+            <a:off x="6293815" y="4087367"/>
+            <a:ext cx="4297680" cy="2084831"/>
           </a:xfrm>
           <a:prstGeom prst="roundRect">
             <a:avLst/>
@@ -12419,8 +12419,8 @@
         </p:nvSpPr>
         <p:spPr>
           <a:xfrm>
-            <a:off x="6537960" y="4279392"/>
-            <a:ext cx="4096512" cy="1847088"/>
+            <a:off x="6568135" y="4270247"/>
+            <a:ext cx="3749040" cy="1810511"/>
           </a:xfrm>
           <a:prstGeom prst="rect">
             <a:avLst/>

</xml_diff>

<commit_message>
Vervang alle contact-emojis door officiele TT Clinics merkiconen (SVG & PNG)
</commit_message>
<xml_diff>
--- a/TT_Clinics_Bedrijfsplan.pptx
+++ b/TT_Clinics_Bedrijfsplan.pptx
@@ -5023,8 +5023,8 @@
         </p:nvSpPr>
         <p:spPr>
           <a:xfrm>
-            <a:off x="8010144" y="2011680"/>
-            <a:ext cx="2322576" cy="4023360"/>
+            <a:off x="7982712" y="1965960"/>
+            <a:ext cx="2377440" cy="365760"/>
           </a:xfrm>
           <a:prstGeom prst="rect">
             <a:avLst/>
@@ -5038,7 +5038,7 @@
           <a:lstStyle/>
           <a:p>
             <a:pPr>
-              <a:defRPr sz="1600" b="1">
+              <a:defRPr sz="1500" b="1">
                 <a:solidFill>
                   <a:srgbClr val="111827"/>
                 </a:solidFill>
@@ -5047,77 +5047,13 @@
             </a:pPr>
             <a:r>
               <a:t>DIRECT CONTACT</a:t>
-            </a:r>
-          </a:p>
-          <a:p>
-            <a:pPr>
-              <a:spcBef>
-                <a:spcPts val="600"/>
-              </a:spcBef>
-              <a:defRPr sz="1200">
-                <a:solidFill>
-                  <a:srgbClr val="475569"/>
-                </a:solidFill>
-                <a:latin typeface="Arial"/>
-              </a:defRPr>
-            </a:pPr>
-            <a:r>
-              <a:t>E-mail: info@ttclinics.nl</a:t>
-            </a:r>
-          </a:p>
-          <a:p>
-            <a:pPr>
-              <a:spcBef>
-                <a:spcPts val="600"/>
-              </a:spcBef>
-              <a:defRPr sz="1200">
-                <a:solidFill>
-                  <a:srgbClr val="475569"/>
-                </a:solidFill>
-                <a:latin typeface="Arial"/>
-              </a:defRPr>
-            </a:pPr>
-            <a:r>
-              <a:t>Telefoon: 06 - 12345678</a:t>
-            </a:r>
-          </a:p>
-          <a:p>
-            <a:pPr>
-              <a:spcBef>
-                <a:spcPts val="600"/>
-              </a:spcBef>
-              <a:defRPr sz="1200">
-                <a:solidFill>
-                  <a:srgbClr val="475569"/>
-                </a:solidFill>
-                <a:latin typeface="Arial"/>
-              </a:defRPr>
-            </a:pPr>
-            <a:r>
-              <a:t>Website: www.ttclinics.nl</a:t>
-            </a:r>
-          </a:p>
-          <a:p>
-            <a:pPr>
-              <a:spcBef>
-                <a:spcPts val="600"/>
-              </a:spcBef>
-              <a:defRPr sz="1200">
-                <a:solidFill>
-                  <a:srgbClr val="475569"/>
-                </a:solidFill>
-                <a:latin typeface="Arial"/>
-              </a:defRPr>
-            </a:pPr>
-            <a:r>
-              <a:t>Locaties: Kantoor &amp; sportzalen</a:t>
             </a:r>
           </a:p>
         </p:txBody>
       </p:sp>
       <p:pic>
         <p:nvPicPr>
-          <p:cNvPr id="16" name="Picture 15" descr="qr-ttclinics.png"/>
+          <p:cNvPr id="16" name="Picture 15" descr="icon-mail.png"/>
           <p:cNvPicPr>
             <a:picLocks noChangeAspect="1"/>
           </p:cNvPicPr>
@@ -5131,6 +5067,186 @@
         </p:blipFill>
         <p:spPr>
           <a:xfrm>
+            <a:off x="8010144" y="2423160"/>
+            <a:ext cx="384048" cy="384048"/>
+          </a:xfrm>
+          <a:prstGeom prst="rect">
+            <a:avLst/>
+          </a:prstGeom>
+        </p:spPr>
+      </p:pic>
+      <p:sp>
+        <p:nvSpPr>
+          <p:cNvPr id="17" name="TextBox 16"/>
+          <p:cNvSpPr txBox="1"/>
+          <p:nvPr/>
+        </p:nvSpPr>
+        <p:spPr>
+          <a:xfrm>
+            <a:off x="8503920" y="2459736"/>
+            <a:ext cx="2011680" cy="347472"/>
+          </a:xfrm>
+          <a:prstGeom prst="rect">
+            <a:avLst/>
+          </a:prstGeom>
+          <a:noFill/>
+        </p:spPr>
+        <p:txBody>
+          <a:bodyPr wrap="square" lIns="0" tIns="0">
+            <a:spAutoFit/>
+          </a:bodyPr>
+          <a:lstStyle/>
+          <a:p>
+            <a:pPr>
+              <a:defRPr sz="1200" b="1">
+                <a:solidFill>
+                  <a:srgbClr val="111827"/>
+                </a:solidFill>
+                <a:latin typeface="Arial Black"/>
+              </a:defRPr>
+            </a:pPr>
+            <a:r>
+              <a:t>info@ttclinics.nl</a:t>
+            </a:r>
+          </a:p>
+        </p:txBody>
+      </p:sp>
+      <p:pic>
+        <p:nvPicPr>
+          <p:cNvPr id="18" name="Picture 17" descr="icon-phone.png"/>
+          <p:cNvPicPr>
+            <a:picLocks noChangeAspect="1"/>
+          </p:cNvPicPr>
+          <p:nvPr/>
+        </p:nvPicPr>
+        <p:blipFill>
+          <a:blip r:embed="rId5"/>
+          <a:stretch>
+            <a:fillRect/>
+          </a:stretch>
+        </p:blipFill>
+        <p:spPr>
+          <a:xfrm>
+            <a:off x="8010144" y="2953512"/>
+            <a:ext cx="384048" cy="384048"/>
+          </a:xfrm>
+          <a:prstGeom prst="rect">
+            <a:avLst/>
+          </a:prstGeom>
+        </p:spPr>
+      </p:pic>
+      <p:sp>
+        <p:nvSpPr>
+          <p:cNvPr id="19" name="TextBox 18"/>
+          <p:cNvSpPr txBox="1"/>
+          <p:nvPr/>
+        </p:nvSpPr>
+        <p:spPr>
+          <a:xfrm>
+            <a:off x="8503920" y="2990088"/>
+            <a:ext cx="2011680" cy="347472"/>
+          </a:xfrm>
+          <a:prstGeom prst="rect">
+            <a:avLst/>
+          </a:prstGeom>
+          <a:noFill/>
+        </p:spPr>
+        <p:txBody>
+          <a:bodyPr wrap="square" lIns="0" tIns="0">
+            <a:spAutoFit/>
+          </a:bodyPr>
+          <a:lstStyle/>
+          <a:p>
+            <a:pPr>
+              <a:defRPr sz="1200" b="1">
+                <a:solidFill>
+                  <a:srgbClr val="111827"/>
+                </a:solidFill>
+                <a:latin typeface="Arial Black"/>
+              </a:defRPr>
+            </a:pPr>
+            <a:r>
+              <a:t>06 - 12345678</a:t>
+            </a:r>
+          </a:p>
+        </p:txBody>
+      </p:sp>
+      <p:pic>
+        <p:nvPicPr>
+          <p:cNvPr id="20" name="Picture 19" descr="icon-web.png"/>
+          <p:cNvPicPr>
+            <a:picLocks noChangeAspect="1"/>
+          </p:cNvPicPr>
+          <p:nvPr/>
+        </p:nvPicPr>
+        <p:blipFill>
+          <a:blip r:embed="rId6"/>
+          <a:stretch>
+            <a:fillRect/>
+          </a:stretch>
+        </p:blipFill>
+        <p:spPr>
+          <a:xfrm>
+            <a:off x="8010144" y="3483864"/>
+            <a:ext cx="384048" cy="384048"/>
+          </a:xfrm>
+          <a:prstGeom prst="rect">
+            <a:avLst/>
+          </a:prstGeom>
+        </p:spPr>
+      </p:pic>
+      <p:sp>
+        <p:nvSpPr>
+          <p:cNvPr id="21" name="TextBox 20"/>
+          <p:cNvSpPr txBox="1"/>
+          <p:nvPr/>
+        </p:nvSpPr>
+        <p:spPr>
+          <a:xfrm>
+            <a:off x="8503920" y="3520440"/>
+            <a:ext cx="2011680" cy="347472"/>
+          </a:xfrm>
+          <a:prstGeom prst="rect">
+            <a:avLst/>
+          </a:prstGeom>
+          <a:noFill/>
+        </p:spPr>
+        <p:txBody>
+          <a:bodyPr wrap="square" lIns="0" tIns="0">
+            <a:spAutoFit/>
+          </a:bodyPr>
+          <a:lstStyle/>
+          <a:p>
+            <a:pPr>
+              <a:defRPr sz="1200" b="1">
+                <a:solidFill>
+                  <a:srgbClr val="D95500"/>
+                </a:solidFill>
+                <a:latin typeface="Arial Black"/>
+              </a:defRPr>
+            </a:pPr>
+            <a:r>
+              <a:t>www.ttclinics.nl</a:t>
+            </a:r>
+          </a:p>
+        </p:txBody>
+      </p:sp>
+      <p:pic>
+        <p:nvPicPr>
+          <p:cNvPr id="22" name="Picture 21" descr="qr-ttclinics.png"/>
+          <p:cNvPicPr>
+            <a:picLocks noChangeAspect="1"/>
+          </p:cNvPicPr>
+          <p:nvPr/>
+        </p:nvPicPr>
+        <p:blipFill>
+          <a:blip r:embed="rId7"/>
+          <a:stretch>
+            <a:fillRect/>
+          </a:stretch>
+        </p:blipFill>
+        <p:spPr>
+          <a:xfrm>
             <a:off x="8439912" y="4297680"/>
             <a:ext cx="1444752" cy="1444752"/>
           </a:xfrm>
@@ -5141,7 +5257,7 @@
       </p:pic>
       <p:sp>
         <p:nvSpPr>
-          <p:cNvPr id="17" name="TextBox 16"/>
+          <p:cNvPr id="23" name="TextBox 22"/>
           <p:cNvSpPr txBox="1"/>
           <p:nvPr/>
         </p:nvSpPr>

</xml_diff>

<commit_message>
Maak logo groter en voeg duidelijke TT Clinics aanduiding toe op alle slides
</commit_message>
<xml_diff>
--- a/TT_Clinics_Bedrijfsplan.pptx
+++ b/TT_Clinics_Bedrijfsplan.pptx
@@ -3229,7 +3229,7 @@
       </p:sp>
       <p:pic>
         <p:nvPicPr>
-          <p:cNvPr id="5" name="Picture 4" descr="logo-transparent.png"/>
+          <p:cNvPr id="5" name="Picture 4" descr="logo-lockup-cover.png"/>
           <p:cNvPicPr>
             <a:picLocks noChangeAspect="1"/>
           </p:cNvPicPr>
@@ -3243,8 +3243,8 @@
         </p:blipFill>
         <p:spPr>
           <a:xfrm>
-            <a:off x="1737360" y="1005840"/>
-            <a:ext cx="1348334" cy="1280160"/>
+            <a:off x="1737360" y="841248"/>
+            <a:ext cx="4437126" cy="1508760"/>
           </a:xfrm>
           <a:prstGeom prst="rect">
             <a:avLst/>
@@ -3540,7 +3540,7 @@
       </p:sp>
       <p:pic>
         <p:nvPicPr>
-          <p:cNvPr id="4" name="Picture 3" descr="logo-transparent.png"/>
+          <p:cNvPr id="4" name="Picture 3" descr="logo-lockup-header.png"/>
           <p:cNvPicPr>
             <a:picLocks noChangeAspect="1"/>
           </p:cNvPicPr>
@@ -3554,8 +3554,8 @@
         </p:blipFill>
         <p:spPr>
           <a:xfrm>
-            <a:off x="9144000" y="438912"/>
-            <a:ext cx="722322" cy="685800"/>
+            <a:off x="8458200" y="384048"/>
+            <a:ext cx="2128746" cy="777240"/>
           </a:xfrm>
           <a:prstGeom prst="rect">
             <a:avLst/>
@@ -3571,7 +3571,7 @@
         <p:spPr>
           <a:xfrm>
             <a:off x="1600200" y="438912"/>
-            <a:ext cx="7315200" cy="320040"/>
+            <a:ext cx="6583680" cy="320040"/>
           </a:xfrm>
           <a:prstGeom prst="rect">
             <a:avLst/>
@@ -3607,7 +3607,7 @@
         <p:spPr>
           <a:xfrm>
             <a:off x="1600200" y="749808"/>
-            <a:ext cx="7589520" cy="731520"/>
+            <a:ext cx="6675120" cy="731520"/>
           </a:xfrm>
           <a:prstGeom prst="rect">
             <a:avLst/>
@@ -4558,7 +4558,7 @@
       </p:sp>
       <p:pic>
         <p:nvPicPr>
-          <p:cNvPr id="4" name="Picture 3" descr="logo-transparent.png"/>
+          <p:cNvPr id="4" name="Picture 3" descr="logo-lockup-header.png"/>
           <p:cNvPicPr>
             <a:picLocks noChangeAspect="1"/>
           </p:cNvPicPr>
@@ -4572,8 +4572,8 @@
         </p:blipFill>
         <p:spPr>
           <a:xfrm>
-            <a:off x="9144000" y="438912"/>
-            <a:ext cx="722322" cy="685800"/>
+            <a:off x="8458200" y="384048"/>
+            <a:ext cx="2128746" cy="777240"/>
           </a:xfrm>
           <a:prstGeom prst="rect">
             <a:avLst/>
@@ -4589,7 +4589,7 @@
         <p:spPr>
           <a:xfrm>
             <a:off x="1600200" y="438912"/>
-            <a:ext cx="7315200" cy="320040"/>
+            <a:ext cx="6583680" cy="320040"/>
           </a:xfrm>
           <a:prstGeom prst="rect">
             <a:avLst/>
@@ -4625,7 +4625,7 @@
         <p:spPr>
           <a:xfrm>
             <a:off x="1600200" y="749808"/>
-            <a:ext cx="7589520" cy="731520"/>
+            <a:ext cx="6675120" cy="731520"/>
           </a:xfrm>
           <a:prstGeom prst="rect">
             <a:avLst/>
@@ -5397,7 +5397,7 @@
       </p:sp>
       <p:pic>
         <p:nvPicPr>
-          <p:cNvPr id="4" name="Picture 3" descr="logo-transparent.png"/>
+          <p:cNvPr id="4" name="Picture 3" descr="logo-lockup-header.png"/>
           <p:cNvPicPr>
             <a:picLocks noChangeAspect="1"/>
           </p:cNvPicPr>
@@ -5411,8 +5411,8 @@
         </p:blipFill>
         <p:spPr>
           <a:xfrm>
-            <a:off x="9144000" y="438912"/>
-            <a:ext cx="722322" cy="685800"/>
+            <a:off x="8458200" y="384048"/>
+            <a:ext cx="2128746" cy="777240"/>
           </a:xfrm>
           <a:prstGeom prst="rect">
             <a:avLst/>
@@ -5428,7 +5428,7 @@
         <p:spPr>
           <a:xfrm>
             <a:off x="1600200" y="438912"/>
-            <a:ext cx="7315200" cy="320040"/>
+            <a:ext cx="6583680" cy="320040"/>
           </a:xfrm>
           <a:prstGeom prst="rect">
             <a:avLst/>
@@ -5464,7 +5464,7 @@
         <p:spPr>
           <a:xfrm>
             <a:off x="1600200" y="749808"/>
-            <a:ext cx="7589520" cy="731520"/>
+            <a:ext cx="6675120" cy="731520"/>
           </a:xfrm>
           <a:prstGeom prst="rect">
             <a:avLst/>
@@ -6332,7 +6332,7 @@
       </p:sp>
       <p:pic>
         <p:nvPicPr>
-          <p:cNvPr id="4" name="Picture 3" descr="logo-transparent.png"/>
+          <p:cNvPr id="4" name="Picture 3" descr="logo-lockup-header.png"/>
           <p:cNvPicPr>
             <a:picLocks noChangeAspect="1"/>
           </p:cNvPicPr>
@@ -6346,8 +6346,8 @@
         </p:blipFill>
         <p:spPr>
           <a:xfrm>
-            <a:off x="9144000" y="438912"/>
-            <a:ext cx="722322" cy="685800"/>
+            <a:off x="8458200" y="384048"/>
+            <a:ext cx="2128746" cy="777240"/>
           </a:xfrm>
           <a:prstGeom prst="rect">
             <a:avLst/>
@@ -6363,7 +6363,7 @@
         <p:spPr>
           <a:xfrm>
             <a:off x="1600200" y="438912"/>
-            <a:ext cx="7315200" cy="320040"/>
+            <a:ext cx="6583680" cy="320040"/>
           </a:xfrm>
           <a:prstGeom prst="rect">
             <a:avLst/>
@@ -6399,7 +6399,7 @@
         <p:spPr>
           <a:xfrm>
             <a:off x="1600200" y="749808"/>
-            <a:ext cx="7589520" cy="731520"/>
+            <a:ext cx="6675120" cy="731520"/>
           </a:xfrm>
           <a:prstGeom prst="rect">
             <a:avLst/>
@@ -7163,7 +7163,7 @@
       </p:sp>
       <p:pic>
         <p:nvPicPr>
-          <p:cNvPr id="4" name="Picture 3" descr="logo-transparent.png"/>
+          <p:cNvPr id="4" name="Picture 3" descr="logo-lockup-header.png"/>
           <p:cNvPicPr>
             <a:picLocks noChangeAspect="1"/>
           </p:cNvPicPr>
@@ -7177,8 +7177,8 @@
         </p:blipFill>
         <p:spPr>
           <a:xfrm>
-            <a:off x="9144000" y="438912"/>
-            <a:ext cx="722322" cy="685800"/>
+            <a:off x="8458200" y="384048"/>
+            <a:ext cx="2128746" cy="777240"/>
           </a:xfrm>
           <a:prstGeom prst="rect">
             <a:avLst/>
@@ -7194,7 +7194,7 @@
         <p:spPr>
           <a:xfrm>
             <a:off x="1600200" y="438912"/>
-            <a:ext cx="7315200" cy="320040"/>
+            <a:ext cx="6583680" cy="320040"/>
           </a:xfrm>
           <a:prstGeom prst="rect">
             <a:avLst/>
@@ -7230,7 +7230,7 @@
         <p:spPr>
           <a:xfrm>
             <a:off x="1600200" y="749808"/>
-            <a:ext cx="7589520" cy="731520"/>
+            <a:ext cx="6675120" cy="731520"/>
           </a:xfrm>
           <a:prstGeom prst="rect">
             <a:avLst/>
@@ -8181,7 +8181,7 @@
       </p:sp>
       <p:pic>
         <p:nvPicPr>
-          <p:cNvPr id="4" name="Picture 3" descr="logo-transparent.png"/>
+          <p:cNvPr id="4" name="Picture 3" descr="logo-lockup-header.png"/>
           <p:cNvPicPr>
             <a:picLocks noChangeAspect="1"/>
           </p:cNvPicPr>
@@ -8195,8 +8195,8 @@
         </p:blipFill>
         <p:spPr>
           <a:xfrm>
-            <a:off x="9144000" y="438912"/>
-            <a:ext cx="722322" cy="685800"/>
+            <a:off x="8458200" y="384048"/>
+            <a:ext cx="2128746" cy="777240"/>
           </a:xfrm>
           <a:prstGeom prst="rect">
             <a:avLst/>
@@ -8212,7 +8212,7 @@
         <p:spPr>
           <a:xfrm>
             <a:off x="1600200" y="438912"/>
-            <a:ext cx="7315200" cy="320040"/>
+            <a:ext cx="6583680" cy="320040"/>
           </a:xfrm>
           <a:prstGeom prst="rect">
             <a:avLst/>
@@ -8248,7 +8248,7 @@
         <p:spPr>
           <a:xfrm>
             <a:off x="1600200" y="749808"/>
-            <a:ext cx="7589520" cy="731520"/>
+            <a:ext cx="6675120" cy="731520"/>
           </a:xfrm>
           <a:prstGeom prst="rect">
             <a:avLst/>
@@ -9116,7 +9116,7 @@
       </p:sp>
       <p:pic>
         <p:nvPicPr>
-          <p:cNvPr id="4" name="Picture 3" descr="logo-transparent.png"/>
+          <p:cNvPr id="4" name="Picture 3" descr="logo-lockup-header.png"/>
           <p:cNvPicPr>
             <a:picLocks noChangeAspect="1"/>
           </p:cNvPicPr>
@@ -9130,8 +9130,8 @@
         </p:blipFill>
         <p:spPr>
           <a:xfrm>
-            <a:off x="9144000" y="438912"/>
-            <a:ext cx="722322" cy="685800"/>
+            <a:off x="8458200" y="384048"/>
+            <a:ext cx="2128746" cy="777240"/>
           </a:xfrm>
           <a:prstGeom prst="rect">
             <a:avLst/>
@@ -9147,7 +9147,7 @@
         <p:spPr>
           <a:xfrm>
             <a:off x="1600200" y="438912"/>
-            <a:ext cx="7315200" cy="320040"/>
+            <a:ext cx="6583680" cy="320040"/>
           </a:xfrm>
           <a:prstGeom prst="rect">
             <a:avLst/>
@@ -9183,7 +9183,7 @@
         <p:spPr>
           <a:xfrm>
             <a:off x="1600200" y="749808"/>
-            <a:ext cx="7589520" cy="731520"/>
+            <a:ext cx="6675120" cy="731520"/>
           </a:xfrm>
           <a:prstGeom prst="rect">
             <a:avLst/>
@@ -10039,7 +10039,7 @@
       </p:sp>
       <p:pic>
         <p:nvPicPr>
-          <p:cNvPr id="4" name="Picture 3" descr="logo-transparent.png"/>
+          <p:cNvPr id="4" name="Picture 3" descr="logo-lockup-header.png"/>
           <p:cNvPicPr>
             <a:picLocks noChangeAspect="1"/>
           </p:cNvPicPr>
@@ -10053,8 +10053,8 @@
         </p:blipFill>
         <p:spPr>
           <a:xfrm>
-            <a:off x="9144000" y="438912"/>
-            <a:ext cx="722322" cy="685800"/>
+            <a:off x="8458200" y="384048"/>
+            <a:ext cx="2128746" cy="777240"/>
           </a:xfrm>
           <a:prstGeom prst="rect">
             <a:avLst/>
@@ -10070,7 +10070,7 @@
         <p:spPr>
           <a:xfrm>
             <a:off x="1600200" y="438912"/>
-            <a:ext cx="7315200" cy="320040"/>
+            <a:ext cx="6583680" cy="320040"/>
           </a:xfrm>
           <a:prstGeom prst="rect">
             <a:avLst/>
@@ -10106,7 +10106,7 @@
         <p:spPr>
           <a:xfrm>
             <a:off x="1600200" y="749808"/>
-            <a:ext cx="7589520" cy="731520"/>
+            <a:ext cx="6675120" cy="731520"/>
           </a:xfrm>
           <a:prstGeom prst="rect">
             <a:avLst/>
@@ -10999,7 +10999,7 @@
       </p:sp>
       <p:pic>
         <p:nvPicPr>
-          <p:cNvPr id="4" name="Picture 3" descr="logo-transparent.png"/>
+          <p:cNvPr id="4" name="Picture 3" descr="logo-lockup-header.png"/>
           <p:cNvPicPr>
             <a:picLocks noChangeAspect="1"/>
           </p:cNvPicPr>
@@ -11013,8 +11013,8 @@
         </p:blipFill>
         <p:spPr>
           <a:xfrm>
-            <a:off x="9144000" y="438912"/>
-            <a:ext cx="722322" cy="685800"/>
+            <a:off x="8458200" y="384048"/>
+            <a:ext cx="2128746" cy="777240"/>
           </a:xfrm>
           <a:prstGeom prst="rect">
             <a:avLst/>
@@ -11030,7 +11030,7 @@
         <p:spPr>
           <a:xfrm>
             <a:off x="1600200" y="438912"/>
-            <a:ext cx="7315200" cy="320040"/>
+            <a:ext cx="6583680" cy="320040"/>
           </a:xfrm>
           <a:prstGeom prst="rect">
             <a:avLst/>
@@ -11066,7 +11066,7 @@
         <p:spPr>
           <a:xfrm>
             <a:off x="1600200" y="749808"/>
-            <a:ext cx="7589520" cy="731520"/>
+            <a:ext cx="6675120" cy="731520"/>
           </a:xfrm>
           <a:prstGeom prst="rect">
             <a:avLst/>
@@ -11858,7 +11858,7 @@
       </p:sp>
       <p:pic>
         <p:nvPicPr>
-          <p:cNvPr id="4" name="Picture 3" descr="logo-transparent.png"/>
+          <p:cNvPr id="4" name="Picture 3" descr="logo-lockup-header.png"/>
           <p:cNvPicPr>
             <a:picLocks noChangeAspect="1"/>
           </p:cNvPicPr>
@@ -11872,8 +11872,8 @@
         </p:blipFill>
         <p:spPr>
           <a:xfrm>
-            <a:off x="9144000" y="438912"/>
-            <a:ext cx="722322" cy="685800"/>
+            <a:off x="8458200" y="384048"/>
+            <a:ext cx="2128746" cy="777240"/>
           </a:xfrm>
           <a:prstGeom prst="rect">
             <a:avLst/>
@@ -11889,7 +11889,7 @@
         <p:spPr>
           <a:xfrm>
             <a:off x="1600200" y="438912"/>
-            <a:ext cx="7315200" cy="320040"/>
+            <a:ext cx="6583680" cy="320040"/>
           </a:xfrm>
           <a:prstGeom prst="rect">
             <a:avLst/>
@@ -11925,7 +11925,7 @@
         <p:spPr>
           <a:xfrm>
             <a:off x="1600200" y="749808"/>
-            <a:ext cx="7589520" cy="731520"/>
+            <a:ext cx="6675120" cy="731520"/>
           </a:xfrm>
           <a:prstGeom prst="rect">
             <a:avLst/>

</xml_diff>